<commit_message>
docs: publish three-platform release matrix
</commit_message>
<xml_diff>
--- a/docs/presentation/BAI-Work-Project-Deck.pptx
+++ b/docs/presentation/BAI-Work-Project-Deck.pptx
@@ -2,34 +2,34 @@
 <file path=ppt/presentation.xml><?xml version="1.0" encoding="utf-8"?>
 <p:presentation xmlns:p="http://schemas.openxmlformats.org/presentationml/2006/main">
   <p:sldMasterIdLst>
-    <p:sldMasterId xmlns:r="http://schemas.openxmlformats.org/officeDocument/2006/relationships" id="2147483648" r:id="Rf4e07752ad8246d8"/>
+    <p:sldMasterId xmlns:r="http://schemas.openxmlformats.org/officeDocument/2006/relationships" id="2147483648" r:id="Ra51c8cb52c25498b"/>
   </p:sldMasterIdLst>
   <p:notesMasterIdLst>
-    <p:notesMasterId xmlns:r="http://schemas.openxmlformats.org/officeDocument/2006/relationships" r:id="R6355f06dfe6445ba"/>
+    <p:notesMasterId xmlns:r="http://schemas.openxmlformats.org/officeDocument/2006/relationships" r:id="Rf3dac73567314d31"/>
   </p:notesMasterIdLst>
   <p:sldIdLst>
-    <p:sldId xmlns:r="http://schemas.openxmlformats.org/officeDocument/2006/relationships" id="256" r:id="R69190ba7b4eb4390"/>
-    <p:sldId xmlns:r="http://schemas.openxmlformats.org/officeDocument/2006/relationships" id="257" r:id="R7d1ce893710147cf"/>
-    <p:sldId xmlns:r="http://schemas.openxmlformats.org/officeDocument/2006/relationships" id="258" r:id="R9b23bcaacd3d4710"/>
-    <p:sldId xmlns:r="http://schemas.openxmlformats.org/officeDocument/2006/relationships" id="259" r:id="Rcf02ef41b06a4e8c"/>
-    <p:sldId xmlns:r="http://schemas.openxmlformats.org/officeDocument/2006/relationships" id="260" r:id="R2ca05bf4e92847f0"/>
-    <p:sldId xmlns:r="http://schemas.openxmlformats.org/officeDocument/2006/relationships" id="261" r:id="R5288b80ada774112"/>
-    <p:sldId xmlns:r="http://schemas.openxmlformats.org/officeDocument/2006/relationships" id="262" r:id="R2848c6a5e8e144a5"/>
-    <p:sldId xmlns:r="http://schemas.openxmlformats.org/officeDocument/2006/relationships" id="263" r:id="R6b349f31e9b840a7"/>
-    <p:sldId xmlns:r="http://schemas.openxmlformats.org/officeDocument/2006/relationships" id="264" r:id="R4e01ca43563448bc"/>
-    <p:sldId xmlns:r="http://schemas.openxmlformats.org/officeDocument/2006/relationships" id="265" r:id="Rc0d2b244c61b4445"/>
-    <p:sldId xmlns:r="http://schemas.openxmlformats.org/officeDocument/2006/relationships" id="266" r:id="R3d502c27b4db4e5b"/>
-    <p:sldId xmlns:r="http://schemas.openxmlformats.org/officeDocument/2006/relationships" id="267" r:id="R627808e9a816496c"/>
-    <p:sldId xmlns:r="http://schemas.openxmlformats.org/officeDocument/2006/relationships" id="268" r:id="Rf6d48c47ba214c1b"/>
-    <p:sldId xmlns:r="http://schemas.openxmlformats.org/officeDocument/2006/relationships" id="269" r:id="Rb9c55fad3ac64ff4"/>
-    <p:sldId xmlns:r="http://schemas.openxmlformats.org/officeDocument/2006/relationships" id="270" r:id="R212b8f395f714866"/>
-    <p:sldId xmlns:r="http://schemas.openxmlformats.org/officeDocument/2006/relationships" id="271" r:id="R625f8d154f864738"/>
-    <p:sldId xmlns:r="http://schemas.openxmlformats.org/officeDocument/2006/relationships" id="272" r:id="R2d52a163dfce41a0"/>
-    <p:sldId xmlns:r="http://schemas.openxmlformats.org/officeDocument/2006/relationships" id="273" r:id="Rd54e7074f1c04f31"/>
-    <p:sldId xmlns:r="http://schemas.openxmlformats.org/officeDocument/2006/relationships" id="274" r:id="Rfbcf3f06db21419c"/>
-    <p:sldId xmlns:r="http://schemas.openxmlformats.org/officeDocument/2006/relationships" id="275" r:id="Rd38ca60be5b24c8a"/>
-    <p:sldId xmlns:r="http://schemas.openxmlformats.org/officeDocument/2006/relationships" id="276" r:id="R33a2ba1ea79748f4"/>
-    <p:sldId xmlns:r="http://schemas.openxmlformats.org/officeDocument/2006/relationships" id="277" r:id="R6c26951d183d4543"/>
+    <p:sldId xmlns:r="http://schemas.openxmlformats.org/officeDocument/2006/relationships" id="256" r:id="R3d6d1a3f25004809"/>
+    <p:sldId xmlns:r="http://schemas.openxmlformats.org/officeDocument/2006/relationships" id="257" r:id="Rbcef86a7b90449a7"/>
+    <p:sldId xmlns:r="http://schemas.openxmlformats.org/officeDocument/2006/relationships" id="258" r:id="R9c23a4e4c2ea4d48"/>
+    <p:sldId xmlns:r="http://schemas.openxmlformats.org/officeDocument/2006/relationships" id="259" r:id="Rda2c94cf675a4236"/>
+    <p:sldId xmlns:r="http://schemas.openxmlformats.org/officeDocument/2006/relationships" id="260" r:id="R85545c0d381a4eb4"/>
+    <p:sldId xmlns:r="http://schemas.openxmlformats.org/officeDocument/2006/relationships" id="261" r:id="Rba5d354a0be548f9"/>
+    <p:sldId xmlns:r="http://schemas.openxmlformats.org/officeDocument/2006/relationships" id="262" r:id="R38b7c07771b34042"/>
+    <p:sldId xmlns:r="http://schemas.openxmlformats.org/officeDocument/2006/relationships" id="263" r:id="R7d13729fa85e4bd8"/>
+    <p:sldId xmlns:r="http://schemas.openxmlformats.org/officeDocument/2006/relationships" id="264" r:id="R5d3e5a81770a436d"/>
+    <p:sldId xmlns:r="http://schemas.openxmlformats.org/officeDocument/2006/relationships" id="265" r:id="R238bd042b9d94eb1"/>
+    <p:sldId xmlns:r="http://schemas.openxmlformats.org/officeDocument/2006/relationships" id="266" r:id="R91b39da2ecd744e9"/>
+    <p:sldId xmlns:r="http://schemas.openxmlformats.org/officeDocument/2006/relationships" id="267" r:id="R7cafb154789e481a"/>
+    <p:sldId xmlns:r="http://schemas.openxmlformats.org/officeDocument/2006/relationships" id="268" r:id="R69754fc845fe4c2b"/>
+    <p:sldId xmlns:r="http://schemas.openxmlformats.org/officeDocument/2006/relationships" id="269" r:id="Rce5eda3158204eee"/>
+    <p:sldId xmlns:r="http://schemas.openxmlformats.org/officeDocument/2006/relationships" id="270" r:id="R9b3e4b14be214fe7"/>
+    <p:sldId xmlns:r="http://schemas.openxmlformats.org/officeDocument/2006/relationships" id="271" r:id="R026fba3bb06b47c0"/>
+    <p:sldId xmlns:r="http://schemas.openxmlformats.org/officeDocument/2006/relationships" id="272" r:id="Rda4343208e7f4861"/>
+    <p:sldId xmlns:r="http://schemas.openxmlformats.org/officeDocument/2006/relationships" id="273" r:id="R3f3921dde19e419f"/>
+    <p:sldId xmlns:r="http://schemas.openxmlformats.org/officeDocument/2006/relationships" id="274" r:id="R78bdbf2c98774503"/>
+    <p:sldId xmlns:r="http://schemas.openxmlformats.org/officeDocument/2006/relationships" id="275" r:id="R71f9b9aa0fe44ab7"/>
+    <p:sldId xmlns:r="http://schemas.openxmlformats.org/officeDocument/2006/relationships" id="276" r:id="R9f8199efcd254619"/>
+    <p:sldId xmlns:r="http://schemas.openxmlformats.org/officeDocument/2006/relationships" id="277" r:id="Rbddbf31f2578428c"/>
   </p:sldIdLst>
   <p:sldSz cx="12192000" cy="6858000"/>
   <p:notesSz cx="6858000" cy="9144000"/>
@@ -2008,7 +2008,7 @@
   </p:cSld>
   <p:clrMap bg1="lt1" tx1="dk1" bg2="lt2" tx2="dk2" accent1="accent1" accent2="accent2" accent3="accent3" accent4="accent4" accent5="accent5" accent6="accent6" hlink="hlink" folHlink="folHlink"/>
   <p:sldLayoutIdLst>
-    <p:sldLayoutId xmlns:r="http://schemas.openxmlformats.org/officeDocument/2006/relationships" id="2147483649" r:id="R8785448dbf8949e0"/>
+    <p:sldLayoutId xmlns:r="http://schemas.openxmlformats.org/officeDocument/2006/relationships" id="2147483649" r:id="Rc44680824878465e"/>
   </p:sldLayoutIdLst>
   <p:txStyles>
     <p:titleStyle>
@@ -2559,7 +2559,7 @@
           <p:cNvPr id="1" name="">
             <a:extLst xmlns:a="http://schemas.openxmlformats.org/drawingml/2006/main">
               <a:ext uri="{FF2B5EF4-FFF2-40B4-BE49-F238E27FC236}">
-                <a16:creationId xmlns:a16="http://schemas.microsoft.com/office/drawing/2014/main" id="{30904C86-053C-4BEA-AD8C-7CEA2B684DFD}"/>
+                <a16:creationId xmlns:a16="http://schemas.microsoft.com/office/drawing/2014/main" id="{26945D80-AD52-4EDA-AD85-248C46751852}"/>
               </a:ext>
             </a:extLst>
           </p:cNvPr>
@@ -2590,7 +2590,7 @@
           <p:cNvPr id="2" name="">
             <a:extLst xmlns:a="http://schemas.openxmlformats.org/drawingml/2006/main">
               <a:ext uri="{FF2B5EF4-FFF2-40B4-BE49-F238E27FC236}">
-                <a16:creationId xmlns:a16="http://schemas.microsoft.com/office/drawing/2014/main" id="{B56827E3-1096-45DA-AB56-9AFABB85365D}"/>
+                <a16:creationId xmlns:a16="http://schemas.microsoft.com/office/drawing/2014/main" id="{0C0939F2-E6F4-4709-A56A-A9DAADFF64F3}"/>
               </a:ext>
             </a:extLst>
           </p:cNvPr>
@@ -2622,7 +2622,7 @@
           <p:nvPr/>
         </p:nvPicPr>
         <p:blipFill>
-          <a:blip xmlns:r="http://schemas.openxmlformats.org/officeDocument/2006/relationships" xmlns:a="http://schemas.openxmlformats.org/drawingml/2006/main" r:embed="R046bae8b981c434a"/>
+          <a:blip xmlns:r="http://schemas.openxmlformats.org/officeDocument/2006/relationships" xmlns:a="http://schemas.openxmlformats.org/drawingml/2006/main" r:embed="R65ef781e0c344e52"/>
           <a:stretch xmlns:a="http://schemas.openxmlformats.org/drawingml/2006/main"/>
         </p:blipFill>
         <p:spPr>
@@ -2640,7 +2640,7 @@
           <p:cNvPr id="4" name="">
             <a:extLst xmlns:a="http://schemas.openxmlformats.org/drawingml/2006/main">
               <a:ext uri="{FF2B5EF4-FFF2-40B4-BE49-F238E27FC236}">
-                <a16:creationId xmlns:a16="http://schemas.microsoft.com/office/drawing/2014/main" id="{E0DE7500-01CC-4C7B-9DFF-D127BAA7D3D2}"/>
+                <a16:creationId xmlns:a16="http://schemas.microsoft.com/office/drawing/2014/main" id="{22E42ABC-F47A-4DAB-8222-060164C20519}"/>
               </a:ext>
             </a:extLst>
           </p:cNvPr>
@@ -2690,7 +2690,7 @@
           <p:cNvPr id="5" name="">
             <a:extLst xmlns:a="http://schemas.openxmlformats.org/drawingml/2006/main">
               <a:ext uri="{FF2B5EF4-FFF2-40B4-BE49-F238E27FC236}">
-                <a16:creationId xmlns:a16="http://schemas.microsoft.com/office/drawing/2014/main" id="{BF2E30B5-C811-481F-B20F-45FBCC4FF30C}"/>
+                <a16:creationId xmlns:a16="http://schemas.microsoft.com/office/drawing/2014/main" id="{2F053C32-A51A-4BE5-A4D6-4CC987D7135A}"/>
               </a:ext>
             </a:extLst>
           </p:cNvPr>
@@ -2740,7 +2740,7 @@
           <p:cNvPr id="6" name="">
             <a:extLst xmlns:a="http://schemas.openxmlformats.org/drawingml/2006/main">
               <a:ext uri="{FF2B5EF4-FFF2-40B4-BE49-F238E27FC236}">
-                <a16:creationId xmlns:a16="http://schemas.microsoft.com/office/drawing/2014/main" id="{3005D6E0-BA00-44EE-99F4-297F6DEF9DC6}"/>
+                <a16:creationId xmlns:a16="http://schemas.microsoft.com/office/drawing/2014/main" id="{CDAA3A7D-43C3-40C6-B13C-4C24103A0C9D}"/>
               </a:ext>
             </a:extLst>
           </p:cNvPr>
@@ -2790,7 +2790,7 @@
           <p:cNvPr id="7" name="">
             <a:extLst xmlns:a="http://schemas.openxmlformats.org/drawingml/2006/main">
               <a:ext uri="{FF2B5EF4-FFF2-40B4-BE49-F238E27FC236}">
-                <a16:creationId xmlns:a16="http://schemas.microsoft.com/office/drawing/2014/main" id="{846AACAA-CD92-4F82-AC27-D934EE3C3066}"/>
+                <a16:creationId xmlns:a16="http://schemas.microsoft.com/office/drawing/2014/main" id="{86D90310-96B8-4282-B887-84A1649F801D}"/>
               </a:ext>
             </a:extLst>
           </p:cNvPr>
@@ -2840,7 +2840,7 @@
           <p:cNvPr id="8" name="">
             <a:extLst xmlns:a="http://schemas.openxmlformats.org/drawingml/2006/main">
               <a:ext uri="{FF2B5EF4-FFF2-40B4-BE49-F238E27FC236}">
-                <a16:creationId xmlns:a16="http://schemas.microsoft.com/office/drawing/2014/main" id="{2CB99338-A34F-4C24-93A9-40123644885E}"/>
+                <a16:creationId xmlns:a16="http://schemas.microsoft.com/office/drawing/2014/main" id="{758AD6BB-C42E-4F83-B4A7-AB429304CD02}"/>
               </a:ext>
             </a:extLst>
           </p:cNvPr>
@@ -2871,7 +2871,7 @@
           <p:cNvPr id="9" name="">
             <a:extLst xmlns:a="http://schemas.openxmlformats.org/drawingml/2006/main">
               <a:ext uri="{FF2B5EF4-FFF2-40B4-BE49-F238E27FC236}">
-                <a16:creationId xmlns:a16="http://schemas.microsoft.com/office/drawing/2014/main" id="{2A2BFF39-C068-4091-B613-94282D0DB002}"/>
+                <a16:creationId xmlns:a16="http://schemas.microsoft.com/office/drawing/2014/main" id="{FCC7D749-C42D-45BD-9628-E676CC1EE1C2}"/>
               </a:ext>
             </a:extLst>
           </p:cNvPr>
@@ -2902,7 +2902,7 @@
           <p:cNvPr id="10" name="">
             <a:extLst xmlns:a="http://schemas.openxmlformats.org/drawingml/2006/main">
               <a:ext uri="{FF2B5EF4-FFF2-40B4-BE49-F238E27FC236}">
-                <a16:creationId xmlns:a16="http://schemas.microsoft.com/office/drawing/2014/main" id="{63112500-C894-4ED2-8B82-E76EF8672EB5}"/>
+                <a16:creationId xmlns:a16="http://schemas.microsoft.com/office/drawing/2014/main" id="{B746D5B8-4922-4001-A576-CD628CAA0D73}"/>
               </a:ext>
             </a:extLst>
           </p:cNvPr>
@@ -2984,7 +2984,7 @@
     </p:spTree>
     <p:extLst>
       <p:ext uri="{BB962C8B-B14F-4D97-AF65-F5344CB8AC3E}">
-        <p14:creationId xmlns:p14="http://schemas.microsoft.com/office/powerpoint/2010/main" val="286783506"/>
+        <p14:creationId xmlns:p14="http://schemas.microsoft.com/office/powerpoint/2010/main" val="897071804"/>
       </p:ext>
     </p:extLst>
   </p:cSld>
@@ -3015,7 +3015,7 @@
           <p:cNvPr id="1" name="">
             <a:extLst xmlns:a="http://schemas.openxmlformats.org/drawingml/2006/main">
               <a:ext uri="{FF2B5EF4-FFF2-40B4-BE49-F238E27FC236}">
-                <a16:creationId xmlns:a16="http://schemas.microsoft.com/office/drawing/2014/main" id="{7E6020A9-3931-419B-A25E-8F16B62ADAC2}"/>
+                <a16:creationId xmlns:a16="http://schemas.microsoft.com/office/drawing/2014/main" id="{C1E5D00E-F002-46F2-9941-F3836A585D06}"/>
               </a:ext>
             </a:extLst>
           </p:cNvPr>
@@ -3046,7 +3046,7 @@
           <p:cNvPr id="2" name="">
             <a:extLst xmlns:a="http://schemas.openxmlformats.org/drawingml/2006/main">
               <a:ext uri="{FF2B5EF4-FFF2-40B4-BE49-F238E27FC236}">
-                <a16:creationId xmlns:a16="http://schemas.microsoft.com/office/drawing/2014/main" id="{26FA160A-4598-47AD-ABBC-E59BCCCD8B66}"/>
+                <a16:creationId xmlns:a16="http://schemas.microsoft.com/office/drawing/2014/main" id="{13E2B98C-0A79-44AA-A1E8-687802246B09}"/>
               </a:ext>
             </a:extLst>
           </p:cNvPr>
@@ -3096,7 +3096,7 @@
           <p:cNvPr id="3" name="">
             <a:extLst xmlns:a="http://schemas.openxmlformats.org/drawingml/2006/main">
               <a:ext uri="{FF2B5EF4-FFF2-40B4-BE49-F238E27FC236}">
-                <a16:creationId xmlns:a16="http://schemas.microsoft.com/office/drawing/2014/main" id="{5032FC88-C56F-4D85-9F38-26DE3D2D54BB}"/>
+                <a16:creationId xmlns:a16="http://schemas.microsoft.com/office/drawing/2014/main" id="{9C01D443-9909-4B76-A4C5-3CAC9D358DAB}"/>
               </a:ext>
             </a:extLst>
           </p:cNvPr>
@@ -3146,7 +3146,7 @@
           <p:cNvPr id="4" name="">
             <a:extLst xmlns:a="http://schemas.openxmlformats.org/drawingml/2006/main">
               <a:ext uri="{FF2B5EF4-FFF2-40B4-BE49-F238E27FC236}">
-                <a16:creationId xmlns:a16="http://schemas.microsoft.com/office/drawing/2014/main" id="{AC216CB5-C1E5-41B7-BD12-91085249C29A}"/>
+                <a16:creationId xmlns:a16="http://schemas.microsoft.com/office/drawing/2014/main" id="{1DD42378-02CD-4AD7-8477-5E28FB228A66}"/>
               </a:ext>
             </a:extLst>
           </p:cNvPr>
@@ -3196,7 +3196,7 @@
           <p:cNvPr id="5" name="">
             <a:extLst xmlns:a="http://schemas.openxmlformats.org/drawingml/2006/main">
               <a:ext uri="{FF2B5EF4-FFF2-40B4-BE49-F238E27FC236}">
-                <a16:creationId xmlns:a16="http://schemas.microsoft.com/office/drawing/2014/main" id="{FBC69E98-B3A2-4ABB-B43E-0516CD5D76EA}"/>
+                <a16:creationId xmlns:a16="http://schemas.microsoft.com/office/drawing/2014/main" id="{34B627EF-E4B0-44D1-AB96-DD2FAD7C97F5}"/>
               </a:ext>
             </a:extLst>
           </p:cNvPr>
@@ -3227,7 +3227,7 @@
           <p:cNvPr id="6" name="">
             <a:extLst xmlns:a="http://schemas.openxmlformats.org/drawingml/2006/main">
               <a:ext uri="{FF2B5EF4-FFF2-40B4-BE49-F238E27FC236}">
-                <a16:creationId xmlns:a16="http://schemas.microsoft.com/office/drawing/2014/main" id="{B1AC2A6D-C7F0-4C38-B753-7C1809E1BCA1}"/>
+                <a16:creationId xmlns:a16="http://schemas.microsoft.com/office/drawing/2014/main" id="{364030EF-11CB-44D2-9526-E4366A4E5C1D}"/>
               </a:ext>
             </a:extLst>
           </p:cNvPr>
@@ -3277,7 +3277,7 @@
           <p:cNvPr id="7" name="">
             <a:extLst xmlns:a="http://schemas.openxmlformats.org/drawingml/2006/main">
               <a:ext uri="{FF2B5EF4-FFF2-40B4-BE49-F238E27FC236}">
-                <a16:creationId xmlns:a16="http://schemas.microsoft.com/office/drawing/2014/main" id="{70EB7FF3-A5B5-489D-B876-35DCA3933A5E}"/>
+                <a16:creationId xmlns:a16="http://schemas.microsoft.com/office/drawing/2014/main" id="{0D07A43B-0AF6-44E8-B066-24CB7D663575}"/>
               </a:ext>
             </a:extLst>
           </p:cNvPr>
@@ -3327,7 +3327,7 @@
           <p:cNvPr id="8" name="">
             <a:extLst xmlns:a="http://schemas.openxmlformats.org/drawingml/2006/main">
               <a:ext uri="{FF2B5EF4-FFF2-40B4-BE49-F238E27FC236}">
-                <a16:creationId xmlns:a16="http://schemas.microsoft.com/office/drawing/2014/main" id="{C615E4A1-AA95-4E98-A1C5-EC2CEBA92470}"/>
+                <a16:creationId xmlns:a16="http://schemas.microsoft.com/office/drawing/2014/main" id="{BDE59677-3438-48C1-B041-B4314C064E46}"/>
               </a:ext>
             </a:extLst>
           </p:cNvPr>
@@ -3358,7 +3358,7 @@
           <p:cNvPr id="9" name="">
             <a:extLst xmlns:a="http://schemas.openxmlformats.org/drawingml/2006/main">
               <a:ext uri="{FF2B5EF4-FFF2-40B4-BE49-F238E27FC236}">
-                <a16:creationId xmlns:a16="http://schemas.microsoft.com/office/drawing/2014/main" id="{823147AE-432A-4C16-8229-7F5537B41D91}"/>
+                <a16:creationId xmlns:a16="http://schemas.microsoft.com/office/drawing/2014/main" id="{F9910145-04DD-43B9-B983-B95B8918CDA6}"/>
               </a:ext>
             </a:extLst>
           </p:cNvPr>
@@ -3408,7 +3408,7 @@
           <p:cNvPr id="10" name="">
             <a:extLst xmlns:a="http://schemas.openxmlformats.org/drawingml/2006/main">
               <a:ext uri="{FF2B5EF4-FFF2-40B4-BE49-F238E27FC236}">
-                <a16:creationId xmlns:a16="http://schemas.microsoft.com/office/drawing/2014/main" id="{E3C6F979-3C24-4B0F-A219-09D98D713482}"/>
+                <a16:creationId xmlns:a16="http://schemas.microsoft.com/office/drawing/2014/main" id="{4FC80BF4-613C-4E13-B7D6-F8F8AFD5CF00}"/>
               </a:ext>
             </a:extLst>
           </p:cNvPr>
@@ -3458,7 +3458,7 @@
           <p:cNvPr id="11" name="">
             <a:extLst xmlns:a="http://schemas.openxmlformats.org/drawingml/2006/main">
               <a:ext uri="{FF2B5EF4-FFF2-40B4-BE49-F238E27FC236}">
-                <a16:creationId xmlns:a16="http://schemas.microsoft.com/office/drawing/2014/main" id="{03808D22-6BE4-436D-B594-83BEA51EB8A7}"/>
+                <a16:creationId xmlns:a16="http://schemas.microsoft.com/office/drawing/2014/main" id="{EC2A2A9F-F2A8-40E1-8DFB-D2CBD940F37F}"/>
               </a:ext>
             </a:extLst>
           </p:cNvPr>
@@ -3489,7 +3489,7 @@
           <p:cNvPr id="12" name="">
             <a:extLst xmlns:a="http://schemas.openxmlformats.org/drawingml/2006/main">
               <a:ext uri="{FF2B5EF4-FFF2-40B4-BE49-F238E27FC236}">
-                <a16:creationId xmlns:a16="http://schemas.microsoft.com/office/drawing/2014/main" id="{EEBC2D82-11CB-47DE-8F1B-E3DCB540CE13}"/>
+                <a16:creationId xmlns:a16="http://schemas.microsoft.com/office/drawing/2014/main" id="{3C4C7B31-A371-48AC-844B-A74AC33CC618}"/>
               </a:ext>
             </a:extLst>
           </p:cNvPr>
@@ -3539,7 +3539,7 @@
           <p:cNvPr id="13" name="">
             <a:extLst xmlns:a="http://schemas.openxmlformats.org/drawingml/2006/main">
               <a:ext uri="{FF2B5EF4-FFF2-40B4-BE49-F238E27FC236}">
-                <a16:creationId xmlns:a16="http://schemas.microsoft.com/office/drawing/2014/main" id="{C6BB0CA0-0241-4633-BF88-D4AFC9E7EB42}"/>
+                <a16:creationId xmlns:a16="http://schemas.microsoft.com/office/drawing/2014/main" id="{E1A9A01B-93D0-4642-9B99-AD0FD4D61BEC}"/>
               </a:ext>
             </a:extLst>
           </p:cNvPr>
@@ -3589,7 +3589,7 @@
           <p:cNvPr id="14" name="">
             <a:extLst xmlns:a="http://schemas.openxmlformats.org/drawingml/2006/main">
               <a:ext uri="{FF2B5EF4-FFF2-40B4-BE49-F238E27FC236}">
-                <a16:creationId xmlns:a16="http://schemas.microsoft.com/office/drawing/2014/main" id="{9ABAADCF-2612-4AF8-B739-460BE200A118}"/>
+                <a16:creationId xmlns:a16="http://schemas.microsoft.com/office/drawing/2014/main" id="{9FA7F86E-7974-40D5-BDCD-3D69B2F956C0}"/>
               </a:ext>
             </a:extLst>
           </p:cNvPr>
@@ -3620,7 +3620,7 @@
           <p:cNvPr id="15" name="">
             <a:extLst xmlns:a="http://schemas.openxmlformats.org/drawingml/2006/main">
               <a:ext uri="{FF2B5EF4-FFF2-40B4-BE49-F238E27FC236}">
-                <a16:creationId xmlns:a16="http://schemas.microsoft.com/office/drawing/2014/main" id="{8C2A015E-B367-4562-B26F-D5154F8BEFE4}"/>
+                <a16:creationId xmlns:a16="http://schemas.microsoft.com/office/drawing/2014/main" id="{0631A388-619F-4D3E-96D3-43B6E352086C}"/>
               </a:ext>
             </a:extLst>
           </p:cNvPr>
@@ -3670,7 +3670,7 @@
           <p:cNvPr id="16" name="">
             <a:extLst xmlns:a="http://schemas.openxmlformats.org/drawingml/2006/main">
               <a:ext uri="{FF2B5EF4-FFF2-40B4-BE49-F238E27FC236}">
-                <a16:creationId xmlns:a16="http://schemas.microsoft.com/office/drawing/2014/main" id="{192C075F-0B5F-4911-A2AD-C2C1C01F41EF}"/>
+                <a16:creationId xmlns:a16="http://schemas.microsoft.com/office/drawing/2014/main" id="{C54D1505-74BB-43AA-B536-B86900F68906}"/>
               </a:ext>
             </a:extLst>
           </p:cNvPr>
@@ -3705,7 +3705,7 @@
           <p:nvPr/>
         </p:nvPicPr>
         <p:blipFill>
-          <a:blip xmlns:r="http://schemas.openxmlformats.org/officeDocument/2006/relationships" xmlns:a="http://schemas.openxmlformats.org/drawingml/2006/main" r:embed="R0f337912783b4389"/>
+          <a:blip xmlns:r="http://schemas.openxmlformats.org/officeDocument/2006/relationships" xmlns:a="http://schemas.openxmlformats.org/drawingml/2006/main" r:embed="R6e4b073dcc3b44c2"/>
           <a:stretch xmlns:a="http://schemas.openxmlformats.org/drawingml/2006/main"/>
         </p:blipFill>
         <p:spPr>
@@ -3723,7 +3723,7 @@
           <p:cNvPr id="18" name="">
             <a:extLst xmlns:a="http://schemas.openxmlformats.org/drawingml/2006/main">
               <a:ext uri="{FF2B5EF4-FFF2-40B4-BE49-F238E27FC236}">
-                <a16:creationId xmlns:a16="http://schemas.microsoft.com/office/drawing/2014/main" id="{91BF5E08-1B74-4F0F-A783-48BEFD3C6B62}"/>
+                <a16:creationId xmlns:a16="http://schemas.microsoft.com/office/drawing/2014/main" id="{6637EB1E-5BFF-4403-8F8B-20417E554DA3}"/>
               </a:ext>
             </a:extLst>
           </p:cNvPr>
@@ -3773,7 +3773,7 @@
           <p:cNvPr id="19" name="">
             <a:extLst xmlns:a="http://schemas.openxmlformats.org/drawingml/2006/main">
               <a:ext uri="{FF2B5EF4-FFF2-40B4-BE49-F238E27FC236}">
-                <a16:creationId xmlns:a16="http://schemas.microsoft.com/office/drawing/2014/main" id="{D7654AB1-4DF7-4B1F-B804-8EB89B6DFD86}"/>
+                <a16:creationId xmlns:a16="http://schemas.microsoft.com/office/drawing/2014/main" id="{A489B0F2-A241-402E-BF4B-6B3CCC82E8D2}"/>
               </a:ext>
             </a:extLst>
           </p:cNvPr>
@@ -3821,7 +3821,7 @@
     </p:spTree>
     <p:extLst>
       <p:ext uri="{BB962C8B-B14F-4D97-AF65-F5344CB8AC3E}">
-        <p14:creationId xmlns:p14="http://schemas.microsoft.com/office/powerpoint/2010/main" val="298446023"/>
+        <p14:creationId xmlns:p14="http://schemas.microsoft.com/office/powerpoint/2010/main" val="642575013"/>
       </p:ext>
     </p:extLst>
   </p:cSld>
@@ -3852,7 +3852,7 @@
           <p:cNvPr id="1" name="">
             <a:extLst xmlns:a="http://schemas.openxmlformats.org/drawingml/2006/main">
               <a:ext uri="{FF2B5EF4-FFF2-40B4-BE49-F238E27FC236}">
-                <a16:creationId xmlns:a16="http://schemas.microsoft.com/office/drawing/2014/main" id="{33769626-CD35-443C-AE81-57ADF4911907}"/>
+                <a16:creationId xmlns:a16="http://schemas.microsoft.com/office/drawing/2014/main" id="{3F98ACDD-2517-44B4-94CA-928EF73DBC0B}"/>
               </a:ext>
             </a:extLst>
           </p:cNvPr>
@@ -3883,7 +3883,7 @@
           <p:cNvPr id="2" name="">
             <a:extLst xmlns:a="http://schemas.openxmlformats.org/drawingml/2006/main">
               <a:ext uri="{FF2B5EF4-FFF2-40B4-BE49-F238E27FC236}">
-                <a16:creationId xmlns:a16="http://schemas.microsoft.com/office/drawing/2014/main" id="{05F5ACD1-086B-4B17-AF01-957A1BC2BB1F}"/>
+                <a16:creationId xmlns:a16="http://schemas.microsoft.com/office/drawing/2014/main" id="{D2A70E16-D106-4250-B016-CF14A32C0EA0}"/>
               </a:ext>
             </a:extLst>
           </p:cNvPr>
@@ -3933,7 +3933,7 @@
           <p:cNvPr id="3" name="">
             <a:extLst xmlns:a="http://schemas.openxmlformats.org/drawingml/2006/main">
               <a:ext uri="{FF2B5EF4-FFF2-40B4-BE49-F238E27FC236}">
-                <a16:creationId xmlns:a16="http://schemas.microsoft.com/office/drawing/2014/main" id="{82DF708B-C63D-4782-90BE-6F7C2AD92A81}"/>
+                <a16:creationId xmlns:a16="http://schemas.microsoft.com/office/drawing/2014/main" id="{3D8D5378-8A3B-4655-B23C-88C779E89159}"/>
               </a:ext>
             </a:extLst>
           </p:cNvPr>
@@ -3983,7 +3983,7 @@
           <p:cNvPr id="4" name="">
             <a:extLst xmlns:a="http://schemas.openxmlformats.org/drawingml/2006/main">
               <a:ext uri="{FF2B5EF4-FFF2-40B4-BE49-F238E27FC236}">
-                <a16:creationId xmlns:a16="http://schemas.microsoft.com/office/drawing/2014/main" id="{1FA8B9C2-B664-47A0-9073-6464B06FB543}"/>
+                <a16:creationId xmlns:a16="http://schemas.microsoft.com/office/drawing/2014/main" id="{9B7D7C15-52B9-4BD7-BA40-3B2B6183D25A}"/>
               </a:ext>
             </a:extLst>
           </p:cNvPr>
@@ -4018,7 +4018,7 @@
           <p:cNvPr id="5" name="">
             <a:extLst xmlns:a="http://schemas.openxmlformats.org/drawingml/2006/main">
               <a:ext uri="{FF2B5EF4-FFF2-40B4-BE49-F238E27FC236}">
-                <a16:creationId xmlns:a16="http://schemas.microsoft.com/office/drawing/2014/main" id="{5BB9B69E-D455-4A44-AB9C-0CEB03918CB6}"/>
+                <a16:creationId xmlns:a16="http://schemas.microsoft.com/office/drawing/2014/main" id="{143AECD7-B713-4D9E-8A47-78045BBD11D6}"/>
               </a:ext>
             </a:extLst>
           </p:cNvPr>
@@ -4068,7 +4068,7 @@
           <p:cNvPr id="6" name="">
             <a:extLst xmlns:a="http://schemas.openxmlformats.org/drawingml/2006/main">
               <a:ext uri="{FF2B5EF4-FFF2-40B4-BE49-F238E27FC236}">
-                <a16:creationId xmlns:a16="http://schemas.microsoft.com/office/drawing/2014/main" id="{4729A380-02B3-4C71-965B-32445972A632}"/>
+                <a16:creationId xmlns:a16="http://schemas.microsoft.com/office/drawing/2014/main" id="{573CD14B-C22D-4D59-BE50-E62CB2CAC563}"/>
               </a:ext>
             </a:extLst>
           </p:cNvPr>
@@ -4152,7 +4152,7 @@
           <p:cNvPr id="7" name="">
             <a:extLst xmlns:a="http://schemas.openxmlformats.org/drawingml/2006/main">
               <a:ext uri="{FF2B5EF4-FFF2-40B4-BE49-F238E27FC236}">
-                <a16:creationId xmlns:a16="http://schemas.microsoft.com/office/drawing/2014/main" id="{E02764D6-8326-4B29-A6EC-D460215CD199}"/>
+                <a16:creationId xmlns:a16="http://schemas.microsoft.com/office/drawing/2014/main" id="{8FC9F303-20A4-44D2-97FC-75B68CDE16BB}"/>
               </a:ext>
             </a:extLst>
           </p:cNvPr>
@@ -4187,7 +4187,7 @@
           <p:cNvPr id="8" name="">
             <a:extLst xmlns:a="http://schemas.openxmlformats.org/drawingml/2006/main">
               <a:ext uri="{FF2B5EF4-FFF2-40B4-BE49-F238E27FC236}">
-                <a16:creationId xmlns:a16="http://schemas.microsoft.com/office/drawing/2014/main" id="{7224B3F9-D8BB-4A86-84A3-C8AD19410EB5}"/>
+                <a16:creationId xmlns:a16="http://schemas.microsoft.com/office/drawing/2014/main" id="{090E2F85-46DE-492F-889D-3704F325C522}"/>
               </a:ext>
             </a:extLst>
           </p:cNvPr>
@@ -4237,7 +4237,7 @@
           <p:cNvPr id="9" name="">
             <a:extLst xmlns:a="http://schemas.openxmlformats.org/drawingml/2006/main">
               <a:ext uri="{FF2B5EF4-FFF2-40B4-BE49-F238E27FC236}">
-                <a16:creationId xmlns:a16="http://schemas.microsoft.com/office/drawing/2014/main" id="{B890969E-62BE-49E4-801B-2D794D9CB619}"/>
+                <a16:creationId xmlns:a16="http://schemas.microsoft.com/office/drawing/2014/main" id="{A1DA676B-4DB6-4365-ADF1-40D6234AEA4E}"/>
               </a:ext>
             </a:extLst>
           </p:cNvPr>
@@ -4321,7 +4321,7 @@
           <p:cNvPr id="10" name="">
             <a:extLst xmlns:a="http://schemas.openxmlformats.org/drawingml/2006/main">
               <a:ext uri="{FF2B5EF4-FFF2-40B4-BE49-F238E27FC236}">
-                <a16:creationId xmlns:a16="http://schemas.microsoft.com/office/drawing/2014/main" id="{A6345EDC-774F-42D3-A238-C71D213753B4}"/>
+                <a16:creationId xmlns:a16="http://schemas.microsoft.com/office/drawing/2014/main" id="{B91C5FDF-A4F5-4CA7-83D6-8673F8888471}"/>
               </a:ext>
             </a:extLst>
           </p:cNvPr>
@@ -4356,7 +4356,7 @@
           <p:cNvPr id="11" name="">
             <a:extLst xmlns:a="http://schemas.openxmlformats.org/drawingml/2006/main">
               <a:ext uri="{FF2B5EF4-FFF2-40B4-BE49-F238E27FC236}">
-                <a16:creationId xmlns:a16="http://schemas.microsoft.com/office/drawing/2014/main" id="{A3478809-BE71-4EB5-8B94-B4F6EAA7A747}"/>
+                <a16:creationId xmlns:a16="http://schemas.microsoft.com/office/drawing/2014/main" id="{D3A5B309-710A-4980-B355-69EECA303FE5}"/>
               </a:ext>
             </a:extLst>
           </p:cNvPr>
@@ -4406,7 +4406,7 @@
           <p:cNvPr id="12" name="">
             <a:extLst xmlns:a="http://schemas.openxmlformats.org/drawingml/2006/main">
               <a:ext uri="{FF2B5EF4-FFF2-40B4-BE49-F238E27FC236}">
-                <a16:creationId xmlns:a16="http://schemas.microsoft.com/office/drawing/2014/main" id="{0870C2F0-A417-4B17-AE03-9356FEC27E5C}"/>
+                <a16:creationId xmlns:a16="http://schemas.microsoft.com/office/drawing/2014/main" id="{2ABE91EB-DB87-44E2-9111-0CD06266F455}"/>
               </a:ext>
             </a:extLst>
           </p:cNvPr>
@@ -4480,7 +4480,7 @@
                   <a:srgbClr val="1F2933"/>
                 </a:solidFill>
               </a:rPr>
-              <a:t>创建 app-local venv 后运行 baicode.exe</a:t>
+              <a:t>在用户数据目录创建 venv 后运行 baicode.exe</a:t>
             </a:r>
           </a:p>
         </p:txBody>
@@ -4490,7 +4490,7 @@
           <p:cNvPr id="13" name="">
             <a:extLst xmlns:a="http://schemas.openxmlformats.org/drawingml/2006/main">
               <a:ext uri="{FF2B5EF4-FFF2-40B4-BE49-F238E27FC236}">
-                <a16:creationId xmlns:a16="http://schemas.microsoft.com/office/drawing/2014/main" id="{CE32A0D5-0F19-442D-8592-BC604E2F99FD}"/>
+                <a16:creationId xmlns:a16="http://schemas.microsoft.com/office/drawing/2014/main" id="{9FDBA9AA-C3E5-4D33-B70E-3C5930150D2D}"/>
               </a:ext>
             </a:extLst>
           </p:cNvPr>
@@ -4525,7 +4525,7 @@
           <p:nvPr/>
         </p:nvPicPr>
         <p:blipFill>
-          <a:blip xmlns:r="http://schemas.openxmlformats.org/officeDocument/2006/relationships" xmlns:a="http://schemas.openxmlformats.org/drawingml/2006/main" r:embed="Ra7c75caea2f8450b"/>
+          <a:blip xmlns:r="http://schemas.openxmlformats.org/officeDocument/2006/relationships" xmlns:a="http://schemas.openxmlformats.org/drawingml/2006/main" r:embed="Rea1dbbd5747d432c"/>
           <a:stretch xmlns:a="http://schemas.openxmlformats.org/drawingml/2006/main"/>
         </p:blipFill>
         <p:spPr>
@@ -4543,7 +4543,7 @@
           <p:cNvPr id="15" name="">
             <a:extLst xmlns:a="http://schemas.openxmlformats.org/drawingml/2006/main">
               <a:ext uri="{FF2B5EF4-FFF2-40B4-BE49-F238E27FC236}">
-                <a16:creationId xmlns:a16="http://schemas.microsoft.com/office/drawing/2014/main" id="{BA650418-3975-4CFB-BC66-3EB41A86A043}"/>
+                <a16:creationId xmlns:a16="http://schemas.microsoft.com/office/drawing/2014/main" id="{6CD245BD-5D21-417F-88D6-92B2ABD87A4F}"/>
               </a:ext>
             </a:extLst>
           </p:cNvPr>
@@ -4593,7 +4593,7 @@
           <p:cNvPr id="16" name="">
             <a:extLst xmlns:a="http://schemas.openxmlformats.org/drawingml/2006/main">
               <a:ext uri="{FF2B5EF4-FFF2-40B4-BE49-F238E27FC236}">
-                <a16:creationId xmlns:a16="http://schemas.microsoft.com/office/drawing/2014/main" id="{03E71991-FDAA-4DF6-9665-D56037179E43}"/>
+                <a16:creationId xmlns:a16="http://schemas.microsoft.com/office/drawing/2014/main" id="{354EA8C1-EFCD-484F-9FFE-FF54D214C5D6}"/>
               </a:ext>
             </a:extLst>
           </p:cNvPr>
@@ -4641,7 +4641,7 @@
     </p:spTree>
     <p:extLst>
       <p:ext uri="{BB962C8B-B14F-4D97-AF65-F5344CB8AC3E}">
-        <p14:creationId xmlns:p14="http://schemas.microsoft.com/office/powerpoint/2010/main" val="421318551"/>
+        <p14:creationId xmlns:p14="http://schemas.microsoft.com/office/powerpoint/2010/main" val="1084015244"/>
       </p:ext>
     </p:extLst>
   </p:cSld>
@@ -4672,7 +4672,7 @@
           <p:cNvPr id="1" name="">
             <a:extLst xmlns:a="http://schemas.openxmlformats.org/drawingml/2006/main">
               <a:ext uri="{FF2B5EF4-FFF2-40B4-BE49-F238E27FC236}">
-                <a16:creationId xmlns:a16="http://schemas.microsoft.com/office/drawing/2014/main" id="{C1F6B969-E82D-47B2-89D6-7A4A587CD3E6}"/>
+                <a16:creationId xmlns:a16="http://schemas.microsoft.com/office/drawing/2014/main" id="{A5D27141-B6D1-43AA-9AD3-8353D3732023}"/>
               </a:ext>
             </a:extLst>
           </p:cNvPr>
@@ -4703,7 +4703,7 @@
           <p:cNvPr id="2" name="">
             <a:extLst xmlns:a="http://schemas.openxmlformats.org/drawingml/2006/main">
               <a:ext uri="{FF2B5EF4-FFF2-40B4-BE49-F238E27FC236}">
-                <a16:creationId xmlns:a16="http://schemas.microsoft.com/office/drawing/2014/main" id="{AC9C1C4B-6877-49A2-B53C-913D1447CD5D}"/>
+                <a16:creationId xmlns:a16="http://schemas.microsoft.com/office/drawing/2014/main" id="{122F8308-D5A3-4C60-B3DE-21F4E7367159}"/>
               </a:ext>
             </a:extLst>
           </p:cNvPr>
@@ -4753,7 +4753,7 @@
           <p:cNvPr id="3" name="">
             <a:extLst xmlns:a="http://schemas.openxmlformats.org/drawingml/2006/main">
               <a:ext uri="{FF2B5EF4-FFF2-40B4-BE49-F238E27FC236}">
-                <a16:creationId xmlns:a16="http://schemas.microsoft.com/office/drawing/2014/main" id="{8731C71D-12FC-422C-969E-2E22EE8E2FCC}"/>
+                <a16:creationId xmlns:a16="http://schemas.microsoft.com/office/drawing/2014/main" id="{859486F7-35BA-45BC-94C7-B782E619881C}"/>
               </a:ext>
             </a:extLst>
           </p:cNvPr>
@@ -4803,7 +4803,7 @@
           <p:cNvPr id="4" name="">
             <a:extLst xmlns:a="http://schemas.openxmlformats.org/drawingml/2006/main">
               <a:ext uri="{FF2B5EF4-FFF2-40B4-BE49-F238E27FC236}">
-                <a16:creationId xmlns:a16="http://schemas.microsoft.com/office/drawing/2014/main" id="{3FA2EE41-FA3B-4350-8D38-9006C7A39235}"/>
+                <a16:creationId xmlns:a16="http://schemas.microsoft.com/office/drawing/2014/main" id="{0F864AC3-A1F7-49E0-93EB-EAED9DFA3A8D}"/>
               </a:ext>
             </a:extLst>
           </p:cNvPr>
@@ -4853,7 +4853,7 @@
           <p:cNvPr id="5" name="">
             <a:extLst xmlns:a="http://schemas.openxmlformats.org/drawingml/2006/main">
               <a:ext uri="{FF2B5EF4-FFF2-40B4-BE49-F238E27FC236}">
-                <a16:creationId xmlns:a16="http://schemas.microsoft.com/office/drawing/2014/main" id="{2958FB26-A0A3-4E0F-B391-AE7E3171E8DD}"/>
+                <a16:creationId xmlns:a16="http://schemas.microsoft.com/office/drawing/2014/main" id="{2B49BC7B-34F4-49F2-94F6-48606DCF8FD4}"/>
               </a:ext>
             </a:extLst>
           </p:cNvPr>
@@ -4903,7 +4903,7 @@
           <p:cNvPr id="6" name="">
             <a:extLst xmlns:a="http://schemas.openxmlformats.org/drawingml/2006/main">
               <a:ext uri="{FF2B5EF4-FFF2-40B4-BE49-F238E27FC236}">
-                <a16:creationId xmlns:a16="http://schemas.microsoft.com/office/drawing/2014/main" id="{9AC7C8CA-B982-4E96-825E-E9234358C5C5}"/>
+                <a16:creationId xmlns:a16="http://schemas.microsoft.com/office/drawing/2014/main" id="{B0D82853-2E98-40E5-AE26-43A2465D80B9}"/>
               </a:ext>
             </a:extLst>
           </p:cNvPr>
@@ -4934,7 +4934,7 @@
           <p:cNvPr id="7" name="">
             <a:extLst xmlns:a="http://schemas.openxmlformats.org/drawingml/2006/main">
               <a:ext uri="{FF2B5EF4-FFF2-40B4-BE49-F238E27FC236}">
-                <a16:creationId xmlns:a16="http://schemas.microsoft.com/office/drawing/2014/main" id="{1617F8FC-3D30-4147-B4C2-ABA202B2DB17}"/>
+                <a16:creationId xmlns:a16="http://schemas.microsoft.com/office/drawing/2014/main" id="{DEC7DC43-77F9-4280-9C7A-AFF0580BE747}"/>
               </a:ext>
             </a:extLst>
           </p:cNvPr>
@@ -4984,7 +4984,7 @@
           <p:cNvPr id="8" name="">
             <a:extLst xmlns:a="http://schemas.openxmlformats.org/drawingml/2006/main">
               <a:ext uri="{FF2B5EF4-FFF2-40B4-BE49-F238E27FC236}">
-                <a16:creationId xmlns:a16="http://schemas.microsoft.com/office/drawing/2014/main" id="{06084849-7E8A-4291-BE86-826E3E4D808C}"/>
+                <a16:creationId xmlns:a16="http://schemas.microsoft.com/office/drawing/2014/main" id="{D0F9E5B2-C4D2-4416-A261-06253C2EA913}"/>
               </a:ext>
             </a:extLst>
           </p:cNvPr>
@@ -5015,7 +5015,7 @@
           <p:cNvPr id="9" name="">
             <a:extLst xmlns:a="http://schemas.openxmlformats.org/drawingml/2006/main">
               <a:ext uri="{FF2B5EF4-FFF2-40B4-BE49-F238E27FC236}">
-                <a16:creationId xmlns:a16="http://schemas.microsoft.com/office/drawing/2014/main" id="{CF772808-7CD6-49F0-B62C-442BFEF89D49}"/>
+                <a16:creationId xmlns:a16="http://schemas.microsoft.com/office/drawing/2014/main" id="{00A912C7-9747-4DC0-8909-C7D3426D5022}"/>
               </a:ext>
             </a:extLst>
           </p:cNvPr>
@@ -5065,7 +5065,7 @@
           <p:cNvPr id="10" name="">
             <a:extLst xmlns:a="http://schemas.openxmlformats.org/drawingml/2006/main">
               <a:ext uri="{FF2B5EF4-FFF2-40B4-BE49-F238E27FC236}">
-                <a16:creationId xmlns:a16="http://schemas.microsoft.com/office/drawing/2014/main" id="{CB4F9012-F111-4AF0-9C76-91DA00B2CC91}"/>
+                <a16:creationId xmlns:a16="http://schemas.microsoft.com/office/drawing/2014/main" id="{6BEDEB83-0274-4639-9C2C-8227719EFAF5}"/>
               </a:ext>
             </a:extLst>
           </p:cNvPr>
@@ -5096,7 +5096,7 @@
           <p:cNvPr id="11" name="">
             <a:extLst xmlns:a="http://schemas.openxmlformats.org/drawingml/2006/main">
               <a:ext uri="{FF2B5EF4-FFF2-40B4-BE49-F238E27FC236}">
-                <a16:creationId xmlns:a16="http://schemas.microsoft.com/office/drawing/2014/main" id="{B3075F1A-F2AB-4FE1-A66E-D7F28989B3F7}"/>
+                <a16:creationId xmlns:a16="http://schemas.microsoft.com/office/drawing/2014/main" id="{F8442765-4271-41C3-9217-9C12CD7E83A7}"/>
               </a:ext>
             </a:extLst>
           </p:cNvPr>
@@ -5146,7 +5146,7 @@
           <p:cNvPr id="12" name="">
             <a:extLst xmlns:a="http://schemas.openxmlformats.org/drawingml/2006/main">
               <a:ext uri="{FF2B5EF4-FFF2-40B4-BE49-F238E27FC236}">
-                <a16:creationId xmlns:a16="http://schemas.microsoft.com/office/drawing/2014/main" id="{8CBE0DC0-D5F9-4C93-8E65-D214B911E10A}"/>
+                <a16:creationId xmlns:a16="http://schemas.microsoft.com/office/drawing/2014/main" id="{22AA56CC-094E-4A99-B903-1AAFC6C4EA17}"/>
               </a:ext>
             </a:extLst>
           </p:cNvPr>
@@ -5177,7 +5177,7 @@
           <p:cNvPr id="13" name="">
             <a:extLst xmlns:a="http://schemas.openxmlformats.org/drawingml/2006/main">
               <a:ext uri="{FF2B5EF4-FFF2-40B4-BE49-F238E27FC236}">
-                <a16:creationId xmlns:a16="http://schemas.microsoft.com/office/drawing/2014/main" id="{2D504919-1153-4093-A550-50D454124696}"/>
+                <a16:creationId xmlns:a16="http://schemas.microsoft.com/office/drawing/2014/main" id="{161C382F-14DF-4ED8-A1F9-001D200FD0F2}"/>
               </a:ext>
             </a:extLst>
           </p:cNvPr>
@@ -5227,7 +5227,7 @@
           <p:cNvPr id="14" name="">
             <a:extLst xmlns:a="http://schemas.openxmlformats.org/drawingml/2006/main">
               <a:ext uri="{FF2B5EF4-FFF2-40B4-BE49-F238E27FC236}">
-                <a16:creationId xmlns:a16="http://schemas.microsoft.com/office/drawing/2014/main" id="{E642C501-B563-46C2-B461-5EA255FA9D71}"/>
+                <a16:creationId xmlns:a16="http://schemas.microsoft.com/office/drawing/2014/main" id="{3E0920AC-E807-4DD1-BDE6-A97084DCEB89}"/>
               </a:ext>
             </a:extLst>
           </p:cNvPr>
@@ -5258,7 +5258,7 @@
           <p:cNvPr id="15" name="">
             <a:extLst xmlns:a="http://schemas.openxmlformats.org/drawingml/2006/main">
               <a:ext uri="{FF2B5EF4-FFF2-40B4-BE49-F238E27FC236}">
-                <a16:creationId xmlns:a16="http://schemas.microsoft.com/office/drawing/2014/main" id="{9F536547-D5C3-46E2-B8D9-5F6E9D8D2181}"/>
+                <a16:creationId xmlns:a16="http://schemas.microsoft.com/office/drawing/2014/main" id="{778A6D3B-4A80-4BBB-A391-DF693B9B463A}"/>
               </a:ext>
             </a:extLst>
           </p:cNvPr>
@@ -5308,7 +5308,7 @@
           <p:cNvPr id="16" name="">
             <a:extLst xmlns:a="http://schemas.openxmlformats.org/drawingml/2006/main">
               <a:ext uri="{FF2B5EF4-FFF2-40B4-BE49-F238E27FC236}">
-                <a16:creationId xmlns:a16="http://schemas.microsoft.com/office/drawing/2014/main" id="{3292C94B-4867-48BC-9E36-9C907F9E75D7}"/>
+                <a16:creationId xmlns:a16="http://schemas.microsoft.com/office/drawing/2014/main" id="{643388FE-5230-4D25-A15B-0CA55F8083B9}"/>
               </a:ext>
             </a:extLst>
           </p:cNvPr>
@@ -5339,7 +5339,7 @@
           <p:cNvPr id="17" name="">
             <a:extLst xmlns:a="http://schemas.openxmlformats.org/drawingml/2006/main">
               <a:ext uri="{FF2B5EF4-FFF2-40B4-BE49-F238E27FC236}">
-                <a16:creationId xmlns:a16="http://schemas.microsoft.com/office/drawing/2014/main" id="{6E1F939E-D979-44E4-ADBA-408C7E2B9D53}"/>
+                <a16:creationId xmlns:a16="http://schemas.microsoft.com/office/drawing/2014/main" id="{4F612111-2AC8-4CFC-A9D5-AFEBE3337E2F}"/>
               </a:ext>
             </a:extLst>
           </p:cNvPr>
@@ -5389,7 +5389,7 @@
           <p:cNvPr id="18" name="">
             <a:extLst xmlns:a="http://schemas.openxmlformats.org/drawingml/2006/main">
               <a:ext uri="{FF2B5EF4-FFF2-40B4-BE49-F238E27FC236}">
-                <a16:creationId xmlns:a16="http://schemas.microsoft.com/office/drawing/2014/main" id="{01C95372-2B32-4AB1-BBB4-CB7ABEDA154E}"/>
+                <a16:creationId xmlns:a16="http://schemas.microsoft.com/office/drawing/2014/main" id="{22365A18-B7F6-4B2B-9FB5-01139B8C748B}"/>
               </a:ext>
             </a:extLst>
           </p:cNvPr>
@@ -5420,7 +5420,7 @@
           <p:cNvPr id="19" name="">
             <a:extLst xmlns:a="http://schemas.openxmlformats.org/drawingml/2006/main">
               <a:ext uri="{FF2B5EF4-FFF2-40B4-BE49-F238E27FC236}">
-                <a16:creationId xmlns:a16="http://schemas.microsoft.com/office/drawing/2014/main" id="{DEEBAD0F-57A3-479F-AEAC-6C40C4F3C036}"/>
+                <a16:creationId xmlns:a16="http://schemas.microsoft.com/office/drawing/2014/main" id="{03F1903A-C88B-4C91-BD26-EE99B26E695D}"/>
               </a:ext>
             </a:extLst>
           </p:cNvPr>
@@ -5470,7 +5470,7 @@
           <p:cNvPr id="20" name="">
             <a:extLst xmlns:a="http://schemas.openxmlformats.org/drawingml/2006/main">
               <a:ext uri="{FF2B5EF4-FFF2-40B4-BE49-F238E27FC236}">
-                <a16:creationId xmlns:a16="http://schemas.microsoft.com/office/drawing/2014/main" id="{8F1D6C34-BC07-4FC7-AB39-4DBC955A8A5E}"/>
+                <a16:creationId xmlns:a16="http://schemas.microsoft.com/office/drawing/2014/main" id="{B5B64565-3DE4-4F44-AD38-D57F97368EE6}"/>
               </a:ext>
             </a:extLst>
           </p:cNvPr>
@@ -5501,7 +5501,7 @@
           <p:cNvPr id="21" name="">
             <a:extLst xmlns:a="http://schemas.openxmlformats.org/drawingml/2006/main">
               <a:ext uri="{FF2B5EF4-FFF2-40B4-BE49-F238E27FC236}">
-                <a16:creationId xmlns:a16="http://schemas.microsoft.com/office/drawing/2014/main" id="{574CF24F-451E-4749-AA49-509D3C74AD61}"/>
+                <a16:creationId xmlns:a16="http://schemas.microsoft.com/office/drawing/2014/main" id="{3425EF83-B7B0-40C1-A243-6C770BF997C3}"/>
               </a:ext>
             </a:extLst>
           </p:cNvPr>
@@ -5536,7 +5536,7 @@
           <p:cNvPr id="22" name="">
             <a:extLst xmlns:a="http://schemas.openxmlformats.org/drawingml/2006/main">
               <a:ext uri="{FF2B5EF4-FFF2-40B4-BE49-F238E27FC236}">
-                <a16:creationId xmlns:a16="http://schemas.microsoft.com/office/drawing/2014/main" id="{A5BAED2D-2A08-47BC-8D5D-2A5220ECBB28}"/>
+                <a16:creationId xmlns:a16="http://schemas.microsoft.com/office/drawing/2014/main" id="{7C6D12E5-B704-41CF-B997-2E984B1F3ED8}"/>
               </a:ext>
             </a:extLst>
           </p:cNvPr>
@@ -5586,7 +5586,7 @@
           <p:cNvPr id="23" name="">
             <a:extLst xmlns:a="http://schemas.openxmlformats.org/drawingml/2006/main">
               <a:ext uri="{FF2B5EF4-FFF2-40B4-BE49-F238E27FC236}">
-                <a16:creationId xmlns:a16="http://schemas.microsoft.com/office/drawing/2014/main" id="{835756D1-89FB-44BF-9259-3099C9F5F3B2}"/>
+                <a16:creationId xmlns:a16="http://schemas.microsoft.com/office/drawing/2014/main" id="{28E9420F-7CAF-4793-8DD9-ED2903E80D4C}"/>
               </a:ext>
             </a:extLst>
           </p:cNvPr>
@@ -5621,7 +5621,7 @@
           <p:nvPr/>
         </p:nvPicPr>
         <p:blipFill>
-          <a:blip xmlns:r="http://schemas.openxmlformats.org/officeDocument/2006/relationships" xmlns:a="http://schemas.openxmlformats.org/drawingml/2006/main" r:embed="Rec134ab49572448b"/>
+          <a:blip xmlns:r="http://schemas.openxmlformats.org/officeDocument/2006/relationships" xmlns:a="http://schemas.openxmlformats.org/drawingml/2006/main" r:embed="Rc11299c3132042b0"/>
           <a:stretch xmlns:a="http://schemas.openxmlformats.org/drawingml/2006/main"/>
         </p:blipFill>
         <p:spPr>
@@ -5639,7 +5639,7 @@
           <p:cNvPr id="25" name="">
             <a:extLst xmlns:a="http://schemas.openxmlformats.org/drawingml/2006/main">
               <a:ext uri="{FF2B5EF4-FFF2-40B4-BE49-F238E27FC236}">
-                <a16:creationId xmlns:a16="http://schemas.microsoft.com/office/drawing/2014/main" id="{6D844090-2334-4E5E-AC7B-BF1DC52FC768}"/>
+                <a16:creationId xmlns:a16="http://schemas.microsoft.com/office/drawing/2014/main" id="{20DF4744-260E-4C57-A8E5-EA92B724B624}"/>
               </a:ext>
             </a:extLst>
           </p:cNvPr>
@@ -5689,7 +5689,7 @@
           <p:cNvPr id="26" name="">
             <a:extLst xmlns:a="http://schemas.openxmlformats.org/drawingml/2006/main">
               <a:ext uri="{FF2B5EF4-FFF2-40B4-BE49-F238E27FC236}">
-                <a16:creationId xmlns:a16="http://schemas.microsoft.com/office/drawing/2014/main" id="{CB3F3C81-53D8-40F7-BA64-35AEEFFBCE6C}"/>
+                <a16:creationId xmlns:a16="http://schemas.microsoft.com/office/drawing/2014/main" id="{ACAD6D86-6B7F-48C7-B9AE-93D1DC55B38B}"/>
               </a:ext>
             </a:extLst>
           </p:cNvPr>
@@ -5737,7 +5737,7 @@
     </p:spTree>
     <p:extLst>
       <p:ext uri="{BB962C8B-B14F-4D97-AF65-F5344CB8AC3E}">
-        <p14:creationId xmlns:p14="http://schemas.microsoft.com/office/powerpoint/2010/main" val="792717903"/>
+        <p14:creationId xmlns:p14="http://schemas.microsoft.com/office/powerpoint/2010/main" val="1251110487"/>
       </p:ext>
     </p:extLst>
   </p:cSld>
@@ -5768,7 +5768,7 @@
           <p:cNvPr id="1" name="">
             <a:extLst xmlns:a="http://schemas.openxmlformats.org/drawingml/2006/main">
               <a:ext uri="{FF2B5EF4-FFF2-40B4-BE49-F238E27FC236}">
-                <a16:creationId xmlns:a16="http://schemas.microsoft.com/office/drawing/2014/main" id="{600A1EBB-D09D-493E-9CB3-B8F126831AF2}"/>
+                <a16:creationId xmlns:a16="http://schemas.microsoft.com/office/drawing/2014/main" id="{12A649A1-384E-497C-83A8-F5620FEB2F9F}"/>
               </a:ext>
             </a:extLst>
           </p:cNvPr>
@@ -5799,7 +5799,7 @@
           <p:cNvPr id="2" name="">
             <a:extLst xmlns:a="http://schemas.openxmlformats.org/drawingml/2006/main">
               <a:ext uri="{FF2B5EF4-FFF2-40B4-BE49-F238E27FC236}">
-                <a16:creationId xmlns:a16="http://schemas.microsoft.com/office/drawing/2014/main" id="{A62A92A3-CB5C-41B1-B0D1-C482DF7B08EB}"/>
+                <a16:creationId xmlns:a16="http://schemas.microsoft.com/office/drawing/2014/main" id="{6DC06F5E-4AFE-46FE-9961-01311FDD2F4A}"/>
               </a:ext>
             </a:extLst>
           </p:cNvPr>
@@ -5849,7 +5849,7 @@
           <p:cNvPr id="3" name="">
             <a:extLst xmlns:a="http://schemas.openxmlformats.org/drawingml/2006/main">
               <a:ext uri="{FF2B5EF4-FFF2-40B4-BE49-F238E27FC236}">
-                <a16:creationId xmlns:a16="http://schemas.microsoft.com/office/drawing/2014/main" id="{D7001CED-E0CF-4767-949C-DB11BB0D838F}"/>
+                <a16:creationId xmlns:a16="http://schemas.microsoft.com/office/drawing/2014/main" id="{84FD6AF9-7EEB-4EFA-92D3-B48B6F8DDA93}"/>
               </a:ext>
             </a:extLst>
           </p:cNvPr>
@@ -5899,7 +5899,7 @@
           <p:cNvPr id="4" name="">
             <a:extLst xmlns:a="http://schemas.openxmlformats.org/drawingml/2006/main">
               <a:ext uri="{FF2B5EF4-FFF2-40B4-BE49-F238E27FC236}">
-                <a16:creationId xmlns:a16="http://schemas.microsoft.com/office/drawing/2014/main" id="{2D0A5422-A644-491F-9E14-E9EF83F32806}"/>
+                <a16:creationId xmlns:a16="http://schemas.microsoft.com/office/drawing/2014/main" id="{0D84F4A4-9622-4AD9-95B4-92DE1229FB91}"/>
               </a:ext>
             </a:extLst>
           </p:cNvPr>
@@ -5934,7 +5934,7 @@
           <p:cNvPr id="5" name="">
             <a:extLst xmlns:a="http://schemas.openxmlformats.org/drawingml/2006/main">
               <a:ext uri="{FF2B5EF4-FFF2-40B4-BE49-F238E27FC236}">
-                <a16:creationId xmlns:a16="http://schemas.microsoft.com/office/drawing/2014/main" id="{862CB082-0324-4561-ACA7-A91A729106FD}"/>
+                <a16:creationId xmlns:a16="http://schemas.microsoft.com/office/drawing/2014/main" id="{0D1357A3-6180-4EA6-A01C-58A0C4CD6017}"/>
               </a:ext>
             </a:extLst>
           </p:cNvPr>
@@ -5984,7 +5984,7 @@
           <p:cNvPr id="6" name="">
             <a:extLst xmlns:a="http://schemas.openxmlformats.org/drawingml/2006/main">
               <a:ext uri="{FF2B5EF4-FFF2-40B4-BE49-F238E27FC236}">
-                <a16:creationId xmlns:a16="http://schemas.microsoft.com/office/drawing/2014/main" id="{B99D411C-2F60-4452-ADB9-255313826694}"/>
+                <a16:creationId xmlns:a16="http://schemas.microsoft.com/office/drawing/2014/main" id="{59CD3D98-B8D2-421D-8DEC-1594BDE372DD}"/>
               </a:ext>
             </a:extLst>
           </p:cNvPr>
@@ -6068,7 +6068,7 @@
           <p:cNvPr id="7" name="">
             <a:extLst xmlns:a="http://schemas.openxmlformats.org/drawingml/2006/main">
               <a:ext uri="{FF2B5EF4-FFF2-40B4-BE49-F238E27FC236}">
-                <a16:creationId xmlns:a16="http://schemas.microsoft.com/office/drawing/2014/main" id="{871E5F25-E99D-4846-8142-CB8A1639A17F}"/>
+                <a16:creationId xmlns:a16="http://schemas.microsoft.com/office/drawing/2014/main" id="{C3B0A949-AA78-44D6-B089-FC2DD84F6D6A}"/>
               </a:ext>
             </a:extLst>
           </p:cNvPr>
@@ -6099,7 +6099,7 @@
           <p:cNvPr id="8" name="">
             <a:extLst xmlns:a="http://schemas.openxmlformats.org/drawingml/2006/main">
               <a:ext uri="{FF2B5EF4-FFF2-40B4-BE49-F238E27FC236}">
-                <a16:creationId xmlns:a16="http://schemas.microsoft.com/office/drawing/2014/main" id="{90EE60AC-4DDF-4B83-8327-7029A65F2726}"/>
+                <a16:creationId xmlns:a16="http://schemas.microsoft.com/office/drawing/2014/main" id="{8006AFF1-3255-44B0-AF2D-1F198A7B96E4}"/>
               </a:ext>
             </a:extLst>
           </p:cNvPr>
@@ -6149,7 +6149,7 @@
           <p:cNvPr id="9" name="">
             <a:extLst xmlns:a="http://schemas.openxmlformats.org/drawingml/2006/main">
               <a:ext uri="{FF2B5EF4-FFF2-40B4-BE49-F238E27FC236}">
-                <a16:creationId xmlns:a16="http://schemas.microsoft.com/office/drawing/2014/main" id="{79FCAAEB-E968-41A0-864A-C5895D8310BD}"/>
+                <a16:creationId xmlns:a16="http://schemas.microsoft.com/office/drawing/2014/main" id="{E0999EA9-8583-4984-9A8C-9329FBC01882}"/>
               </a:ext>
             </a:extLst>
           </p:cNvPr>
@@ -6180,7 +6180,7 @@
           <p:cNvPr id="10" name="">
             <a:extLst xmlns:a="http://schemas.openxmlformats.org/drawingml/2006/main">
               <a:ext uri="{FF2B5EF4-FFF2-40B4-BE49-F238E27FC236}">
-                <a16:creationId xmlns:a16="http://schemas.microsoft.com/office/drawing/2014/main" id="{42880E97-58D2-4C3B-BE6A-0F0659ECA5E9}"/>
+                <a16:creationId xmlns:a16="http://schemas.microsoft.com/office/drawing/2014/main" id="{9C46A87A-3D47-40C0-8B7A-4012C3EA036C}"/>
               </a:ext>
             </a:extLst>
           </p:cNvPr>
@@ -6230,7 +6230,7 @@
           <p:cNvPr id="11" name="">
             <a:extLst xmlns:a="http://schemas.openxmlformats.org/drawingml/2006/main">
               <a:ext uri="{FF2B5EF4-FFF2-40B4-BE49-F238E27FC236}">
-                <a16:creationId xmlns:a16="http://schemas.microsoft.com/office/drawing/2014/main" id="{57B342B4-D550-42AA-8479-15AA602EB536}"/>
+                <a16:creationId xmlns:a16="http://schemas.microsoft.com/office/drawing/2014/main" id="{974920D7-59C9-46EC-A1F5-6F3C3CC6152F}"/>
               </a:ext>
             </a:extLst>
           </p:cNvPr>
@@ -6261,7 +6261,7 @@
           <p:cNvPr id="12" name="">
             <a:extLst xmlns:a="http://schemas.openxmlformats.org/drawingml/2006/main">
               <a:ext uri="{FF2B5EF4-FFF2-40B4-BE49-F238E27FC236}">
-                <a16:creationId xmlns:a16="http://schemas.microsoft.com/office/drawing/2014/main" id="{3D1E32AC-99F8-4C56-BDE4-C7290D36F0EE}"/>
+                <a16:creationId xmlns:a16="http://schemas.microsoft.com/office/drawing/2014/main" id="{19A45A10-98C2-4462-9A01-F3C943FBAAEF}"/>
               </a:ext>
             </a:extLst>
           </p:cNvPr>
@@ -6311,7 +6311,7 @@
           <p:cNvPr id="13" name="">
             <a:extLst xmlns:a="http://schemas.openxmlformats.org/drawingml/2006/main">
               <a:ext uri="{FF2B5EF4-FFF2-40B4-BE49-F238E27FC236}">
-                <a16:creationId xmlns:a16="http://schemas.microsoft.com/office/drawing/2014/main" id="{B163F3F9-D8F0-4177-86DD-C17F2351346C}"/>
+                <a16:creationId xmlns:a16="http://schemas.microsoft.com/office/drawing/2014/main" id="{BB230F5A-B866-4967-947D-4DD20062D9DF}"/>
               </a:ext>
             </a:extLst>
           </p:cNvPr>
@@ -6342,7 +6342,7 @@
           <p:cNvPr id="14" name="">
             <a:extLst xmlns:a="http://schemas.openxmlformats.org/drawingml/2006/main">
               <a:ext uri="{FF2B5EF4-FFF2-40B4-BE49-F238E27FC236}">
-                <a16:creationId xmlns:a16="http://schemas.microsoft.com/office/drawing/2014/main" id="{25083715-995F-41A7-B74C-742CC523DF7B}"/>
+                <a16:creationId xmlns:a16="http://schemas.microsoft.com/office/drawing/2014/main" id="{6B377639-8684-4E5A-A2D6-BF904EC89609}"/>
               </a:ext>
             </a:extLst>
           </p:cNvPr>
@@ -6392,7 +6392,7 @@
           <p:cNvPr id="15" name="">
             <a:extLst xmlns:a="http://schemas.openxmlformats.org/drawingml/2006/main">
               <a:ext uri="{FF2B5EF4-FFF2-40B4-BE49-F238E27FC236}">
-                <a16:creationId xmlns:a16="http://schemas.microsoft.com/office/drawing/2014/main" id="{669E4FFC-7943-4453-AB77-9317D331435E}"/>
+                <a16:creationId xmlns:a16="http://schemas.microsoft.com/office/drawing/2014/main" id="{20ECA754-AAA0-4ED3-ADA4-33D145B4DCEE}"/>
               </a:ext>
             </a:extLst>
           </p:cNvPr>
@@ -6427,7 +6427,7 @@
           <p:nvPr/>
         </p:nvPicPr>
         <p:blipFill>
-          <a:blip xmlns:r="http://schemas.openxmlformats.org/officeDocument/2006/relationships" xmlns:a="http://schemas.openxmlformats.org/drawingml/2006/main" r:embed="R40debc156634421e"/>
+          <a:blip xmlns:r="http://schemas.openxmlformats.org/officeDocument/2006/relationships" xmlns:a="http://schemas.openxmlformats.org/drawingml/2006/main" r:embed="Reaf5b17595704321"/>
           <a:stretch xmlns:a="http://schemas.openxmlformats.org/drawingml/2006/main"/>
         </p:blipFill>
         <p:spPr>
@@ -6445,7 +6445,7 @@
           <p:cNvPr id="17" name="">
             <a:extLst xmlns:a="http://schemas.openxmlformats.org/drawingml/2006/main">
               <a:ext uri="{FF2B5EF4-FFF2-40B4-BE49-F238E27FC236}">
-                <a16:creationId xmlns:a16="http://schemas.microsoft.com/office/drawing/2014/main" id="{7BB49A44-75AB-41AA-95A8-069E6A1EBBBB}"/>
+                <a16:creationId xmlns:a16="http://schemas.microsoft.com/office/drawing/2014/main" id="{EA5D7230-16CE-4113-9353-6122E01EF001}"/>
               </a:ext>
             </a:extLst>
           </p:cNvPr>
@@ -6495,7 +6495,7 @@
           <p:cNvPr id="18" name="">
             <a:extLst xmlns:a="http://schemas.openxmlformats.org/drawingml/2006/main">
               <a:ext uri="{FF2B5EF4-FFF2-40B4-BE49-F238E27FC236}">
-                <a16:creationId xmlns:a16="http://schemas.microsoft.com/office/drawing/2014/main" id="{EAF41E47-29BA-4087-99C2-BABDBCC2AF5E}"/>
+                <a16:creationId xmlns:a16="http://schemas.microsoft.com/office/drawing/2014/main" id="{84352F50-9A0D-4863-A337-F0CDEA775785}"/>
               </a:ext>
             </a:extLst>
           </p:cNvPr>
@@ -6543,7 +6543,7 @@
     </p:spTree>
     <p:extLst>
       <p:ext uri="{BB962C8B-B14F-4D97-AF65-F5344CB8AC3E}">
-        <p14:creationId xmlns:p14="http://schemas.microsoft.com/office/powerpoint/2010/main" val="1536175834"/>
+        <p14:creationId xmlns:p14="http://schemas.microsoft.com/office/powerpoint/2010/main" val="1639497942"/>
       </p:ext>
     </p:extLst>
   </p:cSld>
@@ -6574,7 +6574,7 @@
           <p:cNvPr id="1" name="">
             <a:extLst xmlns:a="http://schemas.openxmlformats.org/drawingml/2006/main">
               <a:ext uri="{FF2B5EF4-FFF2-40B4-BE49-F238E27FC236}">
-                <a16:creationId xmlns:a16="http://schemas.microsoft.com/office/drawing/2014/main" id="{5E66B5AE-BAE5-417A-9E5C-A773CDAD16FE}"/>
+                <a16:creationId xmlns:a16="http://schemas.microsoft.com/office/drawing/2014/main" id="{3C35B750-99EC-4037-A488-C895BC11B232}"/>
               </a:ext>
             </a:extLst>
           </p:cNvPr>
@@ -6605,7 +6605,7 @@
           <p:cNvPr id="2" name="">
             <a:extLst xmlns:a="http://schemas.openxmlformats.org/drawingml/2006/main">
               <a:ext uri="{FF2B5EF4-FFF2-40B4-BE49-F238E27FC236}">
-                <a16:creationId xmlns:a16="http://schemas.microsoft.com/office/drawing/2014/main" id="{553D4354-4AA1-4C79-A1C3-B4E29A7B58FD}"/>
+                <a16:creationId xmlns:a16="http://schemas.microsoft.com/office/drawing/2014/main" id="{4B8AE966-AB8F-4371-B924-20C31CAA02AB}"/>
               </a:ext>
             </a:extLst>
           </p:cNvPr>
@@ -6655,7 +6655,7 @@
           <p:cNvPr id="3" name="">
             <a:extLst xmlns:a="http://schemas.openxmlformats.org/drawingml/2006/main">
               <a:ext uri="{FF2B5EF4-FFF2-40B4-BE49-F238E27FC236}">
-                <a16:creationId xmlns:a16="http://schemas.microsoft.com/office/drawing/2014/main" id="{432FCBE8-2FC1-4FE5-8E8C-8DE43BDA091F}"/>
+                <a16:creationId xmlns:a16="http://schemas.microsoft.com/office/drawing/2014/main" id="{EE9E967B-2899-4063-BC1D-2664F087DBE2}"/>
               </a:ext>
             </a:extLst>
           </p:cNvPr>
@@ -6705,7 +6705,7 @@
           <p:cNvPr id="4" name="">
             <a:extLst xmlns:a="http://schemas.openxmlformats.org/drawingml/2006/main">
               <a:ext uri="{FF2B5EF4-FFF2-40B4-BE49-F238E27FC236}">
-                <a16:creationId xmlns:a16="http://schemas.microsoft.com/office/drawing/2014/main" id="{1131CDE5-C49F-49E8-9C17-EA80AEC32509}"/>
+                <a16:creationId xmlns:a16="http://schemas.microsoft.com/office/drawing/2014/main" id="{94399E46-2841-41C1-BF8A-4A30933E11BF}"/>
               </a:ext>
             </a:extLst>
           </p:cNvPr>
@@ -6755,7 +6755,7 @@
           <p:cNvPr id="5" name="">
             <a:extLst xmlns:a="http://schemas.openxmlformats.org/drawingml/2006/main">
               <a:ext uri="{FF2B5EF4-FFF2-40B4-BE49-F238E27FC236}">
-                <a16:creationId xmlns:a16="http://schemas.microsoft.com/office/drawing/2014/main" id="{65701FE5-C3F8-4C64-989F-6533B7F47952}"/>
+                <a16:creationId xmlns:a16="http://schemas.microsoft.com/office/drawing/2014/main" id="{4E4B8A2E-A01D-444D-964B-E2AD0E54B69C}"/>
               </a:ext>
             </a:extLst>
           </p:cNvPr>
@@ -6805,7 +6805,7 @@
           <p:cNvPr id="6" name="">
             <a:extLst xmlns:a="http://schemas.openxmlformats.org/drawingml/2006/main">
               <a:ext uri="{FF2B5EF4-FFF2-40B4-BE49-F238E27FC236}">
-                <a16:creationId xmlns:a16="http://schemas.microsoft.com/office/drawing/2014/main" id="{96837719-A3AF-4AEF-ACFE-2D8B499938AB}"/>
+                <a16:creationId xmlns:a16="http://schemas.microsoft.com/office/drawing/2014/main" id="{7195471F-FA6C-4F1B-A874-8E3B8285D3CB}"/>
               </a:ext>
             </a:extLst>
           </p:cNvPr>
@@ -6855,7 +6855,7 @@
           <p:cNvPr id="7" name="">
             <a:extLst xmlns:a="http://schemas.openxmlformats.org/drawingml/2006/main">
               <a:ext uri="{FF2B5EF4-FFF2-40B4-BE49-F238E27FC236}">
-                <a16:creationId xmlns:a16="http://schemas.microsoft.com/office/drawing/2014/main" id="{D1140008-93D3-4813-8855-3ACD72AE8963}"/>
+                <a16:creationId xmlns:a16="http://schemas.microsoft.com/office/drawing/2014/main" id="{02D6CDCD-E7A2-42AD-93FE-DFCE9DE13184}"/>
               </a:ext>
             </a:extLst>
           </p:cNvPr>
@@ -6905,7 +6905,7 @@
           <p:cNvPr id="8" name="">
             <a:extLst xmlns:a="http://schemas.openxmlformats.org/drawingml/2006/main">
               <a:ext uri="{FF2B5EF4-FFF2-40B4-BE49-F238E27FC236}">
-                <a16:creationId xmlns:a16="http://schemas.microsoft.com/office/drawing/2014/main" id="{90711550-B9E7-497C-8264-97DFD0831B15}"/>
+                <a16:creationId xmlns:a16="http://schemas.microsoft.com/office/drawing/2014/main" id="{F23887E1-21FD-40AE-A607-E6ADD37A393E}"/>
               </a:ext>
             </a:extLst>
           </p:cNvPr>
@@ -6936,7 +6936,7 @@
           <p:cNvPr id="9" name="">
             <a:extLst xmlns:a="http://schemas.openxmlformats.org/drawingml/2006/main">
               <a:ext uri="{FF2B5EF4-FFF2-40B4-BE49-F238E27FC236}">
-                <a16:creationId xmlns:a16="http://schemas.microsoft.com/office/drawing/2014/main" id="{1061FE88-40CE-4B12-8385-540196F66197}"/>
+                <a16:creationId xmlns:a16="http://schemas.microsoft.com/office/drawing/2014/main" id="{D7302C3A-7A1F-4033-A03F-2156849AA51F}"/>
               </a:ext>
             </a:extLst>
           </p:cNvPr>
@@ -6986,7 +6986,7 @@
           <p:cNvPr id="10" name="">
             <a:extLst xmlns:a="http://schemas.openxmlformats.org/drawingml/2006/main">
               <a:ext uri="{FF2B5EF4-FFF2-40B4-BE49-F238E27FC236}">
-                <a16:creationId xmlns:a16="http://schemas.microsoft.com/office/drawing/2014/main" id="{13C61EBA-412F-49DB-9E4A-A09065E238DE}"/>
+                <a16:creationId xmlns:a16="http://schemas.microsoft.com/office/drawing/2014/main" id="{EB3E072F-0919-4A1C-B258-9B70906F0918}"/>
               </a:ext>
             </a:extLst>
           </p:cNvPr>
@@ -7036,7 +7036,7 @@
           <p:cNvPr id="11" name="">
             <a:extLst xmlns:a="http://schemas.openxmlformats.org/drawingml/2006/main">
               <a:ext uri="{FF2B5EF4-FFF2-40B4-BE49-F238E27FC236}">
-                <a16:creationId xmlns:a16="http://schemas.microsoft.com/office/drawing/2014/main" id="{3E43A81B-597B-4ACE-A761-C4773E34B777}"/>
+                <a16:creationId xmlns:a16="http://schemas.microsoft.com/office/drawing/2014/main" id="{6B5DB668-78EA-41C2-B9A9-6F2DC5C9BF90}"/>
               </a:ext>
             </a:extLst>
           </p:cNvPr>
@@ -7086,7 +7086,7 @@
           <p:cNvPr id="12" name="">
             <a:extLst xmlns:a="http://schemas.openxmlformats.org/drawingml/2006/main">
               <a:ext uri="{FF2B5EF4-FFF2-40B4-BE49-F238E27FC236}">
-                <a16:creationId xmlns:a16="http://schemas.microsoft.com/office/drawing/2014/main" id="{FA1DE972-12BE-46A4-9E7C-16BBA1B23A0B}"/>
+                <a16:creationId xmlns:a16="http://schemas.microsoft.com/office/drawing/2014/main" id="{BD0C9BAE-3010-439F-B843-7F041E8F93BB}"/>
               </a:ext>
             </a:extLst>
           </p:cNvPr>
@@ -7136,7 +7136,7 @@
           <p:cNvPr id="13" name="">
             <a:extLst xmlns:a="http://schemas.openxmlformats.org/drawingml/2006/main">
               <a:ext uri="{FF2B5EF4-FFF2-40B4-BE49-F238E27FC236}">
-                <a16:creationId xmlns:a16="http://schemas.microsoft.com/office/drawing/2014/main" id="{E74D2977-3E5C-43CE-8416-9568CFF69995}"/>
+                <a16:creationId xmlns:a16="http://schemas.microsoft.com/office/drawing/2014/main" id="{1E8BBDAC-229F-4715-8E1B-C9DBA30805C7}"/>
               </a:ext>
             </a:extLst>
           </p:cNvPr>
@@ -7167,7 +7167,7 @@
           <p:cNvPr id="14" name="">
             <a:extLst xmlns:a="http://schemas.openxmlformats.org/drawingml/2006/main">
               <a:ext uri="{FF2B5EF4-FFF2-40B4-BE49-F238E27FC236}">
-                <a16:creationId xmlns:a16="http://schemas.microsoft.com/office/drawing/2014/main" id="{B53DD0F9-84D4-423B-88F9-8C54AF13A43B}"/>
+                <a16:creationId xmlns:a16="http://schemas.microsoft.com/office/drawing/2014/main" id="{5E62F5AB-8674-45A0-B66F-722B1118D94F}"/>
               </a:ext>
             </a:extLst>
           </p:cNvPr>
@@ -7217,7 +7217,7 @@
           <p:cNvPr id="15" name="">
             <a:extLst xmlns:a="http://schemas.openxmlformats.org/drawingml/2006/main">
               <a:ext uri="{FF2B5EF4-FFF2-40B4-BE49-F238E27FC236}">
-                <a16:creationId xmlns:a16="http://schemas.microsoft.com/office/drawing/2014/main" id="{F6E2D05A-739F-43F3-88EE-8EB382A12B17}"/>
+                <a16:creationId xmlns:a16="http://schemas.microsoft.com/office/drawing/2014/main" id="{486551FA-A005-4DC2-A0F1-25D8D7B5C5D0}"/>
               </a:ext>
             </a:extLst>
           </p:cNvPr>
@@ -7267,7 +7267,7 @@
           <p:cNvPr id="16" name="">
             <a:extLst xmlns:a="http://schemas.openxmlformats.org/drawingml/2006/main">
               <a:ext uri="{FF2B5EF4-FFF2-40B4-BE49-F238E27FC236}">
-                <a16:creationId xmlns:a16="http://schemas.microsoft.com/office/drawing/2014/main" id="{22CAED7B-0733-4B1B-86CA-D0D85E1691ED}"/>
+                <a16:creationId xmlns:a16="http://schemas.microsoft.com/office/drawing/2014/main" id="{2FAE0A6D-C99F-484F-B37E-D579EBD1D68D}"/>
               </a:ext>
             </a:extLst>
           </p:cNvPr>
@@ -7317,7 +7317,7 @@
           <p:cNvPr id="17" name="">
             <a:extLst xmlns:a="http://schemas.openxmlformats.org/drawingml/2006/main">
               <a:ext uri="{FF2B5EF4-FFF2-40B4-BE49-F238E27FC236}">
-                <a16:creationId xmlns:a16="http://schemas.microsoft.com/office/drawing/2014/main" id="{16864330-A44B-4CB5-9685-073D6BC641E0}"/>
+                <a16:creationId xmlns:a16="http://schemas.microsoft.com/office/drawing/2014/main" id="{03F6786A-3445-4DED-8836-94F508C88BC8}"/>
               </a:ext>
             </a:extLst>
           </p:cNvPr>
@@ -7367,7 +7367,7 @@
           <p:cNvPr id="18" name="">
             <a:extLst xmlns:a="http://schemas.openxmlformats.org/drawingml/2006/main">
               <a:ext uri="{FF2B5EF4-FFF2-40B4-BE49-F238E27FC236}">
-                <a16:creationId xmlns:a16="http://schemas.microsoft.com/office/drawing/2014/main" id="{92182389-B691-4484-A569-8C710C64FEE9}"/>
+                <a16:creationId xmlns:a16="http://schemas.microsoft.com/office/drawing/2014/main" id="{71DF2433-724E-4BC8-9B67-CFB13E95ABF9}"/>
               </a:ext>
             </a:extLst>
           </p:cNvPr>
@@ -7398,7 +7398,7 @@
           <p:cNvPr id="19" name="">
             <a:extLst xmlns:a="http://schemas.openxmlformats.org/drawingml/2006/main">
               <a:ext uri="{FF2B5EF4-FFF2-40B4-BE49-F238E27FC236}">
-                <a16:creationId xmlns:a16="http://schemas.microsoft.com/office/drawing/2014/main" id="{A215A905-43DF-4A60-B8E1-87AB77476C2C}"/>
+                <a16:creationId xmlns:a16="http://schemas.microsoft.com/office/drawing/2014/main" id="{DAE1FB50-10E7-46A5-94B4-96DA23796FAE}"/>
               </a:ext>
             </a:extLst>
           </p:cNvPr>
@@ -7448,7 +7448,7 @@
           <p:cNvPr id="20" name="">
             <a:extLst xmlns:a="http://schemas.openxmlformats.org/drawingml/2006/main">
               <a:ext uri="{FF2B5EF4-FFF2-40B4-BE49-F238E27FC236}">
-                <a16:creationId xmlns:a16="http://schemas.microsoft.com/office/drawing/2014/main" id="{33E604BC-2CCA-4190-B16A-6D8AD1C4FF68}"/>
+                <a16:creationId xmlns:a16="http://schemas.microsoft.com/office/drawing/2014/main" id="{B73020BE-A3A7-46A6-966D-71B63D7A8313}"/>
               </a:ext>
             </a:extLst>
           </p:cNvPr>
@@ -7498,7 +7498,7 @@
           <p:cNvPr id="21" name="">
             <a:extLst xmlns:a="http://schemas.openxmlformats.org/drawingml/2006/main">
               <a:ext uri="{FF2B5EF4-FFF2-40B4-BE49-F238E27FC236}">
-                <a16:creationId xmlns:a16="http://schemas.microsoft.com/office/drawing/2014/main" id="{45D620C9-9D08-40D6-A65D-80036B82B6A3}"/>
+                <a16:creationId xmlns:a16="http://schemas.microsoft.com/office/drawing/2014/main" id="{7A4522FC-EA77-42A6-B9C9-0888F577EA1B}"/>
               </a:ext>
             </a:extLst>
           </p:cNvPr>
@@ -7548,7 +7548,7 @@
           <p:cNvPr id="22" name="">
             <a:extLst xmlns:a="http://schemas.openxmlformats.org/drawingml/2006/main">
               <a:ext uri="{FF2B5EF4-FFF2-40B4-BE49-F238E27FC236}">
-                <a16:creationId xmlns:a16="http://schemas.microsoft.com/office/drawing/2014/main" id="{929BB163-04FB-499B-B9F2-E2AC3B509729}"/>
+                <a16:creationId xmlns:a16="http://schemas.microsoft.com/office/drawing/2014/main" id="{9DD37E9E-2BB8-474E-A258-57936EDDE8E3}"/>
               </a:ext>
             </a:extLst>
           </p:cNvPr>
@@ -7598,7 +7598,7 @@
           <p:cNvPr id="23" name="">
             <a:extLst xmlns:a="http://schemas.openxmlformats.org/drawingml/2006/main">
               <a:ext uri="{FF2B5EF4-FFF2-40B4-BE49-F238E27FC236}">
-                <a16:creationId xmlns:a16="http://schemas.microsoft.com/office/drawing/2014/main" id="{3A0F6FEF-1693-4E67-B393-96FF671A467B}"/>
+                <a16:creationId xmlns:a16="http://schemas.microsoft.com/office/drawing/2014/main" id="{313D8788-3D64-493A-BA4B-C76AB8610FBC}"/>
               </a:ext>
             </a:extLst>
           </p:cNvPr>
@@ -7629,7 +7629,7 @@
           <p:cNvPr id="24" name="">
             <a:extLst xmlns:a="http://schemas.openxmlformats.org/drawingml/2006/main">
               <a:ext uri="{FF2B5EF4-FFF2-40B4-BE49-F238E27FC236}">
-                <a16:creationId xmlns:a16="http://schemas.microsoft.com/office/drawing/2014/main" id="{9DA4BE7C-0778-4B4C-81A0-24FFCF6AB06F}"/>
+                <a16:creationId xmlns:a16="http://schemas.microsoft.com/office/drawing/2014/main" id="{FA5F3A24-581D-4D29-AE10-37771E30A0DB}"/>
               </a:ext>
             </a:extLst>
           </p:cNvPr>
@@ -7664,7 +7664,7 @@
           <p:nvPr/>
         </p:nvPicPr>
         <p:blipFill>
-          <a:blip xmlns:r="http://schemas.openxmlformats.org/officeDocument/2006/relationships" xmlns:a="http://schemas.openxmlformats.org/drawingml/2006/main" r:embed="Rd9766cf208ff4bdb"/>
+          <a:blip xmlns:r="http://schemas.openxmlformats.org/officeDocument/2006/relationships" xmlns:a="http://schemas.openxmlformats.org/drawingml/2006/main" r:embed="R1fe23bb13c5a4be0"/>
           <a:stretch xmlns:a="http://schemas.openxmlformats.org/drawingml/2006/main"/>
         </p:blipFill>
         <p:spPr>
@@ -7682,7 +7682,7 @@
           <p:cNvPr id="26" name="">
             <a:extLst xmlns:a="http://schemas.openxmlformats.org/drawingml/2006/main">
               <a:ext uri="{FF2B5EF4-FFF2-40B4-BE49-F238E27FC236}">
-                <a16:creationId xmlns:a16="http://schemas.microsoft.com/office/drawing/2014/main" id="{B0CEE9BB-F23F-4ED8-9AEA-A83F36BC55B8}"/>
+                <a16:creationId xmlns:a16="http://schemas.microsoft.com/office/drawing/2014/main" id="{77A4A5D4-68B9-4675-A9AA-A747669FAAFD}"/>
               </a:ext>
             </a:extLst>
           </p:cNvPr>
@@ -7732,7 +7732,7 @@
           <p:cNvPr id="27" name="">
             <a:extLst xmlns:a="http://schemas.openxmlformats.org/drawingml/2006/main">
               <a:ext uri="{FF2B5EF4-FFF2-40B4-BE49-F238E27FC236}">
-                <a16:creationId xmlns:a16="http://schemas.microsoft.com/office/drawing/2014/main" id="{288C5967-106F-47F7-AD0B-C48AF3636933}"/>
+                <a16:creationId xmlns:a16="http://schemas.microsoft.com/office/drawing/2014/main" id="{21B6C53B-2AA2-41AB-B037-7B0F9F2E0180}"/>
               </a:ext>
             </a:extLst>
           </p:cNvPr>
@@ -7780,7 +7780,7 @@
     </p:spTree>
     <p:extLst>
       <p:ext uri="{BB962C8B-B14F-4D97-AF65-F5344CB8AC3E}">
-        <p14:creationId xmlns:p14="http://schemas.microsoft.com/office/powerpoint/2010/main" val="1948676864"/>
+        <p14:creationId xmlns:p14="http://schemas.microsoft.com/office/powerpoint/2010/main" val="1941389232"/>
       </p:ext>
     </p:extLst>
   </p:cSld>
@@ -7811,7 +7811,7 @@
           <p:cNvPr id="1" name="">
             <a:extLst xmlns:a="http://schemas.openxmlformats.org/drawingml/2006/main">
               <a:ext uri="{FF2B5EF4-FFF2-40B4-BE49-F238E27FC236}">
-                <a16:creationId xmlns:a16="http://schemas.microsoft.com/office/drawing/2014/main" id="{11E861FA-3AD4-464E-A8B6-41D907E555A2}"/>
+                <a16:creationId xmlns:a16="http://schemas.microsoft.com/office/drawing/2014/main" id="{A4D8B5A4-9799-4A4D-9254-A5F854139CB5}"/>
               </a:ext>
             </a:extLst>
           </p:cNvPr>
@@ -7842,7 +7842,7 @@
           <p:cNvPr id="2" name="">
             <a:extLst xmlns:a="http://schemas.openxmlformats.org/drawingml/2006/main">
               <a:ext uri="{FF2B5EF4-FFF2-40B4-BE49-F238E27FC236}">
-                <a16:creationId xmlns:a16="http://schemas.microsoft.com/office/drawing/2014/main" id="{20A63D5E-DA60-448A-8550-3D76E3F6C424}"/>
+                <a16:creationId xmlns:a16="http://schemas.microsoft.com/office/drawing/2014/main" id="{F69F77DE-4868-4389-B832-5D194BAEE69C}"/>
               </a:ext>
             </a:extLst>
           </p:cNvPr>
@@ -7892,7 +7892,7 @@
           <p:cNvPr id="3" name="">
             <a:extLst xmlns:a="http://schemas.openxmlformats.org/drawingml/2006/main">
               <a:ext uri="{FF2B5EF4-FFF2-40B4-BE49-F238E27FC236}">
-                <a16:creationId xmlns:a16="http://schemas.microsoft.com/office/drawing/2014/main" id="{A5D45C27-D060-42BB-9F35-120586404FC7}"/>
+                <a16:creationId xmlns:a16="http://schemas.microsoft.com/office/drawing/2014/main" id="{DADFEF49-ADCB-4DCF-8A7A-05F60D3EC746}"/>
               </a:ext>
             </a:extLst>
           </p:cNvPr>
@@ -7942,7 +7942,7 @@
           <p:cNvPr id="4" name="">
             <a:extLst xmlns:a="http://schemas.openxmlformats.org/drawingml/2006/main">
               <a:ext uri="{FF2B5EF4-FFF2-40B4-BE49-F238E27FC236}">
-                <a16:creationId xmlns:a16="http://schemas.microsoft.com/office/drawing/2014/main" id="{2098081F-34BF-4821-A7D9-9ED3A42C319C}"/>
+                <a16:creationId xmlns:a16="http://schemas.microsoft.com/office/drawing/2014/main" id="{70AE0A19-060A-4EE7-9198-929437A5099D}"/>
               </a:ext>
             </a:extLst>
           </p:cNvPr>
@@ -7977,7 +7977,7 @@
           <p:cNvPr id="5" name="">
             <a:extLst xmlns:a="http://schemas.openxmlformats.org/drawingml/2006/main">
               <a:ext uri="{FF2B5EF4-FFF2-40B4-BE49-F238E27FC236}">
-                <a16:creationId xmlns:a16="http://schemas.microsoft.com/office/drawing/2014/main" id="{64110B6C-3786-4FD5-A1B6-47518611715E}"/>
+                <a16:creationId xmlns:a16="http://schemas.microsoft.com/office/drawing/2014/main" id="{18D3EDB7-C48F-4260-BF66-4597B1F25129}"/>
               </a:ext>
             </a:extLst>
           </p:cNvPr>
@@ -8027,7 +8027,7 @@
           <p:cNvPr id="6" name="">
             <a:extLst xmlns:a="http://schemas.openxmlformats.org/drawingml/2006/main">
               <a:ext uri="{FF2B5EF4-FFF2-40B4-BE49-F238E27FC236}">
-                <a16:creationId xmlns:a16="http://schemas.microsoft.com/office/drawing/2014/main" id="{0C786621-2DE1-4C95-A6A8-7419CF37ABA3}"/>
+                <a16:creationId xmlns:a16="http://schemas.microsoft.com/office/drawing/2014/main" id="{E97AB7EA-D0B1-4F45-8A5A-A9D259E42B98}"/>
               </a:ext>
             </a:extLst>
           </p:cNvPr>
@@ -8077,7 +8077,7 @@
           <p:cNvPr id="7" name="">
             <a:extLst xmlns:a="http://schemas.openxmlformats.org/drawingml/2006/main">
               <a:ext uri="{FF2B5EF4-FFF2-40B4-BE49-F238E27FC236}">
-                <a16:creationId xmlns:a16="http://schemas.microsoft.com/office/drawing/2014/main" id="{039F232B-683F-46E6-A5C4-9C345AF7AD08}"/>
+                <a16:creationId xmlns:a16="http://schemas.microsoft.com/office/drawing/2014/main" id="{0F2C9F4F-7D92-40A6-9952-64CF5FCC2416}"/>
               </a:ext>
             </a:extLst>
           </p:cNvPr>
@@ -8112,7 +8112,7 @@
           <p:cNvPr id="8" name="">
             <a:extLst xmlns:a="http://schemas.openxmlformats.org/drawingml/2006/main">
               <a:ext uri="{FF2B5EF4-FFF2-40B4-BE49-F238E27FC236}">
-                <a16:creationId xmlns:a16="http://schemas.microsoft.com/office/drawing/2014/main" id="{E6DD4A82-374B-46C7-AB68-70CE918E54FE}"/>
+                <a16:creationId xmlns:a16="http://schemas.microsoft.com/office/drawing/2014/main" id="{940FE4DD-3486-442F-AC3B-AAD3041E81E2}"/>
               </a:ext>
             </a:extLst>
           </p:cNvPr>
@@ -8162,7 +8162,7 @@
           <p:cNvPr id="9" name="">
             <a:extLst xmlns:a="http://schemas.openxmlformats.org/drawingml/2006/main">
               <a:ext uri="{FF2B5EF4-FFF2-40B4-BE49-F238E27FC236}">
-                <a16:creationId xmlns:a16="http://schemas.microsoft.com/office/drawing/2014/main" id="{BEEC17CC-0415-4A62-981E-44268EF91442}"/>
+                <a16:creationId xmlns:a16="http://schemas.microsoft.com/office/drawing/2014/main" id="{65DD3472-E43D-4862-A276-83C97CB28B26}"/>
               </a:ext>
             </a:extLst>
           </p:cNvPr>
@@ -8212,7 +8212,7 @@
           <p:cNvPr id="10" name="">
             <a:extLst xmlns:a="http://schemas.openxmlformats.org/drawingml/2006/main">
               <a:ext uri="{FF2B5EF4-FFF2-40B4-BE49-F238E27FC236}">
-                <a16:creationId xmlns:a16="http://schemas.microsoft.com/office/drawing/2014/main" id="{688AC5B5-DC45-4F27-A1A8-A92F396D7CAD}"/>
+                <a16:creationId xmlns:a16="http://schemas.microsoft.com/office/drawing/2014/main" id="{73EF8C40-6469-4F75-A610-E37DA086E65D}"/>
               </a:ext>
             </a:extLst>
           </p:cNvPr>
@@ -8247,7 +8247,7 @@
           <p:cNvPr id="11" name="">
             <a:extLst xmlns:a="http://schemas.openxmlformats.org/drawingml/2006/main">
               <a:ext uri="{FF2B5EF4-FFF2-40B4-BE49-F238E27FC236}">
-                <a16:creationId xmlns:a16="http://schemas.microsoft.com/office/drawing/2014/main" id="{39122059-3C2A-48C6-8651-5265D12B7DA3}"/>
+                <a16:creationId xmlns:a16="http://schemas.microsoft.com/office/drawing/2014/main" id="{FDEF69E5-8E8A-4CD7-9312-F8D6E1786638}"/>
               </a:ext>
             </a:extLst>
           </p:cNvPr>
@@ -8297,7 +8297,7 @@
           <p:cNvPr id="12" name="">
             <a:extLst xmlns:a="http://schemas.openxmlformats.org/drawingml/2006/main">
               <a:ext uri="{FF2B5EF4-FFF2-40B4-BE49-F238E27FC236}">
-                <a16:creationId xmlns:a16="http://schemas.microsoft.com/office/drawing/2014/main" id="{61A29D69-DB18-4BB9-B246-419B6BF48E51}"/>
+                <a16:creationId xmlns:a16="http://schemas.microsoft.com/office/drawing/2014/main" id="{953CDAD8-7921-46F9-99C1-12DA794FBE1C}"/>
               </a:ext>
             </a:extLst>
           </p:cNvPr>
@@ -8347,7 +8347,7 @@
           <p:cNvPr id="13" name="">
             <a:extLst xmlns:a="http://schemas.openxmlformats.org/drawingml/2006/main">
               <a:ext uri="{FF2B5EF4-FFF2-40B4-BE49-F238E27FC236}">
-                <a16:creationId xmlns:a16="http://schemas.microsoft.com/office/drawing/2014/main" id="{C3403770-5375-4D5B-8544-BF5E51187EC8}"/>
+                <a16:creationId xmlns:a16="http://schemas.microsoft.com/office/drawing/2014/main" id="{FFA92B63-9B42-482C-9222-67F644E39FED}"/>
               </a:ext>
             </a:extLst>
           </p:cNvPr>
@@ -8382,7 +8382,7 @@
           <p:cNvPr id="14" name="">
             <a:extLst xmlns:a="http://schemas.openxmlformats.org/drawingml/2006/main">
               <a:ext uri="{FF2B5EF4-FFF2-40B4-BE49-F238E27FC236}">
-                <a16:creationId xmlns:a16="http://schemas.microsoft.com/office/drawing/2014/main" id="{0C2A9389-7E73-4650-94D1-E18908259D2D}"/>
+                <a16:creationId xmlns:a16="http://schemas.microsoft.com/office/drawing/2014/main" id="{7CAA2978-C0E4-4B69-A76C-54669C2A0889}"/>
               </a:ext>
             </a:extLst>
           </p:cNvPr>
@@ -8432,7 +8432,7 @@
           <p:cNvPr id="15" name="">
             <a:extLst xmlns:a="http://schemas.openxmlformats.org/drawingml/2006/main">
               <a:ext uri="{FF2B5EF4-FFF2-40B4-BE49-F238E27FC236}">
-                <a16:creationId xmlns:a16="http://schemas.microsoft.com/office/drawing/2014/main" id="{BF27A728-5F0A-4022-9FFC-F581D9E78AFE}"/>
+                <a16:creationId xmlns:a16="http://schemas.microsoft.com/office/drawing/2014/main" id="{F340AF19-E016-48EE-A58C-89ACD9B366BE}"/>
               </a:ext>
             </a:extLst>
           </p:cNvPr>
@@ -8482,7 +8482,7 @@
           <p:cNvPr id="16" name="">
             <a:extLst xmlns:a="http://schemas.openxmlformats.org/drawingml/2006/main">
               <a:ext uri="{FF2B5EF4-FFF2-40B4-BE49-F238E27FC236}">
-                <a16:creationId xmlns:a16="http://schemas.microsoft.com/office/drawing/2014/main" id="{0607C49F-E96F-43CA-96FF-430382BDB35A}"/>
+                <a16:creationId xmlns:a16="http://schemas.microsoft.com/office/drawing/2014/main" id="{26A1C897-4696-4531-ADB0-06CBE671D00C}"/>
               </a:ext>
             </a:extLst>
           </p:cNvPr>
@@ -8517,7 +8517,7 @@
           <p:cNvPr id="17" name="">
             <a:extLst xmlns:a="http://schemas.openxmlformats.org/drawingml/2006/main">
               <a:ext uri="{FF2B5EF4-FFF2-40B4-BE49-F238E27FC236}">
-                <a16:creationId xmlns:a16="http://schemas.microsoft.com/office/drawing/2014/main" id="{C1415694-0BA1-4FD5-B5B1-43F16ED80706}"/>
+                <a16:creationId xmlns:a16="http://schemas.microsoft.com/office/drawing/2014/main" id="{35EBEF04-7019-4670-A705-75C9BA21B478}"/>
               </a:ext>
             </a:extLst>
           </p:cNvPr>
@@ -8567,7 +8567,7 @@
           <p:cNvPr id="18" name="">
             <a:extLst xmlns:a="http://schemas.openxmlformats.org/drawingml/2006/main">
               <a:ext uri="{FF2B5EF4-FFF2-40B4-BE49-F238E27FC236}">
-                <a16:creationId xmlns:a16="http://schemas.microsoft.com/office/drawing/2014/main" id="{B2353533-C158-4B7D-8D3F-25BF110389CE}"/>
+                <a16:creationId xmlns:a16="http://schemas.microsoft.com/office/drawing/2014/main" id="{BDC4E8B4-EDCF-4044-A4C7-8F0557C975A5}"/>
               </a:ext>
             </a:extLst>
           </p:cNvPr>
@@ -8617,7 +8617,7 @@
           <p:cNvPr id="19" name="">
             <a:extLst xmlns:a="http://schemas.openxmlformats.org/drawingml/2006/main">
               <a:ext uri="{FF2B5EF4-FFF2-40B4-BE49-F238E27FC236}">
-                <a16:creationId xmlns:a16="http://schemas.microsoft.com/office/drawing/2014/main" id="{A9C2188E-5FBC-4C19-A246-15874417CFF9}"/>
+                <a16:creationId xmlns:a16="http://schemas.microsoft.com/office/drawing/2014/main" id="{7CA56C8E-24A3-4387-8422-BB6E5C59E8CE}"/>
               </a:ext>
             </a:extLst>
           </p:cNvPr>
@@ -8652,7 +8652,7 @@
           <p:nvPr/>
         </p:nvPicPr>
         <p:blipFill>
-          <a:blip xmlns:r="http://schemas.openxmlformats.org/officeDocument/2006/relationships" xmlns:a="http://schemas.openxmlformats.org/drawingml/2006/main" r:embed="Rce52e5085d0a443a"/>
+          <a:blip xmlns:r="http://schemas.openxmlformats.org/officeDocument/2006/relationships" xmlns:a="http://schemas.openxmlformats.org/drawingml/2006/main" r:embed="R20f55d58092c4c37"/>
           <a:stretch xmlns:a="http://schemas.openxmlformats.org/drawingml/2006/main"/>
         </p:blipFill>
         <p:spPr>
@@ -8670,7 +8670,7 @@
           <p:cNvPr id="21" name="">
             <a:extLst xmlns:a="http://schemas.openxmlformats.org/drawingml/2006/main">
               <a:ext uri="{FF2B5EF4-FFF2-40B4-BE49-F238E27FC236}">
-                <a16:creationId xmlns:a16="http://schemas.microsoft.com/office/drawing/2014/main" id="{C118932E-9EB7-42D7-831B-9C5168217CCD}"/>
+                <a16:creationId xmlns:a16="http://schemas.microsoft.com/office/drawing/2014/main" id="{E479E2B3-38D9-4081-87E8-E6F37F3DF6F3}"/>
               </a:ext>
             </a:extLst>
           </p:cNvPr>
@@ -8720,7 +8720,7 @@
           <p:cNvPr id="22" name="">
             <a:extLst xmlns:a="http://schemas.openxmlformats.org/drawingml/2006/main">
               <a:ext uri="{FF2B5EF4-FFF2-40B4-BE49-F238E27FC236}">
-                <a16:creationId xmlns:a16="http://schemas.microsoft.com/office/drawing/2014/main" id="{D57E5E54-1882-4AC8-A849-9BC1E37D4AB0}"/>
+                <a16:creationId xmlns:a16="http://schemas.microsoft.com/office/drawing/2014/main" id="{33A3A089-5354-48CC-8228-00D470B75701}"/>
               </a:ext>
             </a:extLst>
           </p:cNvPr>
@@ -8768,7 +8768,7 @@
     </p:spTree>
     <p:extLst>
       <p:ext uri="{BB962C8B-B14F-4D97-AF65-F5344CB8AC3E}">
-        <p14:creationId xmlns:p14="http://schemas.microsoft.com/office/powerpoint/2010/main" val="2085519014"/>
+        <p14:creationId xmlns:p14="http://schemas.microsoft.com/office/powerpoint/2010/main" val="756097917"/>
       </p:ext>
     </p:extLst>
   </p:cSld>
@@ -8799,7 +8799,7 @@
           <p:cNvPr id="1" name="">
             <a:extLst xmlns:a="http://schemas.openxmlformats.org/drawingml/2006/main">
               <a:ext uri="{FF2B5EF4-FFF2-40B4-BE49-F238E27FC236}">
-                <a16:creationId xmlns:a16="http://schemas.microsoft.com/office/drawing/2014/main" id="{2A28D9BF-3E11-448B-A0CE-DDDCDBEC801B}"/>
+                <a16:creationId xmlns:a16="http://schemas.microsoft.com/office/drawing/2014/main" id="{058075F2-E6A4-4C08-89E3-69C2F8F12BF6}"/>
               </a:ext>
             </a:extLst>
           </p:cNvPr>
@@ -8830,7 +8830,7 @@
           <p:cNvPr id="2" name="">
             <a:extLst xmlns:a="http://schemas.openxmlformats.org/drawingml/2006/main">
               <a:ext uri="{FF2B5EF4-FFF2-40B4-BE49-F238E27FC236}">
-                <a16:creationId xmlns:a16="http://schemas.microsoft.com/office/drawing/2014/main" id="{CC4F095B-7844-48AC-9082-E5F6B910C7FF}"/>
+                <a16:creationId xmlns:a16="http://schemas.microsoft.com/office/drawing/2014/main" id="{531F5A8C-B9B7-48BB-AA91-107205723F37}"/>
               </a:ext>
             </a:extLst>
           </p:cNvPr>
@@ -8880,7 +8880,7 @@
           <p:cNvPr id="3" name="">
             <a:extLst xmlns:a="http://schemas.openxmlformats.org/drawingml/2006/main">
               <a:ext uri="{FF2B5EF4-FFF2-40B4-BE49-F238E27FC236}">
-                <a16:creationId xmlns:a16="http://schemas.microsoft.com/office/drawing/2014/main" id="{B2B2CEDE-8ED2-4F7B-A588-AE5F7EB8859C}"/>
+                <a16:creationId xmlns:a16="http://schemas.microsoft.com/office/drawing/2014/main" id="{690215B5-2519-4199-8669-80E31089C125}"/>
               </a:ext>
             </a:extLst>
           </p:cNvPr>
@@ -8920,7 +8920,7 @@
                   <a:srgbClr val="0D1117"/>
                 </a:solidFill>
               </a:rPr>
-              <a:t>当前产品迭代只发布 Mac Intel，其他平台延后验证</a:t>
+              <a:t>0.1.0 已完成三个桌面平台的原生构建与启动验证</a:t>
             </a:r>
           </a:p>
         </p:txBody>
@@ -8930,7 +8930,7 @@
           <p:cNvPr id="4" name="">
             <a:extLst xmlns:a="http://schemas.openxmlformats.org/drawingml/2006/main">
               <a:ext uri="{FF2B5EF4-FFF2-40B4-BE49-F238E27FC236}">
-                <a16:creationId xmlns:a16="http://schemas.microsoft.com/office/drawing/2014/main" id="{41A9ED6A-846D-4256-AD3C-5C3A81F5D96A}"/>
+                <a16:creationId xmlns:a16="http://schemas.microsoft.com/office/drawing/2014/main" id="{D1E7ED6B-43F6-49AD-BB27-73FB748C72DE}"/>
               </a:ext>
             </a:extLst>
           </p:cNvPr>
@@ -8965,7 +8965,7 @@
           <p:cNvPr id="5" name="">
             <a:extLst xmlns:a="http://schemas.openxmlformats.org/drawingml/2006/main">
               <a:ext uri="{FF2B5EF4-FFF2-40B4-BE49-F238E27FC236}">
-                <a16:creationId xmlns:a16="http://schemas.microsoft.com/office/drawing/2014/main" id="{01B8B025-5094-43CC-A331-5A8D75AE90D2}"/>
+                <a16:creationId xmlns:a16="http://schemas.microsoft.com/office/drawing/2014/main" id="{62F52EEA-23FC-454F-A7ED-0862F70B6AAA}"/>
               </a:ext>
             </a:extLst>
           </p:cNvPr>
@@ -9015,7 +9015,7 @@
           <p:cNvPr id="6" name="">
             <a:extLst xmlns:a="http://schemas.openxmlformats.org/drawingml/2006/main">
               <a:ext uri="{FF2B5EF4-FFF2-40B4-BE49-F238E27FC236}">
-                <a16:creationId xmlns:a16="http://schemas.microsoft.com/office/drawing/2014/main" id="{4B84C070-F3CD-499E-9EF0-BC9A7DF598C1}"/>
+                <a16:creationId xmlns:a16="http://schemas.microsoft.com/office/drawing/2014/main" id="{15BAA25F-2566-4590-9CD4-034869A6DBF5}"/>
               </a:ext>
             </a:extLst>
           </p:cNvPr>
@@ -9082,7 +9082,7 @@
           <p:cNvPr id="7" name="">
             <a:extLst xmlns:a="http://schemas.openxmlformats.org/drawingml/2006/main">
               <a:ext uri="{FF2B5EF4-FFF2-40B4-BE49-F238E27FC236}">
-                <a16:creationId xmlns:a16="http://schemas.microsoft.com/office/drawing/2014/main" id="{CAD8DDDF-684B-434B-94BE-450AF85B4685}"/>
+                <a16:creationId xmlns:a16="http://schemas.microsoft.com/office/drawing/2014/main" id="{9D535468-F93A-4B47-A825-536FEC6030AB}"/>
               </a:ext>
             </a:extLst>
           </p:cNvPr>
@@ -9122,7 +9122,7 @@
                   <a:srgbClr val="0E6374"/>
                 </a:solidFill>
               </a:rPr>
-              <a:t>当前发布候选，包含 Intel runtime</a:t>
+              <a:t>Intel runner 验证，包含自持 runtime</a:t>
             </a:r>
           </a:p>
         </p:txBody>
@@ -9132,7 +9132,7 @@
           <p:cNvPr id="8" name="">
             <a:extLst xmlns:a="http://schemas.openxmlformats.org/drawingml/2006/main">
               <a:ext uri="{FF2B5EF4-FFF2-40B4-BE49-F238E27FC236}">
-                <a16:creationId xmlns:a16="http://schemas.microsoft.com/office/drawing/2014/main" id="{4C5E1C99-9047-4377-AC2F-8469897C21CD}"/>
+                <a16:creationId xmlns:a16="http://schemas.microsoft.com/office/drawing/2014/main" id="{D47F4FA2-C112-4BD6-8D2E-4DDF882052CD}"/>
               </a:ext>
             </a:extLst>
           </p:cNvPr>
@@ -9163,7 +9163,7 @@
           <p:cNvPr id="9" name="">
             <a:extLst xmlns:a="http://schemas.openxmlformats.org/drawingml/2006/main">
               <a:ext uri="{FF2B5EF4-FFF2-40B4-BE49-F238E27FC236}">
-                <a16:creationId xmlns:a16="http://schemas.microsoft.com/office/drawing/2014/main" id="{855EE0E5-9879-44C8-94AB-A7D9C5ABAB77}"/>
+                <a16:creationId xmlns:a16="http://schemas.microsoft.com/office/drawing/2014/main" id="{63C97E8C-EDD9-49BE-A60C-CCD9D9A21808}"/>
               </a:ext>
             </a:extLst>
           </p:cNvPr>
@@ -9198,7 +9198,7 @@
           <p:cNvPr id="10" name="">
             <a:extLst xmlns:a="http://schemas.openxmlformats.org/drawingml/2006/main">
               <a:ext uri="{FF2B5EF4-FFF2-40B4-BE49-F238E27FC236}">
-                <a16:creationId xmlns:a16="http://schemas.microsoft.com/office/drawing/2014/main" id="{0C38B180-E97E-4EF5-AEFC-FC808B9BC63D}"/>
+                <a16:creationId xmlns:a16="http://schemas.microsoft.com/office/drawing/2014/main" id="{767D5A05-2338-4230-979F-8ACB93832BCD}"/>
               </a:ext>
             </a:extLst>
           </p:cNvPr>
@@ -9248,7 +9248,7 @@
           <p:cNvPr id="11" name="">
             <a:extLst xmlns:a="http://schemas.openxmlformats.org/drawingml/2006/main">
               <a:ext uri="{FF2B5EF4-FFF2-40B4-BE49-F238E27FC236}">
-                <a16:creationId xmlns:a16="http://schemas.microsoft.com/office/drawing/2014/main" id="{64EEAAF6-F76A-4642-A75D-6BEF37DB6DB7}"/>
+                <a16:creationId xmlns:a16="http://schemas.microsoft.com/office/drawing/2014/main" id="{1D296BFB-43C3-42F7-AE59-FAE2FD52B817}"/>
               </a:ext>
             </a:extLst>
           </p:cNvPr>
@@ -9288,7 +9288,24 @@
                   <a:srgbClr val="0D1117"/>
                 </a:solidFill>
               </a:rPr>
-              <a:t>暂缓发布</a:t>
+              <a:t>BAI-Work-0.1.0-mac-arm64.dmg</a:t>
+            </a:r>
+          </a:p>
+          <a:p xmlns:a="http://schemas.openxmlformats.org/drawingml/2006/main">
+            <a:pPr algn="l">
+              <a:defRPr sz="1500" b="1">
+                <a:solidFill>
+                  <a:srgbClr val="0D1117"/>
+                </a:solidFill>
+              </a:defRPr>
+            </a:pPr>
+            <a:r>
+              <a:rPr sz="1500" b="1">
+                <a:solidFill>
+                  <a:srgbClr val="0D1117"/>
+                </a:solidFill>
+              </a:rPr>
+              <a:t>BAI-Work-0.1.0-mac-arm64.zip</a:t>
             </a:r>
           </a:p>
         </p:txBody>
@@ -9298,7 +9315,7 @@
           <p:cNvPr id="12" name="">
             <a:extLst xmlns:a="http://schemas.openxmlformats.org/drawingml/2006/main">
               <a:ext uri="{FF2B5EF4-FFF2-40B4-BE49-F238E27FC236}">
-                <a16:creationId xmlns:a16="http://schemas.microsoft.com/office/drawing/2014/main" id="{69265A9D-A895-4DEC-B641-BDF4782308B8}"/>
+                <a16:creationId xmlns:a16="http://schemas.microsoft.com/office/drawing/2014/main" id="{B5E46097-1D48-43CD-B906-C595E6474260}"/>
               </a:ext>
             </a:extLst>
           </p:cNvPr>
@@ -9338,7 +9355,7 @@
                   <a:srgbClr val="0E6374"/>
                 </a:solidFill>
               </a:rPr>
-              <a:t>Intel 版本稳定后再做真机验证</a:t>
+              <a:t>M1 runner 验证，使用官方 wheelhouse</a:t>
             </a:r>
           </a:p>
         </p:txBody>
@@ -9348,7 +9365,7 @@
           <p:cNvPr id="13" name="">
             <a:extLst xmlns:a="http://schemas.openxmlformats.org/drawingml/2006/main">
               <a:ext uri="{FF2B5EF4-FFF2-40B4-BE49-F238E27FC236}">
-                <a16:creationId xmlns:a16="http://schemas.microsoft.com/office/drawing/2014/main" id="{10903140-6708-4225-ADAB-9951003A096B}"/>
+                <a16:creationId xmlns:a16="http://schemas.microsoft.com/office/drawing/2014/main" id="{77018A15-73B6-417F-8FFE-344BB1E9C322}"/>
               </a:ext>
             </a:extLst>
           </p:cNvPr>
@@ -9379,7 +9396,7 @@
           <p:cNvPr id="14" name="">
             <a:extLst xmlns:a="http://schemas.openxmlformats.org/drawingml/2006/main">
               <a:ext uri="{FF2B5EF4-FFF2-40B4-BE49-F238E27FC236}">
-                <a16:creationId xmlns:a16="http://schemas.microsoft.com/office/drawing/2014/main" id="{EC4511F4-19C5-4E7A-9EDC-8F05F5289349}"/>
+                <a16:creationId xmlns:a16="http://schemas.microsoft.com/office/drawing/2014/main" id="{4E5363C7-404C-4609-9F3E-55329D5A2EEC}"/>
               </a:ext>
             </a:extLst>
           </p:cNvPr>
@@ -9414,7 +9431,7 @@
           <p:cNvPr id="15" name="">
             <a:extLst xmlns:a="http://schemas.openxmlformats.org/drawingml/2006/main">
               <a:ext uri="{FF2B5EF4-FFF2-40B4-BE49-F238E27FC236}">
-                <a16:creationId xmlns:a16="http://schemas.microsoft.com/office/drawing/2014/main" id="{ABDE33FD-C397-4FBA-AB42-AE77EDFE291C}"/>
+                <a16:creationId xmlns:a16="http://schemas.microsoft.com/office/drawing/2014/main" id="{B1D9D15D-CF3A-4335-BB6A-36D4DF29BDA6}"/>
               </a:ext>
             </a:extLst>
           </p:cNvPr>
@@ -9464,7 +9481,7 @@
           <p:cNvPr id="16" name="">
             <a:extLst xmlns:a="http://schemas.openxmlformats.org/drawingml/2006/main">
               <a:ext uri="{FF2B5EF4-FFF2-40B4-BE49-F238E27FC236}">
-                <a16:creationId xmlns:a16="http://schemas.microsoft.com/office/drawing/2014/main" id="{4CF94EF0-9BB2-4DFE-AE74-98CC07908E91}"/>
+                <a16:creationId xmlns:a16="http://schemas.microsoft.com/office/drawing/2014/main" id="{F2523D40-A1C5-4B12-B7DF-1EF5FEAB1BAA}"/>
               </a:ext>
             </a:extLst>
           </p:cNvPr>
@@ -9504,7 +9521,7 @@
                   <a:srgbClr val="0D1117"/>
                 </a:solidFill>
               </a:rPr>
-              <a:t>暂缓发布</a:t>
+              <a:t>BAI-Work-0.1.0-win-x64.exe</a:t>
             </a:r>
           </a:p>
         </p:txBody>
@@ -9514,7 +9531,7 @@
           <p:cNvPr id="17" name="">
             <a:extLst xmlns:a="http://schemas.openxmlformats.org/drawingml/2006/main">
               <a:ext uri="{FF2B5EF4-FFF2-40B4-BE49-F238E27FC236}">
-                <a16:creationId xmlns:a16="http://schemas.microsoft.com/office/drawing/2014/main" id="{E2AC6A81-5CAA-4766-8669-47C6828DF4E4}"/>
+                <a16:creationId xmlns:a16="http://schemas.microsoft.com/office/drawing/2014/main" id="{CB88522C-06B4-4505-920B-D8E306890E74}"/>
               </a:ext>
             </a:extLst>
           </p:cNvPr>
@@ -9554,7 +9571,7 @@
                   <a:srgbClr val="0E6374"/>
                 </a:solidFill>
               </a:rPr>
-              <a:t>Intel 版本稳定后再做安装验证</a:t>
+              <a:t>Windows 2025 runner 验证，NSIS 安装器</a:t>
             </a:r>
           </a:p>
         </p:txBody>
@@ -9564,7 +9581,7 @@
           <p:cNvPr id="18" name="">
             <a:extLst xmlns:a="http://schemas.openxmlformats.org/drawingml/2006/main">
               <a:ext uri="{FF2B5EF4-FFF2-40B4-BE49-F238E27FC236}">
-                <a16:creationId xmlns:a16="http://schemas.microsoft.com/office/drawing/2014/main" id="{B0FE9E3D-0CBB-494C-B44E-9DCE9081C3AE}"/>
+                <a16:creationId xmlns:a16="http://schemas.microsoft.com/office/drawing/2014/main" id="{F17D54E5-4C61-4CB9-9982-08AA6B1A0072}"/>
               </a:ext>
             </a:extLst>
           </p:cNvPr>
@@ -9595,7 +9612,7 @@
           <p:cNvPr id="19" name="">
             <a:extLst xmlns:a="http://schemas.openxmlformats.org/drawingml/2006/main">
               <a:ext uri="{FF2B5EF4-FFF2-40B4-BE49-F238E27FC236}">
-                <a16:creationId xmlns:a16="http://schemas.microsoft.com/office/drawing/2014/main" id="{F0BED767-D1B0-4AC0-A47A-BCB041851042}"/>
+                <a16:creationId xmlns:a16="http://schemas.microsoft.com/office/drawing/2014/main" id="{7FE16557-8299-4F08-BFC0-94E551A5D782}"/>
               </a:ext>
             </a:extLst>
           </p:cNvPr>
@@ -9630,7 +9647,7 @@
           <p:nvPr/>
         </p:nvPicPr>
         <p:blipFill>
-          <a:blip xmlns:r="http://schemas.openxmlformats.org/officeDocument/2006/relationships" xmlns:a="http://schemas.openxmlformats.org/drawingml/2006/main" r:embed="R009d2110d89a4489"/>
+          <a:blip xmlns:r="http://schemas.openxmlformats.org/officeDocument/2006/relationships" xmlns:a="http://schemas.openxmlformats.org/drawingml/2006/main" r:embed="R2d387e67187f4365"/>
           <a:stretch xmlns:a="http://schemas.openxmlformats.org/drawingml/2006/main"/>
         </p:blipFill>
         <p:spPr>
@@ -9648,7 +9665,7 @@
           <p:cNvPr id="21" name="">
             <a:extLst xmlns:a="http://schemas.openxmlformats.org/drawingml/2006/main">
               <a:ext uri="{FF2B5EF4-FFF2-40B4-BE49-F238E27FC236}">
-                <a16:creationId xmlns:a16="http://schemas.microsoft.com/office/drawing/2014/main" id="{4C6D192C-0D50-490D-9BDE-27A2AB95DDB7}"/>
+                <a16:creationId xmlns:a16="http://schemas.microsoft.com/office/drawing/2014/main" id="{7BFAB74F-7D39-4C40-A7AF-3B51AF36E399}"/>
               </a:ext>
             </a:extLst>
           </p:cNvPr>
@@ -9698,7 +9715,7 @@
           <p:cNvPr id="22" name="">
             <a:extLst xmlns:a="http://schemas.openxmlformats.org/drawingml/2006/main">
               <a:ext uri="{FF2B5EF4-FFF2-40B4-BE49-F238E27FC236}">
-                <a16:creationId xmlns:a16="http://schemas.microsoft.com/office/drawing/2014/main" id="{DA59AAEC-AD0C-460C-942C-DDCAFA3870DD}"/>
+                <a16:creationId xmlns:a16="http://schemas.microsoft.com/office/drawing/2014/main" id="{B3183199-DD09-4AAC-A9B2-B21958D65270}"/>
               </a:ext>
             </a:extLst>
           </p:cNvPr>
@@ -9746,7 +9763,7 @@
     </p:spTree>
     <p:extLst>
       <p:ext uri="{BB962C8B-B14F-4D97-AF65-F5344CB8AC3E}">
-        <p14:creationId xmlns:p14="http://schemas.microsoft.com/office/powerpoint/2010/main" val="546602073"/>
+        <p14:creationId xmlns:p14="http://schemas.microsoft.com/office/powerpoint/2010/main" val="635460999"/>
       </p:ext>
     </p:extLst>
   </p:cSld>
@@ -9777,7 +9794,7 @@
           <p:cNvPr id="1" name="">
             <a:extLst xmlns:a="http://schemas.openxmlformats.org/drawingml/2006/main">
               <a:ext uri="{FF2B5EF4-FFF2-40B4-BE49-F238E27FC236}">
-                <a16:creationId xmlns:a16="http://schemas.microsoft.com/office/drawing/2014/main" id="{3010BF72-A0B8-4792-96A2-16B8A3F4E62C}"/>
+                <a16:creationId xmlns:a16="http://schemas.microsoft.com/office/drawing/2014/main" id="{7A62A6D2-8A66-426C-96FC-1E2D689A7F36}"/>
               </a:ext>
             </a:extLst>
           </p:cNvPr>
@@ -9808,7 +9825,7 @@
           <p:cNvPr id="2" name="">
             <a:extLst xmlns:a="http://schemas.openxmlformats.org/drawingml/2006/main">
               <a:ext uri="{FF2B5EF4-FFF2-40B4-BE49-F238E27FC236}">
-                <a16:creationId xmlns:a16="http://schemas.microsoft.com/office/drawing/2014/main" id="{743F3EE4-D574-4CD2-9286-4B7B5EAB7B24}"/>
+                <a16:creationId xmlns:a16="http://schemas.microsoft.com/office/drawing/2014/main" id="{B3B17746-94DC-40CA-A67C-9DC8A237A560}"/>
               </a:ext>
             </a:extLst>
           </p:cNvPr>
@@ -9858,7 +9875,7 @@
           <p:cNvPr id="3" name="">
             <a:extLst xmlns:a="http://schemas.openxmlformats.org/drawingml/2006/main">
               <a:ext uri="{FF2B5EF4-FFF2-40B4-BE49-F238E27FC236}">
-                <a16:creationId xmlns:a16="http://schemas.microsoft.com/office/drawing/2014/main" id="{26996405-FC95-4BC2-95EC-1CEFA16AEF1D}"/>
+                <a16:creationId xmlns:a16="http://schemas.microsoft.com/office/drawing/2014/main" id="{FC94DF9D-2F55-41A8-B527-CE8BFA3FE7D3}"/>
               </a:ext>
             </a:extLst>
           </p:cNvPr>
@@ -9908,7 +9925,7 @@
           <p:cNvPr id="4" name="">
             <a:extLst xmlns:a="http://schemas.openxmlformats.org/drawingml/2006/main">
               <a:ext uri="{FF2B5EF4-FFF2-40B4-BE49-F238E27FC236}">
-                <a16:creationId xmlns:a16="http://schemas.microsoft.com/office/drawing/2014/main" id="{6D0F4EBA-D6C7-404F-8DE9-5F28E91D3853}"/>
+                <a16:creationId xmlns:a16="http://schemas.microsoft.com/office/drawing/2014/main" id="{6E64A927-8CBD-45E0-9825-AA9B1B2173B0}"/>
               </a:ext>
             </a:extLst>
           </p:cNvPr>
@@ -9939,7 +9956,7 @@
           <p:cNvPr id="5" name="">
             <a:extLst xmlns:a="http://schemas.openxmlformats.org/drawingml/2006/main">
               <a:ext uri="{FF2B5EF4-FFF2-40B4-BE49-F238E27FC236}">
-                <a16:creationId xmlns:a16="http://schemas.microsoft.com/office/drawing/2014/main" id="{D0B780DF-0817-4DDC-9D2C-D1DDA6124C2D}"/>
+                <a16:creationId xmlns:a16="http://schemas.microsoft.com/office/drawing/2014/main" id="{DDB9014D-BF39-48AC-B642-13B892F93E29}"/>
               </a:ext>
             </a:extLst>
           </p:cNvPr>
@@ -9989,7 +10006,7 @@
           <p:cNvPr id="6" name="">
             <a:extLst xmlns:a="http://schemas.openxmlformats.org/drawingml/2006/main">
               <a:ext uri="{FF2B5EF4-FFF2-40B4-BE49-F238E27FC236}">
-                <a16:creationId xmlns:a16="http://schemas.microsoft.com/office/drawing/2014/main" id="{1E581791-0E02-4841-8393-C8DC881E6C68}"/>
+                <a16:creationId xmlns:a16="http://schemas.microsoft.com/office/drawing/2014/main" id="{B486A72B-84A0-4D6D-A4A6-E5DD19A5767C}"/>
               </a:ext>
             </a:extLst>
           </p:cNvPr>
@@ -10039,7 +10056,7 @@
           <p:cNvPr id="7" name="">
             <a:extLst xmlns:a="http://schemas.openxmlformats.org/drawingml/2006/main">
               <a:ext uri="{FF2B5EF4-FFF2-40B4-BE49-F238E27FC236}">
-                <a16:creationId xmlns:a16="http://schemas.microsoft.com/office/drawing/2014/main" id="{DD0499C5-A8BA-4002-834A-7AEA2ABA53A2}"/>
+                <a16:creationId xmlns:a16="http://schemas.microsoft.com/office/drawing/2014/main" id="{BCEF7844-D144-4A49-BD84-23C87108D823}"/>
               </a:ext>
             </a:extLst>
           </p:cNvPr>
@@ -10070,7 +10087,7 @@
           <p:cNvPr id="8" name="">
             <a:extLst xmlns:a="http://schemas.openxmlformats.org/drawingml/2006/main">
               <a:ext uri="{FF2B5EF4-FFF2-40B4-BE49-F238E27FC236}">
-                <a16:creationId xmlns:a16="http://schemas.microsoft.com/office/drawing/2014/main" id="{1B8AD2C3-AA2A-4B40-B382-E920B969212B}"/>
+                <a16:creationId xmlns:a16="http://schemas.microsoft.com/office/drawing/2014/main" id="{BC02696C-DEED-4340-9E0D-F8C5C1CB9302}"/>
               </a:ext>
             </a:extLst>
           </p:cNvPr>
@@ -10120,7 +10137,7 @@
           <p:cNvPr id="9" name="">
             <a:extLst xmlns:a="http://schemas.openxmlformats.org/drawingml/2006/main">
               <a:ext uri="{FF2B5EF4-FFF2-40B4-BE49-F238E27FC236}">
-                <a16:creationId xmlns:a16="http://schemas.microsoft.com/office/drawing/2014/main" id="{8C50C3A6-2055-47C1-B624-13DB501D2115}"/>
+                <a16:creationId xmlns:a16="http://schemas.microsoft.com/office/drawing/2014/main" id="{9141E3F9-D7D3-4DC7-A82C-DC08375CE764}"/>
               </a:ext>
             </a:extLst>
           </p:cNvPr>
@@ -10170,7 +10187,7 @@
           <p:cNvPr id="10" name="">
             <a:extLst xmlns:a="http://schemas.openxmlformats.org/drawingml/2006/main">
               <a:ext uri="{FF2B5EF4-FFF2-40B4-BE49-F238E27FC236}">
-                <a16:creationId xmlns:a16="http://schemas.microsoft.com/office/drawing/2014/main" id="{DD25D27B-601F-4E4D-ACAD-7058350B2BC6}"/>
+                <a16:creationId xmlns:a16="http://schemas.microsoft.com/office/drawing/2014/main" id="{0E950A5F-7DCC-40F1-B40B-1CBFF58690CD}"/>
               </a:ext>
             </a:extLst>
           </p:cNvPr>
@@ -10201,7 +10218,7 @@
           <p:cNvPr id="11" name="">
             <a:extLst xmlns:a="http://schemas.openxmlformats.org/drawingml/2006/main">
               <a:ext uri="{FF2B5EF4-FFF2-40B4-BE49-F238E27FC236}">
-                <a16:creationId xmlns:a16="http://schemas.microsoft.com/office/drawing/2014/main" id="{893829E9-8697-4012-9B91-86F8D54F23A1}"/>
+                <a16:creationId xmlns:a16="http://schemas.microsoft.com/office/drawing/2014/main" id="{CC79426D-BFA8-419C-9EB5-BC3502135F41}"/>
               </a:ext>
             </a:extLst>
           </p:cNvPr>
@@ -10251,7 +10268,7 @@
           <p:cNvPr id="12" name="">
             <a:extLst xmlns:a="http://schemas.openxmlformats.org/drawingml/2006/main">
               <a:ext uri="{FF2B5EF4-FFF2-40B4-BE49-F238E27FC236}">
-                <a16:creationId xmlns:a16="http://schemas.microsoft.com/office/drawing/2014/main" id="{E71FA24B-2228-4B9D-AAEC-C65D32DA7066}"/>
+                <a16:creationId xmlns:a16="http://schemas.microsoft.com/office/drawing/2014/main" id="{6EBF0CC9-A027-4C3D-B796-8B1914D72966}"/>
               </a:ext>
             </a:extLst>
           </p:cNvPr>
@@ -10301,7 +10318,7 @@
           <p:cNvPr id="13" name="">
             <a:extLst xmlns:a="http://schemas.openxmlformats.org/drawingml/2006/main">
               <a:ext uri="{FF2B5EF4-FFF2-40B4-BE49-F238E27FC236}">
-                <a16:creationId xmlns:a16="http://schemas.microsoft.com/office/drawing/2014/main" id="{AA05AF52-6D9E-48BF-925B-D0B692E26B40}"/>
+                <a16:creationId xmlns:a16="http://schemas.microsoft.com/office/drawing/2014/main" id="{3FB5377C-3F89-4AA9-A29C-EC25527B76E6}"/>
               </a:ext>
             </a:extLst>
           </p:cNvPr>
@@ -10332,7 +10349,7 @@
           <p:cNvPr id="14" name="">
             <a:extLst xmlns:a="http://schemas.openxmlformats.org/drawingml/2006/main">
               <a:ext uri="{FF2B5EF4-FFF2-40B4-BE49-F238E27FC236}">
-                <a16:creationId xmlns:a16="http://schemas.microsoft.com/office/drawing/2014/main" id="{381889D4-9C5F-465C-AB45-B03EB965C084}"/>
+                <a16:creationId xmlns:a16="http://schemas.microsoft.com/office/drawing/2014/main" id="{92772297-5E29-40DE-9F0C-C8FF41469E6B}"/>
               </a:ext>
             </a:extLst>
           </p:cNvPr>
@@ -10382,7 +10399,7 @@
           <p:cNvPr id="15" name="">
             <a:extLst xmlns:a="http://schemas.openxmlformats.org/drawingml/2006/main">
               <a:ext uri="{FF2B5EF4-FFF2-40B4-BE49-F238E27FC236}">
-                <a16:creationId xmlns:a16="http://schemas.microsoft.com/office/drawing/2014/main" id="{BE5E0397-040D-4241-A026-E7410DAD178D}"/>
+                <a16:creationId xmlns:a16="http://schemas.microsoft.com/office/drawing/2014/main" id="{AEE2BBC8-2531-4D5B-B81F-10C3AA9278C2}"/>
               </a:ext>
             </a:extLst>
           </p:cNvPr>
@@ -10432,7 +10449,7 @@
           <p:cNvPr id="16" name="">
             <a:extLst xmlns:a="http://schemas.openxmlformats.org/drawingml/2006/main">
               <a:ext uri="{FF2B5EF4-FFF2-40B4-BE49-F238E27FC236}">
-                <a16:creationId xmlns:a16="http://schemas.microsoft.com/office/drawing/2014/main" id="{0757D85E-BCBE-41E1-A4E1-4600FF1A8517}"/>
+                <a16:creationId xmlns:a16="http://schemas.microsoft.com/office/drawing/2014/main" id="{DD3A15B7-6C05-47CA-8D26-F97A110B2F4B}"/>
               </a:ext>
             </a:extLst>
           </p:cNvPr>
@@ -10463,7 +10480,7 @@
           <p:cNvPr id="17" name="">
             <a:extLst xmlns:a="http://schemas.openxmlformats.org/drawingml/2006/main">
               <a:ext uri="{FF2B5EF4-FFF2-40B4-BE49-F238E27FC236}">
-                <a16:creationId xmlns:a16="http://schemas.microsoft.com/office/drawing/2014/main" id="{C2813D3F-A60A-459A-8D7E-4937BDD5DE50}"/>
+                <a16:creationId xmlns:a16="http://schemas.microsoft.com/office/drawing/2014/main" id="{D7A49BD0-0364-4E6B-B7AF-543553924DDB}"/>
               </a:ext>
             </a:extLst>
           </p:cNvPr>
@@ -10513,7 +10530,7 @@
           <p:cNvPr id="18" name="">
             <a:extLst xmlns:a="http://schemas.openxmlformats.org/drawingml/2006/main">
               <a:ext uri="{FF2B5EF4-FFF2-40B4-BE49-F238E27FC236}">
-                <a16:creationId xmlns:a16="http://schemas.microsoft.com/office/drawing/2014/main" id="{B71EB617-622F-4091-A8E2-831DBEBA3444}"/>
+                <a16:creationId xmlns:a16="http://schemas.microsoft.com/office/drawing/2014/main" id="{1F702AAC-54CF-426F-B4E4-BD17B3B4FFFE}"/>
               </a:ext>
             </a:extLst>
           </p:cNvPr>
@@ -10563,7 +10580,7 @@
           <p:cNvPr id="19" name="">
             <a:extLst xmlns:a="http://schemas.openxmlformats.org/drawingml/2006/main">
               <a:ext uri="{FF2B5EF4-FFF2-40B4-BE49-F238E27FC236}">
-                <a16:creationId xmlns:a16="http://schemas.microsoft.com/office/drawing/2014/main" id="{106CC229-D3B1-49B7-8A06-CC76CDDABE14}"/>
+                <a16:creationId xmlns:a16="http://schemas.microsoft.com/office/drawing/2014/main" id="{F6B79155-520E-460C-B4C4-7D14838EFF1F}"/>
               </a:ext>
             </a:extLst>
           </p:cNvPr>
@@ -10598,7 +10615,7 @@
           <p:nvPr/>
         </p:nvPicPr>
         <p:blipFill>
-          <a:blip xmlns:r="http://schemas.openxmlformats.org/officeDocument/2006/relationships" xmlns:a="http://schemas.openxmlformats.org/drawingml/2006/main" r:embed="R65973ab3a8814a4c"/>
+          <a:blip xmlns:r="http://schemas.openxmlformats.org/officeDocument/2006/relationships" xmlns:a="http://schemas.openxmlformats.org/drawingml/2006/main" r:embed="R29ac850648a948b1"/>
           <a:stretch xmlns:a="http://schemas.openxmlformats.org/drawingml/2006/main"/>
         </p:blipFill>
         <p:spPr>
@@ -10616,7 +10633,7 @@
           <p:cNvPr id="21" name="">
             <a:extLst xmlns:a="http://schemas.openxmlformats.org/drawingml/2006/main">
               <a:ext uri="{FF2B5EF4-FFF2-40B4-BE49-F238E27FC236}">
-                <a16:creationId xmlns:a16="http://schemas.microsoft.com/office/drawing/2014/main" id="{8B109573-49FF-4BFD-B3F9-CB343D166824}"/>
+                <a16:creationId xmlns:a16="http://schemas.microsoft.com/office/drawing/2014/main" id="{360ED614-FD16-4191-B6CD-A2A497B51A29}"/>
               </a:ext>
             </a:extLst>
           </p:cNvPr>
@@ -10666,7 +10683,7 @@
           <p:cNvPr id="22" name="">
             <a:extLst xmlns:a="http://schemas.openxmlformats.org/drawingml/2006/main">
               <a:ext uri="{FF2B5EF4-FFF2-40B4-BE49-F238E27FC236}">
-                <a16:creationId xmlns:a16="http://schemas.microsoft.com/office/drawing/2014/main" id="{55B403B9-E64A-47E1-8689-D917FED8E688}"/>
+                <a16:creationId xmlns:a16="http://schemas.microsoft.com/office/drawing/2014/main" id="{538E92EB-665D-4C8B-8F34-B98E60807352}"/>
               </a:ext>
             </a:extLst>
           </p:cNvPr>
@@ -10714,7 +10731,7 @@
     </p:spTree>
     <p:extLst>
       <p:ext uri="{BB962C8B-B14F-4D97-AF65-F5344CB8AC3E}">
-        <p14:creationId xmlns:p14="http://schemas.microsoft.com/office/powerpoint/2010/main" val="1917221367"/>
+        <p14:creationId xmlns:p14="http://schemas.microsoft.com/office/powerpoint/2010/main" val="1823719505"/>
       </p:ext>
     </p:extLst>
   </p:cSld>
@@ -10745,7 +10762,7 @@
           <p:cNvPr id="1" name="">
             <a:extLst xmlns:a="http://schemas.openxmlformats.org/drawingml/2006/main">
               <a:ext uri="{FF2B5EF4-FFF2-40B4-BE49-F238E27FC236}">
-                <a16:creationId xmlns:a16="http://schemas.microsoft.com/office/drawing/2014/main" id="{31D75E08-C3E5-4873-A489-CDC98F5A30A1}"/>
+                <a16:creationId xmlns:a16="http://schemas.microsoft.com/office/drawing/2014/main" id="{400A2C84-A01F-4812-8C5B-C29A362AB4FB}"/>
               </a:ext>
             </a:extLst>
           </p:cNvPr>
@@ -10776,7 +10793,7 @@
           <p:cNvPr id="2" name="">
             <a:extLst xmlns:a="http://schemas.openxmlformats.org/drawingml/2006/main">
               <a:ext uri="{FF2B5EF4-FFF2-40B4-BE49-F238E27FC236}">
-                <a16:creationId xmlns:a16="http://schemas.microsoft.com/office/drawing/2014/main" id="{5B8BFEA8-F902-44AF-AA68-FA014FA6600F}"/>
+                <a16:creationId xmlns:a16="http://schemas.microsoft.com/office/drawing/2014/main" id="{DB20F5AA-44BB-450F-9DD6-DD16EE6E7FE8}"/>
               </a:ext>
             </a:extLst>
           </p:cNvPr>
@@ -10826,7 +10843,7 @@
           <p:cNvPr id="3" name="">
             <a:extLst xmlns:a="http://schemas.openxmlformats.org/drawingml/2006/main">
               <a:ext uri="{FF2B5EF4-FFF2-40B4-BE49-F238E27FC236}">
-                <a16:creationId xmlns:a16="http://schemas.microsoft.com/office/drawing/2014/main" id="{729236BA-18D4-4C87-9BCE-8D339956A54F}"/>
+                <a16:creationId xmlns:a16="http://schemas.microsoft.com/office/drawing/2014/main" id="{4DD214A4-280C-4ECB-B9BE-ABADF0B3C4E0}"/>
               </a:ext>
             </a:extLst>
           </p:cNvPr>
@@ -10876,7 +10893,7 @@
           <p:cNvPr id="4" name="">
             <a:extLst xmlns:a="http://schemas.openxmlformats.org/drawingml/2006/main">
               <a:ext uri="{FF2B5EF4-FFF2-40B4-BE49-F238E27FC236}">
-                <a16:creationId xmlns:a16="http://schemas.microsoft.com/office/drawing/2014/main" id="{48778B29-60A1-4CDE-B88D-30E2A00A8FD1}"/>
+                <a16:creationId xmlns:a16="http://schemas.microsoft.com/office/drawing/2014/main" id="{C3B1EE4A-A78E-4142-BB40-C9F065C48B69}"/>
               </a:ext>
             </a:extLst>
           </p:cNvPr>
@@ -10926,7 +10943,7 @@
           <p:cNvPr id="5" name="">
             <a:extLst xmlns:a="http://schemas.openxmlformats.org/drawingml/2006/main">
               <a:ext uri="{FF2B5EF4-FFF2-40B4-BE49-F238E27FC236}">
-                <a16:creationId xmlns:a16="http://schemas.microsoft.com/office/drawing/2014/main" id="{8D58C76A-E848-4768-A5BD-80504BA3E260}"/>
+                <a16:creationId xmlns:a16="http://schemas.microsoft.com/office/drawing/2014/main" id="{A1159AF4-74B4-4B4F-8B54-7B943ECACA78}"/>
               </a:ext>
             </a:extLst>
           </p:cNvPr>
@@ -10957,7 +10974,7 @@
           <p:cNvPr id="6" name="">
             <a:extLst xmlns:a="http://schemas.openxmlformats.org/drawingml/2006/main">
               <a:ext uri="{FF2B5EF4-FFF2-40B4-BE49-F238E27FC236}">
-                <a16:creationId xmlns:a16="http://schemas.microsoft.com/office/drawing/2014/main" id="{5265487C-79D8-4B5D-A709-B0FDBB3425CF}"/>
+                <a16:creationId xmlns:a16="http://schemas.microsoft.com/office/drawing/2014/main" id="{E42DA8E1-71BB-43EE-9224-B207240D8BBF}"/>
               </a:ext>
             </a:extLst>
           </p:cNvPr>
@@ -11007,7 +11024,7 @@
           <p:cNvPr id="7" name="">
             <a:extLst xmlns:a="http://schemas.openxmlformats.org/drawingml/2006/main">
               <a:ext uri="{FF2B5EF4-FFF2-40B4-BE49-F238E27FC236}">
-                <a16:creationId xmlns:a16="http://schemas.microsoft.com/office/drawing/2014/main" id="{879288D1-3285-49B0-ACBF-07F859676DAA}"/>
+                <a16:creationId xmlns:a16="http://schemas.microsoft.com/office/drawing/2014/main" id="{3F954D7D-4CAF-4E5C-AD89-1D471F36E83D}"/>
               </a:ext>
             </a:extLst>
           </p:cNvPr>
@@ -11057,7 +11074,7 @@
           <p:cNvPr id="8" name="">
             <a:extLst xmlns:a="http://schemas.openxmlformats.org/drawingml/2006/main">
               <a:ext uri="{FF2B5EF4-FFF2-40B4-BE49-F238E27FC236}">
-                <a16:creationId xmlns:a16="http://schemas.microsoft.com/office/drawing/2014/main" id="{D6F4D2DF-36DF-4143-8CC9-3858DAEAFC94}"/>
+                <a16:creationId xmlns:a16="http://schemas.microsoft.com/office/drawing/2014/main" id="{D9451D0B-7F84-4EF2-8EE1-5ED101D22A07}"/>
               </a:ext>
             </a:extLst>
           </p:cNvPr>
@@ -11088,7 +11105,7 @@
           <p:cNvPr id="9" name="">
             <a:extLst xmlns:a="http://schemas.openxmlformats.org/drawingml/2006/main">
               <a:ext uri="{FF2B5EF4-FFF2-40B4-BE49-F238E27FC236}">
-                <a16:creationId xmlns:a16="http://schemas.microsoft.com/office/drawing/2014/main" id="{3E20CF56-DD63-436E-8403-0E943B250800}"/>
+                <a16:creationId xmlns:a16="http://schemas.microsoft.com/office/drawing/2014/main" id="{C26F9A81-17B3-4B36-AD84-7757686AAE44}"/>
               </a:ext>
             </a:extLst>
           </p:cNvPr>
@@ -11138,7 +11155,7 @@
           <p:cNvPr id="10" name="">
             <a:extLst xmlns:a="http://schemas.openxmlformats.org/drawingml/2006/main">
               <a:ext uri="{FF2B5EF4-FFF2-40B4-BE49-F238E27FC236}">
-                <a16:creationId xmlns:a16="http://schemas.microsoft.com/office/drawing/2014/main" id="{7EC6F346-52A1-48ED-893F-757A94608793}"/>
+                <a16:creationId xmlns:a16="http://schemas.microsoft.com/office/drawing/2014/main" id="{E094EDDF-AD1C-45EB-BB0A-3A8059B8B5C0}"/>
               </a:ext>
             </a:extLst>
           </p:cNvPr>
@@ -11188,7 +11205,7 @@
           <p:cNvPr id="11" name="">
             <a:extLst xmlns:a="http://schemas.openxmlformats.org/drawingml/2006/main">
               <a:ext uri="{FF2B5EF4-FFF2-40B4-BE49-F238E27FC236}">
-                <a16:creationId xmlns:a16="http://schemas.microsoft.com/office/drawing/2014/main" id="{4BB04AE8-484B-42BA-BE89-E9A5A4C1EFCD}"/>
+                <a16:creationId xmlns:a16="http://schemas.microsoft.com/office/drawing/2014/main" id="{65E77E6C-655B-49C8-AC3E-EDDD2C13CFFB}"/>
               </a:ext>
             </a:extLst>
           </p:cNvPr>
@@ -11219,7 +11236,7 @@
           <p:cNvPr id="12" name="">
             <a:extLst xmlns:a="http://schemas.openxmlformats.org/drawingml/2006/main">
               <a:ext uri="{FF2B5EF4-FFF2-40B4-BE49-F238E27FC236}">
-                <a16:creationId xmlns:a16="http://schemas.microsoft.com/office/drawing/2014/main" id="{F757979A-4371-4B5A-8139-E15DE4B2FE31}"/>
+                <a16:creationId xmlns:a16="http://schemas.microsoft.com/office/drawing/2014/main" id="{8DD54F70-07F6-476A-95A7-B2E89A3D8003}"/>
               </a:ext>
             </a:extLst>
           </p:cNvPr>
@@ -11269,7 +11286,7 @@
           <p:cNvPr id="13" name="">
             <a:extLst xmlns:a="http://schemas.openxmlformats.org/drawingml/2006/main">
               <a:ext uri="{FF2B5EF4-FFF2-40B4-BE49-F238E27FC236}">
-                <a16:creationId xmlns:a16="http://schemas.microsoft.com/office/drawing/2014/main" id="{2E54F6FE-A87D-46CC-BFA8-939C5B5EFCF4}"/>
+                <a16:creationId xmlns:a16="http://schemas.microsoft.com/office/drawing/2014/main" id="{0DCA98D6-AE8A-407F-A076-D5B64239878F}"/>
               </a:ext>
             </a:extLst>
           </p:cNvPr>
@@ -11319,7 +11336,7 @@
           <p:cNvPr id="14" name="">
             <a:extLst xmlns:a="http://schemas.openxmlformats.org/drawingml/2006/main">
               <a:ext uri="{FF2B5EF4-FFF2-40B4-BE49-F238E27FC236}">
-                <a16:creationId xmlns:a16="http://schemas.microsoft.com/office/drawing/2014/main" id="{35F94BA6-2FFA-40B7-9711-2C52B2E6AF28}"/>
+                <a16:creationId xmlns:a16="http://schemas.microsoft.com/office/drawing/2014/main" id="{467257FD-8684-482F-858B-26EB0BDFEF49}"/>
               </a:ext>
             </a:extLst>
           </p:cNvPr>
@@ -11350,7 +11367,7 @@
           <p:cNvPr id="15" name="">
             <a:extLst xmlns:a="http://schemas.openxmlformats.org/drawingml/2006/main">
               <a:ext uri="{FF2B5EF4-FFF2-40B4-BE49-F238E27FC236}">
-                <a16:creationId xmlns:a16="http://schemas.microsoft.com/office/drawing/2014/main" id="{3522883F-1145-4A06-8421-82EDE91487F0}"/>
+                <a16:creationId xmlns:a16="http://schemas.microsoft.com/office/drawing/2014/main" id="{C31C3627-E2E0-4AB3-8425-E33A2256C2CF}"/>
               </a:ext>
             </a:extLst>
           </p:cNvPr>
@@ -11400,7 +11417,7 @@
           <p:cNvPr id="16" name="">
             <a:extLst xmlns:a="http://schemas.openxmlformats.org/drawingml/2006/main">
               <a:ext uri="{FF2B5EF4-FFF2-40B4-BE49-F238E27FC236}">
-                <a16:creationId xmlns:a16="http://schemas.microsoft.com/office/drawing/2014/main" id="{1DDEDD0F-A152-4CE8-9308-0E51D639D225}"/>
+                <a16:creationId xmlns:a16="http://schemas.microsoft.com/office/drawing/2014/main" id="{28E6F040-BF78-474D-A6CE-70CB5C79D723}"/>
               </a:ext>
             </a:extLst>
           </p:cNvPr>
@@ -11450,7 +11467,7 @@
           <p:cNvPr id="17" name="">
             <a:extLst xmlns:a="http://schemas.openxmlformats.org/drawingml/2006/main">
               <a:ext uri="{FF2B5EF4-FFF2-40B4-BE49-F238E27FC236}">
-                <a16:creationId xmlns:a16="http://schemas.microsoft.com/office/drawing/2014/main" id="{402DD007-7CE2-4A21-A04E-29257AFBE180}"/>
+                <a16:creationId xmlns:a16="http://schemas.microsoft.com/office/drawing/2014/main" id="{AE0ACE27-847A-44F1-80B5-1BF8F268E968}"/>
               </a:ext>
             </a:extLst>
           </p:cNvPr>
@@ -11481,7 +11498,7 @@
           <p:cNvPr id="18" name="">
             <a:extLst xmlns:a="http://schemas.openxmlformats.org/drawingml/2006/main">
               <a:ext uri="{FF2B5EF4-FFF2-40B4-BE49-F238E27FC236}">
-                <a16:creationId xmlns:a16="http://schemas.microsoft.com/office/drawing/2014/main" id="{291CBD8F-C602-4992-9BF9-D8C198FB9AEC}"/>
+                <a16:creationId xmlns:a16="http://schemas.microsoft.com/office/drawing/2014/main" id="{0D6EE375-39E8-4D0E-9CAF-E6AA396B2238}"/>
               </a:ext>
             </a:extLst>
           </p:cNvPr>
@@ -11531,7 +11548,7 @@
           <p:cNvPr id="19" name="">
             <a:extLst xmlns:a="http://schemas.openxmlformats.org/drawingml/2006/main">
               <a:ext uri="{FF2B5EF4-FFF2-40B4-BE49-F238E27FC236}">
-                <a16:creationId xmlns:a16="http://schemas.microsoft.com/office/drawing/2014/main" id="{05B5F85D-FCF4-47AC-8C79-9AAB0C5A5472}"/>
+                <a16:creationId xmlns:a16="http://schemas.microsoft.com/office/drawing/2014/main" id="{04F48020-B5D4-4E55-A214-DD64520E8660}"/>
               </a:ext>
             </a:extLst>
           </p:cNvPr>
@@ -11566,7 +11583,7 @@
           <p:nvPr/>
         </p:nvPicPr>
         <p:blipFill>
-          <a:blip xmlns:r="http://schemas.openxmlformats.org/officeDocument/2006/relationships" xmlns:a="http://schemas.openxmlformats.org/drawingml/2006/main" r:embed="R4fe42b23099c4828"/>
+          <a:blip xmlns:r="http://schemas.openxmlformats.org/officeDocument/2006/relationships" xmlns:a="http://schemas.openxmlformats.org/drawingml/2006/main" r:embed="R6759dacc0d1c4734"/>
           <a:stretch xmlns:a="http://schemas.openxmlformats.org/drawingml/2006/main"/>
         </p:blipFill>
         <p:spPr>
@@ -11584,7 +11601,7 @@
           <p:cNvPr id="21" name="">
             <a:extLst xmlns:a="http://schemas.openxmlformats.org/drawingml/2006/main">
               <a:ext uri="{FF2B5EF4-FFF2-40B4-BE49-F238E27FC236}">
-                <a16:creationId xmlns:a16="http://schemas.microsoft.com/office/drawing/2014/main" id="{50B99153-2B52-4A85-87C7-6E3295983A4B}"/>
+                <a16:creationId xmlns:a16="http://schemas.microsoft.com/office/drawing/2014/main" id="{2364EF8B-4060-4F43-BE49-958D16E6C413}"/>
               </a:ext>
             </a:extLst>
           </p:cNvPr>
@@ -11634,7 +11651,7 @@
           <p:cNvPr id="22" name="">
             <a:extLst xmlns:a="http://schemas.openxmlformats.org/drawingml/2006/main">
               <a:ext uri="{FF2B5EF4-FFF2-40B4-BE49-F238E27FC236}">
-                <a16:creationId xmlns:a16="http://schemas.microsoft.com/office/drawing/2014/main" id="{C9C47983-1677-4EB5-B621-95B9BF9D5DB8}"/>
+                <a16:creationId xmlns:a16="http://schemas.microsoft.com/office/drawing/2014/main" id="{0815BD8D-9C75-41D2-AC3B-B521ECA36ECD}"/>
               </a:ext>
             </a:extLst>
           </p:cNvPr>
@@ -11682,7 +11699,7 @@
     </p:spTree>
     <p:extLst>
       <p:ext uri="{BB962C8B-B14F-4D97-AF65-F5344CB8AC3E}">
-        <p14:creationId xmlns:p14="http://schemas.microsoft.com/office/powerpoint/2010/main" val="671997685"/>
+        <p14:creationId xmlns:p14="http://schemas.microsoft.com/office/powerpoint/2010/main" val="1613608530"/>
       </p:ext>
     </p:extLst>
   </p:cSld>
@@ -11713,7 +11730,7 @@
           <p:cNvPr id="1" name="">
             <a:extLst xmlns:a="http://schemas.openxmlformats.org/drawingml/2006/main">
               <a:ext uri="{FF2B5EF4-FFF2-40B4-BE49-F238E27FC236}">
-                <a16:creationId xmlns:a16="http://schemas.microsoft.com/office/drawing/2014/main" id="{CDF7EF94-D391-4E37-A36B-B06DB86F5D47}"/>
+                <a16:creationId xmlns:a16="http://schemas.microsoft.com/office/drawing/2014/main" id="{231E0CC9-36F2-4E5C-B56D-20277B62CE67}"/>
               </a:ext>
             </a:extLst>
           </p:cNvPr>
@@ -11744,7 +11761,7 @@
           <p:cNvPr id="2" name="">
             <a:extLst xmlns:a="http://schemas.openxmlformats.org/drawingml/2006/main">
               <a:ext uri="{FF2B5EF4-FFF2-40B4-BE49-F238E27FC236}">
-                <a16:creationId xmlns:a16="http://schemas.microsoft.com/office/drawing/2014/main" id="{C79B6008-0CCB-43E9-9EF7-02CBCD7B1725}"/>
+                <a16:creationId xmlns:a16="http://schemas.microsoft.com/office/drawing/2014/main" id="{875108DF-FD8C-4145-ADEC-9CB07A196A79}"/>
               </a:ext>
             </a:extLst>
           </p:cNvPr>
@@ -11794,7 +11811,7 @@
           <p:cNvPr id="3" name="">
             <a:extLst xmlns:a="http://schemas.openxmlformats.org/drawingml/2006/main">
               <a:ext uri="{FF2B5EF4-FFF2-40B4-BE49-F238E27FC236}">
-                <a16:creationId xmlns:a16="http://schemas.microsoft.com/office/drawing/2014/main" id="{AF6DC803-52DD-4F7B-B908-06F09D8B47AF}"/>
+                <a16:creationId xmlns:a16="http://schemas.microsoft.com/office/drawing/2014/main" id="{B0FB2A34-6DAF-4896-AD25-AD111D1ACF77}"/>
               </a:ext>
             </a:extLst>
           </p:cNvPr>
@@ -11844,7 +11861,7 @@
           <p:cNvPr id="4" name="">
             <a:extLst xmlns:a="http://schemas.openxmlformats.org/drawingml/2006/main">
               <a:ext uri="{FF2B5EF4-FFF2-40B4-BE49-F238E27FC236}">
-                <a16:creationId xmlns:a16="http://schemas.microsoft.com/office/drawing/2014/main" id="{391D70A0-3ABD-4CA9-B501-3F6252F3E6DD}"/>
+                <a16:creationId xmlns:a16="http://schemas.microsoft.com/office/drawing/2014/main" id="{899AFE4E-86E1-4EC1-A44C-788DA2424DBC}"/>
               </a:ext>
             </a:extLst>
           </p:cNvPr>
@@ -11879,7 +11896,7 @@
           <p:cNvPr id="5" name="">
             <a:extLst xmlns:a="http://schemas.openxmlformats.org/drawingml/2006/main">
               <a:ext uri="{FF2B5EF4-FFF2-40B4-BE49-F238E27FC236}">
-                <a16:creationId xmlns:a16="http://schemas.microsoft.com/office/drawing/2014/main" id="{6E9F9304-45A8-483C-9780-C040DB1121BC}"/>
+                <a16:creationId xmlns:a16="http://schemas.microsoft.com/office/drawing/2014/main" id="{311F0607-22BF-449E-BFD1-59E564229B17}"/>
               </a:ext>
             </a:extLst>
           </p:cNvPr>
@@ -11929,7 +11946,7 @@
           <p:cNvPr id="6" name="">
             <a:extLst xmlns:a="http://schemas.openxmlformats.org/drawingml/2006/main">
               <a:ext uri="{FF2B5EF4-FFF2-40B4-BE49-F238E27FC236}">
-                <a16:creationId xmlns:a16="http://schemas.microsoft.com/office/drawing/2014/main" id="{96E0489D-1F60-4015-8DDB-F0821B80FDD6}"/>
+                <a16:creationId xmlns:a16="http://schemas.microsoft.com/office/drawing/2014/main" id="{DBDAC530-0773-46DF-8F0C-0C2A00E19E4B}"/>
               </a:ext>
             </a:extLst>
           </p:cNvPr>
@@ -11960,7 +11977,7 @@
           <p:cNvPr id="7" name="">
             <a:extLst xmlns:a="http://schemas.openxmlformats.org/drawingml/2006/main">
               <a:ext uri="{FF2B5EF4-FFF2-40B4-BE49-F238E27FC236}">
-                <a16:creationId xmlns:a16="http://schemas.microsoft.com/office/drawing/2014/main" id="{F1C7814A-2B13-4FDF-8481-7062B9FEB4A2}"/>
+                <a16:creationId xmlns:a16="http://schemas.microsoft.com/office/drawing/2014/main" id="{2D5F76EB-AF05-4196-843B-251085E57483}"/>
               </a:ext>
             </a:extLst>
           </p:cNvPr>
@@ -12010,7 +12027,7 @@
           <p:cNvPr id="8" name="">
             <a:extLst xmlns:a="http://schemas.openxmlformats.org/drawingml/2006/main">
               <a:ext uri="{FF2B5EF4-FFF2-40B4-BE49-F238E27FC236}">
-                <a16:creationId xmlns:a16="http://schemas.microsoft.com/office/drawing/2014/main" id="{A379A63B-B9C1-46D1-B93C-4014B824918C}"/>
+                <a16:creationId xmlns:a16="http://schemas.microsoft.com/office/drawing/2014/main" id="{4E3D12A7-25EA-4281-9645-3F42CAFFD0B6}"/>
               </a:ext>
             </a:extLst>
           </p:cNvPr>
@@ -12041,7 +12058,7 @@
           <p:cNvPr id="9" name="">
             <a:extLst xmlns:a="http://schemas.openxmlformats.org/drawingml/2006/main">
               <a:ext uri="{FF2B5EF4-FFF2-40B4-BE49-F238E27FC236}">
-                <a16:creationId xmlns:a16="http://schemas.microsoft.com/office/drawing/2014/main" id="{934E3511-B206-46D3-BE07-0E16184444F2}"/>
+                <a16:creationId xmlns:a16="http://schemas.microsoft.com/office/drawing/2014/main" id="{173FFFF1-45CA-48AF-8111-5430D7F1AE78}"/>
               </a:ext>
             </a:extLst>
           </p:cNvPr>
@@ -12091,7 +12108,7 @@
           <p:cNvPr id="10" name="">
             <a:extLst xmlns:a="http://schemas.openxmlformats.org/drawingml/2006/main">
               <a:ext uri="{FF2B5EF4-FFF2-40B4-BE49-F238E27FC236}">
-                <a16:creationId xmlns:a16="http://schemas.microsoft.com/office/drawing/2014/main" id="{1028E668-6945-4C66-BE30-013A427FD30A}"/>
+                <a16:creationId xmlns:a16="http://schemas.microsoft.com/office/drawing/2014/main" id="{8B317475-ABAC-48BB-8131-79E3EE3F58E4}"/>
               </a:ext>
             </a:extLst>
           </p:cNvPr>
@@ -12122,7 +12139,7 @@
           <p:cNvPr id="11" name="">
             <a:extLst xmlns:a="http://schemas.openxmlformats.org/drawingml/2006/main">
               <a:ext uri="{FF2B5EF4-FFF2-40B4-BE49-F238E27FC236}">
-                <a16:creationId xmlns:a16="http://schemas.microsoft.com/office/drawing/2014/main" id="{08CB0CE8-CCA8-4CEF-9CDE-42C0AEE0FE3C}"/>
+                <a16:creationId xmlns:a16="http://schemas.microsoft.com/office/drawing/2014/main" id="{FE628BE9-4BE4-4AD6-88D3-C6EFD72E3AD3}"/>
               </a:ext>
             </a:extLst>
           </p:cNvPr>
@@ -12172,7 +12189,7 @@
           <p:cNvPr id="12" name="">
             <a:extLst xmlns:a="http://schemas.openxmlformats.org/drawingml/2006/main">
               <a:ext uri="{FF2B5EF4-FFF2-40B4-BE49-F238E27FC236}">
-                <a16:creationId xmlns:a16="http://schemas.microsoft.com/office/drawing/2014/main" id="{2871F8B1-4CC6-4EF2-BA08-D40B95083CAF}"/>
+                <a16:creationId xmlns:a16="http://schemas.microsoft.com/office/drawing/2014/main" id="{2109A5AD-38A8-4378-BBFE-3B0146CF4269}"/>
               </a:ext>
             </a:extLst>
           </p:cNvPr>
@@ -12207,7 +12224,7 @@
           <p:cNvPr id="13" name="">
             <a:extLst xmlns:a="http://schemas.openxmlformats.org/drawingml/2006/main">
               <a:ext uri="{FF2B5EF4-FFF2-40B4-BE49-F238E27FC236}">
-                <a16:creationId xmlns:a16="http://schemas.microsoft.com/office/drawing/2014/main" id="{34334BCC-165A-457B-942A-C15F17EFEA55}"/>
+                <a16:creationId xmlns:a16="http://schemas.microsoft.com/office/drawing/2014/main" id="{E120A711-F04C-4568-97E7-D6DAEB5C0BCF}"/>
               </a:ext>
             </a:extLst>
           </p:cNvPr>
@@ -12257,7 +12274,7 @@
           <p:cNvPr id="14" name="">
             <a:extLst xmlns:a="http://schemas.openxmlformats.org/drawingml/2006/main">
               <a:ext uri="{FF2B5EF4-FFF2-40B4-BE49-F238E27FC236}">
-                <a16:creationId xmlns:a16="http://schemas.microsoft.com/office/drawing/2014/main" id="{6D09A92F-0685-41E3-AF2B-AB7A7C5A1E3A}"/>
+                <a16:creationId xmlns:a16="http://schemas.microsoft.com/office/drawing/2014/main" id="{C312A1CF-7C8B-4ABE-BC6D-ED06FD0684C3}"/>
               </a:ext>
             </a:extLst>
           </p:cNvPr>
@@ -12288,7 +12305,7 @@
           <p:cNvPr id="15" name="">
             <a:extLst xmlns:a="http://schemas.openxmlformats.org/drawingml/2006/main">
               <a:ext uri="{FF2B5EF4-FFF2-40B4-BE49-F238E27FC236}">
-                <a16:creationId xmlns:a16="http://schemas.microsoft.com/office/drawing/2014/main" id="{A87F150E-C79D-4474-94C2-A50EABF66EA4}"/>
+                <a16:creationId xmlns:a16="http://schemas.microsoft.com/office/drawing/2014/main" id="{9981FF3C-83CB-44F5-9CC6-241FF363845F}"/>
               </a:ext>
             </a:extLst>
           </p:cNvPr>
@@ -12338,7 +12355,7 @@
           <p:cNvPr id="16" name="">
             <a:extLst xmlns:a="http://schemas.openxmlformats.org/drawingml/2006/main">
               <a:ext uri="{FF2B5EF4-FFF2-40B4-BE49-F238E27FC236}">
-                <a16:creationId xmlns:a16="http://schemas.microsoft.com/office/drawing/2014/main" id="{2A8C86EA-FAB4-4D81-80AB-010B0FE6D12E}"/>
+                <a16:creationId xmlns:a16="http://schemas.microsoft.com/office/drawing/2014/main" id="{EE751B24-F603-42D3-A074-40FC48280F6E}"/>
               </a:ext>
             </a:extLst>
           </p:cNvPr>
@@ -12369,7 +12386,7 @@
           <p:cNvPr id="17" name="">
             <a:extLst xmlns:a="http://schemas.openxmlformats.org/drawingml/2006/main">
               <a:ext uri="{FF2B5EF4-FFF2-40B4-BE49-F238E27FC236}">
-                <a16:creationId xmlns:a16="http://schemas.microsoft.com/office/drawing/2014/main" id="{3DBE0232-6211-4587-99D3-2BF5D5A76AB1}"/>
+                <a16:creationId xmlns:a16="http://schemas.microsoft.com/office/drawing/2014/main" id="{FB6CC5CE-A52E-4158-9882-C022284103FF}"/>
               </a:ext>
             </a:extLst>
           </p:cNvPr>
@@ -12419,7 +12436,7 @@
           <p:cNvPr id="18" name="">
             <a:extLst xmlns:a="http://schemas.openxmlformats.org/drawingml/2006/main">
               <a:ext uri="{FF2B5EF4-FFF2-40B4-BE49-F238E27FC236}">
-                <a16:creationId xmlns:a16="http://schemas.microsoft.com/office/drawing/2014/main" id="{71F29AB9-EFFC-44A6-A958-1B177E07A704}"/>
+                <a16:creationId xmlns:a16="http://schemas.microsoft.com/office/drawing/2014/main" id="{7383116D-AC50-4678-99EE-B7DA6DF62140}"/>
               </a:ext>
             </a:extLst>
           </p:cNvPr>
@@ -12450,7 +12467,7 @@
           <p:cNvPr id="19" name="">
             <a:extLst xmlns:a="http://schemas.openxmlformats.org/drawingml/2006/main">
               <a:ext uri="{FF2B5EF4-FFF2-40B4-BE49-F238E27FC236}">
-                <a16:creationId xmlns:a16="http://schemas.microsoft.com/office/drawing/2014/main" id="{EB08DA5D-13F3-4A63-85BD-6293CD72F78B}"/>
+                <a16:creationId xmlns:a16="http://schemas.microsoft.com/office/drawing/2014/main" id="{8E307CDA-0C01-4507-BFF5-3A3A01E684A7}"/>
               </a:ext>
             </a:extLst>
           </p:cNvPr>
@@ -12500,7 +12517,7 @@
           <p:cNvPr id="20" name="">
             <a:extLst xmlns:a="http://schemas.openxmlformats.org/drawingml/2006/main">
               <a:ext uri="{FF2B5EF4-FFF2-40B4-BE49-F238E27FC236}">
-                <a16:creationId xmlns:a16="http://schemas.microsoft.com/office/drawing/2014/main" id="{3A81C9B2-5E6E-4536-A4D5-8B6EA47E7328}"/>
+                <a16:creationId xmlns:a16="http://schemas.microsoft.com/office/drawing/2014/main" id="{3D9F3BAA-8220-447F-BD7B-1CA04F08E85D}"/>
               </a:ext>
             </a:extLst>
           </p:cNvPr>
@@ -12535,7 +12552,7 @@
           <p:cNvPr id="21" name="">
             <a:extLst xmlns:a="http://schemas.openxmlformats.org/drawingml/2006/main">
               <a:ext uri="{FF2B5EF4-FFF2-40B4-BE49-F238E27FC236}">
-                <a16:creationId xmlns:a16="http://schemas.microsoft.com/office/drawing/2014/main" id="{1AB8C890-495D-4FFD-A279-29F65BCA430B}"/>
+                <a16:creationId xmlns:a16="http://schemas.microsoft.com/office/drawing/2014/main" id="{275029A4-FA4D-49B9-83AF-29C72D99FA74}"/>
               </a:ext>
             </a:extLst>
           </p:cNvPr>
@@ -12575,7 +12592,7 @@
                   <a:srgbClr val="0E6374"/>
                 </a:solidFill>
               </a:rPr>
-              <a:t>后续平台</a:t>
+              <a:t>原生平台</a:t>
             </a:r>
           </a:p>
         </p:txBody>
@@ -12585,7 +12602,7 @@
           <p:cNvPr id="22" name="">
             <a:extLst xmlns:a="http://schemas.openxmlformats.org/drawingml/2006/main">
               <a:ext uri="{FF2B5EF4-FFF2-40B4-BE49-F238E27FC236}">
-                <a16:creationId xmlns:a16="http://schemas.microsoft.com/office/drawing/2014/main" id="{CE06F727-1083-4B72-8E98-959BE7967843}"/>
+                <a16:creationId xmlns:a16="http://schemas.microsoft.com/office/drawing/2014/main" id="{C33161BD-09D9-4FC2-A6AB-D335C168C56A}"/>
               </a:ext>
             </a:extLst>
           </p:cNvPr>
@@ -12616,7 +12633,7 @@
           <p:cNvPr id="23" name="">
             <a:extLst xmlns:a="http://schemas.openxmlformats.org/drawingml/2006/main">
               <a:ext uri="{FF2B5EF4-FFF2-40B4-BE49-F238E27FC236}">
-                <a16:creationId xmlns:a16="http://schemas.microsoft.com/office/drawing/2014/main" id="{F41A2644-3132-48F6-8366-E6E4F542739F}"/>
+                <a16:creationId xmlns:a16="http://schemas.microsoft.com/office/drawing/2014/main" id="{61FD76D0-0686-493E-AB9C-FD4604C06233}"/>
               </a:ext>
             </a:extLst>
           </p:cNvPr>
@@ -12656,7 +12673,7 @@
                   <a:srgbClr val="1F2933"/>
                 </a:solidFill>
               </a:rPr>
-              <a:t>Mac arm64 真机 smoke</a:t>
+              <a:t>Mac Intel x64 packaged smoke</a:t>
             </a:r>
           </a:p>
         </p:txBody>
@@ -12666,7 +12683,7 @@
           <p:cNvPr id="24" name="">
             <a:extLst xmlns:a="http://schemas.openxmlformats.org/drawingml/2006/main">
               <a:ext uri="{FF2B5EF4-FFF2-40B4-BE49-F238E27FC236}">
-                <a16:creationId xmlns:a16="http://schemas.microsoft.com/office/drawing/2014/main" id="{BE12414C-6C9D-4D29-BE0D-BA160934849A}"/>
+                <a16:creationId xmlns:a16="http://schemas.microsoft.com/office/drawing/2014/main" id="{623F5334-6109-4E62-8E06-349CCAF9AA79}"/>
               </a:ext>
             </a:extLst>
           </p:cNvPr>
@@ -12697,7 +12714,7 @@
           <p:cNvPr id="25" name="">
             <a:extLst xmlns:a="http://schemas.openxmlformats.org/drawingml/2006/main">
               <a:ext uri="{FF2B5EF4-FFF2-40B4-BE49-F238E27FC236}">
-                <a16:creationId xmlns:a16="http://schemas.microsoft.com/office/drawing/2014/main" id="{46B3B1A6-95D5-46F4-A074-93B5394635F2}"/>
+                <a16:creationId xmlns:a16="http://schemas.microsoft.com/office/drawing/2014/main" id="{FF7F2362-BECD-49E7-8678-14C0038FFE59}"/>
               </a:ext>
             </a:extLst>
           </p:cNvPr>
@@ -12737,7 +12754,7 @@
                   <a:srgbClr val="1F2933"/>
                 </a:solidFill>
               </a:rPr>
-              <a:t>Windows NSIS 安装 / 卸载</a:t>
+              <a:t>Mac arm64 M1 packaged smoke</a:t>
             </a:r>
           </a:p>
         </p:txBody>
@@ -12747,7 +12764,7 @@
           <p:cNvPr id="26" name="">
             <a:extLst xmlns:a="http://schemas.openxmlformats.org/drawingml/2006/main">
               <a:ext uri="{FF2B5EF4-FFF2-40B4-BE49-F238E27FC236}">
-                <a16:creationId xmlns:a16="http://schemas.microsoft.com/office/drawing/2014/main" id="{97A0DE1C-E508-464D-95D0-22F26E6361B6}"/>
+                <a16:creationId xmlns:a16="http://schemas.microsoft.com/office/drawing/2014/main" id="{0A5C4307-14E0-46F2-88FE-2C93D2B53578}"/>
               </a:ext>
             </a:extLst>
           </p:cNvPr>
@@ -12778,7 +12795,7 @@
           <p:cNvPr id="27" name="">
             <a:extLst xmlns:a="http://schemas.openxmlformats.org/drawingml/2006/main">
               <a:ext uri="{FF2B5EF4-FFF2-40B4-BE49-F238E27FC236}">
-                <a16:creationId xmlns:a16="http://schemas.microsoft.com/office/drawing/2014/main" id="{8F277464-51A3-4F25-8A8A-2ABF515B8A16}"/>
+                <a16:creationId xmlns:a16="http://schemas.microsoft.com/office/drawing/2014/main" id="{3F4C450A-936E-43BF-AA11-F57F6F66E9D0}"/>
               </a:ext>
             </a:extLst>
           </p:cNvPr>
@@ -12818,7 +12835,7 @@
                   <a:srgbClr val="1F2933"/>
                 </a:solidFill>
               </a:rPr>
-              <a:t>wheelhouse venv bootstrap</a:t>
+              <a:t>Windows x64 NSIS + runtime smoke</a:t>
             </a:r>
           </a:p>
         </p:txBody>
@@ -12828,7 +12845,7 @@
           <p:cNvPr id="28" name="">
             <a:extLst xmlns:a="http://schemas.openxmlformats.org/drawingml/2006/main">
               <a:ext uri="{FF2B5EF4-FFF2-40B4-BE49-F238E27FC236}">
-                <a16:creationId xmlns:a16="http://schemas.microsoft.com/office/drawing/2014/main" id="{2FECF11B-D111-45C5-A1ED-D09750F10EC6}"/>
+                <a16:creationId xmlns:a16="http://schemas.microsoft.com/office/drawing/2014/main" id="{160FC0C7-2F8F-4001-B626-24DD40341A57}"/>
               </a:ext>
             </a:extLst>
           </p:cNvPr>
@@ -12863,7 +12880,7 @@
           <p:cNvPr id="29" name="">
             <a:extLst xmlns:a="http://schemas.openxmlformats.org/drawingml/2006/main">
               <a:ext uri="{FF2B5EF4-FFF2-40B4-BE49-F238E27FC236}">
-                <a16:creationId xmlns:a16="http://schemas.microsoft.com/office/drawing/2014/main" id="{E179C2C2-331A-4F5B-8BFF-7453FD171D29}"/>
+                <a16:creationId xmlns:a16="http://schemas.microsoft.com/office/drawing/2014/main" id="{C628AFE7-2375-4CB7-9468-BC7C131F4A82}"/>
               </a:ext>
             </a:extLst>
           </p:cNvPr>
@@ -12913,7 +12930,7 @@
           <p:cNvPr id="30" name="">
             <a:extLst xmlns:a="http://schemas.openxmlformats.org/drawingml/2006/main">
               <a:ext uri="{FF2B5EF4-FFF2-40B4-BE49-F238E27FC236}">
-                <a16:creationId xmlns:a16="http://schemas.microsoft.com/office/drawing/2014/main" id="{6C1B6A48-ED78-42F0-A58F-2E736A7BA15D}"/>
+                <a16:creationId xmlns:a16="http://schemas.microsoft.com/office/drawing/2014/main" id="{04BDC41F-0FDE-46F3-8BDB-9DF99CDE37B3}"/>
               </a:ext>
             </a:extLst>
           </p:cNvPr>
@@ -12944,7 +12961,7 @@
           <p:cNvPr id="31" name="">
             <a:extLst xmlns:a="http://schemas.openxmlformats.org/drawingml/2006/main">
               <a:ext uri="{FF2B5EF4-FFF2-40B4-BE49-F238E27FC236}">
-                <a16:creationId xmlns:a16="http://schemas.microsoft.com/office/drawing/2014/main" id="{E114C2F2-CC20-427A-B116-EE5AB14A2C2A}"/>
+                <a16:creationId xmlns:a16="http://schemas.microsoft.com/office/drawing/2014/main" id="{6BECC75A-66BD-45AD-853D-445B07FCE4E0}"/>
               </a:ext>
             </a:extLst>
           </p:cNvPr>
@@ -12994,7 +13011,7 @@
           <p:cNvPr id="32" name="">
             <a:extLst xmlns:a="http://schemas.openxmlformats.org/drawingml/2006/main">
               <a:ext uri="{FF2B5EF4-FFF2-40B4-BE49-F238E27FC236}">
-                <a16:creationId xmlns:a16="http://schemas.microsoft.com/office/drawing/2014/main" id="{B36C4A5E-997B-47EA-A754-87F73D403E64}"/>
+                <a16:creationId xmlns:a16="http://schemas.microsoft.com/office/drawing/2014/main" id="{B15B9AF1-22F5-4037-B048-A132530EFF5C}"/>
               </a:ext>
             </a:extLst>
           </p:cNvPr>
@@ -13025,7 +13042,7 @@
           <p:cNvPr id="33" name="">
             <a:extLst xmlns:a="http://schemas.openxmlformats.org/drawingml/2006/main">
               <a:ext uri="{FF2B5EF4-FFF2-40B4-BE49-F238E27FC236}">
-                <a16:creationId xmlns:a16="http://schemas.microsoft.com/office/drawing/2014/main" id="{290BA204-7664-479A-9A9D-54138D8A88E7}"/>
+                <a16:creationId xmlns:a16="http://schemas.microsoft.com/office/drawing/2014/main" id="{35BC5EA1-3DB9-4680-9397-2B000562B51E}"/>
               </a:ext>
             </a:extLst>
           </p:cNvPr>
@@ -13075,7 +13092,7 @@
           <p:cNvPr id="34" name="">
             <a:extLst xmlns:a="http://schemas.openxmlformats.org/drawingml/2006/main">
               <a:ext uri="{FF2B5EF4-FFF2-40B4-BE49-F238E27FC236}">
-                <a16:creationId xmlns:a16="http://schemas.microsoft.com/office/drawing/2014/main" id="{C223C8E5-39EC-4D61-A5D9-401DE4D6AD18}"/>
+                <a16:creationId xmlns:a16="http://schemas.microsoft.com/office/drawing/2014/main" id="{15259D86-F94D-4D22-A1B1-50203AD2D766}"/>
               </a:ext>
             </a:extLst>
           </p:cNvPr>
@@ -13106,7 +13123,7 @@
           <p:cNvPr id="35" name="">
             <a:extLst xmlns:a="http://schemas.openxmlformats.org/drawingml/2006/main">
               <a:ext uri="{FF2B5EF4-FFF2-40B4-BE49-F238E27FC236}">
-                <a16:creationId xmlns:a16="http://schemas.microsoft.com/office/drawing/2014/main" id="{A6ED97AE-51F8-4119-A50C-2C9E59E1DADF}"/>
+                <a16:creationId xmlns:a16="http://schemas.microsoft.com/office/drawing/2014/main" id="{B9ACCD11-C189-4BB4-AA4D-25AECE5B6806}"/>
               </a:ext>
             </a:extLst>
           </p:cNvPr>
@@ -13156,7 +13173,7 @@
           <p:cNvPr id="36" name="">
             <a:extLst xmlns:a="http://schemas.openxmlformats.org/drawingml/2006/main">
               <a:ext uri="{FF2B5EF4-FFF2-40B4-BE49-F238E27FC236}">
-                <a16:creationId xmlns:a16="http://schemas.microsoft.com/office/drawing/2014/main" id="{586A15F9-50E8-4563-970E-053EC3D5A98F}"/>
+                <a16:creationId xmlns:a16="http://schemas.microsoft.com/office/drawing/2014/main" id="{A556DCBF-4DAA-4CE1-83AB-C4216B9BAF82}"/>
               </a:ext>
             </a:extLst>
           </p:cNvPr>
@@ -13191,7 +13208,7 @@
           <p:nvPr/>
         </p:nvPicPr>
         <p:blipFill>
-          <a:blip xmlns:r="http://schemas.openxmlformats.org/officeDocument/2006/relationships" xmlns:a="http://schemas.openxmlformats.org/drawingml/2006/main" r:embed="Rda53369e0db04d1e"/>
+          <a:blip xmlns:r="http://schemas.openxmlformats.org/officeDocument/2006/relationships" xmlns:a="http://schemas.openxmlformats.org/drawingml/2006/main" r:embed="R49e0895385b342b8"/>
           <a:stretch xmlns:a="http://schemas.openxmlformats.org/drawingml/2006/main"/>
         </p:blipFill>
         <p:spPr>
@@ -13209,7 +13226,7 @@
           <p:cNvPr id="38" name="">
             <a:extLst xmlns:a="http://schemas.openxmlformats.org/drawingml/2006/main">
               <a:ext uri="{FF2B5EF4-FFF2-40B4-BE49-F238E27FC236}">
-                <a16:creationId xmlns:a16="http://schemas.microsoft.com/office/drawing/2014/main" id="{795533F7-C2E7-4BB5-866D-991C01AA0E6A}"/>
+                <a16:creationId xmlns:a16="http://schemas.microsoft.com/office/drawing/2014/main" id="{9F210B6B-853B-4805-A9BF-A78D2800D89F}"/>
               </a:ext>
             </a:extLst>
           </p:cNvPr>
@@ -13259,7 +13276,7 @@
           <p:cNvPr id="39" name="">
             <a:extLst xmlns:a="http://schemas.openxmlformats.org/drawingml/2006/main">
               <a:ext uri="{FF2B5EF4-FFF2-40B4-BE49-F238E27FC236}">
-                <a16:creationId xmlns:a16="http://schemas.microsoft.com/office/drawing/2014/main" id="{F3B93A82-A51A-4645-852F-6A2774DDF299}"/>
+                <a16:creationId xmlns:a16="http://schemas.microsoft.com/office/drawing/2014/main" id="{8C69E982-9733-4D04-B8BC-EB965CB14FF9}"/>
               </a:ext>
             </a:extLst>
           </p:cNvPr>
@@ -13307,7 +13324,7 @@
     </p:spTree>
     <p:extLst>
       <p:ext uri="{BB962C8B-B14F-4D97-AF65-F5344CB8AC3E}">
-        <p14:creationId xmlns:p14="http://schemas.microsoft.com/office/powerpoint/2010/main" val="1479292932"/>
+        <p14:creationId xmlns:p14="http://schemas.microsoft.com/office/powerpoint/2010/main" val="422993195"/>
       </p:ext>
     </p:extLst>
   </p:cSld>
@@ -13338,7 +13355,7 @@
           <p:cNvPr id="1" name="">
             <a:extLst xmlns:a="http://schemas.openxmlformats.org/drawingml/2006/main">
               <a:ext uri="{FF2B5EF4-FFF2-40B4-BE49-F238E27FC236}">
-                <a16:creationId xmlns:a16="http://schemas.microsoft.com/office/drawing/2014/main" id="{807504D9-0177-4899-B3D1-5203910D1306}"/>
+                <a16:creationId xmlns:a16="http://schemas.microsoft.com/office/drawing/2014/main" id="{EAD827A8-AB68-4A39-B1FB-3637954090D8}"/>
               </a:ext>
             </a:extLst>
           </p:cNvPr>
@@ -13369,7 +13386,7 @@
           <p:cNvPr id="2" name="">
             <a:extLst xmlns:a="http://schemas.openxmlformats.org/drawingml/2006/main">
               <a:ext uri="{FF2B5EF4-FFF2-40B4-BE49-F238E27FC236}">
-                <a16:creationId xmlns:a16="http://schemas.microsoft.com/office/drawing/2014/main" id="{25D43514-2DF1-463B-BF45-E135A98BFE20}"/>
+                <a16:creationId xmlns:a16="http://schemas.microsoft.com/office/drawing/2014/main" id="{92B864C3-C486-4411-883B-A325D262DFBA}"/>
               </a:ext>
             </a:extLst>
           </p:cNvPr>
@@ -13419,7 +13436,7 @@
           <p:cNvPr id="3" name="">
             <a:extLst xmlns:a="http://schemas.openxmlformats.org/drawingml/2006/main">
               <a:ext uri="{FF2B5EF4-FFF2-40B4-BE49-F238E27FC236}">
-                <a16:creationId xmlns:a16="http://schemas.microsoft.com/office/drawing/2014/main" id="{A4A9002F-2897-4DE8-9DCD-FA151105DD68}"/>
+                <a16:creationId xmlns:a16="http://schemas.microsoft.com/office/drawing/2014/main" id="{06C629B2-7E55-4BDF-9F79-8D536448D8E0}"/>
               </a:ext>
             </a:extLst>
           </p:cNvPr>
@@ -13469,7 +13486,7 @@
           <p:cNvPr id="4" name="">
             <a:extLst xmlns:a="http://schemas.openxmlformats.org/drawingml/2006/main">
               <a:ext uri="{FF2B5EF4-FFF2-40B4-BE49-F238E27FC236}">
-                <a16:creationId xmlns:a16="http://schemas.microsoft.com/office/drawing/2014/main" id="{7B17A47A-1005-42EA-9E65-DAE8B97CA5C5}"/>
+                <a16:creationId xmlns:a16="http://schemas.microsoft.com/office/drawing/2014/main" id="{995DDBAB-1595-4F4E-B02C-7AA736619C98}"/>
               </a:ext>
             </a:extLst>
           </p:cNvPr>
@@ -13504,7 +13521,7 @@
           <p:cNvPr id="5" name="">
             <a:extLst xmlns:a="http://schemas.openxmlformats.org/drawingml/2006/main">
               <a:ext uri="{FF2B5EF4-FFF2-40B4-BE49-F238E27FC236}">
-                <a16:creationId xmlns:a16="http://schemas.microsoft.com/office/drawing/2014/main" id="{5AE5137A-5607-419A-A910-B163663A441B}"/>
+                <a16:creationId xmlns:a16="http://schemas.microsoft.com/office/drawing/2014/main" id="{C154A1F5-EAF9-403F-A711-DDDF7E67181A}"/>
               </a:ext>
             </a:extLst>
           </p:cNvPr>
@@ -13554,7 +13571,7 @@
           <p:cNvPr id="6" name="">
             <a:extLst xmlns:a="http://schemas.openxmlformats.org/drawingml/2006/main">
               <a:ext uri="{FF2B5EF4-FFF2-40B4-BE49-F238E27FC236}">
-                <a16:creationId xmlns:a16="http://schemas.microsoft.com/office/drawing/2014/main" id="{C24E078A-9F3F-4451-A910-6F5952392D83}"/>
+                <a16:creationId xmlns:a16="http://schemas.microsoft.com/office/drawing/2014/main" id="{FE3795C4-2B5F-46E4-A788-847B4AD04456}"/>
               </a:ext>
             </a:extLst>
           </p:cNvPr>
@@ -13604,7 +13621,7 @@
           <p:cNvPr id="7" name="">
             <a:extLst xmlns:a="http://schemas.openxmlformats.org/drawingml/2006/main">
               <a:ext uri="{FF2B5EF4-FFF2-40B4-BE49-F238E27FC236}">
-                <a16:creationId xmlns:a16="http://schemas.microsoft.com/office/drawing/2014/main" id="{5435F8D2-349B-4DC5-B55C-2415C12857D5}"/>
+                <a16:creationId xmlns:a16="http://schemas.microsoft.com/office/drawing/2014/main" id="{C9E94826-B0E0-44DE-B91D-873386C06A63}"/>
               </a:ext>
             </a:extLst>
           </p:cNvPr>
@@ -13639,7 +13656,7 @@
           <p:cNvPr id="8" name="">
             <a:extLst xmlns:a="http://schemas.openxmlformats.org/drawingml/2006/main">
               <a:ext uri="{FF2B5EF4-FFF2-40B4-BE49-F238E27FC236}">
-                <a16:creationId xmlns:a16="http://schemas.microsoft.com/office/drawing/2014/main" id="{F4EC8724-8D39-40F1-A1FC-E490E9FA42BE}"/>
+                <a16:creationId xmlns:a16="http://schemas.microsoft.com/office/drawing/2014/main" id="{260B57BF-4078-4FB3-9ACC-153500A01162}"/>
               </a:ext>
             </a:extLst>
           </p:cNvPr>
@@ -13689,7 +13706,7 @@
           <p:cNvPr id="9" name="">
             <a:extLst xmlns:a="http://schemas.openxmlformats.org/drawingml/2006/main">
               <a:ext uri="{FF2B5EF4-FFF2-40B4-BE49-F238E27FC236}">
-                <a16:creationId xmlns:a16="http://schemas.microsoft.com/office/drawing/2014/main" id="{E6BDFA99-223B-4731-A516-E17C28C2C96F}"/>
+                <a16:creationId xmlns:a16="http://schemas.microsoft.com/office/drawing/2014/main" id="{8B8D91D6-427A-4742-A6D4-EC921A192272}"/>
               </a:ext>
             </a:extLst>
           </p:cNvPr>
@@ -13739,7 +13756,7 @@
           <p:cNvPr id="10" name="">
             <a:extLst xmlns:a="http://schemas.openxmlformats.org/drawingml/2006/main">
               <a:ext uri="{FF2B5EF4-FFF2-40B4-BE49-F238E27FC236}">
-                <a16:creationId xmlns:a16="http://schemas.microsoft.com/office/drawing/2014/main" id="{D53C62B5-2D32-46A9-87E3-A8A81CE6A66E}"/>
+                <a16:creationId xmlns:a16="http://schemas.microsoft.com/office/drawing/2014/main" id="{BAD968EB-2845-4F51-8817-E2DCFB3F8B54}"/>
               </a:ext>
             </a:extLst>
           </p:cNvPr>
@@ -13774,7 +13791,7 @@
           <p:cNvPr id="11" name="">
             <a:extLst xmlns:a="http://schemas.openxmlformats.org/drawingml/2006/main">
               <a:ext uri="{FF2B5EF4-FFF2-40B4-BE49-F238E27FC236}">
-                <a16:creationId xmlns:a16="http://schemas.microsoft.com/office/drawing/2014/main" id="{DF714DB3-47BE-4FBC-BF66-1C0947F404EE}"/>
+                <a16:creationId xmlns:a16="http://schemas.microsoft.com/office/drawing/2014/main" id="{7711D42E-467E-49EE-ADB7-EE0617079C0B}"/>
               </a:ext>
             </a:extLst>
           </p:cNvPr>
@@ -13824,7 +13841,7 @@
           <p:cNvPr id="12" name="">
             <a:extLst xmlns:a="http://schemas.openxmlformats.org/drawingml/2006/main">
               <a:ext uri="{FF2B5EF4-FFF2-40B4-BE49-F238E27FC236}">
-                <a16:creationId xmlns:a16="http://schemas.microsoft.com/office/drawing/2014/main" id="{0BBEDEEF-F44E-4E7F-84C1-E7B404CEE398}"/>
+                <a16:creationId xmlns:a16="http://schemas.microsoft.com/office/drawing/2014/main" id="{19905B85-971B-4785-98E1-3CCA2AC06A37}"/>
               </a:ext>
             </a:extLst>
           </p:cNvPr>
@@ -13874,7 +13891,7 @@
           <p:cNvPr id="13" name="">
             <a:extLst xmlns:a="http://schemas.openxmlformats.org/drawingml/2006/main">
               <a:ext uri="{FF2B5EF4-FFF2-40B4-BE49-F238E27FC236}">
-                <a16:creationId xmlns:a16="http://schemas.microsoft.com/office/drawing/2014/main" id="{16BD4480-1822-4403-ABAA-D62B8247F359}"/>
+                <a16:creationId xmlns:a16="http://schemas.microsoft.com/office/drawing/2014/main" id="{0B2C6511-1C16-4A81-B8B0-BE39EC4BC569}"/>
               </a:ext>
             </a:extLst>
           </p:cNvPr>
@@ -13909,7 +13926,7 @@
           <p:cNvPr id="14" name="">
             <a:extLst xmlns:a="http://schemas.openxmlformats.org/drawingml/2006/main">
               <a:ext uri="{FF2B5EF4-FFF2-40B4-BE49-F238E27FC236}">
-                <a16:creationId xmlns:a16="http://schemas.microsoft.com/office/drawing/2014/main" id="{D2D7F77E-5A12-425E-8659-DDDBC7C37B44}"/>
+                <a16:creationId xmlns:a16="http://schemas.microsoft.com/office/drawing/2014/main" id="{1B45A1DA-2AFE-4DA4-85EA-DBEA83646393}"/>
               </a:ext>
             </a:extLst>
           </p:cNvPr>
@@ -13959,7 +13976,7 @@
           <p:cNvPr id="15" name="">
             <a:extLst xmlns:a="http://schemas.openxmlformats.org/drawingml/2006/main">
               <a:ext uri="{FF2B5EF4-FFF2-40B4-BE49-F238E27FC236}">
-                <a16:creationId xmlns:a16="http://schemas.microsoft.com/office/drawing/2014/main" id="{DE709D5A-65B0-4B30-A458-7982C6D8C8C3}"/>
+                <a16:creationId xmlns:a16="http://schemas.microsoft.com/office/drawing/2014/main" id="{C472A4B5-8297-44C7-AF69-9F8EFF61C793}"/>
               </a:ext>
             </a:extLst>
           </p:cNvPr>
@@ -14009,7 +14026,7 @@
           <p:cNvPr id="16" name="">
             <a:extLst xmlns:a="http://schemas.openxmlformats.org/drawingml/2006/main">
               <a:ext uri="{FF2B5EF4-FFF2-40B4-BE49-F238E27FC236}">
-                <a16:creationId xmlns:a16="http://schemas.microsoft.com/office/drawing/2014/main" id="{65F365E3-B7FE-4A84-94C2-0955F0700F59}"/>
+                <a16:creationId xmlns:a16="http://schemas.microsoft.com/office/drawing/2014/main" id="{ABF2A7C8-AFF3-4E67-8FDB-5E738E1DB3EA}"/>
               </a:ext>
             </a:extLst>
           </p:cNvPr>
@@ -14044,7 +14061,7 @@
           <p:nvPr/>
         </p:nvPicPr>
         <p:blipFill>
-          <a:blip xmlns:r="http://schemas.openxmlformats.org/officeDocument/2006/relationships" xmlns:a="http://schemas.openxmlformats.org/drawingml/2006/main" r:embed="Rc2cffcedef3c46a8"/>
+          <a:blip xmlns:r="http://schemas.openxmlformats.org/officeDocument/2006/relationships" xmlns:a="http://schemas.openxmlformats.org/drawingml/2006/main" r:embed="R5dace8200dfc4253"/>
           <a:stretch xmlns:a="http://schemas.openxmlformats.org/drawingml/2006/main"/>
         </p:blipFill>
         <p:spPr>
@@ -14062,7 +14079,7 @@
           <p:cNvPr id="18" name="">
             <a:extLst xmlns:a="http://schemas.openxmlformats.org/drawingml/2006/main">
               <a:ext uri="{FF2B5EF4-FFF2-40B4-BE49-F238E27FC236}">
-                <a16:creationId xmlns:a16="http://schemas.microsoft.com/office/drawing/2014/main" id="{F7F4F28D-6DFC-4F8D-AE5D-B4BC04B7134E}"/>
+                <a16:creationId xmlns:a16="http://schemas.microsoft.com/office/drawing/2014/main" id="{3B2AB0E7-F9C1-46FE-A73C-DA117C25764C}"/>
               </a:ext>
             </a:extLst>
           </p:cNvPr>
@@ -14112,7 +14129,7 @@
           <p:cNvPr id="19" name="">
             <a:extLst xmlns:a="http://schemas.openxmlformats.org/drawingml/2006/main">
               <a:ext uri="{FF2B5EF4-FFF2-40B4-BE49-F238E27FC236}">
-                <a16:creationId xmlns:a16="http://schemas.microsoft.com/office/drawing/2014/main" id="{1C2AC600-88A8-43A9-AA6D-081DB8CE8ED7}"/>
+                <a16:creationId xmlns:a16="http://schemas.microsoft.com/office/drawing/2014/main" id="{668D082E-A359-420E-8969-C8EAA17E856A}"/>
               </a:ext>
             </a:extLst>
           </p:cNvPr>
@@ -14160,7 +14177,7 @@
     </p:spTree>
     <p:extLst>
       <p:ext uri="{BB962C8B-B14F-4D97-AF65-F5344CB8AC3E}">
-        <p14:creationId xmlns:p14="http://schemas.microsoft.com/office/powerpoint/2010/main" val="1928789808"/>
+        <p14:creationId xmlns:p14="http://schemas.microsoft.com/office/powerpoint/2010/main" val="1269623103"/>
       </p:ext>
     </p:extLst>
   </p:cSld>
@@ -14191,7 +14208,7 @@
           <p:cNvPr id="1" name="">
             <a:extLst xmlns:a="http://schemas.openxmlformats.org/drawingml/2006/main">
               <a:ext uri="{FF2B5EF4-FFF2-40B4-BE49-F238E27FC236}">
-                <a16:creationId xmlns:a16="http://schemas.microsoft.com/office/drawing/2014/main" id="{A631D752-741A-4531-AF84-100C1ACD9D2E}"/>
+                <a16:creationId xmlns:a16="http://schemas.microsoft.com/office/drawing/2014/main" id="{05CC909B-9966-4A0E-9650-4810951CEC5C}"/>
               </a:ext>
             </a:extLst>
           </p:cNvPr>
@@ -14222,7 +14239,7 @@
           <p:cNvPr id="2" name="">
             <a:extLst xmlns:a="http://schemas.openxmlformats.org/drawingml/2006/main">
               <a:ext uri="{FF2B5EF4-FFF2-40B4-BE49-F238E27FC236}">
-                <a16:creationId xmlns:a16="http://schemas.microsoft.com/office/drawing/2014/main" id="{5533DE7F-5548-415E-A99C-3F4A1C6375B9}"/>
+                <a16:creationId xmlns:a16="http://schemas.microsoft.com/office/drawing/2014/main" id="{B92D37C9-CA6D-4AA1-AE18-715775009D7D}"/>
               </a:ext>
             </a:extLst>
           </p:cNvPr>
@@ -14272,7 +14289,7 @@
           <p:cNvPr id="3" name="">
             <a:extLst xmlns:a="http://schemas.openxmlformats.org/drawingml/2006/main">
               <a:ext uri="{FF2B5EF4-FFF2-40B4-BE49-F238E27FC236}">
-                <a16:creationId xmlns:a16="http://schemas.microsoft.com/office/drawing/2014/main" id="{5EAE640F-9738-4DD4-A6D4-DC3A0814E668}"/>
+                <a16:creationId xmlns:a16="http://schemas.microsoft.com/office/drawing/2014/main" id="{203A1D8C-1EE4-4D49-86FB-C960170E8F8C}"/>
               </a:ext>
             </a:extLst>
           </p:cNvPr>
@@ -14322,7 +14339,7 @@
           <p:cNvPr id="4" name="">
             <a:extLst xmlns:a="http://schemas.openxmlformats.org/drawingml/2006/main">
               <a:ext uri="{FF2B5EF4-FFF2-40B4-BE49-F238E27FC236}">
-                <a16:creationId xmlns:a16="http://schemas.microsoft.com/office/drawing/2014/main" id="{25D0F1CE-3A70-4264-905D-9E28BF420ECE}"/>
+                <a16:creationId xmlns:a16="http://schemas.microsoft.com/office/drawing/2014/main" id="{2A9C8AAC-A1DD-49D8-8819-1922802BBD48}"/>
               </a:ext>
             </a:extLst>
           </p:cNvPr>
@@ -14372,7 +14389,7 @@
           <p:cNvPr id="5" name="">
             <a:extLst xmlns:a="http://schemas.openxmlformats.org/drawingml/2006/main">
               <a:ext uri="{FF2B5EF4-FFF2-40B4-BE49-F238E27FC236}">
-                <a16:creationId xmlns:a16="http://schemas.microsoft.com/office/drawing/2014/main" id="{9B227C72-8303-44DC-8A51-BF9A87A4B01F}"/>
+                <a16:creationId xmlns:a16="http://schemas.microsoft.com/office/drawing/2014/main" id="{C536E91F-7343-441C-AB2A-0A3CF81CD2D3}"/>
               </a:ext>
             </a:extLst>
           </p:cNvPr>
@@ -14422,7 +14439,7 @@
           <p:cNvPr id="6" name="">
             <a:extLst xmlns:a="http://schemas.openxmlformats.org/drawingml/2006/main">
               <a:ext uri="{FF2B5EF4-FFF2-40B4-BE49-F238E27FC236}">
-                <a16:creationId xmlns:a16="http://schemas.microsoft.com/office/drawing/2014/main" id="{AA7A88ED-3BFF-4E0B-80C9-9825C1085266}"/>
+                <a16:creationId xmlns:a16="http://schemas.microsoft.com/office/drawing/2014/main" id="{D49A98CC-9FA4-4418-B6BA-67473F8C3F98}"/>
               </a:ext>
             </a:extLst>
           </p:cNvPr>
@@ -14453,7 +14470,7 @@
           <p:cNvPr id="7" name="">
             <a:extLst xmlns:a="http://schemas.openxmlformats.org/drawingml/2006/main">
               <a:ext uri="{FF2B5EF4-FFF2-40B4-BE49-F238E27FC236}">
-                <a16:creationId xmlns:a16="http://schemas.microsoft.com/office/drawing/2014/main" id="{6789DFF9-F8D0-47C5-B4E9-850C880C45F5}"/>
+                <a16:creationId xmlns:a16="http://schemas.microsoft.com/office/drawing/2014/main" id="{C159217F-90DB-4031-8159-E5EB503E226B}"/>
               </a:ext>
             </a:extLst>
           </p:cNvPr>
@@ -14503,7 +14520,7 @@
           <p:cNvPr id="8" name="">
             <a:extLst xmlns:a="http://schemas.openxmlformats.org/drawingml/2006/main">
               <a:ext uri="{FF2B5EF4-FFF2-40B4-BE49-F238E27FC236}">
-                <a16:creationId xmlns:a16="http://schemas.microsoft.com/office/drawing/2014/main" id="{866E02D0-5DC4-4467-A6A0-742C3772FBA8}"/>
+                <a16:creationId xmlns:a16="http://schemas.microsoft.com/office/drawing/2014/main" id="{2B411E2D-0C93-4588-AE11-9C01639B7CC2}"/>
               </a:ext>
             </a:extLst>
           </p:cNvPr>
@@ -14534,7 +14551,7 @@
           <p:cNvPr id="9" name="">
             <a:extLst xmlns:a="http://schemas.openxmlformats.org/drawingml/2006/main">
               <a:ext uri="{FF2B5EF4-FFF2-40B4-BE49-F238E27FC236}">
-                <a16:creationId xmlns:a16="http://schemas.microsoft.com/office/drawing/2014/main" id="{D5D93FFF-DE27-4FAF-97CC-56C8D507A3B4}"/>
+                <a16:creationId xmlns:a16="http://schemas.microsoft.com/office/drawing/2014/main" id="{C566F65B-D654-46AB-B00C-699CAECDA301}"/>
               </a:ext>
             </a:extLst>
           </p:cNvPr>
@@ -14574,7 +14591,7 @@
                   <a:srgbClr val="1F2933"/>
                 </a:solidFill>
               </a:rPr>
-              <a:t>Mac Intel x64 App、DMG、ZIP 与 bundled runtime 已完成真实 smoke。</a:t>
+              <a:t>Mac Intel、Mac Apple Silicon 与 Windows x64 产物均完成原生 CI smoke。</a:t>
             </a:r>
           </a:p>
         </p:txBody>
@@ -14584,7 +14601,7 @@
           <p:cNvPr id="10" name="">
             <a:extLst xmlns:a="http://schemas.openxmlformats.org/drawingml/2006/main">
               <a:ext uri="{FF2B5EF4-FFF2-40B4-BE49-F238E27FC236}">
-                <a16:creationId xmlns:a16="http://schemas.microsoft.com/office/drawing/2014/main" id="{5100CF56-F50E-4FBD-9FAD-DD5DCB6B7A3C}"/>
+                <a16:creationId xmlns:a16="http://schemas.microsoft.com/office/drawing/2014/main" id="{EDFF46A8-8F65-474B-9452-FDD138B45AFD}"/>
               </a:ext>
             </a:extLst>
           </p:cNvPr>
@@ -14615,7 +14632,7 @@
           <p:cNvPr id="11" name="">
             <a:extLst xmlns:a="http://schemas.openxmlformats.org/drawingml/2006/main">
               <a:ext uri="{FF2B5EF4-FFF2-40B4-BE49-F238E27FC236}">
-                <a16:creationId xmlns:a16="http://schemas.microsoft.com/office/drawing/2014/main" id="{C3DE535F-6878-4C4E-983F-D047A06140FF}"/>
+                <a16:creationId xmlns:a16="http://schemas.microsoft.com/office/drawing/2014/main" id="{86116473-C232-432A-88CE-C9270403DA1E}"/>
               </a:ext>
             </a:extLst>
           </p:cNvPr>
@@ -14655,7 +14672,7 @@
                   <a:srgbClr val="1F2933"/>
                 </a:solidFill>
               </a:rPr>
-              <a:t>BAI Code 0.9.1 的 Intel runtime 与官方 wheelhouse 分发路径已实现。</a:t>
+              <a:t>BAI Code 0.9.1 的 Intel runtime 与两平台官方 wheelhouse 已完成离线安装验证。</a:t>
             </a:r>
           </a:p>
         </p:txBody>
@@ -14665,7 +14682,7 @@
           <p:cNvPr id="12" name="">
             <a:extLst xmlns:a="http://schemas.openxmlformats.org/drawingml/2006/main">
               <a:ext uri="{FF2B5EF4-FFF2-40B4-BE49-F238E27FC236}">
-                <a16:creationId xmlns:a16="http://schemas.microsoft.com/office/drawing/2014/main" id="{9EF30430-BC42-400D-9F6A-6382F9401CBC}"/>
+                <a16:creationId xmlns:a16="http://schemas.microsoft.com/office/drawing/2014/main" id="{2EA84E4E-A12B-4547-B6C9-EB5E69D87BBC}"/>
               </a:ext>
             </a:extLst>
           </p:cNvPr>
@@ -14696,7 +14713,7 @@
           <p:cNvPr id="13" name="">
             <a:extLst xmlns:a="http://schemas.openxmlformats.org/drawingml/2006/main">
               <a:ext uri="{FF2B5EF4-FFF2-40B4-BE49-F238E27FC236}">
-                <a16:creationId xmlns:a16="http://schemas.microsoft.com/office/drawing/2014/main" id="{2DF757EC-51CB-418D-A0D0-E7EB670F5364}"/>
+                <a16:creationId xmlns:a16="http://schemas.microsoft.com/office/drawing/2014/main" id="{86355C89-854B-47D7-B265-0183F61671D1}"/>
               </a:ext>
             </a:extLst>
           </p:cNvPr>
@@ -14746,7 +14763,7 @@
           <p:cNvPr id="14" name="">
             <a:extLst xmlns:a="http://schemas.openxmlformats.org/drawingml/2006/main">
               <a:ext uri="{FF2B5EF4-FFF2-40B4-BE49-F238E27FC236}">
-                <a16:creationId xmlns:a16="http://schemas.microsoft.com/office/drawing/2014/main" id="{98C3EA8D-456C-4BA8-A18A-D7B1576BE533}"/>
+                <a16:creationId xmlns:a16="http://schemas.microsoft.com/office/drawing/2014/main" id="{8222B921-92B6-4DC8-B985-4FA8C591FC3C}"/>
               </a:ext>
             </a:extLst>
           </p:cNvPr>
@@ -14777,7 +14794,7 @@
           <p:cNvPr id="15" name="">
             <a:extLst xmlns:a="http://schemas.openxmlformats.org/drawingml/2006/main">
               <a:ext uri="{FF2B5EF4-FFF2-40B4-BE49-F238E27FC236}">
-                <a16:creationId xmlns:a16="http://schemas.microsoft.com/office/drawing/2014/main" id="{1364E72F-367A-4C53-B483-E6701D4DAEA1}"/>
+                <a16:creationId xmlns:a16="http://schemas.microsoft.com/office/drawing/2014/main" id="{A79411C1-A5C2-47CD-9794-FF7261E54C68}"/>
               </a:ext>
             </a:extLst>
           </p:cNvPr>
@@ -14827,7 +14844,7 @@
           <p:cNvPr id="16" name="">
             <a:extLst xmlns:a="http://schemas.openxmlformats.org/drawingml/2006/main">
               <a:ext uri="{FF2B5EF4-FFF2-40B4-BE49-F238E27FC236}">
-                <a16:creationId xmlns:a16="http://schemas.microsoft.com/office/drawing/2014/main" id="{52180A85-9798-425E-BD2F-2BA170022D51}"/>
+                <a16:creationId xmlns:a16="http://schemas.microsoft.com/office/drawing/2014/main" id="{83CB4D03-CBA7-40DF-A53C-7496E4876464}"/>
               </a:ext>
             </a:extLst>
           </p:cNvPr>
@@ -14858,7 +14875,7 @@
           <p:cNvPr id="17" name="">
             <a:extLst xmlns:a="http://schemas.openxmlformats.org/drawingml/2006/main">
               <a:ext uri="{FF2B5EF4-FFF2-40B4-BE49-F238E27FC236}">
-                <a16:creationId xmlns:a16="http://schemas.microsoft.com/office/drawing/2014/main" id="{5098013A-4CAD-48EE-BAD8-8407A9CC078E}"/>
+                <a16:creationId xmlns:a16="http://schemas.microsoft.com/office/drawing/2014/main" id="{A5E46105-AF8F-4392-AB6A-EEB5A63D66F7}"/>
               </a:ext>
             </a:extLst>
           </p:cNvPr>
@@ -14898,7 +14915,7 @@
                   <a:srgbClr val="1F2933"/>
                 </a:solidFill>
               </a:rPr>
-              <a:t>签名、公证和真实设备 CI 仍需发布前闭环。</a:t>
+              <a:t>Developer ID、公证与 Windows 代码签名仍需凭据闭环。</a:t>
             </a:r>
           </a:p>
         </p:txBody>
@@ -14908,7 +14925,7 @@
           <p:cNvPr id="18" name="">
             <a:extLst xmlns:a="http://schemas.openxmlformats.org/drawingml/2006/main">
               <a:ext uri="{FF2B5EF4-FFF2-40B4-BE49-F238E27FC236}">
-                <a16:creationId xmlns:a16="http://schemas.microsoft.com/office/drawing/2014/main" id="{0B25A895-2FD6-44C2-B3D6-86316BE7BE4C}"/>
+                <a16:creationId xmlns:a16="http://schemas.microsoft.com/office/drawing/2014/main" id="{31B35728-48E9-4832-A3DB-956ED013DD1D}"/>
               </a:ext>
             </a:extLst>
           </p:cNvPr>
@@ -14939,7 +14956,7 @@
           <p:cNvPr id="19" name="">
             <a:extLst xmlns:a="http://schemas.openxmlformats.org/drawingml/2006/main">
               <a:ext uri="{FF2B5EF4-FFF2-40B4-BE49-F238E27FC236}">
-                <a16:creationId xmlns:a16="http://schemas.microsoft.com/office/drawing/2014/main" id="{B892DB24-3529-4CD7-BB92-AED1AAD57CF5}"/>
+                <a16:creationId xmlns:a16="http://schemas.microsoft.com/office/drawing/2014/main" id="{CAC8A403-E1AE-455E-B1C4-53AF96941A5F}"/>
               </a:ext>
             </a:extLst>
           </p:cNvPr>
@@ -14979,7 +14996,7 @@
                   <a:srgbClr val="1F2933"/>
                 </a:solidFill>
               </a:rPr>
-              <a:t>Mac arm64 与 Windows x64 将在 Intel 版本稳定后继续迭代。</a:t>
+              <a:t>Windows NSIS 的人工安装、升级与卸载体验仍需真实桌面回归。</a:t>
             </a:r>
           </a:p>
         </p:txBody>
@@ -14989,7 +15006,7 @@
           <p:cNvPr id="20" name="">
             <a:extLst xmlns:a="http://schemas.openxmlformats.org/drawingml/2006/main">
               <a:ext uri="{FF2B5EF4-FFF2-40B4-BE49-F238E27FC236}">
-                <a16:creationId xmlns:a16="http://schemas.microsoft.com/office/drawing/2014/main" id="{30B8D2C1-6386-4903-A3AA-1B17E8DDD883}"/>
+                <a16:creationId xmlns:a16="http://schemas.microsoft.com/office/drawing/2014/main" id="{32E4C68E-62C6-49A0-977F-8D4898C54DD2}"/>
               </a:ext>
             </a:extLst>
           </p:cNvPr>
@@ -15020,7 +15037,7 @@
           <p:cNvPr id="21" name="">
             <a:extLst xmlns:a="http://schemas.openxmlformats.org/drawingml/2006/main">
               <a:ext uri="{FF2B5EF4-FFF2-40B4-BE49-F238E27FC236}">
-                <a16:creationId xmlns:a16="http://schemas.microsoft.com/office/drawing/2014/main" id="{CAD9DB71-C9BD-4A9E-9C66-4BF25FAD16E7}"/>
+                <a16:creationId xmlns:a16="http://schemas.microsoft.com/office/drawing/2014/main" id="{43F9CCB3-4AD8-4309-95BD-6BA6114DEF6F}"/>
               </a:ext>
             </a:extLst>
           </p:cNvPr>
@@ -15070,7 +15087,7 @@
           <p:cNvPr id="22" name="">
             <a:extLst xmlns:a="http://schemas.openxmlformats.org/drawingml/2006/main">
               <a:ext uri="{FF2B5EF4-FFF2-40B4-BE49-F238E27FC236}">
-                <a16:creationId xmlns:a16="http://schemas.microsoft.com/office/drawing/2014/main" id="{AEDDAAAC-3CB7-40FB-B709-DE080FE36C85}"/>
+                <a16:creationId xmlns:a16="http://schemas.microsoft.com/office/drawing/2014/main" id="{509D6120-8B50-4641-9498-E517118D28BF}"/>
               </a:ext>
             </a:extLst>
           </p:cNvPr>
@@ -15101,7 +15118,7 @@
           <p:cNvPr id="23" name="">
             <a:extLst xmlns:a="http://schemas.openxmlformats.org/drawingml/2006/main">
               <a:ext uri="{FF2B5EF4-FFF2-40B4-BE49-F238E27FC236}">
-                <a16:creationId xmlns:a16="http://schemas.microsoft.com/office/drawing/2014/main" id="{1B4C26ED-0B35-4B1D-9C5D-E03457481767}"/>
+                <a16:creationId xmlns:a16="http://schemas.microsoft.com/office/drawing/2014/main" id="{8768B07B-7A88-49F8-B98C-EED6D0D4CF52}"/>
               </a:ext>
             </a:extLst>
           </p:cNvPr>
@@ -15136,7 +15153,7 @@
           <p:nvPr/>
         </p:nvPicPr>
         <p:blipFill>
-          <a:blip xmlns:r="http://schemas.openxmlformats.org/officeDocument/2006/relationships" xmlns:a="http://schemas.openxmlformats.org/drawingml/2006/main" r:embed="R8fc2d987a1e2475e"/>
+          <a:blip xmlns:r="http://schemas.openxmlformats.org/officeDocument/2006/relationships" xmlns:a="http://schemas.openxmlformats.org/drawingml/2006/main" r:embed="R9aca5759bde84fff"/>
           <a:stretch xmlns:a="http://schemas.openxmlformats.org/drawingml/2006/main"/>
         </p:blipFill>
         <p:spPr>
@@ -15154,7 +15171,7 @@
           <p:cNvPr id="25" name="">
             <a:extLst xmlns:a="http://schemas.openxmlformats.org/drawingml/2006/main">
               <a:ext uri="{FF2B5EF4-FFF2-40B4-BE49-F238E27FC236}">
-                <a16:creationId xmlns:a16="http://schemas.microsoft.com/office/drawing/2014/main" id="{77DBB4C6-7BA0-4F97-9303-9FFF69AE58CA}"/>
+                <a16:creationId xmlns:a16="http://schemas.microsoft.com/office/drawing/2014/main" id="{E7B39962-6C7A-46CD-BF25-BD5BD03449D7}"/>
               </a:ext>
             </a:extLst>
           </p:cNvPr>
@@ -15204,7 +15221,7 @@
           <p:cNvPr id="26" name="">
             <a:extLst xmlns:a="http://schemas.openxmlformats.org/drawingml/2006/main">
               <a:ext uri="{FF2B5EF4-FFF2-40B4-BE49-F238E27FC236}">
-                <a16:creationId xmlns:a16="http://schemas.microsoft.com/office/drawing/2014/main" id="{61B0C669-F668-43C9-B224-3CF58BDDE79E}"/>
+                <a16:creationId xmlns:a16="http://schemas.microsoft.com/office/drawing/2014/main" id="{7192E5D4-6FB7-4F6E-8FC3-C985D1BF70F8}"/>
               </a:ext>
             </a:extLst>
           </p:cNvPr>
@@ -15252,7 +15269,7 @@
     </p:spTree>
     <p:extLst>
       <p:ext uri="{BB962C8B-B14F-4D97-AF65-F5344CB8AC3E}">
-        <p14:creationId xmlns:p14="http://schemas.microsoft.com/office/powerpoint/2010/main" val="2058576916"/>
+        <p14:creationId xmlns:p14="http://schemas.microsoft.com/office/powerpoint/2010/main" val="930693788"/>
       </p:ext>
     </p:extLst>
   </p:cSld>
@@ -15283,7 +15300,7 @@
           <p:cNvPr id="1" name="">
             <a:extLst xmlns:a="http://schemas.openxmlformats.org/drawingml/2006/main">
               <a:ext uri="{FF2B5EF4-FFF2-40B4-BE49-F238E27FC236}">
-                <a16:creationId xmlns:a16="http://schemas.microsoft.com/office/drawing/2014/main" id="{9540A9EE-9D60-44B2-A445-CF04723A22B4}"/>
+                <a16:creationId xmlns:a16="http://schemas.microsoft.com/office/drawing/2014/main" id="{AE08BB95-09DE-4850-907B-04598C88230D}"/>
               </a:ext>
             </a:extLst>
           </p:cNvPr>
@@ -15314,7 +15331,7 @@
           <p:cNvPr id="2" name="">
             <a:extLst xmlns:a="http://schemas.openxmlformats.org/drawingml/2006/main">
               <a:ext uri="{FF2B5EF4-FFF2-40B4-BE49-F238E27FC236}">
-                <a16:creationId xmlns:a16="http://schemas.microsoft.com/office/drawing/2014/main" id="{AD7E6D0E-5A37-4A1C-9A06-F046413C56E0}"/>
+                <a16:creationId xmlns:a16="http://schemas.microsoft.com/office/drawing/2014/main" id="{DDF768E9-7855-4468-BEA6-D2A8E7D789A2}"/>
               </a:ext>
             </a:extLst>
           </p:cNvPr>
@@ -15364,7 +15381,7 @@
           <p:cNvPr id="3" name="">
             <a:extLst xmlns:a="http://schemas.openxmlformats.org/drawingml/2006/main">
               <a:ext uri="{FF2B5EF4-FFF2-40B4-BE49-F238E27FC236}">
-                <a16:creationId xmlns:a16="http://schemas.microsoft.com/office/drawing/2014/main" id="{BB8E233B-0B0E-4240-80C4-1C13B4694EFD}"/>
+                <a16:creationId xmlns:a16="http://schemas.microsoft.com/office/drawing/2014/main" id="{324C8E93-4EA4-43F7-B37F-0971D6D670CC}"/>
               </a:ext>
             </a:extLst>
           </p:cNvPr>
@@ -15414,7 +15431,7 @@
           <p:cNvPr id="4" name="">
             <a:extLst xmlns:a="http://schemas.openxmlformats.org/drawingml/2006/main">
               <a:ext uri="{FF2B5EF4-FFF2-40B4-BE49-F238E27FC236}">
-                <a16:creationId xmlns:a16="http://schemas.microsoft.com/office/drawing/2014/main" id="{91218B87-5858-44B7-91C1-42C6B6C518D0}"/>
+                <a16:creationId xmlns:a16="http://schemas.microsoft.com/office/drawing/2014/main" id="{1072D900-D4DE-4B01-A4B5-4D7FD0DF3743}"/>
               </a:ext>
             </a:extLst>
           </p:cNvPr>
@@ -15447,7 +15464,7 @@
           <p:cNvPr id="5" name="">
             <a:extLst xmlns:a="http://schemas.openxmlformats.org/drawingml/2006/main">
               <a:ext uri="{FF2B5EF4-FFF2-40B4-BE49-F238E27FC236}">
-                <a16:creationId xmlns:a16="http://schemas.microsoft.com/office/drawing/2014/main" id="{2FC7026B-821C-4DC0-BCA0-70911DE16767}"/>
+                <a16:creationId xmlns:a16="http://schemas.microsoft.com/office/drawing/2014/main" id="{DC02C9BD-7302-433A-AB20-C9FF09823BE2}"/>
               </a:ext>
             </a:extLst>
           </p:cNvPr>
@@ -15497,7 +15514,7 @@
           <p:cNvPr id="6" name="">
             <a:extLst xmlns:a="http://schemas.openxmlformats.org/drawingml/2006/main">
               <a:ext uri="{FF2B5EF4-FFF2-40B4-BE49-F238E27FC236}">
-                <a16:creationId xmlns:a16="http://schemas.microsoft.com/office/drawing/2014/main" id="{DF5C0E47-D7D0-41E8-B692-1792E281E3D6}"/>
+                <a16:creationId xmlns:a16="http://schemas.microsoft.com/office/drawing/2014/main" id="{0F4CEBFD-54BF-4DAA-8DAC-FCA88ACDEB92}"/>
               </a:ext>
             </a:extLst>
           </p:cNvPr>
@@ -15547,7 +15564,7 @@
           <p:cNvPr id="7" name="">
             <a:extLst xmlns:a="http://schemas.openxmlformats.org/drawingml/2006/main">
               <a:ext uri="{FF2B5EF4-FFF2-40B4-BE49-F238E27FC236}">
-                <a16:creationId xmlns:a16="http://schemas.microsoft.com/office/drawing/2014/main" id="{825861A1-973B-485B-BC70-3702C43ABE5B}"/>
+                <a16:creationId xmlns:a16="http://schemas.microsoft.com/office/drawing/2014/main" id="{B77BA9F6-F47B-42B1-99CE-D482EE00F825}"/>
               </a:ext>
             </a:extLst>
           </p:cNvPr>
@@ -15597,7 +15614,7 @@
           <p:cNvPr id="8" name="">
             <a:extLst xmlns:a="http://schemas.openxmlformats.org/drawingml/2006/main">
               <a:ext uri="{FF2B5EF4-FFF2-40B4-BE49-F238E27FC236}">
-                <a16:creationId xmlns:a16="http://schemas.microsoft.com/office/drawing/2014/main" id="{E2BEBC27-EDA8-4F0D-8E63-2B406CF9165E}"/>
+                <a16:creationId xmlns:a16="http://schemas.microsoft.com/office/drawing/2014/main" id="{27ACFA33-B66D-4F85-BD85-B17D86CC6C5A}"/>
               </a:ext>
             </a:extLst>
           </p:cNvPr>
@@ -15630,7 +15647,7 @@
           <p:cNvPr id="9" name="">
             <a:extLst xmlns:a="http://schemas.openxmlformats.org/drawingml/2006/main">
               <a:ext uri="{FF2B5EF4-FFF2-40B4-BE49-F238E27FC236}">
-                <a16:creationId xmlns:a16="http://schemas.microsoft.com/office/drawing/2014/main" id="{6473A7C6-0321-41B0-9060-3354899B0C31}"/>
+                <a16:creationId xmlns:a16="http://schemas.microsoft.com/office/drawing/2014/main" id="{1E925B15-3A87-40D6-9546-0BB74B693DFE}"/>
               </a:ext>
             </a:extLst>
           </p:cNvPr>
@@ -15680,7 +15697,7 @@
           <p:cNvPr id="10" name="">
             <a:extLst xmlns:a="http://schemas.openxmlformats.org/drawingml/2006/main">
               <a:ext uri="{FF2B5EF4-FFF2-40B4-BE49-F238E27FC236}">
-                <a16:creationId xmlns:a16="http://schemas.microsoft.com/office/drawing/2014/main" id="{F43D332A-D26D-4B54-AC49-843F1681FC69}"/>
+                <a16:creationId xmlns:a16="http://schemas.microsoft.com/office/drawing/2014/main" id="{A8F78543-7718-4B5C-B815-C97CC0B1AF4C}"/>
               </a:ext>
             </a:extLst>
           </p:cNvPr>
@@ -15730,7 +15747,7 @@
           <p:cNvPr id="11" name="">
             <a:extLst xmlns:a="http://schemas.openxmlformats.org/drawingml/2006/main">
               <a:ext uri="{FF2B5EF4-FFF2-40B4-BE49-F238E27FC236}">
-                <a16:creationId xmlns:a16="http://schemas.microsoft.com/office/drawing/2014/main" id="{9488035E-F056-4F0C-B357-0EDF799AB88C}"/>
+                <a16:creationId xmlns:a16="http://schemas.microsoft.com/office/drawing/2014/main" id="{A6782F65-7EBA-46E0-B331-0ED0B3F463FB}"/>
               </a:ext>
             </a:extLst>
           </p:cNvPr>
@@ -15780,7 +15797,7 @@
           <p:cNvPr id="12" name="">
             <a:extLst xmlns:a="http://schemas.openxmlformats.org/drawingml/2006/main">
               <a:ext uri="{FF2B5EF4-FFF2-40B4-BE49-F238E27FC236}">
-                <a16:creationId xmlns:a16="http://schemas.microsoft.com/office/drawing/2014/main" id="{76C2E584-96DD-4479-BB4E-60DBF474920F}"/>
+                <a16:creationId xmlns:a16="http://schemas.microsoft.com/office/drawing/2014/main" id="{39DC123D-162D-42B0-B446-29F9531561E1}"/>
               </a:ext>
             </a:extLst>
           </p:cNvPr>
@@ -15813,7 +15830,7 @@
           <p:cNvPr id="13" name="">
             <a:extLst xmlns:a="http://schemas.openxmlformats.org/drawingml/2006/main">
               <a:ext uri="{FF2B5EF4-FFF2-40B4-BE49-F238E27FC236}">
-                <a16:creationId xmlns:a16="http://schemas.microsoft.com/office/drawing/2014/main" id="{55A03942-BE6E-4E84-97E8-A6E88039171F}"/>
+                <a16:creationId xmlns:a16="http://schemas.microsoft.com/office/drawing/2014/main" id="{8FC034FA-0B7A-41DD-9E0E-8421E6B30739}"/>
               </a:ext>
             </a:extLst>
           </p:cNvPr>
@@ -15863,7 +15880,7 @@
           <p:cNvPr id="14" name="">
             <a:extLst xmlns:a="http://schemas.openxmlformats.org/drawingml/2006/main">
               <a:ext uri="{FF2B5EF4-FFF2-40B4-BE49-F238E27FC236}">
-                <a16:creationId xmlns:a16="http://schemas.microsoft.com/office/drawing/2014/main" id="{F9D98252-153F-4C27-947D-75293E60EE3B}"/>
+                <a16:creationId xmlns:a16="http://schemas.microsoft.com/office/drawing/2014/main" id="{C3521241-333C-4E14-B45C-57CCA16B50D8}"/>
               </a:ext>
             </a:extLst>
           </p:cNvPr>
@@ -15913,7 +15930,7 @@
           <p:cNvPr id="15" name="">
             <a:extLst xmlns:a="http://schemas.openxmlformats.org/drawingml/2006/main">
               <a:ext uri="{FF2B5EF4-FFF2-40B4-BE49-F238E27FC236}">
-                <a16:creationId xmlns:a16="http://schemas.microsoft.com/office/drawing/2014/main" id="{1EFB970F-B8CD-49A9-BDF9-8D387E9956A9}"/>
+                <a16:creationId xmlns:a16="http://schemas.microsoft.com/office/drawing/2014/main" id="{026F3041-517B-49F4-A105-3669CB57559A}"/>
               </a:ext>
             </a:extLst>
           </p:cNvPr>
@@ -15963,7 +15980,7 @@
           <p:cNvPr id="16" name="">
             <a:extLst xmlns:a="http://schemas.openxmlformats.org/drawingml/2006/main">
               <a:ext uri="{FF2B5EF4-FFF2-40B4-BE49-F238E27FC236}">
-                <a16:creationId xmlns:a16="http://schemas.microsoft.com/office/drawing/2014/main" id="{7E007EA8-FD45-4A3E-8A62-9F4CE9D587B1}"/>
+                <a16:creationId xmlns:a16="http://schemas.microsoft.com/office/drawing/2014/main" id="{5DB2489F-5182-48B9-B4BE-864A217DAE4A}"/>
               </a:ext>
             </a:extLst>
           </p:cNvPr>
@@ -15996,7 +16013,7 @@
           <p:cNvPr id="17" name="">
             <a:extLst xmlns:a="http://schemas.openxmlformats.org/drawingml/2006/main">
               <a:ext uri="{FF2B5EF4-FFF2-40B4-BE49-F238E27FC236}">
-                <a16:creationId xmlns:a16="http://schemas.microsoft.com/office/drawing/2014/main" id="{F2FF8DF2-670E-4306-8C57-993059A04516}"/>
+                <a16:creationId xmlns:a16="http://schemas.microsoft.com/office/drawing/2014/main" id="{8ADFE2A8-7183-4657-814B-6143B691210E}"/>
               </a:ext>
             </a:extLst>
           </p:cNvPr>
@@ -16046,7 +16063,7 @@
           <p:cNvPr id="18" name="">
             <a:extLst xmlns:a="http://schemas.openxmlformats.org/drawingml/2006/main">
               <a:ext uri="{FF2B5EF4-FFF2-40B4-BE49-F238E27FC236}">
-                <a16:creationId xmlns:a16="http://schemas.microsoft.com/office/drawing/2014/main" id="{F4EC2DE8-63A4-4A3E-9A0A-3B72FB0DD510}"/>
+                <a16:creationId xmlns:a16="http://schemas.microsoft.com/office/drawing/2014/main" id="{9CFD7BC0-48DD-4133-B33F-8DF30D8F22B6}"/>
               </a:ext>
             </a:extLst>
           </p:cNvPr>
@@ -16086,7 +16103,7 @@
                   <a:srgbClr val="0D1117"/>
                 </a:solidFill>
               </a:rPr>
-              <a:t>建设真机 CI</a:t>
+              <a:t>持续维护原生 CI</a:t>
             </a:r>
           </a:p>
         </p:txBody>
@@ -16096,7 +16113,7 @@
           <p:cNvPr id="19" name="">
             <a:extLst xmlns:a="http://schemas.openxmlformats.org/drawingml/2006/main">
               <a:ext uri="{FF2B5EF4-FFF2-40B4-BE49-F238E27FC236}">
-                <a16:creationId xmlns:a16="http://schemas.microsoft.com/office/drawing/2014/main" id="{4B211B70-9C3C-46FD-B263-A3ACBE8BA9F6}"/>
+                <a16:creationId xmlns:a16="http://schemas.microsoft.com/office/drawing/2014/main" id="{7D9C114C-EB5D-4E05-A391-0798C32C8675}"/>
               </a:ext>
             </a:extLst>
           </p:cNvPr>
@@ -16136,7 +16153,7 @@
                   <a:srgbClr val="1F2933"/>
                 </a:solidFill>
               </a:rPr>
-              <a:t>mac x64、mac arm64、Windows x64 构建与安装 smoke 自动化。</a:t>
+              <a:t>保持 mac x64、mac arm64、Windows x64 构建与启动 smoke 稳定。</a:t>
             </a:r>
           </a:p>
         </p:txBody>
@@ -16146,7 +16163,7 @@
           <p:cNvPr id="20" name="">
             <a:extLst xmlns:a="http://schemas.openxmlformats.org/drawingml/2006/main">
               <a:ext uri="{FF2B5EF4-FFF2-40B4-BE49-F238E27FC236}">
-                <a16:creationId xmlns:a16="http://schemas.microsoft.com/office/drawing/2014/main" id="{DEFE3221-B8DD-4566-8D87-389FF58F1C12}"/>
+                <a16:creationId xmlns:a16="http://schemas.microsoft.com/office/drawing/2014/main" id="{AF66ACEB-204D-4E9C-9FA8-B2D2410F2371}"/>
               </a:ext>
             </a:extLst>
           </p:cNvPr>
@@ -16179,7 +16196,7 @@
           <p:cNvPr id="21" name="">
             <a:extLst xmlns:a="http://schemas.openxmlformats.org/drawingml/2006/main">
               <a:ext uri="{FF2B5EF4-FFF2-40B4-BE49-F238E27FC236}">
-                <a16:creationId xmlns:a16="http://schemas.microsoft.com/office/drawing/2014/main" id="{11B8569C-8EDF-47D9-B91C-F04CF9068EF8}"/>
+                <a16:creationId xmlns:a16="http://schemas.microsoft.com/office/drawing/2014/main" id="{24FA7AFC-BC0C-4A3D-94D2-2BEDE7B28B2D}"/>
               </a:ext>
             </a:extLst>
           </p:cNvPr>
@@ -16229,7 +16246,7 @@
           <p:cNvPr id="22" name="">
             <a:extLst xmlns:a="http://schemas.openxmlformats.org/drawingml/2006/main">
               <a:ext uri="{FF2B5EF4-FFF2-40B4-BE49-F238E27FC236}">
-                <a16:creationId xmlns:a16="http://schemas.microsoft.com/office/drawing/2014/main" id="{646D147C-B1B8-4243-9F0A-0D32580F815F}"/>
+                <a16:creationId xmlns:a16="http://schemas.microsoft.com/office/drawing/2014/main" id="{94559871-8290-412E-BEE9-36FA1EDABC9B}"/>
               </a:ext>
             </a:extLst>
           </p:cNvPr>
@@ -16279,7 +16296,7 @@
           <p:cNvPr id="23" name="">
             <a:extLst xmlns:a="http://schemas.openxmlformats.org/drawingml/2006/main">
               <a:ext uri="{FF2B5EF4-FFF2-40B4-BE49-F238E27FC236}">
-                <a16:creationId xmlns:a16="http://schemas.microsoft.com/office/drawing/2014/main" id="{E90BD6F6-F832-41BB-AF6D-473B46B68F4A}"/>
+                <a16:creationId xmlns:a16="http://schemas.microsoft.com/office/drawing/2014/main" id="{A9FCABD2-C333-4639-B659-269E6E3F0050}"/>
               </a:ext>
             </a:extLst>
           </p:cNvPr>
@@ -16329,7 +16346,7 @@
           <p:cNvPr id="24" name="">
             <a:extLst xmlns:a="http://schemas.openxmlformats.org/drawingml/2006/main">
               <a:ext uri="{FF2B5EF4-FFF2-40B4-BE49-F238E27FC236}">
-                <a16:creationId xmlns:a16="http://schemas.microsoft.com/office/drawing/2014/main" id="{02CF0376-7054-46D0-A04F-FAE2B9092E67}"/>
+                <a16:creationId xmlns:a16="http://schemas.microsoft.com/office/drawing/2014/main" id="{9FF067E3-6CC7-493F-99E8-CB2D52D0BB2D}"/>
               </a:ext>
             </a:extLst>
           </p:cNvPr>
@@ -16364,7 +16381,7 @@
           <p:nvPr/>
         </p:nvPicPr>
         <p:blipFill>
-          <a:blip xmlns:r="http://schemas.openxmlformats.org/officeDocument/2006/relationships" xmlns:a="http://schemas.openxmlformats.org/drawingml/2006/main" r:embed="R7280772ed4ae40b2"/>
+          <a:blip xmlns:r="http://schemas.openxmlformats.org/officeDocument/2006/relationships" xmlns:a="http://schemas.openxmlformats.org/drawingml/2006/main" r:embed="Re2209435afc74c46"/>
           <a:stretch xmlns:a="http://schemas.openxmlformats.org/drawingml/2006/main"/>
         </p:blipFill>
         <p:spPr>
@@ -16382,7 +16399,7 @@
           <p:cNvPr id="26" name="">
             <a:extLst xmlns:a="http://schemas.openxmlformats.org/drawingml/2006/main">
               <a:ext uri="{FF2B5EF4-FFF2-40B4-BE49-F238E27FC236}">
-                <a16:creationId xmlns:a16="http://schemas.microsoft.com/office/drawing/2014/main" id="{7ED79CAB-999B-4D85-80E4-05BEE088C4BF}"/>
+                <a16:creationId xmlns:a16="http://schemas.microsoft.com/office/drawing/2014/main" id="{08E8DDA0-B0E0-48C5-A6DC-0A457E1CFA6C}"/>
               </a:ext>
             </a:extLst>
           </p:cNvPr>
@@ -16432,7 +16449,7 @@
           <p:cNvPr id="27" name="">
             <a:extLst xmlns:a="http://schemas.openxmlformats.org/drawingml/2006/main">
               <a:ext uri="{FF2B5EF4-FFF2-40B4-BE49-F238E27FC236}">
-                <a16:creationId xmlns:a16="http://schemas.microsoft.com/office/drawing/2014/main" id="{83DFE02E-A31A-41F9-B329-0FB77E8C4860}"/>
+                <a16:creationId xmlns:a16="http://schemas.microsoft.com/office/drawing/2014/main" id="{13B5FC75-85B8-4285-8EC1-4F08ECE8A08F}"/>
               </a:ext>
             </a:extLst>
           </p:cNvPr>
@@ -16480,7 +16497,7 @@
     </p:spTree>
     <p:extLst>
       <p:ext uri="{BB962C8B-B14F-4D97-AF65-F5344CB8AC3E}">
-        <p14:creationId xmlns:p14="http://schemas.microsoft.com/office/powerpoint/2010/main" val="1037138238"/>
+        <p14:creationId xmlns:p14="http://schemas.microsoft.com/office/powerpoint/2010/main" val="2044895150"/>
       </p:ext>
     </p:extLst>
   </p:cSld>
@@ -16515,7 +16532,7 @@
           <p:nvPr/>
         </p:nvPicPr>
         <p:blipFill>
-          <a:blip xmlns:r="http://schemas.openxmlformats.org/officeDocument/2006/relationships" xmlns:a="http://schemas.openxmlformats.org/drawingml/2006/main" r:embed="R0c59924536a54d4a"/>
+          <a:blip xmlns:r="http://schemas.openxmlformats.org/officeDocument/2006/relationships" xmlns:a="http://schemas.openxmlformats.org/drawingml/2006/main" r:embed="R178c84f177884773"/>
           <a:stretch xmlns:a="http://schemas.openxmlformats.org/drawingml/2006/main"/>
         </p:blipFill>
         <p:spPr>
@@ -16533,7 +16550,7 @@
           <p:cNvPr id="2" name="">
             <a:extLst xmlns:a="http://schemas.openxmlformats.org/drawingml/2006/main">
               <a:ext uri="{FF2B5EF4-FFF2-40B4-BE49-F238E27FC236}">
-                <a16:creationId xmlns:a16="http://schemas.microsoft.com/office/drawing/2014/main" id="{0A3D2BC7-A0CF-47DF-A5B8-273828607FD2}"/>
+                <a16:creationId xmlns:a16="http://schemas.microsoft.com/office/drawing/2014/main" id="{90F0422F-A254-4031-BF64-A4EB5A2F3662}"/>
               </a:ext>
             </a:extLst>
           </p:cNvPr>
@@ -16583,7 +16600,7 @@
           <p:cNvPr id="3" name="">
             <a:extLst xmlns:a="http://schemas.openxmlformats.org/drawingml/2006/main">
               <a:ext uri="{FF2B5EF4-FFF2-40B4-BE49-F238E27FC236}">
-                <a16:creationId xmlns:a16="http://schemas.microsoft.com/office/drawing/2014/main" id="{25BE9E81-9FFC-4131-80B2-BF4407F85857}"/>
+                <a16:creationId xmlns:a16="http://schemas.microsoft.com/office/drawing/2014/main" id="{B1A158E8-E61D-4AB9-AD53-57E883BFF480}"/>
               </a:ext>
             </a:extLst>
           </p:cNvPr>
@@ -16623,7 +16640,7 @@
                   <a:srgbClr val="DDE4EA"/>
                 </a:solidFill>
               </a:rPr>
-              <a:t>当前工程已具备统一品牌、Mac Intel 包体、runtime 适配和安全策略基础。下一阶段的关键，不是继续扩展功能面，而是先把 Intel 版本稳定性、签名、公证和安装体验做到发布级，再恢复其他平台迭代。</a:t>
+              <a:t>当前工程已具备统一品牌、三平台原生产物、runtime 适配和安全策略基础。下一阶段的关键，是把签名、公证、Windows 人工安装回归和官方 service contract 对齐做到发布级。</a:t>
             </a:r>
           </a:p>
         </p:txBody>
@@ -16633,7 +16650,7 @@
           <p:cNvPr id="4" name="">
             <a:extLst xmlns:a="http://schemas.openxmlformats.org/drawingml/2006/main">
               <a:ext uri="{FF2B5EF4-FFF2-40B4-BE49-F238E27FC236}">
-                <a16:creationId xmlns:a16="http://schemas.microsoft.com/office/drawing/2014/main" id="{392E82D4-C197-4DB0-883F-B39F910BB79A}"/>
+                <a16:creationId xmlns:a16="http://schemas.microsoft.com/office/drawing/2014/main" id="{1F33A56B-C887-425F-AD23-C2F49A1023EB}"/>
               </a:ext>
             </a:extLst>
           </p:cNvPr>
@@ -16668,7 +16685,7 @@
           <p:cNvPr id="5" name="">
             <a:extLst xmlns:a="http://schemas.openxmlformats.org/drawingml/2006/main">
               <a:ext uri="{FF2B5EF4-FFF2-40B4-BE49-F238E27FC236}">
-                <a16:creationId xmlns:a16="http://schemas.microsoft.com/office/drawing/2014/main" id="{C4AF1BD6-086C-4901-B58B-EA946D7E26CC}"/>
+                <a16:creationId xmlns:a16="http://schemas.microsoft.com/office/drawing/2014/main" id="{D07A5DF0-56CF-4869-A460-7892B82E94BE}"/>
               </a:ext>
             </a:extLst>
           </p:cNvPr>
@@ -16716,7 +16733,7 @@
     </p:spTree>
     <p:extLst>
       <p:ext uri="{BB962C8B-B14F-4D97-AF65-F5344CB8AC3E}">
-        <p14:creationId xmlns:p14="http://schemas.microsoft.com/office/powerpoint/2010/main" val="1782913625"/>
+        <p14:creationId xmlns:p14="http://schemas.microsoft.com/office/powerpoint/2010/main" val="691819470"/>
       </p:ext>
     </p:extLst>
   </p:cSld>
@@ -16747,7 +16764,7 @@
           <p:cNvPr id="1" name="">
             <a:extLst xmlns:a="http://schemas.openxmlformats.org/drawingml/2006/main">
               <a:ext uri="{FF2B5EF4-FFF2-40B4-BE49-F238E27FC236}">
-                <a16:creationId xmlns:a16="http://schemas.microsoft.com/office/drawing/2014/main" id="{9811B8D5-E8D3-48B6-BB62-9960FC058411}"/>
+                <a16:creationId xmlns:a16="http://schemas.microsoft.com/office/drawing/2014/main" id="{66094B2B-A2D3-4161-B582-C4F110C7A14F}"/>
               </a:ext>
             </a:extLst>
           </p:cNvPr>
@@ -16778,7 +16795,7 @@
           <p:cNvPr id="2" name="">
             <a:extLst xmlns:a="http://schemas.openxmlformats.org/drawingml/2006/main">
               <a:ext uri="{FF2B5EF4-FFF2-40B4-BE49-F238E27FC236}">
-                <a16:creationId xmlns:a16="http://schemas.microsoft.com/office/drawing/2014/main" id="{9E1C8779-14DE-439E-AC91-D0727A6F5991}"/>
+                <a16:creationId xmlns:a16="http://schemas.microsoft.com/office/drawing/2014/main" id="{CC2684E8-B571-478A-AEE5-90E64784CCD5}"/>
               </a:ext>
             </a:extLst>
           </p:cNvPr>
@@ -16828,7 +16845,7 @@
           <p:cNvPr id="3" name="">
             <a:extLst xmlns:a="http://schemas.openxmlformats.org/drawingml/2006/main">
               <a:ext uri="{FF2B5EF4-FFF2-40B4-BE49-F238E27FC236}">
-                <a16:creationId xmlns:a16="http://schemas.microsoft.com/office/drawing/2014/main" id="{B1A42EA9-A756-4BBA-8ABD-AD16EBDBC4F6}"/>
+                <a16:creationId xmlns:a16="http://schemas.microsoft.com/office/drawing/2014/main" id="{C40CD30D-8A25-46AF-958A-2E3DA31A95C5}"/>
               </a:ext>
             </a:extLst>
           </p:cNvPr>
@@ -16878,7 +16895,7 @@
           <p:cNvPr id="4" name="">
             <a:extLst xmlns:a="http://schemas.openxmlformats.org/drawingml/2006/main">
               <a:ext uri="{FF2B5EF4-FFF2-40B4-BE49-F238E27FC236}">
-                <a16:creationId xmlns:a16="http://schemas.microsoft.com/office/drawing/2014/main" id="{8E87F7D2-4FFF-43B4-B6C5-E80C6C4611FA}"/>
+                <a16:creationId xmlns:a16="http://schemas.microsoft.com/office/drawing/2014/main" id="{138DBF00-BECE-4F3A-A854-A4EC8656E941}"/>
               </a:ext>
             </a:extLst>
           </p:cNvPr>
@@ -16928,7 +16945,7 @@
           <p:cNvPr id="5" name="">
             <a:extLst xmlns:a="http://schemas.openxmlformats.org/drawingml/2006/main">
               <a:ext uri="{FF2B5EF4-FFF2-40B4-BE49-F238E27FC236}">
-                <a16:creationId xmlns:a16="http://schemas.microsoft.com/office/drawing/2014/main" id="{54A628DA-5219-4856-B84A-0E3EF5972936}"/>
+                <a16:creationId xmlns:a16="http://schemas.microsoft.com/office/drawing/2014/main" id="{887B898F-2C41-478D-80E9-55BDAF62269A}"/>
               </a:ext>
             </a:extLst>
           </p:cNvPr>
@@ -16959,7 +16976,7 @@
           <p:cNvPr id="6" name="">
             <a:extLst xmlns:a="http://schemas.openxmlformats.org/drawingml/2006/main">
               <a:ext uri="{FF2B5EF4-FFF2-40B4-BE49-F238E27FC236}">
-                <a16:creationId xmlns:a16="http://schemas.microsoft.com/office/drawing/2014/main" id="{5608BDAC-64EE-4E86-BCC8-5E5F70B01652}"/>
+                <a16:creationId xmlns:a16="http://schemas.microsoft.com/office/drawing/2014/main" id="{D773DF0C-46BB-4467-B383-15735038604F}"/>
               </a:ext>
             </a:extLst>
           </p:cNvPr>
@@ -17009,7 +17026,7 @@
           <p:cNvPr id="7" name="">
             <a:extLst xmlns:a="http://schemas.openxmlformats.org/drawingml/2006/main">
               <a:ext uri="{FF2B5EF4-FFF2-40B4-BE49-F238E27FC236}">
-                <a16:creationId xmlns:a16="http://schemas.microsoft.com/office/drawing/2014/main" id="{41297829-F052-4618-A57A-FBCC7F508133}"/>
+                <a16:creationId xmlns:a16="http://schemas.microsoft.com/office/drawing/2014/main" id="{8CDB0E06-8B2D-459E-8EC6-10F3B3D5C365}"/>
               </a:ext>
             </a:extLst>
           </p:cNvPr>
@@ -17040,7 +17057,7 @@
           <p:cNvPr id="8" name="">
             <a:extLst xmlns:a="http://schemas.openxmlformats.org/drawingml/2006/main">
               <a:ext uri="{FF2B5EF4-FFF2-40B4-BE49-F238E27FC236}">
-                <a16:creationId xmlns:a16="http://schemas.microsoft.com/office/drawing/2014/main" id="{92144E13-1201-40BD-851C-875E8708CDAC}"/>
+                <a16:creationId xmlns:a16="http://schemas.microsoft.com/office/drawing/2014/main" id="{C0874A17-7C82-4C6D-8CCA-1990FFF8AA64}"/>
               </a:ext>
             </a:extLst>
           </p:cNvPr>
@@ -17090,7 +17107,7 @@
           <p:cNvPr id="9" name="">
             <a:extLst xmlns:a="http://schemas.openxmlformats.org/drawingml/2006/main">
               <a:ext uri="{FF2B5EF4-FFF2-40B4-BE49-F238E27FC236}">
-                <a16:creationId xmlns:a16="http://schemas.microsoft.com/office/drawing/2014/main" id="{E63F065A-431C-4508-BFB5-C7D80DB1F3FC}"/>
+                <a16:creationId xmlns:a16="http://schemas.microsoft.com/office/drawing/2014/main" id="{2F3F1C7E-A4BB-4393-8B5F-291827FE377A}"/>
               </a:ext>
             </a:extLst>
           </p:cNvPr>
@@ -17121,7 +17138,7 @@
           <p:cNvPr id="10" name="">
             <a:extLst xmlns:a="http://schemas.openxmlformats.org/drawingml/2006/main">
               <a:ext uri="{FF2B5EF4-FFF2-40B4-BE49-F238E27FC236}">
-                <a16:creationId xmlns:a16="http://schemas.microsoft.com/office/drawing/2014/main" id="{519FEA78-C9E2-44C9-9119-D224D0BCEB28}"/>
+                <a16:creationId xmlns:a16="http://schemas.microsoft.com/office/drawing/2014/main" id="{A270728E-F04F-4209-91D8-71E300DD45F5}"/>
               </a:ext>
             </a:extLst>
           </p:cNvPr>
@@ -17171,7 +17188,7 @@
           <p:cNvPr id="11" name="">
             <a:extLst xmlns:a="http://schemas.openxmlformats.org/drawingml/2006/main">
               <a:ext uri="{FF2B5EF4-FFF2-40B4-BE49-F238E27FC236}">
-                <a16:creationId xmlns:a16="http://schemas.microsoft.com/office/drawing/2014/main" id="{73D51C3D-FF95-40DD-8FC5-2447D4C4F3AE}"/>
+                <a16:creationId xmlns:a16="http://schemas.microsoft.com/office/drawing/2014/main" id="{EE5A5D4D-A12D-4A48-B002-0E23903D4AD5}"/>
               </a:ext>
             </a:extLst>
           </p:cNvPr>
@@ -17202,7 +17219,7 @@
           <p:cNvPr id="12" name="">
             <a:extLst xmlns:a="http://schemas.openxmlformats.org/drawingml/2006/main">
               <a:ext uri="{FF2B5EF4-FFF2-40B4-BE49-F238E27FC236}">
-                <a16:creationId xmlns:a16="http://schemas.microsoft.com/office/drawing/2014/main" id="{C363DCB1-45EB-4C40-BD9D-D1AA7538F01D}"/>
+                <a16:creationId xmlns:a16="http://schemas.microsoft.com/office/drawing/2014/main" id="{E8E75770-44D8-4706-9CEC-7E34564BAC99}"/>
               </a:ext>
             </a:extLst>
           </p:cNvPr>
@@ -17252,7 +17269,7 @@
           <p:cNvPr id="13" name="">
             <a:extLst xmlns:a="http://schemas.openxmlformats.org/drawingml/2006/main">
               <a:ext uri="{FF2B5EF4-FFF2-40B4-BE49-F238E27FC236}">
-                <a16:creationId xmlns:a16="http://schemas.microsoft.com/office/drawing/2014/main" id="{F5B32F28-DE3B-47C0-BFB4-5062F29EB2AF}"/>
+                <a16:creationId xmlns:a16="http://schemas.microsoft.com/office/drawing/2014/main" id="{9F431790-41AE-4F2B-890B-D68B1614B616}"/>
               </a:ext>
             </a:extLst>
           </p:cNvPr>
@@ -17283,7 +17300,7 @@
           <p:cNvPr id="14" name="">
             <a:extLst xmlns:a="http://schemas.openxmlformats.org/drawingml/2006/main">
               <a:ext uri="{FF2B5EF4-FFF2-40B4-BE49-F238E27FC236}">
-                <a16:creationId xmlns:a16="http://schemas.microsoft.com/office/drawing/2014/main" id="{31444928-FDDD-45F7-904B-EC3EC2F8B82B}"/>
+                <a16:creationId xmlns:a16="http://schemas.microsoft.com/office/drawing/2014/main" id="{EB939360-9CA3-443D-B16C-5CB466E17EA3}"/>
               </a:ext>
             </a:extLst>
           </p:cNvPr>
@@ -17333,7 +17350,7 @@
           <p:cNvPr id="15" name="">
             <a:extLst xmlns:a="http://schemas.openxmlformats.org/drawingml/2006/main">
               <a:ext uri="{FF2B5EF4-FFF2-40B4-BE49-F238E27FC236}">
-                <a16:creationId xmlns:a16="http://schemas.microsoft.com/office/drawing/2014/main" id="{17F8008F-4812-417B-80EE-A7F3A31B8B48}"/>
+                <a16:creationId xmlns:a16="http://schemas.microsoft.com/office/drawing/2014/main" id="{E400C5F7-FC29-4EDE-891A-4863DE15D6E8}"/>
               </a:ext>
             </a:extLst>
           </p:cNvPr>
@@ -17368,7 +17385,7 @@
           <p:nvPr/>
         </p:nvPicPr>
         <p:blipFill>
-          <a:blip xmlns:r="http://schemas.openxmlformats.org/officeDocument/2006/relationships" xmlns:a="http://schemas.openxmlformats.org/drawingml/2006/main" r:embed="R6d563398c49f4b2b"/>
+          <a:blip xmlns:r="http://schemas.openxmlformats.org/officeDocument/2006/relationships" xmlns:a="http://schemas.openxmlformats.org/drawingml/2006/main" r:embed="R6f34c0dfe75d40a6"/>
           <a:stretch xmlns:a="http://schemas.openxmlformats.org/drawingml/2006/main"/>
         </p:blipFill>
         <p:spPr>
@@ -17386,7 +17403,7 @@
           <p:cNvPr id="17" name="">
             <a:extLst xmlns:a="http://schemas.openxmlformats.org/drawingml/2006/main">
               <a:ext uri="{FF2B5EF4-FFF2-40B4-BE49-F238E27FC236}">
-                <a16:creationId xmlns:a16="http://schemas.microsoft.com/office/drawing/2014/main" id="{66DC406F-4FA2-48C4-9147-EE15B1463145}"/>
+                <a16:creationId xmlns:a16="http://schemas.microsoft.com/office/drawing/2014/main" id="{35D75AB5-7B13-486E-8288-C1C65A4F4860}"/>
               </a:ext>
             </a:extLst>
           </p:cNvPr>
@@ -17436,7 +17453,7 @@
           <p:cNvPr id="18" name="">
             <a:extLst xmlns:a="http://schemas.openxmlformats.org/drawingml/2006/main">
               <a:ext uri="{FF2B5EF4-FFF2-40B4-BE49-F238E27FC236}">
-                <a16:creationId xmlns:a16="http://schemas.microsoft.com/office/drawing/2014/main" id="{00DD442C-F4E9-4B49-8F8C-45D74E100308}"/>
+                <a16:creationId xmlns:a16="http://schemas.microsoft.com/office/drawing/2014/main" id="{16D317D3-6A54-421B-B6EE-4374A0A7D9FF}"/>
               </a:ext>
             </a:extLst>
           </p:cNvPr>
@@ -17484,7 +17501,7 @@
     </p:spTree>
     <p:extLst>
       <p:ext uri="{BB962C8B-B14F-4D97-AF65-F5344CB8AC3E}">
-        <p14:creationId xmlns:p14="http://schemas.microsoft.com/office/powerpoint/2010/main" val="506605051"/>
+        <p14:creationId xmlns:p14="http://schemas.microsoft.com/office/powerpoint/2010/main" val="1909768989"/>
       </p:ext>
     </p:extLst>
   </p:cSld>
@@ -17515,7 +17532,7 @@
           <p:cNvPr id="1" name="">
             <a:extLst xmlns:a="http://schemas.openxmlformats.org/drawingml/2006/main">
               <a:ext uri="{FF2B5EF4-FFF2-40B4-BE49-F238E27FC236}">
-                <a16:creationId xmlns:a16="http://schemas.microsoft.com/office/drawing/2014/main" id="{E8F6EFF7-6491-4EAC-B993-18E88C62AD77}"/>
+                <a16:creationId xmlns:a16="http://schemas.microsoft.com/office/drawing/2014/main" id="{D1E47C29-9F40-4900-9204-25631A5CCA0F}"/>
               </a:ext>
             </a:extLst>
           </p:cNvPr>
@@ -17546,7 +17563,7 @@
           <p:cNvPr id="2" name="">
             <a:extLst xmlns:a="http://schemas.openxmlformats.org/drawingml/2006/main">
               <a:ext uri="{FF2B5EF4-FFF2-40B4-BE49-F238E27FC236}">
-                <a16:creationId xmlns:a16="http://schemas.microsoft.com/office/drawing/2014/main" id="{6881FD8F-34E9-4433-A072-E2A485F0F112}"/>
+                <a16:creationId xmlns:a16="http://schemas.microsoft.com/office/drawing/2014/main" id="{254412EE-B6C7-4BB0-8149-D826CCF6AF6C}"/>
               </a:ext>
             </a:extLst>
           </p:cNvPr>
@@ -17596,7 +17613,7 @@
           <p:cNvPr id="3" name="">
             <a:extLst xmlns:a="http://schemas.openxmlformats.org/drawingml/2006/main">
               <a:ext uri="{FF2B5EF4-FFF2-40B4-BE49-F238E27FC236}">
-                <a16:creationId xmlns:a16="http://schemas.microsoft.com/office/drawing/2014/main" id="{996C23C8-ACE3-4184-A9E3-48E196BFBCAC}"/>
+                <a16:creationId xmlns:a16="http://schemas.microsoft.com/office/drawing/2014/main" id="{9E70EDF3-9278-48AA-9756-32794A8BD16D}"/>
               </a:ext>
             </a:extLst>
           </p:cNvPr>
@@ -17646,7 +17663,7 @@
           <p:cNvPr id="4" name="">
             <a:extLst xmlns:a="http://schemas.openxmlformats.org/drawingml/2006/main">
               <a:ext uri="{FF2B5EF4-FFF2-40B4-BE49-F238E27FC236}">
-                <a16:creationId xmlns:a16="http://schemas.microsoft.com/office/drawing/2014/main" id="{DB0DA9ED-0DF6-466B-AD66-C90BFBC7E613}"/>
+                <a16:creationId xmlns:a16="http://schemas.microsoft.com/office/drawing/2014/main" id="{D165104D-4359-4383-8832-044E4116F873}"/>
               </a:ext>
             </a:extLst>
           </p:cNvPr>
@@ -17696,7 +17713,7 @@
           <p:cNvPr id="5" name="">
             <a:extLst xmlns:a="http://schemas.openxmlformats.org/drawingml/2006/main">
               <a:ext uri="{FF2B5EF4-FFF2-40B4-BE49-F238E27FC236}">
-                <a16:creationId xmlns:a16="http://schemas.microsoft.com/office/drawing/2014/main" id="{EB8DCA3E-A821-4CF9-A886-226B75A40D05}"/>
+                <a16:creationId xmlns:a16="http://schemas.microsoft.com/office/drawing/2014/main" id="{98C6A9E4-9B43-427F-B8F7-0F55A7F3407C}"/>
               </a:ext>
             </a:extLst>
           </p:cNvPr>
@@ -17727,7 +17744,7 @@
           <p:cNvPr id="6" name="">
             <a:extLst xmlns:a="http://schemas.openxmlformats.org/drawingml/2006/main">
               <a:ext uri="{FF2B5EF4-FFF2-40B4-BE49-F238E27FC236}">
-                <a16:creationId xmlns:a16="http://schemas.microsoft.com/office/drawing/2014/main" id="{7307BE84-D4A0-43B1-B44E-293E7AA42CA0}"/>
+                <a16:creationId xmlns:a16="http://schemas.microsoft.com/office/drawing/2014/main" id="{88587BE8-69B2-44E3-BA73-F1B665CDF2C1}"/>
               </a:ext>
             </a:extLst>
           </p:cNvPr>
@@ -17777,7 +17794,7 @@
           <p:cNvPr id="7" name="">
             <a:extLst xmlns:a="http://schemas.openxmlformats.org/drawingml/2006/main">
               <a:ext uri="{FF2B5EF4-FFF2-40B4-BE49-F238E27FC236}">
-                <a16:creationId xmlns:a16="http://schemas.microsoft.com/office/drawing/2014/main" id="{1CBE5040-63C1-4A1C-AB95-AFAD150D132E}"/>
+                <a16:creationId xmlns:a16="http://schemas.microsoft.com/office/drawing/2014/main" id="{9F0F1868-0453-449B-BB37-93BBDB596DCF}"/>
               </a:ext>
             </a:extLst>
           </p:cNvPr>
@@ -17827,7 +17844,7 @@
           <p:cNvPr id="8" name="">
             <a:extLst xmlns:a="http://schemas.openxmlformats.org/drawingml/2006/main">
               <a:ext uri="{FF2B5EF4-FFF2-40B4-BE49-F238E27FC236}">
-                <a16:creationId xmlns:a16="http://schemas.microsoft.com/office/drawing/2014/main" id="{12174D56-2CB7-4428-A07C-AB1BCC5D1E8C}"/>
+                <a16:creationId xmlns:a16="http://schemas.microsoft.com/office/drawing/2014/main" id="{0AE0BC2A-816D-4970-8118-180841E40471}"/>
               </a:ext>
             </a:extLst>
           </p:cNvPr>
@@ -17858,7 +17875,7 @@
           <p:cNvPr id="9" name="">
             <a:extLst xmlns:a="http://schemas.openxmlformats.org/drawingml/2006/main">
               <a:ext uri="{FF2B5EF4-FFF2-40B4-BE49-F238E27FC236}">
-                <a16:creationId xmlns:a16="http://schemas.microsoft.com/office/drawing/2014/main" id="{58F9770D-8138-4A5A-84FA-9CDAC24AE648}"/>
+                <a16:creationId xmlns:a16="http://schemas.microsoft.com/office/drawing/2014/main" id="{8142B0F3-AB50-4FED-9E22-9C5B9DC60186}"/>
               </a:ext>
             </a:extLst>
           </p:cNvPr>
@@ -17908,7 +17925,7 @@
           <p:cNvPr id="10" name="">
             <a:extLst xmlns:a="http://schemas.openxmlformats.org/drawingml/2006/main">
               <a:ext uri="{FF2B5EF4-FFF2-40B4-BE49-F238E27FC236}">
-                <a16:creationId xmlns:a16="http://schemas.microsoft.com/office/drawing/2014/main" id="{CD53F125-A8FC-41D5-AECC-A4FD6A7F5BA3}"/>
+                <a16:creationId xmlns:a16="http://schemas.microsoft.com/office/drawing/2014/main" id="{89A35DDC-EC30-447E-9935-D05B4E65DE0D}"/>
               </a:ext>
             </a:extLst>
           </p:cNvPr>
@@ -17958,7 +17975,7 @@
           <p:cNvPr id="11" name="">
             <a:extLst xmlns:a="http://schemas.openxmlformats.org/drawingml/2006/main">
               <a:ext uri="{FF2B5EF4-FFF2-40B4-BE49-F238E27FC236}">
-                <a16:creationId xmlns:a16="http://schemas.microsoft.com/office/drawing/2014/main" id="{8322718F-1541-480E-AE08-4DA838B7A359}"/>
+                <a16:creationId xmlns:a16="http://schemas.microsoft.com/office/drawing/2014/main" id="{878AAB86-795B-4E56-9809-C397D5449530}"/>
               </a:ext>
             </a:extLst>
           </p:cNvPr>
@@ -17989,7 +18006,7 @@
           <p:cNvPr id="12" name="">
             <a:extLst xmlns:a="http://schemas.openxmlformats.org/drawingml/2006/main">
               <a:ext uri="{FF2B5EF4-FFF2-40B4-BE49-F238E27FC236}">
-                <a16:creationId xmlns:a16="http://schemas.microsoft.com/office/drawing/2014/main" id="{81601581-D985-48B2-8584-075E538D9445}"/>
+                <a16:creationId xmlns:a16="http://schemas.microsoft.com/office/drawing/2014/main" id="{EB992E89-A628-433A-8143-5574843C6C22}"/>
               </a:ext>
             </a:extLst>
           </p:cNvPr>
@@ -18039,7 +18056,7 @@
           <p:cNvPr id="13" name="">
             <a:extLst xmlns:a="http://schemas.openxmlformats.org/drawingml/2006/main">
               <a:ext uri="{FF2B5EF4-FFF2-40B4-BE49-F238E27FC236}">
-                <a16:creationId xmlns:a16="http://schemas.microsoft.com/office/drawing/2014/main" id="{67A790DC-2D3E-434A-8725-0502A62778FA}"/>
+                <a16:creationId xmlns:a16="http://schemas.microsoft.com/office/drawing/2014/main" id="{DCB1509A-B39C-481A-8C1F-FF17EBC424D7}"/>
               </a:ext>
             </a:extLst>
           </p:cNvPr>
@@ -18089,7 +18106,7 @@
           <p:cNvPr id="14" name="">
             <a:extLst xmlns:a="http://schemas.openxmlformats.org/drawingml/2006/main">
               <a:ext uri="{FF2B5EF4-FFF2-40B4-BE49-F238E27FC236}">
-                <a16:creationId xmlns:a16="http://schemas.microsoft.com/office/drawing/2014/main" id="{553E1264-02D8-45FE-86FA-39D9FF5DCDD2}"/>
+                <a16:creationId xmlns:a16="http://schemas.microsoft.com/office/drawing/2014/main" id="{895FBD66-AA5F-4D97-B36A-AE1A60856DAE}"/>
               </a:ext>
             </a:extLst>
           </p:cNvPr>
@@ -18124,7 +18141,7 @@
           <p:nvPr/>
         </p:nvPicPr>
         <p:blipFill>
-          <a:blip xmlns:r="http://schemas.openxmlformats.org/officeDocument/2006/relationships" xmlns:a="http://schemas.openxmlformats.org/drawingml/2006/main" r:embed="R6791e21234ee4a74"/>
+          <a:blip xmlns:r="http://schemas.openxmlformats.org/officeDocument/2006/relationships" xmlns:a="http://schemas.openxmlformats.org/drawingml/2006/main" r:embed="R77bfcb40c6364fd8"/>
           <a:stretch xmlns:a="http://schemas.openxmlformats.org/drawingml/2006/main"/>
         </p:blipFill>
         <p:spPr>
@@ -18142,7 +18159,7 @@
           <p:cNvPr id="16" name="">
             <a:extLst xmlns:a="http://schemas.openxmlformats.org/drawingml/2006/main">
               <a:ext uri="{FF2B5EF4-FFF2-40B4-BE49-F238E27FC236}">
-                <a16:creationId xmlns:a16="http://schemas.microsoft.com/office/drawing/2014/main" id="{FB7D5615-862A-4331-A786-E2FF642BD002}"/>
+                <a16:creationId xmlns:a16="http://schemas.microsoft.com/office/drawing/2014/main" id="{12050D88-1278-4A88-ABDB-997DC14A09A8}"/>
               </a:ext>
             </a:extLst>
           </p:cNvPr>
@@ -18192,7 +18209,7 @@
           <p:cNvPr id="17" name="">
             <a:extLst xmlns:a="http://schemas.openxmlformats.org/drawingml/2006/main">
               <a:ext uri="{FF2B5EF4-FFF2-40B4-BE49-F238E27FC236}">
-                <a16:creationId xmlns:a16="http://schemas.microsoft.com/office/drawing/2014/main" id="{9EF3A5AA-F688-4031-8713-C9C8A18460FC}"/>
+                <a16:creationId xmlns:a16="http://schemas.microsoft.com/office/drawing/2014/main" id="{7CD56507-34C5-4D2A-BA3C-8FB9DAFBC6BB}"/>
               </a:ext>
             </a:extLst>
           </p:cNvPr>
@@ -18240,7 +18257,7 @@
     </p:spTree>
     <p:extLst>
       <p:ext uri="{BB962C8B-B14F-4D97-AF65-F5344CB8AC3E}">
-        <p14:creationId xmlns:p14="http://schemas.microsoft.com/office/powerpoint/2010/main" val="14537944"/>
+        <p14:creationId xmlns:p14="http://schemas.microsoft.com/office/powerpoint/2010/main" val="165023335"/>
       </p:ext>
     </p:extLst>
   </p:cSld>
@@ -18271,7 +18288,7 @@
           <p:cNvPr id="1" name="">
             <a:extLst xmlns:a="http://schemas.openxmlformats.org/drawingml/2006/main">
               <a:ext uri="{FF2B5EF4-FFF2-40B4-BE49-F238E27FC236}">
-                <a16:creationId xmlns:a16="http://schemas.microsoft.com/office/drawing/2014/main" id="{3CB670C0-97CE-49E8-97F2-C16DEED1F02A}"/>
+                <a16:creationId xmlns:a16="http://schemas.microsoft.com/office/drawing/2014/main" id="{B3DBBDCD-70B3-46D6-B2AD-F3653ACFA86E}"/>
               </a:ext>
             </a:extLst>
           </p:cNvPr>
@@ -18302,7 +18319,7 @@
           <p:cNvPr id="2" name="">
             <a:extLst xmlns:a="http://schemas.openxmlformats.org/drawingml/2006/main">
               <a:ext uri="{FF2B5EF4-FFF2-40B4-BE49-F238E27FC236}">
-                <a16:creationId xmlns:a16="http://schemas.microsoft.com/office/drawing/2014/main" id="{F6C19252-232D-4FFE-8E14-601E949596B6}"/>
+                <a16:creationId xmlns:a16="http://schemas.microsoft.com/office/drawing/2014/main" id="{1478FC75-3116-4FAF-83A8-0B72C3313155}"/>
               </a:ext>
             </a:extLst>
           </p:cNvPr>
@@ -18352,7 +18369,7 @@
           <p:cNvPr id="3" name="">
             <a:extLst xmlns:a="http://schemas.openxmlformats.org/drawingml/2006/main">
               <a:ext uri="{FF2B5EF4-FFF2-40B4-BE49-F238E27FC236}">
-                <a16:creationId xmlns:a16="http://schemas.microsoft.com/office/drawing/2014/main" id="{ECD5B4E4-1075-4EBA-91E7-DF8D445214A5}"/>
+                <a16:creationId xmlns:a16="http://schemas.microsoft.com/office/drawing/2014/main" id="{02A2BCD7-82C2-4BE5-AC9F-1DB5DAE486FC}"/>
               </a:ext>
             </a:extLst>
           </p:cNvPr>
@@ -18402,7 +18419,7 @@
           <p:cNvPr id="4" name="">
             <a:extLst xmlns:a="http://schemas.openxmlformats.org/drawingml/2006/main">
               <a:ext uri="{FF2B5EF4-FFF2-40B4-BE49-F238E27FC236}">
-                <a16:creationId xmlns:a16="http://schemas.microsoft.com/office/drawing/2014/main" id="{B766D5CE-69CF-40DE-96CD-75161A4A3FD5}"/>
+                <a16:creationId xmlns:a16="http://schemas.microsoft.com/office/drawing/2014/main" id="{BC39F205-3892-450E-9932-EF4FEC4EA062}"/>
               </a:ext>
             </a:extLst>
           </p:cNvPr>
@@ -18435,7 +18452,7 @@
           <p:cNvPr id="5" name="">
             <a:extLst xmlns:a="http://schemas.openxmlformats.org/drawingml/2006/main">
               <a:ext uri="{FF2B5EF4-FFF2-40B4-BE49-F238E27FC236}">
-                <a16:creationId xmlns:a16="http://schemas.microsoft.com/office/drawing/2014/main" id="{13F27BDF-4038-4772-9530-F1FDC3D72BE4}"/>
+                <a16:creationId xmlns:a16="http://schemas.microsoft.com/office/drawing/2014/main" id="{F5E6B111-6DD3-48F9-95DB-472FB3A7070B}"/>
               </a:ext>
             </a:extLst>
           </p:cNvPr>
@@ -18485,7 +18502,7 @@
           <p:cNvPr id="6" name="">
             <a:extLst xmlns:a="http://schemas.openxmlformats.org/drawingml/2006/main">
               <a:ext uri="{FF2B5EF4-FFF2-40B4-BE49-F238E27FC236}">
-                <a16:creationId xmlns:a16="http://schemas.microsoft.com/office/drawing/2014/main" id="{BCEF07F6-C08C-427C-BA93-A87731F349EB}"/>
+                <a16:creationId xmlns:a16="http://schemas.microsoft.com/office/drawing/2014/main" id="{60A3DDE6-CD69-43D3-9991-094E668F4982}"/>
               </a:ext>
             </a:extLst>
           </p:cNvPr>
@@ -18535,7 +18552,7 @@
           <p:cNvPr id="7" name="">
             <a:extLst xmlns:a="http://schemas.openxmlformats.org/drawingml/2006/main">
               <a:ext uri="{FF2B5EF4-FFF2-40B4-BE49-F238E27FC236}">
-                <a16:creationId xmlns:a16="http://schemas.microsoft.com/office/drawing/2014/main" id="{A035FBE1-D0E5-43F5-AD97-E34CE7636D1E}"/>
+                <a16:creationId xmlns:a16="http://schemas.microsoft.com/office/drawing/2014/main" id="{ACD92F6F-CEBD-4C36-9280-5D36AEFE239A}"/>
               </a:ext>
             </a:extLst>
           </p:cNvPr>
@@ -18585,7 +18602,7 @@
           <p:cNvPr id="8" name="">
             <a:extLst xmlns:a="http://schemas.openxmlformats.org/drawingml/2006/main">
               <a:ext uri="{FF2B5EF4-FFF2-40B4-BE49-F238E27FC236}">
-                <a16:creationId xmlns:a16="http://schemas.microsoft.com/office/drawing/2014/main" id="{178AA8EB-354E-42CD-B84E-519802CF243F}"/>
+                <a16:creationId xmlns:a16="http://schemas.microsoft.com/office/drawing/2014/main" id="{E0260963-A6F8-40DB-9FE3-D3F873B7038E}"/>
               </a:ext>
             </a:extLst>
           </p:cNvPr>
@@ -18635,7 +18652,7 @@
           <p:cNvPr id="9" name="">
             <a:extLst xmlns:a="http://schemas.openxmlformats.org/drawingml/2006/main">
               <a:ext uri="{FF2B5EF4-FFF2-40B4-BE49-F238E27FC236}">
-                <a16:creationId xmlns:a16="http://schemas.microsoft.com/office/drawing/2014/main" id="{F67792CF-0D35-4A1C-967E-0D4E05100FDF}"/>
+                <a16:creationId xmlns:a16="http://schemas.microsoft.com/office/drawing/2014/main" id="{F3379C0D-764F-4AF3-BEA3-812DF1525BCF}"/>
               </a:ext>
             </a:extLst>
           </p:cNvPr>
@@ -18668,7 +18685,7 @@
           <p:cNvPr id="10" name="">
             <a:extLst xmlns:a="http://schemas.openxmlformats.org/drawingml/2006/main">
               <a:ext uri="{FF2B5EF4-FFF2-40B4-BE49-F238E27FC236}">
-                <a16:creationId xmlns:a16="http://schemas.microsoft.com/office/drawing/2014/main" id="{96054BF7-A894-43BE-A8E1-21A6732333B6}"/>
+                <a16:creationId xmlns:a16="http://schemas.microsoft.com/office/drawing/2014/main" id="{ECC5BD32-174E-4CC1-A5F4-8902F10CDF4B}"/>
               </a:ext>
             </a:extLst>
           </p:cNvPr>
@@ -18718,7 +18735,7 @@
           <p:cNvPr id="11" name="">
             <a:extLst xmlns:a="http://schemas.openxmlformats.org/drawingml/2006/main">
               <a:ext uri="{FF2B5EF4-FFF2-40B4-BE49-F238E27FC236}">
-                <a16:creationId xmlns:a16="http://schemas.microsoft.com/office/drawing/2014/main" id="{A1D06C78-DD19-4E01-A4CE-A621A4D83412}"/>
+                <a16:creationId xmlns:a16="http://schemas.microsoft.com/office/drawing/2014/main" id="{C053EE2C-60DC-40D3-BC18-621416C086ED}"/>
               </a:ext>
             </a:extLst>
           </p:cNvPr>
@@ -18768,7 +18785,7 @@
           <p:cNvPr id="12" name="">
             <a:extLst xmlns:a="http://schemas.openxmlformats.org/drawingml/2006/main">
               <a:ext uri="{FF2B5EF4-FFF2-40B4-BE49-F238E27FC236}">
-                <a16:creationId xmlns:a16="http://schemas.microsoft.com/office/drawing/2014/main" id="{A5A560FE-6751-4751-A656-040771290CD2}"/>
+                <a16:creationId xmlns:a16="http://schemas.microsoft.com/office/drawing/2014/main" id="{C1DED71E-5083-4A08-9B2E-072EFFC5D4C3}"/>
               </a:ext>
             </a:extLst>
           </p:cNvPr>
@@ -18818,7 +18835,7 @@
           <p:cNvPr id="13" name="">
             <a:extLst xmlns:a="http://schemas.openxmlformats.org/drawingml/2006/main">
               <a:ext uri="{FF2B5EF4-FFF2-40B4-BE49-F238E27FC236}">
-                <a16:creationId xmlns:a16="http://schemas.microsoft.com/office/drawing/2014/main" id="{2A22B0F9-B528-4B74-BB13-EBEB1FA3AB59}"/>
+                <a16:creationId xmlns:a16="http://schemas.microsoft.com/office/drawing/2014/main" id="{C39F648C-F7BC-47B6-A3A1-383BE1276099}"/>
               </a:ext>
             </a:extLst>
           </p:cNvPr>
@@ -18868,7 +18885,7 @@
           <p:cNvPr id="14" name="">
             <a:extLst xmlns:a="http://schemas.openxmlformats.org/drawingml/2006/main">
               <a:ext uri="{FF2B5EF4-FFF2-40B4-BE49-F238E27FC236}">
-                <a16:creationId xmlns:a16="http://schemas.microsoft.com/office/drawing/2014/main" id="{810E202C-523C-4539-97E7-39DCB5B09384}"/>
+                <a16:creationId xmlns:a16="http://schemas.microsoft.com/office/drawing/2014/main" id="{3F95A170-FFC1-417E-9588-FE9D4214812F}"/>
               </a:ext>
             </a:extLst>
           </p:cNvPr>
@@ -18901,7 +18918,7 @@
           <p:cNvPr id="15" name="">
             <a:extLst xmlns:a="http://schemas.openxmlformats.org/drawingml/2006/main">
               <a:ext uri="{FF2B5EF4-FFF2-40B4-BE49-F238E27FC236}">
-                <a16:creationId xmlns:a16="http://schemas.microsoft.com/office/drawing/2014/main" id="{1AEE5986-1213-4B82-B67F-DDBA1749233B}"/>
+                <a16:creationId xmlns:a16="http://schemas.microsoft.com/office/drawing/2014/main" id="{C83815D0-9864-40A1-953C-77C6D62FE728}"/>
               </a:ext>
             </a:extLst>
           </p:cNvPr>
@@ -18951,7 +18968,7 @@
           <p:cNvPr id="16" name="">
             <a:extLst xmlns:a="http://schemas.openxmlformats.org/drawingml/2006/main">
               <a:ext uri="{FF2B5EF4-FFF2-40B4-BE49-F238E27FC236}">
-                <a16:creationId xmlns:a16="http://schemas.microsoft.com/office/drawing/2014/main" id="{77F4650C-3686-444E-9431-3D79E8153CE2}"/>
+                <a16:creationId xmlns:a16="http://schemas.microsoft.com/office/drawing/2014/main" id="{4AA03FBE-356D-474B-8784-DD0C5B848695}"/>
               </a:ext>
             </a:extLst>
           </p:cNvPr>
@@ -19001,7 +19018,7 @@
           <p:cNvPr id="17" name="">
             <a:extLst xmlns:a="http://schemas.openxmlformats.org/drawingml/2006/main">
               <a:ext uri="{FF2B5EF4-FFF2-40B4-BE49-F238E27FC236}">
-                <a16:creationId xmlns:a16="http://schemas.microsoft.com/office/drawing/2014/main" id="{7873F97B-2733-433E-A565-56427F819C85}"/>
+                <a16:creationId xmlns:a16="http://schemas.microsoft.com/office/drawing/2014/main" id="{84517271-AF70-45AD-A014-25BABA86FC3F}"/>
               </a:ext>
             </a:extLst>
           </p:cNvPr>
@@ -19051,7 +19068,7 @@
           <p:cNvPr id="18" name="">
             <a:extLst xmlns:a="http://schemas.openxmlformats.org/drawingml/2006/main">
               <a:ext uri="{FF2B5EF4-FFF2-40B4-BE49-F238E27FC236}">
-                <a16:creationId xmlns:a16="http://schemas.microsoft.com/office/drawing/2014/main" id="{7779933D-0BA4-420F-A8B1-D6F5E7D213DF}"/>
+                <a16:creationId xmlns:a16="http://schemas.microsoft.com/office/drawing/2014/main" id="{33D225F3-E30D-4010-A899-E081EC5A68D3}"/>
               </a:ext>
             </a:extLst>
           </p:cNvPr>
@@ -19101,7 +19118,7 @@
           <p:cNvPr id="19" name="">
             <a:extLst xmlns:a="http://schemas.openxmlformats.org/drawingml/2006/main">
               <a:ext uri="{FF2B5EF4-FFF2-40B4-BE49-F238E27FC236}">
-                <a16:creationId xmlns:a16="http://schemas.microsoft.com/office/drawing/2014/main" id="{904C7454-ED6F-4835-9C9C-CDC01545A821}"/>
+                <a16:creationId xmlns:a16="http://schemas.microsoft.com/office/drawing/2014/main" id="{CCA30AEA-1C40-49FF-9D97-B72BCCC6B1E4}"/>
               </a:ext>
             </a:extLst>
           </p:cNvPr>
@@ -19134,7 +19151,7 @@
           <p:cNvPr id="20" name="">
             <a:extLst xmlns:a="http://schemas.openxmlformats.org/drawingml/2006/main">
               <a:ext uri="{FF2B5EF4-FFF2-40B4-BE49-F238E27FC236}">
-                <a16:creationId xmlns:a16="http://schemas.microsoft.com/office/drawing/2014/main" id="{0FB9ACF7-990C-49C2-9C18-A6F2358B25EA}"/>
+                <a16:creationId xmlns:a16="http://schemas.microsoft.com/office/drawing/2014/main" id="{BCBFC9D1-0C93-46E4-B9BC-52F73EC7DBFD}"/>
               </a:ext>
             </a:extLst>
           </p:cNvPr>
@@ -19184,7 +19201,7 @@
           <p:cNvPr id="21" name="">
             <a:extLst xmlns:a="http://schemas.openxmlformats.org/drawingml/2006/main">
               <a:ext uri="{FF2B5EF4-FFF2-40B4-BE49-F238E27FC236}">
-                <a16:creationId xmlns:a16="http://schemas.microsoft.com/office/drawing/2014/main" id="{62972729-102D-4CDC-87FB-328303FA86CD}"/>
+                <a16:creationId xmlns:a16="http://schemas.microsoft.com/office/drawing/2014/main" id="{B5D1ED85-34A0-457F-AEC0-40B931BCD0D2}"/>
               </a:ext>
             </a:extLst>
           </p:cNvPr>
@@ -19234,7 +19251,7 @@
           <p:cNvPr id="22" name="">
             <a:extLst xmlns:a="http://schemas.openxmlformats.org/drawingml/2006/main">
               <a:ext uri="{FF2B5EF4-FFF2-40B4-BE49-F238E27FC236}">
-                <a16:creationId xmlns:a16="http://schemas.microsoft.com/office/drawing/2014/main" id="{45F97876-0D5F-4CB4-8C01-9184942C4D3B}"/>
+                <a16:creationId xmlns:a16="http://schemas.microsoft.com/office/drawing/2014/main" id="{853B59A7-6B4C-46CB-96A7-1B5B7E40A6E7}"/>
               </a:ext>
             </a:extLst>
           </p:cNvPr>
@@ -19284,7 +19301,7 @@
           <p:cNvPr id="23" name="">
             <a:extLst xmlns:a="http://schemas.openxmlformats.org/drawingml/2006/main">
               <a:ext uri="{FF2B5EF4-FFF2-40B4-BE49-F238E27FC236}">
-                <a16:creationId xmlns:a16="http://schemas.microsoft.com/office/drawing/2014/main" id="{219F8897-BFB7-47FF-AF07-AA92E4433E9F}"/>
+                <a16:creationId xmlns:a16="http://schemas.microsoft.com/office/drawing/2014/main" id="{F6A2FBAF-9B52-43A2-AB60-5FF56EAD3D8D}"/>
               </a:ext>
             </a:extLst>
           </p:cNvPr>
@@ -19334,7 +19351,7 @@
           <p:cNvPr id="24" name="">
             <a:extLst xmlns:a="http://schemas.openxmlformats.org/drawingml/2006/main">
               <a:ext uri="{FF2B5EF4-FFF2-40B4-BE49-F238E27FC236}">
-                <a16:creationId xmlns:a16="http://schemas.microsoft.com/office/drawing/2014/main" id="{0F9BDD79-117A-4D03-8D20-92968567EFAC}"/>
+                <a16:creationId xmlns:a16="http://schemas.microsoft.com/office/drawing/2014/main" id="{AEC8C279-25B1-4B08-8110-EB374A2F3BED}"/>
               </a:ext>
             </a:extLst>
           </p:cNvPr>
@@ -19367,7 +19384,7 @@
           <p:cNvPr id="25" name="">
             <a:extLst xmlns:a="http://schemas.openxmlformats.org/drawingml/2006/main">
               <a:ext uri="{FF2B5EF4-FFF2-40B4-BE49-F238E27FC236}">
-                <a16:creationId xmlns:a16="http://schemas.microsoft.com/office/drawing/2014/main" id="{9CC4038F-0458-41AB-82DA-D8EE11AE3CBE}"/>
+                <a16:creationId xmlns:a16="http://schemas.microsoft.com/office/drawing/2014/main" id="{0279A071-4AF4-47D3-A221-07F24437D23E}"/>
               </a:ext>
             </a:extLst>
           </p:cNvPr>
@@ -19417,7 +19434,7 @@
           <p:cNvPr id="26" name="">
             <a:extLst xmlns:a="http://schemas.openxmlformats.org/drawingml/2006/main">
               <a:ext uri="{FF2B5EF4-FFF2-40B4-BE49-F238E27FC236}">
-                <a16:creationId xmlns:a16="http://schemas.microsoft.com/office/drawing/2014/main" id="{BA7CBEFB-0A58-4458-AFE6-804A46ECF3A2}"/>
+                <a16:creationId xmlns:a16="http://schemas.microsoft.com/office/drawing/2014/main" id="{F510C94A-3661-446E-A401-B30B8B74B910}"/>
               </a:ext>
             </a:extLst>
           </p:cNvPr>
@@ -19467,7 +19484,7 @@
           <p:cNvPr id="27" name="">
             <a:extLst xmlns:a="http://schemas.openxmlformats.org/drawingml/2006/main">
               <a:ext uri="{FF2B5EF4-FFF2-40B4-BE49-F238E27FC236}">
-                <a16:creationId xmlns:a16="http://schemas.microsoft.com/office/drawing/2014/main" id="{7AEDCC5E-F046-4D86-B0FD-0C7430F8072B}"/>
+                <a16:creationId xmlns:a16="http://schemas.microsoft.com/office/drawing/2014/main" id="{F47E1C7E-7ED7-45CA-AC57-749ABF84131B}"/>
               </a:ext>
             </a:extLst>
           </p:cNvPr>
@@ -19517,7 +19534,7 @@
           <p:cNvPr id="28" name="">
             <a:extLst xmlns:a="http://schemas.openxmlformats.org/drawingml/2006/main">
               <a:ext uri="{FF2B5EF4-FFF2-40B4-BE49-F238E27FC236}">
-                <a16:creationId xmlns:a16="http://schemas.microsoft.com/office/drawing/2014/main" id="{D89F32BB-F5B8-4C57-ABD1-8F370C5D5C56}"/>
+                <a16:creationId xmlns:a16="http://schemas.microsoft.com/office/drawing/2014/main" id="{88D44710-782C-4BAD-A06F-693EA7869D04}"/>
               </a:ext>
             </a:extLst>
           </p:cNvPr>
@@ -19552,7 +19569,7 @@
           <p:nvPr/>
         </p:nvPicPr>
         <p:blipFill>
-          <a:blip xmlns:r="http://schemas.openxmlformats.org/officeDocument/2006/relationships" xmlns:a="http://schemas.openxmlformats.org/drawingml/2006/main" r:embed="R71b8b749d2714773"/>
+          <a:blip xmlns:r="http://schemas.openxmlformats.org/officeDocument/2006/relationships" xmlns:a="http://schemas.openxmlformats.org/drawingml/2006/main" r:embed="R4b6d5b95e8ea41d3"/>
           <a:stretch xmlns:a="http://schemas.openxmlformats.org/drawingml/2006/main"/>
         </p:blipFill>
         <p:spPr>
@@ -19570,7 +19587,7 @@
           <p:cNvPr id="30" name="">
             <a:extLst xmlns:a="http://schemas.openxmlformats.org/drawingml/2006/main">
               <a:ext uri="{FF2B5EF4-FFF2-40B4-BE49-F238E27FC236}">
-                <a16:creationId xmlns:a16="http://schemas.microsoft.com/office/drawing/2014/main" id="{029D21C2-9E21-44D8-9B39-C6CD4A85A0C2}"/>
+                <a16:creationId xmlns:a16="http://schemas.microsoft.com/office/drawing/2014/main" id="{7CA83613-2AA3-482A-AA2C-6A6FC1E650B3}"/>
               </a:ext>
             </a:extLst>
           </p:cNvPr>
@@ -19620,7 +19637,7 @@
           <p:cNvPr id="31" name="">
             <a:extLst xmlns:a="http://schemas.openxmlformats.org/drawingml/2006/main">
               <a:ext uri="{FF2B5EF4-FFF2-40B4-BE49-F238E27FC236}">
-                <a16:creationId xmlns:a16="http://schemas.microsoft.com/office/drawing/2014/main" id="{D1FBB915-32E1-4D63-8389-71773E460B71}"/>
+                <a16:creationId xmlns:a16="http://schemas.microsoft.com/office/drawing/2014/main" id="{6AAC0A7A-97D6-4652-9A11-891AD89D75D7}"/>
               </a:ext>
             </a:extLst>
           </p:cNvPr>
@@ -19668,7 +19685,7 @@
     </p:spTree>
     <p:extLst>
       <p:ext uri="{BB962C8B-B14F-4D97-AF65-F5344CB8AC3E}">
-        <p14:creationId xmlns:p14="http://schemas.microsoft.com/office/powerpoint/2010/main" val="1403925145"/>
+        <p14:creationId xmlns:p14="http://schemas.microsoft.com/office/powerpoint/2010/main" val="672774303"/>
       </p:ext>
     </p:extLst>
   </p:cSld>
@@ -19699,7 +19716,7 @@
           <p:cNvPr id="1" name="">
             <a:extLst xmlns:a="http://schemas.openxmlformats.org/drawingml/2006/main">
               <a:ext uri="{FF2B5EF4-FFF2-40B4-BE49-F238E27FC236}">
-                <a16:creationId xmlns:a16="http://schemas.microsoft.com/office/drawing/2014/main" id="{25B210CC-10A5-4B09-804F-DB3621867E51}"/>
+                <a16:creationId xmlns:a16="http://schemas.microsoft.com/office/drawing/2014/main" id="{8AD371E9-91E0-4B31-AAD8-EFB784BC0609}"/>
               </a:ext>
             </a:extLst>
           </p:cNvPr>
@@ -19730,7 +19747,7 @@
           <p:cNvPr id="2" name="">
             <a:extLst xmlns:a="http://schemas.openxmlformats.org/drawingml/2006/main">
               <a:ext uri="{FF2B5EF4-FFF2-40B4-BE49-F238E27FC236}">
-                <a16:creationId xmlns:a16="http://schemas.microsoft.com/office/drawing/2014/main" id="{75C8410F-C6BD-4DF6-9704-161E7C91542D}"/>
+                <a16:creationId xmlns:a16="http://schemas.microsoft.com/office/drawing/2014/main" id="{94DAECF3-7697-4BBF-B0A4-0BD96E061470}"/>
               </a:ext>
             </a:extLst>
           </p:cNvPr>
@@ -19780,7 +19797,7 @@
           <p:cNvPr id="3" name="">
             <a:extLst xmlns:a="http://schemas.openxmlformats.org/drawingml/2006/main">
               <a:ext uri="{FF2B5EF4-FFF2-40B4-BE49-F238E27FC236}">
-                <a16:creationId xmlns:a16="http://schemas.microsoft.com/office/drawing/2014/main" id="{4A45FD02-BB37-4E4C-82D9-4DA3F7C03F84}"/>
+                <a16:creationId xmlns:a16="http://schemas.microsoft.com/office/drawing/2014/main" id="{C24B3019-3C66-4147-B515-B2B06CE8729D}"/>
               </a:ext>
             </a:extLst>
           </p:cNvPr>
@@ -19830,7 +19847,7 @@
           <p:cNvPr id="4" name="">
             <a:extLst xmlns:a="http://schemas.openxmlformats.org/drawingml/2006/main">
               <a:ext uri="{FF2B5EF4-FFF2-40B4-BE49-F238E27FC236}">
-                <a16:creationId xmlns:a16="http://schemas.microsoft.com/office/drawing/2014/main" id="{28B128B2-D26F-4612-86B9-98A541707536}"/>
+                <a16:creationId xmlns:a16="http://schemas.microsoft.com/office/drawing/2014/main" id="{943B4043-73E5-4BD7-8132-CDD2BA83364B}"/>
               </a:ext>
             </a:extLst>
           </p:cNvPr>
@@ -19865,7 +19882,7 @@
           <p:cNvPr id="5" name="">
             <a:extLst xmlns:a="http://schemas.openxmlformats.org/drawingml/2006/main">
               <a:ext uri="{FF2B5EF4-FFF2-40B4-BE49-F238E27FC236}">
-                <a16:creationId xmlns:a16="http://schemas.microsoft.com/office/drawing/2014/main" id="{2608C571-EC4F-4E64-84DA-6D6D269CBB81}"/>
+                <a16:creationId xmlns:a16="http://schemas.microsoft.com/office/drawing/2014/main" id="{359E83D6-6C5C-4A29-A3C7-64042138DDBF}"/>
               </a:ext>
             </a:extLst>
           </p:cNvPr>
@@ -19896,7 +19913,7 @@
           <p:cNvPr id="6" name="">
             <a:extLst xmlns:a="http://schemas.openxmlformats.org/drawingml/2006/main">
               <a:ext uri="{FF2B5EF4-FFF2-40B4-BE49-F238E27FC236}">
-                <a16:creationId xmlns:a16="http://schemas.microsoft.com/office/drawing/2014/main" id="{3B94F528-2826-49E6-BF62-01EF296E7B65}"/>
+                <a16:creationId xmlns:a16="http://schemas.microsoft.com/office/drawing/2014/main" id="{1DCFEC18-75FF-46B0-BE1D-2D7B540C3D3A}"/>
               </a:ext>
             </a:extLst>
           </p:cNvPr>
@@ -19946,7 +19963,7 @@
           <p:cNvPr id="7" name="">
             <a:extLst xmlns:a="http://schemas.openxmlformats.org/drawingml/2006/main">
               <a:ext uri="{FF2B5EF4-FFF2-40B4-BE49-F238E27FC236}">
-                <a16:creationId xmlns:a16="http://schemas.microsoft.com/office/drawing/2014/main" id="{F128A4C9-62AF-4AC5-80FA-55405049EA1F}"/>
+                <a16:creationId xmlns:a16="http://schemas.microsoft.com/office/drawing/2014/main" id="{DB78139F-564E-45DB-A26D-E20558C36627}"/>
               </a:ext>
             </a:extLst>
           </p:cNvPr>
@@ -19977,7 +19994,7 @@
           <p:cNvPr id="8" name="">
             <a:extLst xmlns:a="http://schemas.openxmlformats.org/drawingml/2006/main">
               <a:ext uri="{FF2B5EF4-FFF2-40B4-BE49-F238E27FC236}">
-                <a16:creationId xmlns:a16="http://schemas.microsoft.com/office/drawing/2014/main" id="{93B2E5AC-BC2B-45CE-B755-99743DF0703B}"/>
+                <a16:creationId xmlns:a16="http://schemas.microsoft.com/office/drawing/2014/main" id="{2DBAF56B-9B9E-4865-B81D-5D527ADF2F66}"/>
               </a:ext>
             </a:extLst>
           </p:cNvPr>
@@ -20008,7 +20025,7 @@
           <p:cNvPr id="9" name="">
             <a:extLst xmlns:a="http://schemas.openxmlformats.org/drawingml/2006/main">
               <a:ext uri="{FF2B5EF4-FFF2-40B4-BE49-F238E27FC236}">
-                <a16:creationId xmlns:a16="http://schemas.microsoft.com/office/drawing/2014/main" id="{C7D24A72-CEA9-463A-B557-466BDD8BED9C}"/>
+                <a16:creationId xmlns:a16="http://schemas.microsoft.com/office/drawing/2014/main" id="{B62AAF29-68EF-4ABD-A292-A9D1BA172E56}"/>
               </a:ext>
             </a:extLst>
           </p:cNvPr>
@@ -20039,7 +20056,7 @@
           <p:cNvPr id="10" name="">
             <a:extLst xmlns:a="http://schemas.openxmlformats.org/drawingml/2006/main">
               <a:ext uri="{FF2B5EF4-FFF2-40B4-BE49-F238E27FC236}">
-                <a16:creationId xmlns:a16="http://schemas.microsoft.com/office/drawing/2014/main" id="{147BE4D8-98BB-43D3-B9DB-94A3465C9D7B}"/>
+                <a16:creationId xmlns:a16="http://schemas.microsoft.com/office/drawing/2014/main" id="{47033173-589F-4AFB-B7A9-C1713A457A70}"/>
               </a:ext>
             </a:extLst>
           </p:cNvPr>
@@ -20123,7 +20140,7 @@
           <p:cNvPr id="11" name="">
             <a:extLst xmlns:a="http://schemas.openxmlformats.org/drawingml/2006/main">
               <a:ext uri="{FF2B5EF4-FFF2-40B4-BE49-F238E27FC236}">
-                <a16:creationId xmlns:a16="http://schemas.microsoft.com/office/drawing/2014/main" id="{F7891C24-79BB-4C2B-AB20-4BA3201B0AA9}"/>
+                <a16:creationId xmlns:a16="http://schemas.microsoft.com/office/drawing/2014/main" id="{60C96CDB-BA66-4561-B653-44BB173C985B}"/>
               </a:ext>
             </a:extLst>
           </p:cNvPr>
@@ -20217,7 +20234,7 @@
           <p:cNvPr id="12" name="">
             <a:extLst xmlns:a="http://schemas.openxmlformats.org/drawingml/2006/main">
               <a:ext uri="{FF2B5EF4-FFF2-40B4-BE49-F238E27FC236}">
-                <a16:creationId xmlns:a16="http://schemas.microsoft.com/office/drawing/2014/main" id="{EC509097-51C7-4526-967A-3DCDD4C1A72C}"/>
+                <a16:creationId xmlns:a16="http://schemas.microsoft.com/office/drawing/2014/main" id="{3290E43F-B0DD-4AC0-980B-DECADC7D3DE0}"/>
               </a:ext>
             </a:extLst>
           </p:cNvPr>
@@ -20318,7 +20335,7 @@
           <p:cNvPr id="13" name="">
             <a:extLst xmlns:a="http://schemas.openxmlformats.org/drawingml/2006/main">
               <a:ext uri="{FF2B5EF4-FFF2-40B4-BE49-F238E27FC236}">
-                <a16:creationId xmlns:a16="http://schemas.microsoft.com/office/drawing/2014/main" id="{99D84CCD-C218-4653-84BF-A82EA5669923}"/>
+                <a16:creationId xmlns:a16="http://schemas.microsoft.com/office/drawing/2014/main" id="{B35D8335-D2B8-4E66-B8B9-AA5DEBEE030F}"/>
               </a:ext>
             </a:extLst>
           </p:cNvPr>
@@ -20349,7 +20366,7 @@
           <p:cNvPr id="14" name="">
             <a:extLst xmlns:a="http://schemas.openxmlformats.org/drawingml/2006/main">
               <a:ext uri="{FF2B5EF4-FFF2-40B4-BE49-F238E27FC236}">
-                <a16:creationId xmlns:a16="http://schemas.microsoft.com/office/drawing/2014/main" id="{60DFE883-CFE2-432B-8184-9CD38A545781}"/>
+                <a16:creationId xmlns:a16="http://schemas.microsoft.com/office/drawing/2014/main" id="{75C178D6-3A4E-4DD8-A5A5-73541EBBCD6B}"/>
               </a:ext>
             </a:extLst>
           </p:cNvPr>
@@ -20399,7 +20416,7 @@
           <p:cNvPr id="15" name="">
             <a:extLst xmlns:a="http://schemas.openxmlformats.org/drawingml/2006/main">
               <a:ext uri="{FF2B5EF4-FFF2-40B4-BE49-F238E27FC236}">
-                <a16:creationId xmlns:a16="http://schemas.microsoft.com/office/drawing/2014/main" id="{BA71B239-10D3-4638-9460-A3B3C09A565A}"/>
+                <a16:creationId xmlns:a16="http://schemas.microsoft.com/office/drawing/2014/main" id="{CB35069B-C695-4123-A90C-BF89272FE7B6}"/>
               </a:ext>
             </a:extLst>
           </p:cNvPr>
@@ -20449,7 +20466,7 @@
           <p:cNvPr id="16" name="">
             <a:extLst xmlns:a="http://schemas.openxmlformats.org/drawingml/2006/main">
               <a:ext uri="{FF2B5EF4-FFF2-40B4-BE49-F238E27FC236}">
-                <a16:creationId xmlns:a16="http://schemas.microsoft.com/office/drawing/2014/main" id="{A8F2B824-4733-413B-B1D0-36F7C7788F83}"/>
+                <a16:creationId xmlns:a16="http://schemas.microsoft.com/office/drawing/2014/main" id="{FDDC978D-E310-43BD-8BAF-4D8FA27AFBA3}"/>
               </a:ext>
             </a:extLst>
           </p:cNvPr>
@@ -20480,7 +20497,7 @@
           <p:cNvPr id="17" name="">
             <a:extLst xmlns:a="http://schemas.openxmlformats.org/drawingml/2006/main">
               <a:ext uri="{FF2B5EF4-FFF2-40B4-BE49-F238E27FC236}">
-                <a16:creationId xmlns:a16="http://schemas.microsoft.com/office/drawing/2014/main" id="{98B0D948-F197-4B17-AC73-5B696526BD5B}"/>
+                <a16:creationId xmlns:a16="http://schemas.microsoft.com/office/drawing/2014/main" id="{F8B3B26F-CAF2-414E-A570-B4CD378B35EA}"/>
               </a:ext>
             </a:extLst>
           </p:cNvPr>
@@ -20530,7 +20547,7 @@
           <p:cNvPr id="18" name="">
             <a:extLst xmlns:a="http://schemas.openxmlformats.org/drawingml/2006/main">
               <a:ext uri="{FF2B5EF4-FFF2-40B4-BE49-F238E27FC236}">
-                <a16:creationId xmlns:a16="http://schemas.microsoft.com/office/drawing/2014/main" id="{05CEFCCF-B8CB-403F-9125-A3233DB3E85F}"/>
+                <a16:creationId xmlns:a16="http://schemas.microsoft.com/office/drawing/2014/main" id="{10FEA8FD-FD94-405F-B4EC-0E990E540AA8}"/>
               </a:ext>
             </a:extLst>
           </p:cNvPr>
@@ -20580,7 +20597,7 @@
           <p:cNvPr id="19" name="">
             <a:extLst xmlns:a="http://schemas.openxmlformats.org/drawingml/2006/main">
               <a:ext uri="{FF2B5EF4-FFF2-40B4-BE49-F238E27FC236}">
-                <a16:creationId xmlns:a16="http://schemas.microsoft.com/office/drawing/2014/main" id="{8A24B8B4-24A9-4A1D-961F-F7547689757A}"/>
+                <a16:creationId xmlns:a16="http://schemas.microsoft.com/office/drawing/2014/main" id="{F8CE098C-ECA4-4E9D-B9F1-A33D1A293210}"/>
               </a:ext>
             </a:extLst>
           </p:cNvPr>
@@ -20611,7 +20628,7 @@
           <p:cNvPr id="20" name="">
             <a:extLst xmlns:a="http://schemas.openxmlformats.org/drawingml/2006/main">
               <a:ext uri="{FF2B5EF4-FFF2-40B4-BE49-F238E27FC236}">
-                <a16:creationId xmlns:a16="http://schemas.microsoft.com/office/drawing/2014/main" id="{29DC89F0-C38F-458C-B03B-5389651FC620}"/>
+                <a16:creationId xmlns:a16="http://schemas.microsoft.com/office/drawing/2014/main" id="{7780C6B2-4F4E-45B0-8BC4-4FBE008D3697}"/>
               </a:ext>
             </a:extLst>
           </p:cNvPr>
@@ -20661,7 +20678,7 @@
           <p:cNvPr id="21" name="">
             <a:extLst xmlns:a="http://schemas.openxmlformats.org/drawingml/2006/main">
               <a:ext uri="{FF2B5EF4-FFF2-40B4-BE49-F238E27FC236}">
-                <a16:creationId xmlns:a16="http://schemas.microsoft.com/office/drawing/2014/main" id="{D4AA6DB7-C227-4443-8132-E706DD917CD6}"/>
+                <a16:creationId xmlns:a16="http://schemas.microsoft.com/office/drawing/2014/main" id="{135FB8A4-92B8-4A1A-9F24-CAB5E12AB306}"/>
               </a:ext>
             </a:extLst>
           </p:cNvPr>
@@ -20711,7 +20728,7 @@
           <p:cNvPr id="22" name="">
             <a:extLst xmlns:a="http://schemas.openxmlformats.org/drawingml/2006/main">
               <a:ext uri="{FF2B5EF4-FFF2-40B4-BE49-F238E27FC236}">
-                <a16:creationId xmlns:a16="http://schemas.microsoft.com/office/drawing/2014/main" id="{EC68C5AE-6D93-47F1-BC97-5A73F2240A9C}"/>
+                <a16:creationId xmlns:a16="http://schemas.microsoft.com/office/drawing/2014/main" id="{04F98D94-E599-4DEA-A7C7-49B80D8BDC2D}"/>
               </a:ext>
             </a:extLst>
           </p:cNvPr>
@@ -20742,7 +20759,7 @@
           <p:cNvPr id="23" name="">
             <a:extLst xmlns:a="http://schemas.openxmlformats.org/drawingml/2006/main">
               <a:ext uri="{FF2B5EF4-FFF2-40B4-BE49-F238E27FC236}">
-                <a16:creationId xmlns:a16="http://schemas.microsoft.com/office/drawing/2014/main" id="{B7D7C952-ADA5-4146-99E4-8FEB3F75474A}"/>
+                <a16:creationId xmlns:a16="http://schemas.microsoft.com/office/drawing/2014/main" id="{4DB4192C-95C0-4AED-B214-59A748E17638}"/>
               </a:ext>
             </a:extLst>
           </p:cNvPr>
@@ -20792,7 +20809,7 @@
           <p:cNvPr id="24" name="">
             <a:extLst xmlns:a="http://schemas.openxmlformats.org/drawingml/2006/main">
               <a:ext uri="{FF2B5EF4-FFF2-40B4-BE49-F238E27FC236}">
-                <a16:creationId xmlns:a16="http://schemas.microsoft.com/office/drawing/2014/main" id="{39B7F7FA-66F7-4151-A6AD-EBA9A5529AFF}"/>
+                <a16:creationId xmlns:a16="http://schemas.microsoft.com/office/drawing/2014/main" id="{297E0E9B-9C40-4EA4-ACBC-DC31DCBB18CB}"/>
               </a:ext>
             </a:extLst>
           </p:cNvPr>
@@ -20842,7 +20859,7 @@
           <p:cNvPr id="25" name="">
             <a:extLst xmlns:a="http://schemas.openxmlformats.org/drawingml/2006/main">
               <a:ext uri="{FF2B5EF4-FFF2-40B4-BE49-F238E27FC236}">
-                <a16:creationId xmlns:a16="http://schemas.microsoft.com/office/drawing/2014/main" id="{F102AF8D-6125-4041-87FC-F857BF1887F6}"/>
+                <a16:creationId xmlns:a16="http://schemas.microsoft.com/office/drawing/2014/main" id="{8F9E1346-AED2-4C99-80F7-2E1361D9D05F}"/>
               </a:ext>
             </a:extLst>
           </p:cNvPr>
@@ -20877,7 +20894,7 @@
           <p:nvPr/>
         </p:nvPicPr>
         <p:blipFill>
-          <a:blip xmlns:r="http://schemas.openxmlformats.org/officeDocument/2006/relationships" xmlns:a="http://schemas.openxmlformats.org/drawingml/2006/main" r:embed="Ra3c9128997f14a60"/>
+          <a:blip xmlns:r="http://schemas.openxmlformats.org/officeDocument/2006/relationships" xmlns:a="http://schemas.openxmlformats.org/drawingml/2006/main" r:embed="Rd4778fbbc44049d9"/>
           <a:stretch xmlns:a="http://schemas.openxmlformats.org/drawingml/2006/main"/>
         </p:blipFill>
         <p:spPr>
@@ -20895,7 +20912,7 @@
           <p:cNvPr id="27" name="">
             <a:extLst xmlns:a="http://schemas.openxmlformats.org/drawingml/2006/main">
               <a:ext uri="{FF2B5EF4-FFF2-40B4-BE49-F238E27FC236}">
-                <a16:creationId xmlns:a16="http://schemas.microsoft.com/office/drawing/2014/main" id="{47487E43-A3B2-4F10-B282-B3956251E4C9}"/>
+                <a16:creationId xmlns:a16="http://schemas.microsoft.com/office/drawing/2014/main" id="{1C32D0C5-4D17-4C5A-8CB1-04F4182D056B}"/>
               </a:ext>
             </a:extLst>
           </p:cNvPr>
@@ -20945,7 +20962,7 @@
           <p:cNvPr id="28" name="">
             <a:extLst xmlns:a="http://schemas.openxmlformats.org/drawingml/2006/main">
               <a:ext uri="{FF2B5EF4-FFF2-40B4-BE49-F238E27FC236}">
-                <a16:creationId xmlns:a16="http://schemas.microsoft.com/office/drawing/2014/main" id="{2B5AAA29-BDCA-406C-A8F9-258AD116209A}"/>
+                <a16:creationId xmlns:a16="http://schemas.microsoft.com/office/drawing/2014/main" id="{4E1B1B12-76C8-4C6C-99A7-B75641C2DC17}"/>
               </a:ext>
             </a:extLst>
           </p:cNvPr>
@@ -20993,7 +21010,7 @@
     </p:spTree>
     <p:extLst>
       <p:ext uri="{BB962C8B-B14F-4D97-AF65-F5344CB8AC3E}">
-        <p14:creationId xmlns:p14="http://schemas.microsoft.com/office/powerpoint/2010/main" val="638371562"/>
+        <p14:creationId xmlns:p14="http://schemas.microsoft.com/office/powerpoint/2010/main" val="148458322"/>
       </p:ext>
     </p:extLst>
   </p:cSld>
@@ -21024,7 +21041,7 @@
           <p:cNvPr id="1" name="">
             <a:extLst xmlns:a="http://schemas.openxmlformats.org/drawingml/2006/main">
               <a:ext uri="{FF2B5EF4-FFF2-40B4-BE49-F238E27FC236}">
-                <a16:creationId xmlns:a16="http://schemas.microsoft.com/office/drawing/2014/main" id="{E21E9399-F87E-475D-BBC6-0F92B8266013}"/>
+                <a16:creationId xmlns:a16="http://schemas.microsoft.com/office/drawing/2014/main" id="{93404B0D-7F78-4FBC-A559-2C2640A881BE}"/>
               </a:ext>
             </a:extLst>
           </p:cNvPr>
@@ -21055,7 +21072,7 @@
           <p:cNvPr id="2" name="">
             <a:extLst xmlns:a="http://schemas.openxmlformats.org/drawingml/2006/main">
               <a:ext uri="{FF2B5EF4-FFF2-40B4-BE49-F238E27FC236}">
-                <a16:creationId xmlns:a16="http://schemas.microsoft.com/office/drawing/2014/main" id="{8C114D77-8E5E-4F2C-AB82-B7472E21DB5E}"/>
+                <a16:creationId xmlns:a16="http://schemas.microsoft.com/office/drawing/2014/main" id="{6D6DCF94-F419-4674-852B-006F0FAA1AE1}"/>
               </a:ext>
             </a:extLst>
           </p:cNvPr>
@@ -21105,7 +21122,7 @@
           <p:cNvPr id="3" name="">
             <a:extLst xmlns:a="http://schemas.openxmlformats.org/drawingml/2006/main">
               <a:ext uri="{FF2B5EF4-FFF2-40B4-BE49-F238E27FC236}">
-                <a16:creationId xmlns:a16="http://schemas.microsoft.com/office/drawing/2014/main" id="{65430812-70FB-4E90-AB25-DBDA4692FEE3}"/>
+                <a16:creationId xmlns:a16="http://schemas.microsoft.com/office/drawing/2014/main" id="{FF4E22BC-55CA-4C77-ABEF-57A7F0645F2D}"/>
               </a:ext>
             </a:extLst>
           </p:cNvPr>
@@ -21155,7 +21172,7 @@
           <p:cNvPr id="4" name="">
             <a:extLst xmlns:a="http://schemas.openxmlformats.org/drawingml/2006/main">
               <a:ext uri="{FF2B5EF4-FFF2-40B4-BE49-F238E27FC236}">
-                <a16:creationId xmlns:a16="http://schemas.microsoft.com/office/drawing/2014/main" id="{5D54BA1A-893D-41F1-9A41-A69AB8175443}"/>
+                <a16:creationId xmlns:a16="http://schemas.microsoft.com/office/drawing/2014/main" id="{F51B8D3C-3E16-4DA2-9602-2C4A8A2FB23F}"/>
               </a:ext>
             </a:extLst>
           </p:cNvPr>
@@ -21190,7 +21207,7 @@
           <p:cNvPr id="5" name="">
             <a:extLst xmlns:a="http://schemas.openxmlformats.org/drawingml/2006/main">
               <a:ext uri="{FF2B5EF4-FFF2-40B4-BE49-F238E27FC236}">
-                <a16:creationId xmlns:a16="http://schemas.microsoft.com/office/drawing/2014/main" id="{97A5A8D3-C5E7-4C5B-9532-28DE2A2653A3}"/>
+                <a16:creationId xmlns:a16="http://schemas.microsoft.com/office/drawing/2014/main" id="{DB923F82-FD12-41D4-A18E-53435FC5D850}"/>
               </a:ext>
             </a:extLst>
           </p:cNvPr>
@@ -21240,7 +21257,7 @@
           <p:cNvPr id="6" name="">
             <a:extLst xmlns:a="http://schemas.openxmlformats.org/drawingml/2006/main">
               <a:ext uri="{FF2B5EF4-FFF2-40B4-BE49-F238E27FC236}">
-                <a16:creationId xmlns:a16="http://schemas.microsoft.com/office/drawing/2014/main" id="{D5997169-26FF-4BDF-84B5-7A55ABD1CEA8}"/>
+                <a16:creationId xmlns:a16="http://schemas.microsoft.com/office/drawing/2014/main" id="{9F29D6AD-82B2-46AA-A028-62B5C5752F68}"/>
               </a:ext>
             </a:extLst>
           </p:cNvPr>
@@ -21341,7 +21358,7 @@
           <p:cNvPr id="7" name="">
             <a:extLst xmlns:a="http://schemas.openxmlformats.org/drawingml/2006/main">
               <a:ext uri="{FF2B5EF4-FFF2-40B4-BE49-F238E27FC236}">
-                <a16:creationId xmlns:a16="http://schemas.microsoft.com/office/drawing/2014/main" id="{852413D0-F0B8-4139-BC49-C70E6717338F}"/>
+                <a16:creationId xmlns:a16="http://schemas.microsoft.com/office/drawing/2014/main" id="{488C972A-C1A6-43A7-A11F-8195C28B6820}"/>
               </a:ext>
             </a:extLst>
           </p:cNvPr>
@@ -21376,7 +21393,7 @@
           <p:cNvPr id="8" name="">
             <a:extLst xmlns:a="http://schemas.openxmlformats.org/drawingml/2006/main">
               <a:ext uri="{FF2B5EF4-FFF2-40B4-BE49-F238E27FC236}">
-                <a16:creationId xmlns:a16="http://schemas.microsoft.com/office/drawing/2014/main" id="{54FDF8A4-FAB0-491D-9EC9-A7A620775208}"/>
+                <a16:creationId xmlns:a16="http://schemas.microsoft.com/office/drawing/2014/main" id="{0477C3CC-A874-431F-BE4E-611ED5C91E98}"/>
               </a:ext>
             </a:extLst>
           </p:cNvPr>
@@ -21426,7 +21443,7 @@
           <p:cNvPr id="9" name="">
             <a:extLst xmlns:a="http://schemas.openxmlformats.org/drawingml/2006/main">
               <a:ext uri="{FF2B5EF4-FFF2-40B4-BE49-F238E27FC236}">
-                <a16:creationId xmlns:a16="http://schemas.microsoft.com/office/drawing/2014/main" id="{DEB98128-341D-48EC-869F-955A100C0EFD}"/>
+                <a16:creationId xmlns:a16="http://schemas.microsoft.com/office/drawing/2014/main" id="{C97AC7FD-D9C3-4CDC-B90C-4B3325839CF6}"/>
               </a:ext>
             </a:extLst>
           </p:cNvPr>
@@ -21527,7 +21544,7 @@
           <p:cNvPr id="10" name="">
             <a:extLst xmlns:a="http://schemas.openxmlformats.org/drawingml/2006/main">
               <a:ext uri="{FF2B5EF4-FFF2-40B4-BE49-F238E27FC236}">
-                <a16:creationId xmlns:a16="http://schemas.microsoft.com/office/drawing/2014/main" id="{F2B500DC-2C76-4840-922B-EFB9E2E58CF2}"/>
+                <a16:creationId xmlns:a16="http://schemas.microsoft.com/office/drawing/2014/main" id="{17C304A9-3705-44F6-9289-B22FDABF310D}"/>
               </a:ext>
             </a:extLst>
           </p:cNvPr>
@@ -21558,7 +21575,7 @@
           <p:cNvPr id="11" name="">
             <a:extLst xmlns:a="http://schemas.openxmlformats.org/drawingml/2006/main">
               <a:ext uri="{FF2B5EF4-FFF2-40B4-BE49-F238E27FC236}">
-                <a16:creationId xmlns:a16="http://schemas.microsoft.com/office/drawing/2014/main" id="{9DA29701-A0BE-4291-9804-2857D30B6FAC}"/>
+                <a16:creationId xmlns:a16="http://schemas.microsoft.com/office/drawing/2014/main" id="{9DFA7F27-2C0B-44CD-B44E-B3485BFAE9C0}"/>
               </a:ext>
             </a:extLst>
           </p:cNvPr>
@@ -21589,7 +21606,7 @@
           <p:cNvPr id="12" name="">
             <a:extLst xmlns:a="http://schemas.openxmlformats.org/drawingml/2006/main">
               <a:ext uri="{FF2B5EF4-FFF2-40B4-BE49-F238E27FC236}">
-                <a16:creationId xmlns:a16="http://schemas.microsoft.com/office/drawing/2014/main" id="{85DC42CC-41B3-42EF-93EE-1E309F9BB81F}"/>
+                <a16:creationId xmlns:a16="http://schemas.microsoft.com/office/drawing/2014/main" id="{7AD3EA7A-4F2D-46F5-AEF7-29824DA4B6B5}"/>
               </a:ext>
             </a:extLst>
           </p:cNvPr>
@@ -21624,7 +21641,7 @@
           <p:nvPr/>
         </p:nvPicPr>
         <p:blipFill>
-          <a:blip xmlns:r="http://schemas.openxmlformats.org/officeDocument/2006/relationships" xmlns:a="http://schemas.openxmlformats.org/drawingml/2006/main" r:embed="R15c1f01ff98341bc"/>
+          <a:blip xmlns:r="http://schemas.openxmlformats.org/officeDocument/2006/relationships" xmlns:a="http://schemas.openxmlformats.org/drawingml/2006/main" r:embed="R7e2b82a43d9d4b4a"/>
           <a:stretch xmlns:a="http://schemas.openxmlformats.org/drawingml/2006/main"/>
         </p:blipFill>
         <p:spPr>
@@ -21642,7 +21659,7 @@
           <p:cNvPr id="14" name="">
             <a:extLst xmlns:a="http://schemas.openxmlformats.org/drawingml/2006/main">
               <a:ext uri="{FF2B5EF4-FFF2-40B4-BE49-F238E27FC236}">
-                <a16:creationId xmlns:a16="http://schemas.microsoft.com/office/drawing/2014/main" id="{C3C16A7D-D81B-4761-8C06-B841108FB63B}"/>
+                <a16:creationId xmlns:a16="http://schemas.microsoft.com/office/drawing/2014/main" id="{0DF806FC-80C2-45F3-B810-27D24CF30BB7}"/>
               </a:ext>
             </a:extLst>
           </p:cNvPr>
@@ -21692,7 +21709,7 @@
           <p:cNvPr id="15" name="">
             <a:extLst xmlns:a="http://schemas.openxmlformats.org/drawingml/2006/main">
               <a:ext uri="{FF2B5EF4-FFF2-40B4-BE49-F238E27FC236}">
-                <a16:creationId xmlns:a16="http://schemas.microsoft.com/office/drawing/2014/main" id="{287B4291-6A91-4AD9-A213-B7F3585B12A3}"/>
+                <a16:creationId xmlns:a16="http://schemas.microsoft.com/office/drawing/2014/main" id="{CBCD2BDB-B001-46AC-9269-393F1B18B27E}"/>
               </a:ext>
             </a:extLst>
           </p:cNvPr>
@@ -21740,7 +21757,7 @@
     </p:spTree>
     <p:extLst>
       <p:ext uri="{BB962C8B-B14F-4D97-AF65-F5344CB8AC3E}">
-        <p14:creationId xmlns:p14="http://schemas.microsoft.com/office/powerpoint/2010/main" val="967971223"/>
+        <p14:creationId xmlns:p14="http://schemas.microsoft.com/office/powerpoint/2010/main" val="120375887"/>
       </p:ext>
     </p:extLst>
   </p:cSld>
@@ -21771,7 +21788,7 @@
           <p:cNvPr id="1" name="">
             <a:extLst xmlns:a="http://schemas.openxmlformats.org/drawingml/2006/main">
               <a:ext uri="{FF2B5EF4-FFF2-40B4-BE49-F238E27FC236}">
-                <a16:creationId xmlns:a16="http://schemas.microsoft.com/office/drawing/2014/main" id="{39038AB2-E96F-4441-AF5C-6BCBEA54EF43}"/>
+                <a16:creationId xmlns:a16="http://schemas.microsoft.com/office/drawing/2014/main" id="{3BADE4D2-1014-4DE2-97D8-F0AC4863AB7E}"/>
               </a:ext>
             </a:extLst>
           </p:cNvPr>
@@ -21802,7 +21819,7 @@
           <p:cNvPr id="2" name="">
             <a:extLst xmlns:a="http://schemas.openxmlformats.org/drawingml/2006/main">
               <a:ext uri="{FF2B5EF4-FFF2-40B4-BE49-F238E27FC236}">
-                <a16:creationId xmlns:a16="http://schemas.microsoft.com/office/drawing/2014/main" id="{987F593A-821C-4F6A-ACDA-18C88286162F}"/>
+                <a16:creationId xmlns:a16="http://schemas.microsoft.com/office/drawing/2014/main" id="{C099DD89-6E0B-4D28-9AA0-9EBF83A0F334}"/>
               </a:ext>
             </a:extLst>
           </p:cNvPr>
@@ -21852,7 +21869,7 @@
           <p:cNvPr id="3" name="">
             <a:extLst xmlns:a="http://schemas.openxmlformats.org/drawingml/2006/main">
               <a:ext uri="{FF2B5EF4-FFF2-40B4-BE49-F238E27FC236}">
-                <a16:creationId xmlns:a16="http://schemas.microsoft.com/office/drawing/2014/main" id="{FFC49D9E-E176-4343-A1ED-2DC417A4B673}"/>
+                <a16:creationId xmlns:a16="http://schemas.microsoft.com/office/drawing/2014/main" id="{85B2AFAB-1832-4971-98CE-BBCE4CB78AE5}"/>
               </a:ext>
             </a:extLst>
           </p:cNvPr>
@@ -21902,7 +21919,7 @@
           <p:cNvPr id="4" name="">
             <a:extLst xmlns:a="http://schemas.openxmlformats.org/drawingml/2006/main">
               <a:ext uri="{FF2B5EF4-FFF2-40B4-BE49-F238E27FC236}">
-                <a16:creationId xmlns:a16="http://schemas.microsoft.com/office/drawing/2014/main" id="{C4F6251C-BB70-4B9F-A0D0-6A681547BBF8}"/>
+                <a16:creationId xmlns:a16="http://schemas.microsoft.com/office/drawing/2014/main" id="{8240FD01-7322-4520-9C52-1A4D81B7E2DC}"/>
               </a:ext>
             </a:extLst>
           </p:cNvPr>
@@ -21937,7 +21954,7 @@
           <p:cNvPr id="5" name="">
             <a:extLst xmlns:a="http://schemas.openxmlformats.org/drawingml/2006/main">
               <a:ext uri="{FF2B5EF4-FFF2-40B4-BE49-F238E27FC236}">
-                <a16:creationId xmlns:a16="http://schemas.microsoft.com/office/drawing/2014/main" id="{59799DCB-1F59-43F5-9FD6-F9FAD44BEA39}"/>
+                <a16:creationId xmlns:a16="http://schemas.microsoft.com/office/drawing/2014/main" id="{05CD9A7E-D98F-4F9D-BB70-CA247B17C01F}"/>
               </a:ext>
             </a:extLst>
           </p:cNvPr>
@@ -21987,7 +22004,7 @@
           <p:cNvPr id="6" name="">
             <a:extLst xmlns:a="http://schemas.openxmlformats.org/drawingml/2006/main">
               <a:ext uri="{FF2B5EF4-FFF2-40B4-BE49-F238E27FC236}">
-                <a16:creationId xmlns:a16="http://schemas.microsoft.com/office/drawing/2014/main" id="{59CD42CE-9936-452D-B63A-3F3F8FD42043}"/>
+                <a16:creationId xmlns:a16="http://schemas.microsoft.com/office/drawing/2014/main" id="{9C62D8A9-D750-4189-BC59-2AA8B29A31C8}"/>
               </a:ext>
             </a:extLst>
           </p:cNvPr>
@@ -22054,7 +22071,7 @@
           <p:cNvPr id="7" name="">
             <a:extLst xmlns:a="http://schemas.openxmlformats.org/drawingml/2006/main">
               <a:ext uri="{FF2B5EF4-FFF2-40B4-BE49-F238E27FC236}">
-                <a16:creationId xmlns:a16="http://schemas.microsoft.com/office/drawing/2014/main" id="{04A1E6A0-5514-4D40-87BD-1D179015E5F2}"/>
+                <a16:creationId xmlns:a16="http://schemas.microsoft.com/office/drawing/2014/main" id="{9CB83B64-10BF-4653-B3A7-7FD0FFA562BA}"/>
               </a:ext>
             </a:extLst>
           </p:cNvPr>
@@ -22104,7 +22121,7 @@
           <p:cNvPr id="8" name="">
             <a:extLst xmlns:a="http://schemas.openxmlformats.org/drawingml/2006/main">
               <a:ext uri="{FF2B5EF4-FFF2-40B4-BE49-F238E27FC236}">
-                <a16:creationId xmlns:a16="http://schemas.microsoft.com/office/drawing/2014/main" id="{7B7104DE-1134-467A-83E7-0E20BEA9ED2A}"/>
+                <a16:creationId xmlns:a16="http://schemas.microsoft.com/office/drawing/2014/main" id="{B3885A43-A561-41BE-A853-5D489CCE914A}"/>
               </a:ext>
             </a:extLst>
           </p:cNvPr>
@@ -22139,7 +22156,7 @@
           <p:cNvPr id="9" name="">
             <a:extLst xmlns:a="http://schemas.openxmlformats.org/drawingml/2006/main">
               <a:ext uri="{FF2B5EF4-FFF2-40B4-BE49-F238E27FC236}">
-                <a16:creationId xmlns:a16="http://schemas.microsoft.com/office/drawing/2014/main" id="{4C946F75-BC6A-4089-B629-A3CE816CDFB1}"/>
+                <a16:creationId xmlns:a16="http://schemas.microsoft.com/office/drawing/2014/main" id="{5D6A1916-6561-4DF4-B00D-CB1E428A5DF7}"/>
               </a:ext>
             </a:extLst>
           </p:cNvPr>
@@ -22189,7 +22206,7 @@
           <p:cNvPr id="10" name="">
             <a:extLst xmlns:a="http://schemas.openxmlformats.org/drawingml/2006/main">
               <a:ext uri="{FF2B5EF4-FFF2-40B4-BE49-F238E27FC236}">
-                <a16:creationId xmlns:a16="http://schemas.microsoft.com/office/drawing/2014/main" id="{8F2BAD23-2D0C-4FEE-9E86-AB1E9344BF8C}"/>
+                <a16:creationId xmlns:a16="http://schemas.microsoft.com/office/drawing/2014/main" id="{76B945F3-83E4-469C-BCEC-CEB988ECD782}"/>
               </a:ext>
             </a:extLst>
           </p:cNvPr>
@@ -22256,7 +22273,7 @@
           <p:cNvPr id="11" name="">
             <a:extLst xmlns:a="http://schemas.openxmlformats.org/drawingml/2006/main">
               <a:ext uri="{FF2B5EF4-FFF2-40B4-BE49-F238E27FC236}">
-                <a16:creationId xmlns:a16="http://schemas.microsoft.com/office/drawing/2014/main" id="{8C40096B-118D-4AD8-8385-54171CC47E4D}"/>
+                <a16:creationId xmlns:a16="http://schemas.microsoft.com/office/drawing/2014/main" id="{ACE7AE50-3ABD-4AC9-8B5A-81C7BEA15170}"/>
               </a:ext>
             </a:extLst>
           </p:cNvPr>
@@ -22306,7 +22323,7 @@
           <p:cNvPr id="12" name="">
             <a:extLst xmlns:a="http://schemas.openxmlformats.org/drawingml/2006/main">
               <a:ext uri="{FF2B5EF4-FFF2-40B4-BE49-F238E27FC236}">
-                <a16:creationId xmlns:a16="http://schemas.microsoft.com/office/drawing/2014/main" id="{B37BC2F7-99F2-4823-9742-A9A88675B326}"/>
+                <a16:creationId xmlns:a16="http://schemas.microsoft.com/office/drawing/2014/main" id="{31E742E6-6E39-4B78-8E87-B78B8904A063}"/>
               </a:ext>
             </a:extLst>
           </p:cNvPr>
@@ -22341,7 +22358,7 @@
           <p:cNvPr id="13" name="">
             <a:extLst xmlns:a="http://schemas.openxmlformats.org/drawingml/2006/main">
               <a:ext uri="{FF2B5EF4-FFF2-40B4-BE49-F238E27FC236}">
-                <a16:creationId xmlns:a16="http://schemas.microsoft.com/office/drawing/2014/main" id="{E319CE14-A0AE-41A3-81ED-94924BD77367}"/>
+                <a16:creationId xmlns:a16="http://schemas.microsoft.com/office/drawing/2014/main" id="{B22A7BFC-29E0-4823-ABA7-26247CF97949}"/>
               </a:ext>
             </a:extLst>
           </p:cNvPr>
@@ -22391,7 +22408,7 @@
           <p:cNvPr id="14" name="">
             <a:extLst xmlns:a="http://schemas.openxmlformats.org/drawingml/2006/main">
               <a:ext uri="{FF2B5EF4-FFF2-40B4-BE49-F238E27FC236}">
-                <a16:creationId xmlns:a16="http://schemas.microsoft.com/office/drawing/2014/main" id="{BD7DA246-29C6-44DC-84BF-68EC475E6366}"/>
+                <a16:creationId xmlns:a16="http://schemas.microsoft.com/office/drawing/2014/main" id="{E0ECFB7C-01F3-46A7-BF06-895068489A54}"/>
               </a:ext>
             </a:extLst>
           </p:cNvPr>
@@ -22475,7 +22492,7 @@
           <p:cNvPr id="15" name="">
             <a:extLst xmlns:a="http://schemas.openxmlformats.org/drawingml/2006/main">
               <a:ext uri="{FF2B5EF4-FFF2-40B4-BE49-F238E27FC236}">
-                <a16:creationId xmlns:a16="http://schemas.microsoft.com/office/drawing/2014/main" id="{85C504BA-417E-42C1-B17F-4676BC6F24B0}"/>
+                <a16:creationId xmlns:a16="http://schemas.microsoft.com/office/drawing/2014/main" id="{AF8F896F-C638-4F08-B6F6-7848D0AABAF2}"/>
               </a:ext>
             </a:extLst>
           </p:cNvPr>
@@ -22525,7 +22542,7 @@
           <p:cNvPr id="16" name="">
             <a:extLst xmlns:a="http://schemas.openxmlformats.org/drawingml/2006/main">
               <a:ext uri="{FF2B5EF4-FFF2-40B4-BE49-F238E27FC236}">
-                <a16:creationId xmlns:a16="http://schemas.microsoft.com/office/drawing/2014/main" id="{D8D62FB9-CF60-4A06-B2D6-4F0D15DF89D1}"/>
+                <a16:creationId xmlns:a16="http://schemas.microsoft.com/office/drawing/2014/main" id="{E25812F6-A10D-4FD9-BC5F-869622E66F8F}"/>
               </a:ext>
             </a:extLst>
           </p:cNvPr>
@@ -22560,7 +22577,7 @@
           <p:cNvPr id="17" name="">
             <a:extLst xmlns:a="http://schemas.openxmlformats.org/drawingml/2006/main">
               <a:ext uri="{FF2B5EF4-FFF2-40B4-BE49-F238E27FC236}">
-                <a16:creationId xmlns:a16="http://schemas.microsoft.com/office/drawing/2014/main" id="{17350E75-AE7D-47C5-85B9-33324DE35F9B}"/>
+                <a16:creationId xmlns:a16="http://schemas.microsoft.com/office/drawing/2014/main" id="{57B48DEE-2A03-4323-A158-088CAA0776B0}"/>
               </a:ext>
             </a:extLst>
           </p:cNvPr>
@@ -22610,7 +22627,7 @@
           <p:cNvPr id="18" name="">
             <a:extLst xmlns:a="http://schemas.openxmlformats.org/drawingml/2006/main">
               <a:ext uri="{FF2B5EF4-FFF2-40B4-BE49-F238E27FC236}">
-                <a16:creationId xmlns:a16="http://schemas.microsoft.com/office/drawing/2014/main" id="{68E33BCD-9A7F-49CB-AB45-8B1C1C6C2964}"/>
+                <a16:creationId xmlns:a16="http://schemas.microsoft.com/office/drawing/2014/main" id="{A8FB9933-77D6-415C-949B-072DA268C032}"/>
               </a:ext>
             </a:extLst>
           </p:cNvPr>
@@ -22694,7 +22711,7 @@
           <p:cNvPr id="19" name="">
             <a:extLst xmlns:a="http://schemas.openxmlformats.org/drawingml/2006/main">
               <a:ext uri="{FF2B5EF4-FFF2-40B4-BE49-F238E27FC236}">
-                <a16:creationId xmlns:a16="http://schemas.microsoft.com/office/drawing/2014/main" id="{0D58D637-EBC0-4125-9E83-111C245E9A6A}"/>
+                <a16:creationId xmlns:a16="http://schemas.microsoft.com/office/drawing/2014/main" id="{759EC42E-E1DF-4011-AC05-47AF95B67777}"/>
               </a:ext>
             </a:extLst>
           </p:cNvPr>
@@ -22744,7 +22761,7 @@
           <p:cNvPr id="20" name="">
             <a:extLst xmlns:a="http://schemas.openxmlformats.org/drawingml/2006/main">
               <a:ext uri="{FF2B5EF4-FFF2-40B4-BE49-F238E27FC236}">
-                <a16:creationId xmlns:a16="http://schemas.microsoft.com/office/drawing/2014/main" id="{39F1A4F9-8EE9-48D8-B1BB-36A94C33E446}"/>
+                <a16:creationId xmlns:a16="http://schemas.microsoft.com/office/drawing/2014/main" id="{A20DA11E-79A6-4870-83F4-4083005C98D6}"/>
               </a:ext>
             </a:extLst>
           </p:cNvPr>
@@ -22779,7 +22796,7 @@
           <p:cNvPr id="21" name="">
             <a:extLst xmlns:a="http://schemas.openxmlformats.org/drawingml/2006/main">
               <a:ext uri="{FF2B5EF4-FFF2-40B4-BE49-F238E27FC236}">
-                <a16:creationId xmlns:a16="http://schemas.microsoft.com/office/drawing/2014/main" id="{FD5694B6-2767-44C4-A0B0-5C0B1CBFC9D3}"/>
+                <a16:creationId xmlns:a16="http://schemas.microsoft.com/office/drawing/2014/main" id="{80B27474-B6BE-417E-8FA7-CB47BD731E8E}"/>
               </a:ext>
             </a:extLst>
           </p:cNvPr>
@@ -22829,7 +22846,7 @@
           <p:cNvPr id="22" name="">
             <a:extLst xmlns:a="http://schemas.openxmlformats.org/drawingml/2006/main">
               <a:ext uri="{FF2B5EF4-FFF2-40B4-BE49-F238E27FC236}">
-                <a16:creationId xmlns:a16="http://schemas.microsoft.com/office/drawing/2014/main" id="{EA97FB16-4674-4A0E-BF15-D9CC93788B7B}"/>
+                <a16:creationId xmlns:a16="http://schemas.microsoft.com/office/drawing/2014/main" id="{E936224C-1512-4F1E-934B-54E6AC352787}"/>
               </a:ext>
             </a:extLst>
           </p:cNvPr>
@@ -22896,7 +22913,7 @@
           <p:cNvPr id="23" name="">
             <a:extLst xmlns:a="http://schemas.openxmlformats.org/drawingml/2006/main">
               <a:ext uri="{FF2B5EF4-FFF2-40B4-BE49-F238E27FC236}">
-                <a16:creationId xmlns:a16="http://schemas.microsoft.com/office/drawing/2014/main" id="{8ABB34C4-EBA0-4174-81E3-D2832311B12F}"/>
+                <a16:creationId xmlns:a16="http://schemas.microsoft.com/office/drawing/2014/main" id="{E8808DB2-01D2-4B57-9729-5DC4DB0915C4}"/>
               </a:ext>
             </a:extLst>
           </p:cNvPr>
@@ -22946,7 +22963,7 @@
           <p:cNvPr id="24" name="">
             <a:extLst xmlns:a="http://schemas.openxmlformats.org/drawingml/2006/main">
               <a:ext uri="{FF2B5EF4-FFF2-40B4-BE49-F238E27FC236}">
-                <a16:creationId xmlns:a16="http://schemas.microsoft.com/office/drawing/2014/main" id="{09C23261-5E2D-48E5-97C5-EBB6DB7FBA9D}"/>
+                <a16:creationId xmlns:a16="http://schemas.microsoft.com/office/drawing/2014/main" id="{E4945FC8-85D1-4E40-9449-A4C6C1042A1A}"/>
               </a:ext>
             </a:extLst>
           </p:cNvPr>
@@ -22981,7 +22998,7 @@
           <p:nvPr/>
         </p:nvPicPr>
         <p:blipFill>
-          <a:blip xmlns:r="http://schemas.openxmlformats.org/officeDocument/2006/relationships" xmlns:a="http://schemas.openxmlformats.org/drawingml/2006/main" r:embed="R79382ec5424f4512"/>
+          <a:blip xmlns:r="http://schemas.openxmlformats.org/officeDocument/2006/relationships" xmlns:a="http://schemas.openxmlformats.org/drawingml/2006/main" r:embed="R1eba8f7d89d142ca"/>
           <a:stretch xmlns:a="http://schemas.openxmlformats.org/drawingml/2006/main"/>
         </p:blipFill>
         <p:spPr>
@@ -22999,7 +23016,7 @@
           <p:cNvPr id="26" name="">
             <a:extLst xmlns:a="http://schemas.openxmlformats.org/drawingml/2006/main">
               <a:ext uri="{FF2B5EF4-FFF2-40B4-BE49-F238E27FC236}">
-                <a16:creationId xmlns:a16="http://schemas.microsoft.com/office/drawing/2014/main" id="{79FE2FAC-25FE-4714-82A2-F34188D1BD87}"/>
+                <a16:creationId xmlns:a16="http://schemas.microsoft.com/office/drawing/2014/main" id="{D1C5AAF0-F6F4-4DE6-BFD4-A8D8F8F72A82}"/>
               </a:ext>
             </a:extLst>
           </p:cNvPr>
@@ -23049,7 +23066,7 @@
           <p:cNvPr id="27" name="">
             <a:extLst xmlns:a="http://schemas.openxmlformats.org/drawingml/2006/main">
               <a:ext uri="{FF2B5EF4-FFF2-40B4-BE49-F238E27FC236}">
-                <a16:creationId xmlns:a16="http://schemas.microsoft.com/office/drawing/2014/main" id="{2D03FB79-AC74-49A9-9E9F-F073C56E1CA5}"/>
+                <a16:creationId xmlns:a16="http://schemas.microsoft.com/office/drawing/2014/main" id="{48F64EFF-CFB1-48D5-A182-989B963209C1}"/>
               </a:ext>
             </a:extLst>
           </p:cNvPr>
@@ -23097,7 +23114,7 @@
     </p:spTree>
     <p:extLst>
       <p:ext uri="{BB962C8B-B14F-4D97-AF65-F5344CB8AC3E}">
-        <p14:creationId xmlns:p14="http://schemas.microsoft.com/office/powerpoint/2010/main" val="918660178"/>
+        <p14:creationId xmlns:p14="http://schemas.microsoft.com/office/powerpoint/2010/main" val="1413776054"/>
       </p:ext>
     </p:extLst>
   </p:cSld>
@@ -23128,7 +23145,7 @@
           <p:cNvPr id="1" name="">
             <a:extLst xmlns:a="http://schemas.openxmlformats.org/drawingml/2006/main">
               <a:ext uri="{FF2B5EF4-FFF2-40B4-BE49-F238E27FC236}">
-                <a16:creationId xmlns:a16="http://schemas.microsoft.com/office/drawing/2014/main" id="{89DA8E0B-8781-4254-9C05-7236A5982D9F}"/>
+                <a16:creationId xmlns:a16="http://schemas.microsoft.com/office/drawing/2014/main" id="{AF4EE09C-DC69-4190-B543-B029F119D2DC}"/>
               </a:ext>
             </a:extLst>
           </p:cNvPr>
@@ -23159,7 +23176,7 @@
           <p:cNvPr id="2" name="">
             <a:extLst xmlns:a="http://schemas.openxmlformats.org/drawingml/2006/main">
               <a:ext uri="{FF2B5EF4-FFF2-40B4-BE49-F238E27FC236}">
-                <a16:creationId xmlns:a16="http://schemas.microsoft.com/office/drawing/2014/main" id="{4270C443-13E4-45EB-84FE-0BAA5316491C}"/>
+                <a16:creationId xmlns:a16="http://schemas.microsoft.com/office/drawing/2014/main" id="{E28255C7-0F8B-4CC3-AC35-CEEBA4777ED6}"/>
               </a:ext>
             </a:extLst>
           </p:cNvPr>
@@ -23209,7 +23226,7 @@
           <p:cNvPr id="3" name="">
             <a:extLst xmlns:a="http://schemas.openxmlformats.org/drawingml/2006/main">
               <a:ext uri="{FF2B5EF4-FFF2-40B4-BE49-F238E27FC236}">
-                <a16:creationId xmlns:a16="http://schemas.microsoft.com/office/drawing/2014/main" id="{B3FA0103-4FB0-4080-8C23-2C064F8A40BF}"/>
+                <a16:creationId xmlns:a16="http://schemas.microsoft.com/office/drawing/2014/main" id="{A74C922F-7BF1-41E1-A203-E6C6D11C563F}"/>
               </a:ext>
             </a:extLst>
           </p:cNvPr>
@@ -23259,7 +23276,7 @@
           <p:cNvPr id="4" name="">
             <a:extLst xmlns:a="http://schemas.openxmlformats.org/drawingml/2006/main">
               <a:ext uri="{FF2B5EF4-FFF2-40B4-BE49-F238E27FC236}">
-                <a16:creationId xmlns:a16="http://schemas.microsoft.com/office/drawing/2014/main" id="{EBE68EC0-BCA9-42F5-AB1E-A61BE5128AB9}"/>
+                <a16:creationId xmlns:a16="http://schemas.microsoft.com/office/drawing/2014/main" id="{6A93E582-46D1-4968-AC04-FAE67968142C}"/>
               </a:ext>
             </a:extLst>
           </p:cNvPr>
@@ -23309,7 +23326,7 @@
           <p:cNvPr id="5" name="">
             <a:extLst xmlns:a="http://schemas.openxmlformats.org/drawingml/2006/main">
               <a:ext uri="{FF2B5EF4-FFF2-40B4-BE49-F238E27FC236}">
-                <a16:creationId xmlns:a16="http://schemas.microsoft.com/office/drawing/2014/main" id="{FB345F83-4C38-49AE-9A82-279CE4F76A88}"/>
+                <a16:creationId xmlns:a16="http://schemas.microsoft.com/office/drawing/2014/main" id="{37CD41AD-85B0-49EB-A522-652AB9F49750}"/>
               </a:ext>
             </a:extLst>
           </p:cNvPr>
@@ -23340,7 +23357,7 @@
           <p:cNvPr id="6" name="">
             <a:extLst xmlns:a="http://schemas.openxmlformats.org/drawingml/2006/main">
               <a:ext uri="{FF2B5EF4-FFF2-40B4-BE49-F238E27FC236}">
-                <a16:creationId xmlns:a16="http://schemas.microsoft.com/office/drawing/2014/main" id="{24B75767-EDF9-43A5-9A0F-3CD54888892A}"/>
+                <a16:creationId xmlns:a16="http://schemas.microsoft.com/office/drawing/2014/main" id="{8223234F-5640-4D18-938C-DFC7001B5112}"/>
               </a:ext>
             </a:extLst>
           </p:cNvPr>
@@ -23371,7 +23388,7 @@
           <p:cNvPr id="7" name="">
             <a:extLst xmlns:a="http://schemas.openxmlformats.org/drawingml/2006/main">
               <a:ext uri="{FF2B5EF4-FFF2-40B4-BE49-F238E27FC236}">
-                <a16:creationId xmlns:a16="http://schemas.microsoft.com/office/drawing/2014/main" id="{C9FECE7C-AC3D-4805-904E-2D5A2D37809C}"/>
+                <a16:creationId xmlns:a16="http://schemas.microsoft.com/office/drawing/2014/main" id="{503F4A46-C8B4-426F-8DBD-BDAD22EAA38A}"/>
               </a:ext>
             </a:extLst>
           </p:cNvPr>
@@ -23421,7 +23438,7 @@
           <p:cNvPr id="8" name="">
             <a:extLst xmlns:a="http://schemas.openxmlformats.org/drawingml/2006/main">
               <a:ext uri="{FF2B5EF4-FFF2-40B4-BE49-F238E27FC236}">
-                <a16:creationId xmlns:a16="http://schemas.microsoft.com/office/drawing/2014/main" id="{F4D9A3BA-3C3F-4AB1-BA86-33801471933F}"/>
+                <a16:creationId xmlns:a16="http://schemas.microsoft.com/office/drawing/2014/main" id="{DB075523-9666-47CE-8BA1-3FAF2CCDB7AC}"/>
               </a:ext>
             </a:extLst>
           </p:cNvPr>
@@ -23452,7 +23469,7 @@
           <p:cNvPr id="9" name="">
             <a:extLst xmlns:a="http://schemas.openxmlformats.org/drawingml/2006/main">
               <a:ext uri="{FF2B5EF4-FFF2-40B4-BE49-F238E27FC236}">
-                <a16:creationId xmlns:a16="http://schemas.microsoft.com/office/drawing/2014/main" id="{411665F6-E1C5-404C-AA76-0B56833C0644}"/>
+                <a16:creationId xmlns:a16="http://schemas.microsoft.com/office/drawing/2014/main" id="{E2017AEC-334D-44AA-BC48-A2FB3B9CA647}"/>
               </a:ext>
             </a:extLst>
           </p:cNvPr>
@@ -23502,7 +23519,7 @@
           <p:cNvPr id="10" name="">
             <a:extLst xmlns:a="http://schemas.openxmlformats.org/drawingml/2006/main">
               <a:ext uri="{FF2B5EF4-FFF2-40B4-BE49-F238E27FC236}">
-                <a16:creationId xmlns:a16="http://schemas.microsoft.com/office/drawing/2014/main" id="{2E41E45D-B90B-4201-8F95-D538EA866356}"/>
+                <a16:creationId xmlns:a16="http://schemas.microsoft.com/office/drawing/2014/main" id="{2B49C4BB-4CD2-454F-98A2-EAF7A20E8318}"/>
               </a:ext>
             </a:extLst>
           </p:cNvPr>
@@ -23533,7 +23550,7 @@
           <p:cNvPr id="11" name="">
             <a:extLst xmlns:a="http://schemas.openxmlformats.org/drawingml/2006/main">
               <a:ext uri="{FF2B5EF4-FFF2-40B4-BE49-F238E27FC236}">
-                <a16:creationId xmlns:a16="http://schemas.microsoft.com/office/drawing/2014/main" id="{9BDAAD1E-3C23-440A-B798-3B51987B3A2D}"/>
+                <a16:creationId xmlns:a16="http://schemas.microsoft.com/office/drawing/2014/main" id="{660FCBB0-780A-42D9-A333-4BAE5600A76D}"/>
               </a:ext>
             </a:extLst>
           </p:cNvPr>
@@ -23583,7 +23600,7 @@
           <p:cNvPr id="12" name="">
             <a:extLst xmlns:a="http://schemas.openxmlformats.org/drawingml/2006/main">
               <a:ext uri="{FF2B5EF4-FFF2-40B4-BE49-F238E27FC236}">
-                <a16:creationId xmlns:a16="http://schemas.microsoft.com/office/drawing/2014/main" id="{0FF994A5-8A66-41FC-AC3E-FFBB68B5C087}"/>
+                <a16:creationId xmlns:a16="http://schemas.microsoft.com/office/drawing/2014/main" id="{942EB28D-CD44-4E62-88C8-AE17C6A5DD67}"/>
               </a:ext>
             </a:extLst>
           </p:cNvPr>
@@ -23633,7 +23650,7 @@
           <p:cNvPr id="13" name="">
             <a:extLst xmlns:a="http://schemas.openxmlformats.org/drawingml/2006/main">
               <a:ext uri="{FF2B5EF4-FFF2-40B4-BE49-F238E27FC236}">
-                <a16:creationId xmlns:a16="http://schemas.microsoft.com/office/drawing/2014/main" id="{B11D4D04-9FB0-40F4-AE88-439713F06BDA}"/>
+                <a16:creationId xmlns:a16="http://schemas.microsoft.com/office/drawing/2014/main" id="{A3A17247-9360-472E-9753-D00449E87F8E}"/>
               </a:ext>
             </a:extLst>
           </p:cNvPr>
@@ -23664,7 +23681,7 @@
           <p:cNvPr id="14" name="">
             <a:extLst xmlns:a="http://schemas.openxmlformats.org/drawingml/2006/main">
               <a:ext uri="{FF2B5EF4-FFF2-40B4-BE49-F238E27FC236}">
-                <a16:creationId xmlns:a16="http://schemas.microsoft.com/office/drawing/2014/main" id="{C9211B43-43EB-4496-91A8-EADA5C801775}"/>
+                <a16:creationId xmlns:a16="http://schemas.microsoft.com/office/drawing/2014/main" id="{F0A1888D-44D3-49C0-829A-2344C569DAA8}"/>
               </a:ext>
             </a:extLst>
           </p:cNvPr>
@@ -23695,7 +23712,7 @@
           <p:cNvPr id="15" name="">
             <a:extLst xmlns:a="http://schemas.openxmlformats.org/drawingml/2006/main">
               <a:ext uri="{FF2B5EF4-FFF2-40B4-BE49-F238E27FC236}">
-                <a16:creationId xmlns:a16="http://schemas.microsoft.com/office/drawing/2014/main" id="{6442DF9F-EA4B-42D9-B43A-963AE7F11C6A}"/>
+                <a16:creationId xmlns:a16="http://schemas.microsoft.com/office/drawing/2014/main" id="{232E1604-1A5C-4E11-B9B3-1FDCFDB0C310}"/>
               </a:ext>
             </a:extLst>
           </p:cNvPr>
@@ -23745,7 +23762,7 @@
           <p:cNvPr id="16" name="">
             <a:extLst xmlns:a="http://schemas.openxmlformats.org/drawingml/2006/main">
               <a:ext uri="{FF2B5EF4-FFF2-40B4-BE49-F238E27FC236}">
-                <a16:creationId xmlns:a16="http://schemas.microsoft.com/office/drawing/2014/main" id="{CD104DDF-59BD-41CE-8D5D-55A62F378331}"/>
+                <a16:creationId xmlns:a16="http://schemas.microsoft.com/office/drawing/2014/main" id="{A99A9433-1E00-48D5-AB98-8F8B3971B018}"/>
               </a:ext>
             </a:extLst>
           </p:cNvPr>
@@ -23776,7 +23793,7 @@
           <p:cNvPr id="17" name="">
             <a:extLst xmlns:a="http://schemas.openxmlformats.org/drawingml/2006/main">
               <a:ext uri="{FF2B5EF4-FFF2-40B4-BE49-F238E27FC236}">
-                <a16:creationId xmlns:a16="http://schemas.microsoft.com/office/drawing/2014/main" id="{56AF6441-2768-4843-96F5-E7A1F5CF45AA}"/>
+                <a16:creationId xmlns:a16="http://schemas.microsoft.com/office/drawing/2014/main" id="{0EE56683-44DB-468D-B0DE-F18A0DF6E7C5}"/>
               </a:ext>
             </a:extLst>
           </p:cNvPr>
@@ -23826,7 +23843,7 @@
           <p:cNvPr id="18" name="">
             <a:extLst xmlns:a="http://schemas.openxmlformats.org/drawingml/2006/main">
               <a:ext uri="{FF2B5EF4-FFF2-40B4-BE49-F238E27FC236}">
-                <a16:creationId xmlns:a16="http://schemas.microsoft.com/office/drawing/2014/main" id="{BD550560-4742-4D40-869C-21D0B0E9B497}"/>
+                <a16:creationId xmlns:a16="http://schemas.microsoft.com/office/drawing/2014/main" id="{EE396A5A-64C8-4A8F-991B-2564C9F706D0}"/>
               </a:ext>
             </a:extLst>
           </p:cNvPr>
@@ -23857,7 +23874,7 @@
           <p:cNvPr id="19" name="">
             <a:extLst xmlns:a="http://schemas.openxmlformats.org/drawingml/2006/main">
               <a:ext uri="{FF2B5EF4-FFF2-40B4-BE49-F238E27FC236}">
-                <a16:creationId xmlns:a16="http://schemas.microsoft.com/office/drawing/2014/main" id="{55FA2A01-E650-43DA-868E-52B5EC361A0F}"/>
+                <a16:creationId xmlns:a16="http://schemas.microsoft.com/office/drawing/2014/main" id="{0FA31711-E09D-490C-B56D-4E2D255CE10E}"/>
               </a:ext>
             </a:extLst>
           </p:cNvPr>
@@ -23907,7 +23924,7 @@
           <p:cNvPr id="20" name="">
             <a:extLst xmlns:a="http://schemas.openxmlformats.org/drawingml/2006/main">
               <a:ext uri="{FF2B5EF4-FFF2-40B4-BE49-F238E27FC236}">
-                <a16:creationId xmlns:a16="http://schemas.microsoft.com/office/drawing/2014/main" id="{222DAA8E-47BC-44A7-A3E1-6B33145B2B2E}"/>
+                <a16:creationId xmlns:a16="http://schemas.microsoft.com/office/drawing/2014/main" id="{8D815F48-66B7-4992-9FC7-DD8D46F06E41}"/>
               </a:ext>
             </a:extLst>
           </p:cNvPr>
@@ -23957,7 +23974,7 @@
           <p:cNvPr id="21" name="">
             <a:extLst xmlns:a="http://schemas.openxmlformats.org/drawingml/2006/main">
               <a:ext uri="{FF2B5EF4-FFF2-40B4-BE49-F238E27FC236}">
-                <a16:creationId xmlns:a16="http://schemas.microsoft.com/office/drawing/2014/main" id="{A78F14D2-B307-4624-AA54-05688B442A6E}"/>
+                <a16:creationId xmlns:a16="http://schemas.microsoft.com/office/drawing/2014/main" id="{9BB6CADE-7AB4-41FB-BB23-22C28560BCCB}"/>
               </a:ext>
             </a:extLst>
           </p:cNvPr>
@@ -23988,7 +24005,7 @@
           <p:cNvPr id="22" name="">
             <a:extLst xmlns:a="http://schemas.openxmlformats.org/drawingml/2006/main">
               <a:ext uri="{FF2B5EF4-FFF2-40B4-BE49-F238E27FC236}">
-                <a16:creationId xmlns:a16="http://schemas.microsoft.com/office/drawing/2014/main" id="{281DB5A7-97CF-4F72-A466-DDEFE88F35D2}"/>
+                <a16:creationId xmlns:a16="http://schemas.microsoft.com/office/drawing/2014/main" id="{73EB057C-2247-4338-B5AC-E87B5132A64A}"/>
               </a:ext>
             </a:extLst>
           </p:cNvPr>
@@ -24019,7 +24036,7 @@
           <p:cNvPr id="23" name="">
             <a:extLst xmlns:a="http://schemas.openxmlformats.org/drawingml/2006/main">
               <a:ext uri="{FF2B5EF4-FFF2-40B4-BE49-F238E27FC236}">
-                <a16:creationId xmlns:a16="http://schemas.microsoft.com/office/drawing/2014/main" id="{1AEB3427-9FC1-4B54-B4CD-E781DF55C6A9}"/>
+                <a16:creationId xmlns:a16="http://schemas.microsoft.com/office/drawing/2014/main" id="{0F162104-4F7D-4776-8B86-A9ABF80C876D}"/>
               </a:ext>
             </a:extLst>
           </p:cNvPr>
@@ -24069,7 +24086,7 @@
           <p:cNvPr id="24" name="">
             <a:extLst xmlns:a="http://schemas.openxmlformats.org/drawingml/2006/main">
               <a:ext uri="{FF2B5EF4-FFF2-40B4-BE49-F238E27FC236}">
-                <a16:creationId xmlns:a16="http://schemas.microsoft.com/office/drawing/2014/main" id="{0ED48ECB-D582-4C77-A31A-7CB6DE4F678D}"/>
+                <a16:creationId xmlns:a16="http://schemas.microsoft.com/office/drawing/2014/main" id="{CC6A4E85-A4B0-4003-9A24-5FE2F6297807}"/>
               </a:ext>
             </a:extLst>
           </p:cNvPr>
@@ -24100,7 +24117,7 @@
           <p:cNvPr id="25" name="">
             <a:extLst xmlns:a="http://schemas.openxmlformats.org/drawingml/2006/main">
               <a:ext uri="{FF2B5EF4-FFF2-40B4-BE49-F238E27FC236}">
-                <a16:creationId xmlns:a16="http://schemas.microsoft.com/office/drawing/2014/main" id="{427B2645-87A1-4501-BC1C-68FDF08C7339}"/>
+                <a16:creationId xmlns:a16="http://schemas.microsoft.com/office/drawing/2014/main" id="{ABE79A55-6FAE-4262-9C41-C5ECCBD03192}"/>
               </a:ext>
             </a:extLst>
           </p:cNvPr>
@@ -24150,7 +24167,7 @@
           <p:cNvPr id="26" name="">
             <a:extLst xmlns:a="http://schemas.openxmlformats.org/drawingml/2006/main">
               <a:ext uri="{FF2B5EF4-FFF2-40B4-BE49-F238E27FC236}">
-                <a16:creationId xmlns:a16="http://schemas.microsoft.com/office/drawing/2014/main" id="{0D3D6642-2A49-427E-8A1F-001D27762676}"/>
+                <a16:creationId xmlns:a16="http://schemas.microsoft.com/office/drawing/2014/main" id="{9ED14469-A40C-42A3-86DC-2961E4AF1036}"/>
               </a:ext>
             </a:extLst>
           </p:cNvPr>
@@ -24181,7 +24198,7 @@
           <p:cNvPr id="27" name="">
             <a:extLst xmlns:a="http://schemas.openxmlformats.org/drawingml/2006/main">
               <a:ext uri="{FF2B5EF4-FFF2-40B4-BE49-F238E27FC236}">
-                <a16:creationId xmlns:a16="http://schemas.microsoft.com/office/drawing/2014/main" id="{FBFD3C07-3D2C-4179-AE2E-261A701E41AE}"/>
+                <a16:creationId xmlns:a16="http://schemas.microsoft.com/office/drawing/2014/main" id="{185197C3-1448-4703-9596-8164A61DC420}"/>
               </a:ext>
             </a:extLst>
           </p:cNvPr>
@@ -24231,7 +24248,7 @@
           <p:cNvPr id="28" name="">
             <a:extLst xmlns:a="http://schemas.openxmlformats.org/drawingml/2006/main">
               <a:ext uri="{FF2B5EF4-FFF2-40B4-BE49-F238E27FC236}">
-                <a16:creationId xmlns:a16="http://schemas.microsoft.com/office/drawing/2014/main" id="{BF8EECAD-F10C-40B5-A29E-81ED5495FAA4}"/>
+                <a16:creationId xmlns:a16="http://schemas.microsoft.com/office/drawing/2014/main" id="{59FD88E6-C1D6-4B56-9DA7-3F317EF01348}"/>
               </a:ext>
             </a:extLst>
           </p:cNvPr>
@@ -24266,7 +24283,7 @@
           <p:nvPr/>
         </p:nvPicPr>
         <p:blipFill>
-          <a:blip xmlns:r="http://schemas.openxmlformats.org/officeDocument/2006/relationships" xmlns:a="http://schemas.openxmlformats.org/drawingml/2006/main" r:embed="R7c93676655da4286"/>
+          <a:blip xmlns:r="http://schemas.openxmlformats.org/officeDocument/2006/relationships" xmlns:a="http://schemas.openxmlformats.org/drawingml/2006/main" r:embed="R8f5c32abad56449b"/>
           <a:stretch xmlns:a="http://schemas.openxmlformats.org/drawingml/2006/main"/>
         </p:blipFill>
         <p:spPr>
@@ -24284,7 +24301,7 @@
           <p:cNvPr id="30" name="">
             <a:extLst xmlns:a="http://schemas.openxmlformats.org/drawingml/2006/main">
               <a:ext uri="{FF2B5EF4-FFF2-40B4-BE49-F238E27FC236}">
-                <a16:creationId xmlns:a16="http://schemas.microsoft.com/office/drawing/2014/main" id="{2240AD55-189A-4019-866C-B707A1A6E82C}"/>
+                <a16:creationId xmlns:a16="http://schemas.microsoft.com/office/drawing/2014/main" id="{6A004670-FB73-4F80-888A-50310946C1F3}"/>
               </a:ext>
             </a:extLst>
           </p:cNvPr>
@@ -24334,7 +24351,7 @@
           <p:cNvPr id="31" name="">
             <a:extLst xmlns:a="http://schemas.openxmlformats.org/drawingml/2006/main">
               <a:ext uri="{FF2B5EF4-FFF2-40B4-BE49-F238E27FC236}">
-                <a16:creationId xmlns:a16="http://schemas.microsoft.com/office/drawing/2014/main" id="{4D38EE95-2DB3-4B14-A19D-773BDA03E3B2}"/>
+                <a16:creationId xmlns:a16="http://schemas.microsoft.com/office/drawing/2014/main" id="{480F2A73-22B8-4B7C-B630-A61F9C2BD680}"/>
               </a:ext>
             </a:extLst>
           </p:cNvPr>
@@ -24382,7 +24399,7 @@
     </p:spTree>
     <p:extLst>
       <p:ext uri="{BB962C8B-B14F-4D97-AF65-F5344CB8AC3E}">
-        <p14:creationId xmlns:p14="http://schemas.microsoft.com/office/powerpoint/2010/main" val="1124702872"/>
+        <p14:creationId xmlns:p14="http://schemas.microsoft.com/office/powerpoint/2010/main" val="547678951"/>
       </p:ext>
     </p:extLst>
   </p:cSld>

</xml_diff>

<commit_message>
release: prepare BAI Work 0.1.1
</commit_message>
<xml_diff>
--- a/docs/presentation/BAI-Work-Project-Deck.pptx
+++ b/docs/presentation/BAI-Work-Project-Deck.pptx
@@ -2,34 +2,34 @@
 <file path=ppt/presentation.xml><?xml version="1.0" encoding="utf-8"?>
 <p:presentation xmlns:p="http://schemas.openxmlformats.org/presentationml/2006/main">
   <p:sldMasterIdLst>
-    <p:sldMasterId xmlns:r="http://schemas.openxmlformats.org/officeDocument/2006/relationships" id="2147483648" r:id="Ra51c8cb52c25498b"/>
+    <p:sldMasterId xmlns:r="http://schemas.openxmlformats.org/officeDocument/2006/relationships" id="2147483648" r:id="Ra19507bb0e8743eb"/>
   </p:sldMasterIdLst>
   <p:notesMasterIdLst>
-    <p:notesMasterId xmlns:r="http://schemas.openxmlformats.org/officeDocument/2006/relationships" r:id="Rf3dac73567314d31"/>
+    <p:notesMasterId xmlns:r="http://schemas.openxmlformats.org/officeDocument/2006/relationships" r:id="R3d830b82fe254e0b"/>
   </p:notesMasterIdLst>
   <p:sldIdLst>
-    <p:sldId xmlns:r="http://schemas.openxmlformats.org/officeDocument/2006/relationships" id="256" r:id="R3d6d1a3f25004809"/>
-    <p:sldId xmlns:r="http://schemas.openxmlformats.org/officeDocument/2006/relationships" id="257" r:id="Rbcef86a7b90449a7"/>
-    <p:sldId xmlns:r="http://schemas.openxmlformats.org/officeDocument/2006/relationships" id="258" r:id="R9c23a4e4c2ea4d48"/>
-    <p:sldId xmlns:r="http://schemas.openxmlformats.org/officeDocument/2006/relationships" id="259" r:id="Rda2c94cf675a4236"/>
-    <p:sldId xmlns:r="http://schemas.openxmlformats.org/officeDocument/2006/relationships" id="260" r:id="R85545c0d381a4eb4"/>
-    <p:sldId xmlns:r="http://schemas.openxmlformats.org/officeDocument/2006/relationships" id="261" r:id="Rba5d354a0be548f9"/>
-    <p:sldId xmlns:r="http://schemas.openxmlformats.org/officeDocument/2006/relationships" id="262" r:id="R38b7c07771b34042"/>
-    <p:sldId xmlns:r="http://schemas.openxmlformats.org/officeDocument/2006/relationships" id="263" r:id="R7d13729fa85e4bd8"/>
-    <p:sldId xmlns:r="http://schemas.openxmlformats.org/officeDocument/2006/relationships" id="264" r:id="R5d3e5a81770a436d"/>
-    <p:sldId xmlns:r="http://schemas.openxmlformats.org/officeDocument/2006/relationships" id="265" r:id="R238bd042b9d94eb1"/>
-    <p:sldId xmlns:r="http://schemas.openxmlformats.org/officeDocument/2006/relationships" id="266" r:id="R91b39da2ecd744e9"/>
-    <p:sldId xmlns:r="http://schemas.openxmlformats.org/officeDocument/2006/relationships" id="267" r:id="R7cafb154789e481a"/>
-    <p:sldId xmlns:r="http://schemas.openxmlformats.org/officeDocument/2006/relationships" id="268" r:id="R69754fc845fe4c2b"/>
-    <p:sldId xmlns:r="http://schemas.openxmlformats.org/officeDocument/2006/relationships" id="269" r:id="Rce5eda3158204eee"/>
-    <p:sldId xmlns:r="http://schemas.openxmlformats.org/officeDocument/2006/relationships" id="270" r:id="R9b3e4b14be214fe7"/>
-    <p:sldId xmlns:r="http://schemas.openxmlformats.org/officeDocument/2006/relationships" id="271" r:id="R026fba3bb06b47c0"/>
-    <p:sldId xmlns:r="http://schemas.openxmlformats.org/officeDocument/2006/relationships" id="272" r:id="Rda4343208e7f4861"/>
-    <p:sldId xmlns:r="http://schemas.openxmlformats.org/officeDocument/2006/relationships" id="273" r:id="R3f3921dde19e419f"/>
-    <p:sldId xmlns:r="http://schemas.openxmlformats.org/officeDocument/2006/relationships" id="274" r:id="R78bdbf2c98774503"/>
-    <p:sldId xmlns:r="http://schemas.openxmlformats.org/officeDocument/2006/relationships" id="275" r:id="R71f9b9aa0fe44ab7"/>
-    <p:sldId xmlns:r="http://schemas.openxmlformats.org/officeDocument/2006/relationships" id="276" r:id="R9f8199efcd254619"/>
-    <p:sldId xmlns:r="http://schemas.openxmlformats.org/officeDocument/2006/relationships" id="277" r:id="Rbddbf31f2578428c"/>
+    <p:sldId xmlns:r="http://schemas.openxmlformats.org/officeDocument/2006/relationships" id="256" r:id="Ra0b7d346725448eb"/>
+    <p:sldId xmlns:r="http://schemas.openxmlformats.org/officeDocument/2006/relationships" id="257" r:id="R6b66c5e9b52d4f7b"/>
+    <p:sldId xmlns:r="http://schemas.openxmlformats.org/officeDocument/2006/relationships" id="258" r:id="Rf82303a81b1044cc"/>
+    <p:sldId xmlns:r="http://schemas.openxmlformats.org/officeDocument/2006/relationships" id="259" r:id="R7698a4623b3c47da"/>
+    <p:sldId xmlns:r="http://schemas.openxmlformats.org/officeDocument/2006/relationships" id="260" r:id="R6f052e7772584427"/>
+    <p:sldId xmlns:r="http://schemas.openxmlformats.org/officeDocument/2006/relationships" id="261" r:id="R7e588872e29547a7"/>
+    <p:sldId xmlns:r="http://schemas.openxmlformats.org/officeDocument/2006/relationships" id="262" r:id="R6cd32f273b5640c7"/>
+    <p:sldId xmlns:r="http://schemas.openxmlformats.org/officeDocument/2006/relationships" id="263" r:id="R39bba9544c5143a4"/>
+    <p:sldId xmlns:r="http://schemas.openxmlformats.org/officeDocument/2006/relationships" id="264" r:id="Ra3b8e414b23d43ea"/>
+    <p:sldId xmlns:r="http://schemas.openxmlformats.org/officeDocument/2006/relationships" id="265" r:id="Ra6da9a008e474680"/>
+    <p:sldId xmlns:r="http://schemas.openxmlformats.org/officeDocument/2006/relationships" id="266" r:id="Ra857a9eedec14901"/>
+    <p:sldId xmlns:r="http://schemas.openxmlformats.org/officeDocument/2006/relationships" id="267" r:id="Rac9b9c2dfed54b25"/>
+    <p:sldId xmlns:r="http://schemas.openxmlformats.org/officeDocument/2006/relationships" id="268" r:id="R6178a71cfa5a41c1"/>
+    <p:sldId xmlns:r="http://schemas.openxmlformats.org/officeDocument/2006/relationships" id="269" r:id="R0a038aa4157546a6"/>
+    <p:sldId xmlns:r="http://schemas.openxmlformats.org/officeDocument/2006/relationships" id="270" r:id="R515d448612c94a10"/>
+    <p:sldId xmlns:r="http://schemas.openxmlformats.org/officeDocument/2006/relationships" id="271" r:id="Rbf417bc4429d4edb"/>
+    <p:sldId xmlns:r="http://schemas.openxmlformats.org/officeDocument/2006/relationships" id="272" r:id="Rff71364370984e69"/>
+    <p:sldId xmlns:r="http://schemas.openxmlformats.org/officeDocument/2006/relationships" id="273" r:id="Ra9ed249d2c6c4808"/>
+    <p:sldId xmlns:r="http://schemas.openxmlformats.org/officeDocument/2006/relationships" id="274" r:id="R62fbe376c54b4331"/>
+    <p:sldId xmlns:r="http://schemas.openxmlformats.org/officeDocument/2006/relationships" id="275" r:id="R136aa67e53884c54"/>
+    <p:sldId xmlns:r="http://schemas.openxmlformats.org/officeDocument/2006/relationships" id="276" r:id="Rbdf32128278d4564"/>
+    <p:sldId xmlns:r="http://schemas.openxmlformats.org/officeDocument/2006/relationships" id="277" r:id="R1ddb7403b8a84347"/>
   </p:sldIdLst>
   <p:sldSz cx="12192000" cy="6858000"/>
   <p:notesSz cx="6858000" cy="9144000"/>
@@ -2008,7 +2008,7 @@
   </p:cSld>
   <p:clrMap bg1="lt1" tx1="dk1" bg2="lt2" tx2="dk2" accent1="accent1" accent2="accent2" accent3="accent3" accent4="accent4" accent5="accent5" accent6="accent6" hlink="hlink" folHlink="folHlink"/>
   <p:sldLayoutIdLst>
-    <p:sldLayoutId xmlns:r="http://schemas.openxmlformats.org/officeDocument/2006/relationships" id="2147483649" r:id="Rc44680824878465e"/>
+    <p:sldLayoutId xmlns:r="http://schemas.openxmlformats.org/officeDocument/2006/relationships" id="2147483649" r:id="R6347275d58f048de"/>
   </p:sldLayoutIdLst>
   <p:txStyles>
     <p:titleStyle>
@@ -2559,7 +2559,7 @@
           <p:cNvPr id="1" name="">
             <a:extLst xmlns:a="http://schemas.openxmlformats.org/drawingml/2006/main">
               <a:ext uri="{FF2B5EF4-FFF2-40B4-BE49-F238E27FC236}">
-                <a16:creationId xmlns:a16="http://schemas.microsoft.com/office/drawing/2014/main" id="{26945D80-AD52-4EDA-AD85-248C46751852}"/>
+                <a16:creationId xmlns:a16="http://schemas.microsoft.com/office/drawing/2014/main" id="{40A79A6E-8F13-4C8A-A152-B7F8318D6909}"/>
               </a:ext>
             </a:extLst>
           </p:cNvPr>
@@ -2590,7 +2590,7 @@
           <p:cNvPr id="2" name="">
             <a:extLst xmlns:a="http://schemas.openxmlformats.org/drawingml/2006/main">
               <a:ext uri="{FF2B5EF4-FFF2-40B4-BE49-F238E27FC236}">
-                <a16:creationId xmlns:a16="http://schemas.microsoft.com/office/drawing/2014/main" id="{0C0939F2-E6F4-4709-A56A-A9DAADFF64F3}"/>
+                <a16:creationId xmlns:a16="http://schemas.microsoft.com/office/drawing/2014/main" id="{B76300C0-9726-429C-83DE-A734C1AC08EA}"/>
               </a:ext>
             </a:extLst>
           </p:cNvPr>
@@ -2622,7 +2622,7 @@
           <p:nvPr/>
         </p:nvPicPr>
         <p:blipFill>
-          <a:blip xmlns:r="http://schemas.openxmlformats.org/officeDocument/2006/relationships" xmlns:a="http://schemas.openxmlformats.org/drawingml/2006/main" r:embed="R65ef781e0c344e52"/>
+          <a:blip xmlns:r="http://schemas.openxmlformats.org/officeDocument/2006/relationships" xmlns:a="http://schemas.openxmlformats.org/drawingml/2006/main" r:embed="Rb4c09f38419b4e3f"/>
           <a:stretch xmlns:a="http://schemas.openxmlformats.org/drawingml/2006/main"/>
         </p:blipFill>
         <p:spPr>
@@ -2640,7 +2640,7 @@
           <p:cNvPr id="4" name="">
             <a:extLst xmlns:a="http://schemas.openxmlformats.org/drawingml/2006/main">
               <a:ext uri="{FF2B5EF4-FFF2-40B4-BE49-F238E27FC236}">
-                <a16:creationId xmlns:a16="http://schemas.microsoft.com/office/drawing/2014/main" id="{22E42ABC-F47A-4DAB-8222-060164C20519}"/>
+                <a16:creationId xmlns:a16="http://schemas.microsoft.com/office/drawing/2014/main" id="{2D6F3CE5-CEA9-47C3-BBFF-24633184929D}"/>
               </a:ext>
             </a:extLst>
           </p:cNvPr>
@@ -2690,7 +2690,7 @@
           <p:cNvPr id="5" name="">
             <a:extLst xmlns:a="http://schemas.openxmlformats.org/drawingml/2006/main">
               <a:ext uri="{FF2B5EF4-FFF2-40B4-BE49-F238E27FC236}">
-                <a16:creationId xmlns:a16="http://schemas.microsoft.com/office/drawing/2014/main" id="{2F053C32-A51A-4BE5-A4D6-4CC987D7135A}"/>
+                <a16:creationId xmlns:a16="http://schemas.microsoft.com/office/drawing/2014/main" id="{52621ACD-9349-4667-B637-BB7DE4DF768A}"/>
               </a:ext>
             </a:extLst>
           </p:cNvPr>
@@ -2740,7 +2740,7 @@
           <p:cNvPr id="6" name="">
             <a:extLst xmlns:a="http://schemas.openxmlformats.org/drawingml/2006/main">
               <a:ext uri="{FF2B5EF4-FFF2-40B4-BE49-F238E27FC236}">
-                <a16:creationId xmlns:a16="http://schemas.microsoft.com/office/drawing/2014/main" id="{CDAA3A7D-43C3-40C6-B13C-4C24103A0C9D}"/>
+                <a16:creationId xmlns:a16="http://schemas.microsoft.com/office/drawing/2014/main" id="{E998CDBD-922D-4390-8B78-D91ABBEE72F9}"/>
               </a:ext>
             </a:extLst>
           </p:cNvPr>
@@ -2790,7 +2790,7 @@
           <p:cNvPr id="7" name="">
             <a:extLst xmlns:a="http://schemas.openxmlformats.org/drawingml/2006/main">
               <a:ext uri="{FF2B5EF4-FFF2-40B4-BE49-F238E27FC236}">
-                <a16:creationId xmlns:a16="http://schemas.microsoft.com/office/drawing/2014/main" id="{86D90310-96B8-4282-B887-84A1649F801D}"/>
+                <a16:creationId xmlns:a16="http://schemas.microsoft.com/office/drawing/2014/main" id="{33B1CC7E-765F-4439-9F13-3D228789A447}"/>
               </a:ext>
             </a:extLst>
           </p:cNvPr>
@@ -2840,7 +2840,7 @@
           <p:cNvPr id="8" name="">
             <a:extLst xmlns:a="http://schemas.openxmlformats.org/drawingml/2006/main">
               <a:ext uri="{FF2B5EF4-FFF2-40B4-BE49-F238E27FC236}">
-                <a16:creationId xmlns:a16="http://schemas.microsoft.com/office/drawing/2014/main" id="{758AD6BB-C42E-4F83-B4A7-AB429304CD02}"/>
+                <a16:creationId xmlns:a16="http://schemas.microsoft.com/office/drawing/2014/main" id="{A265957D-6F5C-4260-8C36-5C8756E208F8}"/>
               </a:ext>
             </a:extLst>
           </p:cNvPr>
@@ -2871,7 +2871,7 @@
           <p:cNvPr id="9" name="">
             <a:extLst xmlns:a="http://schemas.openxmlformats.org/drawingml/2006/main">
               <a:ext uri="{FF2B5EF4-FFF2-40B4-BE49-F238E27FC236}">
-                <a16:creationId xmlns:a16="http://schemas.microsoft.com/office/drawing/2014/main" id="{FCC7D749-C42D-45BD-9628-E676CC1EE1C2}"/>
+                <a16:creationId xmlns:a16="http://schemas.microsoft.com/office/drawing/2014/main" id="{78F03072-2F94-4408-B588-C86A29C73810}"/>
               </a:ext>
             </a:extLst>
           </p:cNvPr>
@@ -2902,7 +2902,7 @@
           <p:cNvPr id="10" name="">
             <a:extLst xmlns:a="http://schemas.openxmlformats.org/drawingml/2006/main">
               <a:ext uri="{FF2B5EF4-FFF2-40B4-BE49-F238E27FC236}">
-                <a16:creationId xmlns:a16="http://schemas.microsoft.com/office/drawing/2014/main" id="{B746D5B8-4922-4001-A576-CD628CAA0D73}"/>
+                <a16:creationId xmlns:a16="http://schemas.microsoft.com/office/drawing/2014/main" id="{04707D6E-3BC9-4E4B-BC6C-DC6F2F1B4661}"/>
               </a:ext>
             </a:extLst>
           </p:cNvPr>
@@ -2984,7 +2984,7 @@
     </p:spTree>
     <p:extLst>
       <p:ext uri="{BB962C8B-B14F-4D97-AF65-F5344CB8AC3E}">
-        <p14:creationId xmlns:p14="http://schemas.microsoft.com/office/powerpoint/2010/main" val="897071804"/>
+        <p14:creationId xmlns:p14="http://schemas.microsoft.com/office/powerpoint/2010/main" val="1416915314"/>
       </p:ext>
     </p:extLst>
   </p:cSld>
@@ -3015,7 +3015,7 @@
           <p:cNvPr id="1" name="">
             <a:extLst xmlns:a="http://schemas.openxmlformats.org/drawingml/2006/main">
               <a:ext uri="{FF2B5EF4-FFF2-40B4-BE49-F238E27FC236}">
-                <a16:creationId xmlns:a16="http://schemas.microsoft.com/office/drawing/2014/main" id="{C1E5D00E-F002-46F2-9941-F3836A585D06}"/>
+                <a16:creationId xmlns:a16="http://schemas.microsoft.com/office/drawing/2014/main" id="{8E43CE40-3854-4A53-A2A5-093DC76424C2}"/>
               </a:ext>
             </a:extLst>
           </p:cNvPr>
@@ -3046,7 +3046,7 @@
           <p:cNvPr id="2" name="">
             <a:extLst xmlns:a="http://schemas.openxmlformats.org/drawingml/2006/main">
               <a:ext uri="{FF2B5EF4-FFF2-40B4-BE49-F238E27FC236}">
-                <a16:creationId xmlns:a16="http://schemas.microsoft.com/office/drawing/2014/main" id="{13E2B98C-0A79-44AA-A1E8-687802246B09}"/>
+                <a16:creationId xmlns:a16="http://schemas.microsoft.com/office/drawing/2014/main" id="{C9CF9713-C61D-47F6-A49C-E3684EFDD346}"/>
               </a:ext>
             </a:extLst>
           </p:cNvPr>
@@ -3096,7 +3096,7 @@
           <p:cNvPr id="3" name="">
             <a:extLst xmlns:a="http://schemas.openxmlformats.org/drawingml/2006/main">
               <a:ext uri="{FF2B5EF4-FFF2-40B4-BE49-F238E27FC236}">
-                <a16:creationId xmlns:a16="http://schemas.microsoft.com/office/drawing/2014/main" id="{9C01D443-9909-4B76-A4C5-3CAC9D358DAB}"/>
+                <a16:creationId xmlns:a16="http://schemas.microsoft.com/office/drawing/2014/main" id="{E4B87B0A-350B-4727-9F69-AA7F7AA1B499}"/>
               </a:ext>
             </a:extLst>
           </p:cNvPr>
@@ -3146,7 +3146,7 @@
           <p:cNvPr id="4" name="">
             <a:extLst xmlns:a="http://schemas.openxmlformats.org/drawingml/2006/main">
               <a:ext uri="{FF2B5EF4-FFF2-40B4-BE49-F238E27FC236}">
-                <a16:creationId xmlns:a16="http://schemas.microsoft.com/office/drawing/2014/main" id="{1DD42378-02CD-4AD7-8477-5E28FB228A66}"/>
+                <a16:creationId xmlns:a16="http://schemas.microsoft.com/office/drawing/2014/main" id="{461E22A6-4689-4587-95B3-129023B2D3A4}"/>
               </a:ext>
             </a:extLst>
           </p:cNvPr>
@@ -3196,7 +3196,7 @@
           <p:cNvPr id="5" name="">
             <a:extLst xmlns:a="http://schemas.openxmlformats.org/drawingml/2006/main">
               <a:ext uri="{FF2B5EF4-FFF2-40B4-BE49-F238E27FC236}">
-                <a16:creationId xmlns:a16="http://schemas.microsoft.com/office/drawing/2014/main" id="{34B627EF-E4B0-44D1-AB96-DD2FAD7C97F5}"/>
+                <a16:creationId xmlns:a16="http://schemas.microsoft.com/office/drawing/2014/main" id="{6A8FE9E9-D3EA-4AEB-A3A8-7B9D4016F85E}"/>
               </a:ext>
             </a:extLst>
           </p:cNvPr>
@@ -3227,7 +3227,7 @@
           <p:cNvPr id="6" name="">
             <a:extLst xmlns:a="http://schemas.openxmlformats.org/drawingml/2006/main">
               <a:ext uri="{FF2B5EF4-FFF2-40B4-BE49-F238E27FC236}">
-                <a16:creationId xmlns:a16="http://schemas.microsoft.com/office/drawing/2014/main" id="{364030EF-11CB-44D2-9526-E4366A4E5C1D}"/>
+                <a16:creationId xmlns:a16="http://schemas.microsoft.com/office/drawing/2014/main" id="{F67C562D-C6FE-4F90-BAF4-9FE8516DA98F}"/>
               </a:ext>
             </a:extLst>
           </p:cNvPr>
@@ -3277,7 +3277,7 @@
           <p:cNvPr id="7" name="">
             <a:extLst xmlns:a="http://schemas.openxmlformats.org/drawingml/2006/main">
               <a:ext uri="{FF2B5EF4-FFF2-40B4-BE49-F238E27FC236}">
-                <a16:creationId xmlns:a16="http://schemas.microsoft.com/office/drawing/2014/main" id="{0D07A43B-0AF6-44E8-B066-24CB7D663575}"/>
+                <a16:creationId xmlns:a16="http://schemas.microsoft.com/office/drawing/2014/main" id="{9A70BE45-2783-4114-964D-846A8C7AABFA}"/>
               </a:ext>
             </a:extLst>
           </p:cNvPr>
@@ -3327,7 +3327,7 @@
           <p:cNvPr id="8" name="">
             <a:extLst xmlns:a="http://schemas.openxmlformats.org/drawingml/2006/main">
               <a:ext uri="{FF2B5EF4-FFF2-40B4-BE49-F238E27FC236}">
-                <a16:creationId xmlns:a16="http://schemas.microsoft.com/office/drawing/2014/main" id="{BDE59677-3438-48C1-B041-B4314C064E46}"/>
+                <a16:creationId xmlns:a16="http://schemas.microsoft.com/office/drawing/2014/main" id="{6884FFE1-11CF-4A2C-A3FB-977ACFADB6CC}"/>
               </a:ext>
             </a:extLst>
           </p:cNvPr>
@@ -3358,7 +3358,7 @@
           <p:cNvPr id="9" name="">
             <a:extLst xmlns:a="http://schemas.openxmlformats.org/drawingml/2006/main">
               <a:ext uri="{FF2B5EF4-FFF2-40B4-BE49-F238E27FC236}">
-                <a16:creationId xmlns:a16="http://schemas.microsoft.com/office/drawing/2014/main" id="{F9910145-04DD-43B9-B983-B95B8918CDA6}"/>
+                <a16:creationId xmlns:a16="http://schemas.microsoft.com/office/drawing/2014/main" id="{F6399763-3AE2-4372-8C8C-134342AE65B2}"/>
               </a:ext>
             </a:extLst>
           </p:cNvPr>
@@ -3408,7 +3408,7 @@
           <p:cNvPr id="10" name="">
             <a:extLst xmlns:a="http://schemas.openxmlformats.org/drawingml/2006/main">
               <a:ext uri="{FF2B5EF4-FFF2-40B4-BE49-F238E27FC236}">
-                <a16:creationId xmlns:a16="http://schemas.microsoft.com/office/drawing/2014/main" id="{4FC80BF4-613C-4E13-B7D6-F8F8AFD5CF00}"/>
+                <a16:creationId xmlns:a16="http://schemas.microsoft.com/office/drawing/2014/main" id="{2872CDDD-A20E-40BA-A02C-E5505914DEEE}"/>
               </a:ext>
             </a:extLst>
           </p:cNvPr>
@@ -3458,7 +3458,7 @@
           <p:cNvPr id="11" name="">
             <a:extLst xmlns:a="http://schemas.openxmlformats.org/drawingml/2006/main">
               <a:ext uri="{FF2B5EF4-FFF2-40B4-BE49-F238E27FC236}">
-                <a16:creationId xmlns:a16="http://schemas.microsoft.com/office/drawing/2014/main" id="{EC2A2A9F-F2A8-40E1-8DFB-D2CBD940F37F}"/>
+                <a16:creationId xmlns:a16="http://schemas.microsoft.com/office/drawing/2014/main" id="{AB0457EA-3483-40DD-99F2-BE19D8D6F7B2}"/>
               </a:ext>
             </a:extLst>
           </p:cNvPr>
@@ -3489,7 +3489,7 @@
           <p:cNvPr id="12" name="">
             <a:extLst xmlns:a="http://schemas.openxmlformats.org/drawingml/2006/main">
               <a:ext uri="{FF2B5EF4-FFF2-40B4-BE49-F238E27FC236}">
-                <a16:creationId xmlns:a16="http://schemas.microsoft.com/office/drawing/2014/main" id="{3C4C7B31-A371-48AC-844B-A74AC33CC618}"/>
+                <a16:creationId xmlns:a16="http://schemas.microsoft.com/office/drawing/2014/main" id="{D31BAF5E-920A-40BF-BA77-D0C3F9DE835A}"/>
               </a:ext>
             </a:extLst>
           </p:cNvPr>
@@ -3539,7 +3539,7 @@
           <p:cNvPr id="13" name="">
             <a:extLst xmlns:a="http://schemas.openxmlformats.org/drawingml/2006/main">
               <a:ext uri="{FF2B5EF4-FFF2-40B4-BE49-F238E27FC236}">
-                <a16:creationId xmlns:a16="http://schemas.microsoft.com/office/drawing/2014/main" id="{E1A9A01B-93D0-4642-9B99-AD0FD4D61BEC}"/>
+                <a16:creationId xmlns:a16="http://schemas.microsoft.com/office/drawing/2014/main" id="{50F35403-B132-43D8-96C3-2DC07F4B4279}"/>
               </a:ext>
             </a:extLst>
           </p:cNvPr>
@@ -3589,7 +3589,7 @@
           <p:cNvPr id="14" name="">
             <a:extLst xmlns:a="http://schemas.openxmlformats.org/drawingml/2006/main">
               <a:ext uri="{FF2B5EF4-FFF2-40B4-BE49-F238E27FC236}">
-                <a16:creationId xmlns:a16="http://schemas.microsoft.com/office/drawing/2014/main" id="{9FA7F86E-7974-40D5-BDCD-3D69B2F956C0}"/>
+                <a16:creationId xmlns:a16="http://schemas.microsoft.com/office/drawing/2014/main" id="{BCEB80D9-1027-4A80-8E22-D3DC05BECDD9}"/>
               </a:ext>
             </a:extLst>
           </p:cNvPr>
@@ -3620,7 +3620,7 @@
           <p:cNvPr id="15" name="">
             <a:extLst xmlns:a="http://schemas.openxmlformats.org/drawingml/2006/main">
               <a:ext uri="{FF2B5EF4-FFF2-40B4-BE49-F238E27FC236}">
-                <a16:creationId xmlns:a16="http://schemas.microsoft.com/office/drawing/2014/main" id="{0631A388-619F-4D3E-96D3-43B6E352086C}"/>
+                <a16:creationId xmlns:a16="http://schemas.microsoft.com/office/drawing/2014/main" id="{18FB21F5-98AE-414F-BD1D-78F9414EC309}"/>
               </a:ext>
             </a:extLst>
           </p:cNvPr>
@@ -3670,7 +3670,7 @@
           <p:cNvPr id="16" name="">
             <a:extLst xmlns:a="http://schemas.openxmlformats.org/drawingml/2006/main">
               <a:ext uri="{FF2B5EF4-FFF2-40B4-BE49-F238E27FC236}">
-                <a16:creationId xmlns:a16="http://schemas.microsoft.com/office/drawing/2014/main" id="{C54D1505-74BB-43AA-B536-B86900F68906}"/>
+                <a16:creationId xmlns:a16="http://schemas.microsoft.com/office/drawing/2014/main" id="{F6AD5EF8-6B86-43EB-BE56-2787FDCBCAD1}"/>
               </a:ext>
             </a:extLst>
           </p:cNvPr>
@@ -3705,7 +3705,7 @@
           <p:nvPr/>
         </p:nvPicPr>
         <p:blipFill>
-          <a:blip xmlns:r="http://schemas.openxmlformats.org/officeDocument/2006/relationships" xmlns:a="http://schemas.openxmlformats.org/drawingml/2006/main" r:embed="R6e4b073dcc3b44c2"/>
+          <a:blip xmlns:r="http://schemas.openxmlformats.org/officeDocument/2006/relationships" xmlns:a="http://schemas.openxmlformats.org/drawingml/2006/main" r:embed="R9608166240bc4f24"/>
           <a:stretch xmlns:a="http://schemas.openxmlformats.org/drawingml/2006/main"/>
         </p:blipFill>
         <p:spPr>
@@ -3723,7 +3723,7 @@
           <p:cNvPr id="18" name="">
             <a:extLst xmlns:a="http://schemas.openxmlformats.org/drawingml/2006/main">
               <a:ext uri="{FF2B5EF4-FFF2-40B4-BE49-F238E27FC236}">
-                <a16:creationId xmlns:a16="http://schemas.microsoft.com/office/drawing/2014/main" id="{6637EB1E-5BFF-4403-8F8B-20417E554DA3}"/>
+                <a16:creationId xmlns:a16="http://schemas.microsoft.com/office/drawing/2014/main" id="{5CAF3F0B-DAF0-4ABD-882C-7D731C4E37D3}"/>
               </a:ext>
             </a:extLst>
           </p:cNvPr>
@@ -3773,7 +3773,7 @@
           <p:cNvPr id="19" name="">
             <a:extLst xmlns:a="http://schemas.openxmlformats.org/drawingml/2006/main">
               <a:ext uri="{FF2B5EF4-FFF2-40B4-BE49-F238E27FC236}">
-                <a16:creationId xmlns:a16="http://schemas.microsoft.com/office/drawing/2014/main" id="{A489B0F2-A241-402E-BF4B-6B3CCC82E8D2}"/>
+                <a16:creationId xmlns:a16="http://schemas.microsoft.com/office/drawing/2014/main" id="{529112A8-D0ED-422B-B53A-DCA2EE753B5F}"/>
               </a:ext>
             </a:extLst>
           </p:cNvPr>
@@ -3821,7 +3821,7 @@
     </p:spTree>
     <p:extLst>
       <p:ext uri="{BB962C8B-B14F-4D97-AF65-F5344CB8AC3E}">
-        <p14:creationId xmlns:p14="http://schemas.microsoft.com/office/powerpoint/2010/main" val="642575013"/>
+        <p14:creationId xmlns:p14="http://schemas.microsoft.com/office/powerpoint/2010/main" val="377000396"/>
       </p:ext>
     </p:extLst>
   </p:cSld>
@@ -3852,7 +3852,7 @@
           <p:cNvPr id="1" name="">
             <a:extLst xmlns:a="http://schemas.openxmlformats.org/drawingml/2006/main">
               <a:ext uri="{FF2B5EF4-FFF2-40B4-BE49-F238E27FC236}">
-                <a16:creationId xmlns:a16="http://schemas.microsoft.com/office/drawing/2014/main" id="{3F98ACDD-2517-44B4-94CA-928EF73DBC0B}"/>
+                <a16:creationId xmlns:a16="http://schemas.microsoft.com/office/drawing/2014/main" id="{EE14B0CC-F507-45E6-90AB-305338D0836F}"/>
               </a:ext>
             </a:extLst>
           </p:cNvPr>
@@ -3883,7 +3883,7 @@
           <p:cNvPr id="2" name="">
             <a:extLst xmlns:a="http://schemas.openxmlformats.org/drawingml/2006/main">
               <a:ext uri="{FF2B5EF4-FFF2-40B4-BE49-F238E27FC236}">
-                <a16:creationId xmlns:a16="http://schemas.microsoft.com/office/drawing/2014/main" id="{D2A70E16-D106-4250-B016-CF14A32C0EA0}"/>
+                <a16:creationId xmlns:a16="http://schemas.microsoft.com/office/drawing/2014/main" id="{9C4407D5-6331-4A6F-BB17-D2E80053282A}"/>
               </a:ext>
             </a:extLst>
           </p:cNvPr>
@@ -3933,7 +3933,7 @@
           <p:cNvPr id="3" name="">
             <a:extLst xmlns:a="http://schemas.openxmlformats.org/drawingml/2006/main">
               <a:ext uri="{FF2B5EF4-FFF2-40B4-BE49-F238E27FC236}">
-                <a16:creationId xmlns:a16="http://schemas.microsoft.com/office/drawing/2014/main" id="{3D8D5378-8A3B-4655-B23C-88C779E89159}"/>
+                <a16:creationId xmlns:a16="http://schemas.microsoft.com/office/drawing/2014/main" id="{7785C535-CA04-4A9B-919D-05B617DDB00B}"/>
               </a:ext>
             </a:extLst>
           </p:cNvPr>
@@ -3983,7 +3983,7 @@
           <p:cNvPr id="4" name="">
             <a:extLst xmlns:a="http://schemas.openxmlformats.org/drawingml/2006/main">
               <a:ext uri="{FF2B5EF4-FFF2-40B4-BE49-F238E27FC236}">
-                <a16:creationId xmlns:a16="http://schemas.microsoft.com/office/drawing/2014/main" id="{9B7D7C15-52B9-4BD7-BA40-3B2B6183D25A}"/>
+                <a16:creationId xmlns:a16="http://schemas.microsoft.com/office/drawing/2014/main" id="{E4CD63F4-CA26-4775-970D-6EE46001B9B9}"/>
               </a:ext>
             </a:extLst>
           </p:cNvPr>
@@ -4018,7 +4018,7 @@
           <p:cNvPr id="5" name="">
             <a:extLst xmlns:a="http://schemas.openxmlformats.org/drawingml/2006/main">
               <a:ext uri="{FF2B5EF4-FFF2-40B4-BE49-F238E27FC236}">
-                <a16:creationId xmlns:a16="http://schemas.microsoft.com/office/drawing/2014/main" id="{143AECD7-B713-4D9E-8A47-78045BBD11D6}"/>
+                <a16:creationId xmlns:a16="http://schemas.microsoft.com/office/drawing/2014/main" id="{6666F973-6EC8-4B60-8DD4-904BA031825B}"/>
               </a:ext>
             </a:extLst>
           </p:cNvPr>
@@ -4068,7 +4068,7 @@
           <p:cNvPr id="6" name="">
             <a:extLst xmlns:a="http://schemas.openxmlformats.org/drawingml/2006/main">
               <a:ext uri="{FF2B5EF4-FFF2-40B4-BE49-F238E27FC236}">
-                <a16:creationId xmlns:a16="http://schemas.microsoft.com/office/drawing/2014/main" id="{573CD14B-C22D-4D59-BE50-E62CB2CAC563}"/>
+                <a16:creationId xmlns:a16="http://schemas.microsoft.com/office/drawing/2014/main" id="{CD6659D8-388D-44A9-88DB-D81010945512}"/>
               </a:ext>
             </a:extLst>
           </p:cNvPr>
@@ -4152,7 +4152,7 @@
           <p:cNvPr id="7" name="">
             <a:extLst xmlns:a="http://schemas.openxmlformats.org/drawingml/2006/main">
               <a:ext uri="{FF2B5EF4-FFF2-40B4-BE49-F238E27FC236}">
-                <a16:creationId xmlns:a16="http://schemas.microsoft.com/office/drawing/2014/main" id="{8FC9F303-20A4-44D2-97FC-75B68CDE16BB}"/>
+                <a16:creationId xmlns:a16="http://schemas.microsoft.com/office/drawing/2014/main" id="{4182EE15-C100-4F7E-B067-2C292ADA6FB6}"/>
               </a:ext>
             </a:extLst>
           </p:cNvPr>
@@ -4187,7 +4187,7 @@
           <p:cNvPr id="8" name="">
             <a:extLst xmlns:a="http://schemas.openxmlformats.org/drawingml/2006/main">
               <a:ext uri="{FF2B5EF4-FFF2-40B4-BE49-F238E27FC236}">
-                <a16:creationId xmlns:a16="http://schemas.microsoft.com/office/drawing/2014/main" id="{090E2F85-46DE-492F-889D-3704F325C522}"/>
+                <a16:creationId xmlns:a16="http://schemas.microsoft.com/office/drawing/2014/main" id="{DC5EBACD-87A1-4845-84A5-7F5F2EC77968}"/>
               </a:ext>
             </a:extLst>
           </p:cNvPr>
@@ -4237,7 +4237,7 @@
           <p:cNvPr id="9" name="">
             <a:extLst xmlns:a="http://schemas.openxmlformats.org/drawingml/2006/main">
               <a:ext uri="{FF2B5EF4-FFF2-40B4-BE49-F238E27FC236}">
-                <a16:creationId xmlns:a16="http://schemas.microsoft.com/office/drawing/2014/main" id="{A1DA676B-4DB6-4365-ADF1-40D6234AEA4E}"/>
+                <a16:creationId xmlns:a16="http://schemas.microsoft.com/office/drawing/2014/main" id="{9D27D7A7-9D3B-4C3A-9552-165D4043B901}"/>
               </a:ext>
             </a:extLst>
           </p:cNvPr>
@@ -4321,7 +4321,7 @@
           <p:cNvPr id="10" name="">
             <a:extLst xmlns:a="http://schemas.openxmlformats.org/drawingml/2006/main">
               <a:ext uri="{FF2B5EF4-FFF2-40B4-BE49-F238E27FC236}">
-                <a16:creationId xmlns:a16="http://schemas.microsoft.com/office/drawing/2014/main" id="{B91C5FDF-A4F5-4CA7-83D6-8673F8888471}"/>
+                <a16:creationId xmlns:a16="http://schemas.microsoft.com/office/drawing/2014/main" id="{6084DCA1-EFBD-42BB-A1C1-8B81A04D5539}"/>
               </a:ext>
             </a:extLst>
           </p:cNvPr>
@@ -4356,7 +4356,7 @@
           <p:cNvPr id="11" name="">
             <a:extLst xmlns:a="http://schemas.openxmlformats.org/drawingml/2006/main">
               <a:ext uri="{FF2B5EF4-FFF2-40B4-BE49-F238E27FC236}">
-                <a16:creationId xmlns:a16="http://schemas.microsoft.com/office/drawing/2014/main" id="{D3A5B309-710A-4980-B355-69EECA303FE5}"/>
+                <a16:creationId xmlns:a16="http://schemas.microsoft.com/office/drawing/2014/main" id="{8BAC35DD-6DC4-4E87-9DA1-375F08DD50E1}"/>
               </a:ext>
             </a:extLst>
           </p:cNvPr>
@@ -4406,7 +4406,7 @@
           <p:cNvPr id="12" name="">
             <a:extLst xmlns:a="http://schemas.openxmlformats.org/drawingml/2006/main">
               <a:ext uri="{FF2B5EF4-FFF2-40B4-BE49-F238E27FC236}">
-                <a16:creationId xmlns:a16="http://schemas.microsoft.com/office/drawing/2014/main" id="{2ABE91EB-DB87-44E2-9111-0CD06266F455}"/>
+                <a16:creationId xmlns:a16="http://schemas.microsoft.com/office/drawing/2014/main" id="{1F922F9B-EDE8-4EE0-8A2C-D102EA0D8C44}"/>
               </a:ext>
             </a:extLst>
           </p:cNvPr>
@@ -4490,7 +4490,7 @@
           <p:cNvPr id="13" name="">
             <a:extLst xmlns:a="http://schemas.openxmlformats.org/drawingml/2006/main">
               <a:ext uri="{FF2B5EF4-FFF2-40B4-BE49-F238E27FC236}">
-                <a16:creationId xmlns:a16="http://schemas.microsoft.com/office/drawing/2014/main" id="{9FDBA9AA-C3E5-4D33-B70E-3C5930150D2D}"/>
+                <a16:creationId xmlns:a16="http://schemas.microsoft.com/office/drawing/2014/main" id="{F0AC8C95-3D21-484F-8060-002BBEE90839}"/>
               </a:ext>
             </a:extLst>
           </p:cNvPr>
@@ -4525,7 +4525,7 @@
           <p:nvPr/>
         </p:nvPicPr>
         <p:blipFill>
-          <a:blip xmlns:r="http://schemas.openxmlformats.org/officeDocument/2006/relationships" xmlns:a="http://schemas.openxmlformats.org/drawingml/2006/main" r:embed="Rea1dbbd5747d432c"/>
+          <a:blip xmlns:r="http://schemas.openxmlformats.org/officeDocument/2006/relationships" xmlns:a="http://schemas.openxmlformats.org/drawingml/2006/main" r:embed="R2eb024ff18f64578"/>
           <a:stretch xmlns:a="http://schemas.openxmlformats.org/drawingml/2006/main"/>
         </p:blipFill>
         <p:spPr>
@@ -4543,7 +4543,7 @@
           <p:cNvPr id="15" name="">
             <a:extLst xmlns:a="http://schemas.openxmlformats.org/drawingml/2006/main">
               <a:ext uri="{FF2B5EF4-FFF2-40B4-BE49-F238E27FC236}">
-                <a16:creationId xmlns:a16="http://schemas.microsoft.com/office/drawing/2014/main" id="{6CD245BD-5D21-417F-88D6-92B2ABD87A4F}"/>
+                <a16:creationId xmlns:a16="http://schemas.microsoft.com/office/drawing/2014/main" id="{CF3C77EF-EBC7-4A2D-9F10-EEADA49C12ED}"/>
               </a:ext>
             </a:extLst>
           </p:cNvPr>
@@ -4593,7 +4593,7 @@
           <p:cNvPr id="16" name="">
             <a:extLst xmlns:a="http://schemas.openxmlformats.org/drawingml/2006/main">
               <a:ext uri="{FF2B5EF4-FFF2-40B4-BE49-F238E27FC236}">
-                <a16:creationId xmlns:a16="http://schemas.microsoft.com/office/drawing/2014/main" id="{354EA8C1-EFCD-484F-9FFE-FF54D214C5D6}"/>
+                <a16:creationId xmlns:a16="http://schemas.microsoft.com/office/drawing/2014/main" id="{B3E680A1-778C-4E39-B6EB-4C3A81F5FD3B}"/>
               </a:ext>
             </a:extLst>
           </p:cNvPr>
@@ -4641,7 +4641,7 @@
     </p:spTree>
     <p:extLst>
       <p:ext uri="{BB962C8B-B14F-4D97-AF65-F5344CB8AC3E}">
-        <p14:creationId xmlns:p14="http://schemas.microsoft.com/office/powerpoint/2010/main" val="1084015244"/>
+        <p14:creationId xmlns:p14="http://schemas.microsoft.com/office/powerpoint/2010/main" val="502258044"/>
       </p:ext>
     </p:extLst>
   </p:cSld>
@@ -4672,7 +4672,7 @@
           <p:cNvPr id="1" name="">
             <a:extLst xmlns:a="http://schemas.openxmlformats.org/drawingml/2006/main">
               <a:ext uri="{FF2B5EF4-FFF2-40B4-BE49-F238E27FC236}">
-                <a16:creationId xmlns:a16="http://schemas.microsoft.com/office/drawing/2014/main" id="{A5D27141-B6D1-43AA-9AD3-8353D3732023}"/>
+                <a16:creationId xmlns:a16="http://schemas.microsoft.com/office/drawing/2014/main" id="{5C2B2B6C-5635-4543-8285-C9D359C97FE8}"/>
               </a:ext>
             </a:extLst>
           </p:cNvPr>
@@ -4703,7 +4703,7 @@
           <p:cNvPr id="2" name="">
             <a:extLst xmlns:a="http://schemas.openxmlformats.org/drawingml/2006/main">
               <a:ext uri="{FF2B5EF4-FFF2-40B4-BE49-F238E27FC236}">
-                <a16:creationId xmlns:a16="http://schemas.microsoft.com/office/drawing/2014/main" id="{122F8308-D5A3-4C60-B3DE-21F4E7367159}"/>
+                <a16:creationId xmlns:a16="http://schemas.microsoft.com/office/drawing/2014/main" id="{C68F4227-5FBF-4A40-80F5-601E063E2146}"/>
               </a:ext>
             </a:extLst>
           </p:cNvPr>
@@ -4753,7 +4753,7 @@
           <p:cNvPr id="3" name="">
             <a:extLst xmlns:a="http://schemas.openxmlformats.org/drawingml/2006/main">
               <a:ext uri="{FF2B5EF4-FFF2-40B4-BE49-F238E27FC236}">
-                <a16:creationId xmlns:a16="http://schemas.microsoft.com/office/drawing/2014/main" id="{859486F7-35BA-45BC-94C7-B782E619881C}"/>
+                <a16:creationId xmlns:a16="http://schemas.microsoft.com/office/drawing/2014/main" id="{6E1D07A7-FA76-4ADE-9E8A-9126BD8C16FA}"/>
               </a:ext>
             </a:extLst>
           </p:cNvPr>
@@ -4803,7 +4803,7 @@
           <p:cNvPr id="4" name="">
             <a:extLst xmlns:a="http://schemas.openxmlformats.org/drawingml/2006/main">
               <a:ext uri="{FF2B5EF4-FFF2-40B4-BE49-F238E27FC236}">
-                <a16:creationId xmlns:a16="http://schemas.microsoft.com/office/drawing/2014/main" id="{0F864AC3-A1F7-49E0-93EB-EAED9DFA3A8D}"/>
+                <a16:creationId xmlns:a16="http://schemas.microsoft.com/office/drawing/2014/main" id="{9B8CBFCC-3B58-43CE-AC24-1A142FF63C15}"/>
               </a:ext>
             </a:extLst>
           </p:cNvPr>
@@ -4853,7 +4853,7 @@
           <p:cNvPr id="5" name="">
             <a:extLst xmlns:a="http://schemas.openxmlformats.org/drawingml/2006/main">
               <a:ext uri="{FF2B5EF4-FFF2-40B4-BE49-F238E27FC236}">
-                <a16:creationId xmlns:a16="http://schemas.microsoft.com/office/drawing/2014/main" id="{2B49BC7B-34F4-49F2-94F6-48606DCF8FD4}"/>
+                <a16:creationId xmlns:a16="http://schemas.microsoft.com/office/drawing/2014/main" id="{E55E5D72-3211-4082-A64D-AD935A958BBB}"/>
               </a:ext>
             </a:extLst>
           </p:cNvPr>
@@ -4903,7 +4903,7 @@
           <p:cNvPr id="6" name="">
             <a:extLst xmlns:a="http://schemas.openxmlformats.org/drawingml/2006/main">
               <a:ext uri="{FF2B5EF4-FFF2-40B4-BE49-F238E27FC236}">
-                <a16:creationId xmlns:a16="http://schemas.microsoft.com/office/drawing/2014/main" id="{B0D82853-2E98-40E5-AE26-43A2465D80B9}"/>
+                <a16:creationId xmlns:a16="http://schemas.microsoft.com/office/drawing/2014/main" id="{DB39F870-AD38-4C3A-A304-E138167827A6}"/>
               </a:ext>
             </a:extLst>
           </p:cNvPr>
@@ -4934,7 +4934,7 @@
           <p:cNvPr id="7" name="">
             <a:extLst xmlns:a="http://schemas.openxmlformats.org/drawingml/2006/main">
               <a:ext uri="{FF2B5EF4-FFF2-40B4-BE49-F238E27FC236}">
-                <a16:creationId xmlns:a16="http://schemas.microsoft.com/office/drawing/2014/main" id="{DEC7DC43-77F9-4280-9C7A-AFF0580BE747}"/>
+                <a16:creationId xmlns:a16="http://schemas.microsoft.com/office/drawing/2014/main" id="{3C10368E-1503-4686-BF69-80FB5CFBCA4B}"/>
               </a:ext>
             </a:extLst>
           </p:cNvPr>
@@ -4984,7 +4984,7 @@
           <p:cNvPr id="8" name="">
             <a:extLst xmlns:a="http://schemas.openxmlformats.org/drawingml/2006/main">
               <a:ext uri="{FF2B5EF4-FFF2-40B4-BE49-F238E27FC236}">
-                <a16:creationId xmlns:a16="http://schemas.microsoft.com/office/drawing/2014/main" id="{D0F9E5B2-C4D2-4416-A261-06253C2EA913}"/>
+                <a16:creationId xmlns:a16="http://schemas.microsoft.com/office/drawing/2014/main" id="{8696B13B-A475-46B5-913B-F8490A485F5D}"/>
               </a:ext>
             </a:extLst>
           </p:cNvPr>
@@ -5015,7 +5015,7 @@
           <p:cNvPr id="9" name="">
             <a:extLst xmlns:a="http://schemas.openxmlformats.org/drawingml/2006/main">
               <a:ext uri="{FF2B5EF4-FFF2-40B4-BE49-F238E27FC236}">
-                <a16:creationId xmlns:a16="http://schemas.microsoft.com/office/drawing/2014/main" id="{00A912C7-9747-4DC0-8909-C7D3426D5022}"/>
+                <a16:creationId xmlns:a16="http://schemas.microsoft.com/office/drawing/2014/main" id="{29008546-1474-47EF-965D-9F814B1CAB01}"/>
               </a:ext>
             </a:extLst>
           </p:cNvPr>
@@ -5065,7 +5065,7 @@
           <p:cNvPr id="10" name="">
             <a:extLst xmlns:a="http://schemas.openxmlformats.org/drawingml/2006/main">
               <a:ext uri="{FF2B5EF4-FFF2-40B4-BE49-F238E27FC236}">
-                <a16:creationId xmlns:a16="http://schemas.microsoft.com/office/drawing/2014/main" id="{6BEDEB83-0274-4639-9C2C-8227719EFAF5}"/>
+                <a16:creationId xmlns:a16="http://schemas.microsoft.com/office/drawing/2014/main" id="{7D1C1BAC-FB7F-400F-A31F-AEC21DFA101E}"/>
               </a:ext>
             </a:extLst>
           </p:cNvPr>
@@ -5096,7 +5096,7 @@
           <p:cNvPr id="11" name="">
             <a:extLst xmlns:a="http://schemas.openxmlformats.org/drawingml/2006/main">
               <a:ext uri="{FF2B5EF4-FFF2-40B4-BE49-F238E27FC236}">
-                <a16:creationId xmlns:a16="http://schemas.microsoft.com/office/drawing/2014/main" id="{F8442765-4271-41C3-9217-9C12CD7E83A7}"/>
+                <a16:creationId xmlns:a16="http://schemas.microsoft.com/office/drawing/2014/main" id="{60959397-B9EC-46EF-B872-CF90B6E3AC55}"/>
               </a:ext>
             </a:extLst>
           </p:cNvPr>
@@ -5146,7 +5146,7 @@
           <p:cNvPr id="12" name="">
             <a:extLst xmlns:a="http://schemas.openxmlformats.org/drawingml/2006/main">
               <a:ext uri="{FF2B5EF4-FFF2-40B4-BE49-F238E27FC236}">
-                <a16:creationId xmlns:a16="http://schemas.microsoft.com/office/drawing/2014/main" id="{22AA56CC-094E-4A99-B903-1AAFC6C4EA17}"/>
+                <a16:creationId xmlns:a16="http://schemas.microsoft.com/office/drawing/2014/main" id="{1844BC77-8BBE-4F96-AC0B-2B4FBDD36725}"/>
               </a:ext>
             </a:extLst>
           </p:cNvPr>
@@ -5177,7 +5177,7 @@
           <p:cNvPr id="13" name="">
             <a:extLst xmlns:a="http://schemas.openxmlformats.org/drawingml/2006/main">
               <a:ext uri="{FF2B5EF4-FFF2-40B4-BE49-F238E27FC236}">
-                <a16:creationId xmlns:a16="http://schemas.microsoft.com/office/drawing/2014/main" id="{161C382F-14DF-4ED8-A1F9-001D200FD0F2}"/>
+                <a16:creationId xmlns:a16="http://schemas.microsoft.com/office/drawing/2014/main" id="{1B7A6C61-8092-479B-9B11-354AEFF2B992}"/>
               </a:ext>
             </a:extLst>
           </p:cNvPr>
@@ -5227,7 +5227,7 @@
           <p:cNvPr id="14" name="">
             <a:extLst xmlns:a="http://schemas.openxmlformats.org/drawingml/2006/main">
               <a:ext uri="{FF2B5EF4-FFF2-40B4-BE49-F238E27FC236}">
-                <a16:creationId xmlns:a16="http://schemas.microsoft.com/office/drawing/2014/main" id="{3E0920AC-E807-4DD1-BDE6-A97084DCEB89}"/>
+                <a16:creationId xmlns:a16="http://schemas.microsoft.com/office/drawing/2014/main" id="{DE1071D2-D8A3-460D-AA94-004150CC41A1}"/>
               </a:ext>
             </a:extLst>
           </p:cNvPr>
@@ -5258,7 +5258,7 @@
           <p:cNvPr id="15" name="">
             <a:extLst xmlns:a="http://schemas.openxmlformats.org/drawingml/2006/main">
               <a:ext uri="{FF2B5EF4-FFF2-40B4-BE49-F238E27FC236}">
-                <a16:creationId xmlns:a16="http://schemas.microsoft.com/office/drawing/2014/main" id="{778A6D3B-4A80-4BBB-A391-DF693B9B463A}"/>
+                <a16:creationId xmlns:a16="http://schemas.microsoft.com/office/drawing/2014/main" id="{81F7AC3D-556F-4A65-8B10-593465A00BE4}"/>
               </a:ext>
             </a:extLst>
           </p:cNvPr>
@@ -5308,7 +5308,7 @@
           <p:cNvPr id="16" name="">
             <a:extLst xmlns:a="http://schemas.openxmlformats.org/drawingml/2006/main">
               <a:ext uri="{FF2B5EF4-FFF2-40B4-BE49-F238E27FC236}">
-                <a16:creationId xmlns:a16="http://schemas.microsoft.com/office/drawing/2014/main" id="{643388FE-5230-4D25-A15B-0CA55F8083B9}"/>
+                <a16:creationId xmlns:a16="http://schemas.microsoft.com/office/drawing/2014/main" id="{EBC97FEF-F915-4223-ABB3-E02F03536CA5}"/>
               </a:ext>
             </a:extLst>
           </p:cNvPr>
@@ -5339,7 +5339,7 @@
           <p:cNvPr id="17" name="">
             <a:extLst xmlns:a="http://schemas.openxmlformats.org/drawingml/2006/main">
               <a:ext uri="{FF2B5EF4-FFF2-40B4-BE49-F238E27FC236}">
-                <a16:creationId xmlns:a16="http://schemas.microsoft.com/office/drawing/2014/main" id="{4F612111-2AC8-4CFC-A9D5-AFEBE3337E2F}"/>
+                <a16:creationId xmlns:a16="http://schemas.microsoft.com/office/drawing/2014/main" id="{637EF722-D1BA-4ADC-82E8-E95767532425}"/>
               </a:ext>
             </a:extLst>
           </p:cNvPr>
@@ -5389,7 +5389,7 @@
           <p:cNvPr id="18" name="">
             <a:extLst xmlns:a="http://schemas.openxmlformats.org/drawingml/2006/main">
               <a:ext uri="{FF2B5EF4-FFF2-40B4-BE49-F238E27FC236}">
-                <a16:creationId xmlns:a16="http://schemas.microsoft.com/office/drawing/2014/main" id="{22365A18-B7F6-4B2B-9FB5-01139B8C748B}"/>
+                <a16:creationId xmlns:a16="http://schemas.microsoft.com/office/drawing/2014/main" id="{84D49B78-4C61-4413-8861-500D127CA7AA}"/>
               </a:ext>
             </a:extLst>
           </p:cNvPr>
@@ -5420,7 +5420,7 @@
           <p:cNvPr id="19" name="">
             <a:extLst xmlns:a="http://schemas.openxmlformats.org/drawingml/2006/main">
               <a:ext uri="{FF2B5EF4-FFF2-40B4-BE49-F238E27FC236}">
-                <a16:creationId xmlns:a16="http://schemas.microsoft.com/office/drawing/2014/main" id="{03F1903A-C88B-4C91-BD26-EE99B26E695D}"/>
+                <a16:creationId xmlns:a16="http://schemas.microsoft.com/office/drawing/2014/main" id="{17E9377E-FD47-4F13-A7F5-3B0F7D9ABF93}"/>
               </a:ext>
             </a:extLst>
           </p:cNvPr>
@@ -5470,7 +5470,7 @@
           <p:cNvPr id="20" name="">
             <a:extLst xmlns:a="http://schemas.openxmlformats.org/drawingml/2006/main">
               <a:ext uri="{FF2B5EF4-FFF2-40B4-BE49-F238E27FC236}">
-                <a16:creationId xmlns:a16="http://schemas.microsoft.com/office/drawing/2014/main" id="{B5B64565-3DE4-4F44-AD38-D57F97368EE6}"/>
+                <a16:creationId xmlns:a16="http://schemas.microsoft.com/office/drawing/2014/main" id="{5B63EAAA-F19D-4462-B78B-752C6831A8D3}"/>
               </a:ext>
             </a:extLst>
           </p:cNvPr>
@@ -5501,7 +5501,7 @@
           <p:cNvPr id="21" name="">
             <a:extLst xmlns:a="http://schemas.openxmlformats.org/drawingml/2006/main">
               <a:ext uri="{FF2B5EF4-FFF2-40B4-BE49-F238E27FC236}">
-                <a16:creationId xmlns:a16="http://schemas.microsoft.com/office/drawing/2014/main" id="{3425EF83-B7B0-40C1-A243-6C770BF997C3}"/>
+                <a16:creationId xmlns:a16="http://schemas.microsoft.com/office/drawing/2014/main" id="{30053DCA-D6E1-43E8-906D-7A3D789C51D9}"/>
               </a:ext>
             </a:extLst>
           </p:cNvPr>
@@ -5536,7 +5536,7 @@
           <p:cNvPr id="22" name="">
             <a:extLst xmlns:a="http://schemas.openxmlformats.org/drawingml/2006/main">
               <a:ext uri="{FF2B5EF4-FFF2-40B4-BE49-F238E27FC236}">
-                <a16:creationId xmlns:a16="http://schemas.microsoft.com/office/drawing/2014/main" id="{7C6D12E5-B704-41CF-B997-2E984B1F3ED8}"/>
+                <a16:creationId xmlns:a16="http://schemas.microsoft.com/office/drawing/2014/main" id="{A4A3508B-65CC-4E4C-BCB2-748C8F8039D8}"/>
               </a:ext>
             </a:extLst>
           </p:cNvPr>
@@ -5586,7 +5586,7 @@
           <p:cNvPr id="23" name="">
             <a:extLst xmlns:a="http://schemas.openxmlformats.org/drawingml/2006/main">
               <a:ext uri="{FF2B5EF4-FFF2-40B4-BE49-F238E27FC236}">
-                <a16:creationId xmlns:a16="http://schemas.microsoft.com/office/drawing/2014/main" id="{28E9420F-7CAF-4793-8DD9-ED2903E80D4C}"/>
+                <a16:creationId xmlns:a16="http://schemas.microsoft.com/office/drawing/2014/main" id="{DEC3EE6F-86BD-46AD-9BC0-8C4555D8B158}"/>
               </a:ext>
             </a:extLst>
           </p:cNvPr>
@@ -5621,7 +5621,7 @@
           <p:nvPr/>
         </p:nvPicPr>
         <p:blipFill>
-          <a:blip xmlns:r="http://schemas.openxmlformats.org/officeDocument/2006/relationships" xmlns:a="http://schemas.openxmlformats.org/drawingml/2006/main" r:embed="Rc11299c3132042b0"/>
+          <a:blip xmlns:r="http://schemas.openxmlformats.org/officeDocument/2006/relationships" xmlns:a="http://schemas.openxmlformats.org/drawingml/2006/main" r:embed="R568ae2ae53804b5c"/>
           <a:stretch xmlns:a="http://schemas.openxmlformats.org/drawingml/2006/main"/>
         </p:blipFill>
         <p:spPr>
@@ -5639,7 +5639,7 @@
           <p:cNvPr id="25" name="">
             <a:extLst xmlns:a="http://schemas.openxmlformats.org/drawingml/2006/main">
               <a:ext uri="{FF2B5EF4-FFF2-40B4-BE49-F238E27FC236}">
-                <a16:creationId xmlns:a16="http://schemas.microsoft.com/office/drawing/2014/main" id="{20DF4744-260E-4C57-A8E5-EA92B724B624}"/>
+                <a16:creationId xmlns:a16="http://schemas.microsoft.com/office/drawing/2014/main" id="{EBCD580F-3045-415D-9F92-92A458FD1DB3}"/>
               </a:ext>
             </a:extLst>
           </p:cNvPr>
@@ -5689,7 +5689,7 @@
           <p:cNvPr id="26" name="">
             <a:extLst xmlns:a="http://schemas.openxmlformats.org/drawingml/2006/main">
               <a:ext uri="{FF2B5EF4-FFF2-40B4-BE49-F238E27FC236}">
-                <a16:creationId xmlns:a16="http://schemas.microsoft.com/office/drawing/2014/main" id="{ACAD6D86-6B7F-48C7-B9AE-93D1DC55B38B}"/>
+                <a16:creationId xmlns:a16="http://schemas.microsoft.com/office/drawing/2014/main" id="{9FC7BEE1-A6DC-4565-B824-5A4F6F9298ED}"/>
               </a:ext>
             </a:extLst>
           </p:cNvPr>
@@ -5737,7 +5737,7 @@
     </p:spTree>
     <p:extLst>
       <p:ext uri="{BB962C8B-B14F-4D97-AF65-F5344CB8AC3E}">
-        <p14:creationId xmlns:p14="http://schemas.microsoft.com/office/powerpoint/2010/main" val="1251110487"/>
+        <p14:creationId xmlns:p14="http://schemas.microsoft.com/office/powerpoint/2010/main" val="1060405352"/>
       </p:ext>
     </p:extLst>
   </p:cSld>
@@ -5768,7 +5768,7 @@
           <p:cNvPr id="1" name="">
             <a:extLst xmlns:a="http://schemas.openxmlformats.org/drawingml/2006/main">
               <a:ext uri="{FF2B5EF4-FFF2-40B4-BE49-F238E27FC236}">
-                <a16:creationId xmlns:a16="http://schemas.microsoft.com/office/drawing/2014/main" id="{12A649A1-384E-497C-83A8-F5620FEB2F9F}"/>
+                <a16:creationId xmlns:a16="http://schemas.microsoft.com/office/drawing/2014/main" id="{032CD89D-C122-4B8D-9CFC-95154FC50FEA}"/>
               </a:ext>
             </a:extLst>
           </p:cNvPr>
@@ -5799,7 +5799,7 @@
           <p:cNvPr id="2" name="">
             <a:extLst xmlns:a="http://schemas.openxmlformats.org/drawingml/2006/main">
               <a:ext uri="{FF2B5EF4-FFF2-40B4-BE49-F238E27FC236}">
-                <a16:creationId xmlns:a16="http://schemas.microsoft.com/office/drawing/2014/main" id="{6DC06F5E-4AFE-46FE-9961-01311FDD2F4A}"/>
+                <a16:creationId xmlns:a16="http://schemas.microsoft.com/office/drawing/2014/main" id="{F9125B1B-8C7A-4506-A48A-F0C55A49DB1D}"/>
               </a:ext>
             </a:extLst>
           </p:cNvPr>
@@ -5849,7 +5849,7 @@
           <p:cNvPr id="3" name="">
             <a:extLst xmlns:a="http://schemas.openxmlformats.org/drawingml/2006/main">
               <a:ext uri="{FF2B5EF4-FFF2-40B4-BE49-F238E27FC236}">
-                <a16:creationId xmlns:a16="http://schemas.microsoft.com/office/drawing/2014/main" id="{84FD6AF9-7EEB-4EFA-92D3-B48B6F8DDA93}"/>
+                <a16:creationId xmlns:a16="http://schemas.microsoft.com/office/drawing/2014/main" id="{351C9117-F7B1-4894-890F-F99048D042CB}"/>
               </a:ext>
             </a:extLst>
           </p:cNvPr>
@@ -5899,7 +5899,7 @@
           <p:cNvPr id="4" name="">
             <a:extLst xmlns:a="http://schemas.openxmlformats.org/drawingml/2006/main">
               <a:ext uri="{FF2B5EF4-FFF2-40B4-BE49-F238E27FC236}">
-                <a16:creationId xmlns:a16="http://schemas.microsoft.com/office/drawing/2014/main" id="{0D84F4A4-9622-4AD9-95B4-92DE1229FB91}"/>
+                <a16:creationId xmlns:a16="http://schemas.microsoft.com/office/drawing/2014/main" id="{7DE33420-E60E-4183-BA0B-9D72A953C979}"/>
               </a:ext>
             </a:extLst>
           </p:cNvPr>
@@ -5934,7 +5934,7 @@
           <p:cNvPr id="5" name="">
             <a:extLst xmlns:a="http://schemas.openxmlformats.org/drawingml/2006/main">
               <a:ext uri="{FF2B5EF4-FFF2-40B4-BE49-F238E27FC236}">
-                <a16:creationId xmlns:a16="http://schemas.microsoft.com/office/drawing/2014/main" id="{0D1357A3-6180-4EA6-A01C-58A0C4CD6017}"/>
+                <a16:creationId xmlns:a16="http://schemas.microsoft.com/office/drawing/2014/main" id="{5AB4746C-4CA7-4165-88E4-AAD74EB9230B}"/>
               </a:ext>
             </a:extLst>
           </p:cNvPr>
@@ -5984,7 +5984,7 @@
           <p:cNvPr id="6" name="">
             <a:extLst xmlns:a="http://schemas.openxmlformats.org/drawingml/2006/main">
               <a:ext uri="{FF2B5EF4-FFF2-40B4-BE49-F238E27FC236}">
-                <a16:creationId xmlns:a16="http://schemas.microsoft.com/office/drawing/2014/main" id="{59CD3D98-B8D2-421D-8DEC-1594BDE372DD}"/>
+                <a16:creationId xmlns:a16="http://schemas.microsoft.com/office/drawing/2014/main" id="{2D4725BC-9C09-4F28-8A99-750640AA9D6A}"/>
               </a:ext>
             </a:extLst>
           </p:cNvPr>
@@ -6068,7 +6068,7 @@
           <p:cNvPr id="7" name="">
             <a:extLst xmlns:a="http://schemas.openxmlformats.org/drawingml/2006/main">
               <a:ext uri="{FF2B5EF4-FFF2-40B4-BE49-F238E27FC236}">
-                <a16:creationId xmlns:a16="http://schemas.microsoft.com/office/drawing/2014/main" id="{C3B0A949-AA78-44D6-B089-FC2DD84F6D6A}"/>
+                <a16:creationId xmlns:a16="http://schemas.microsoft.com/office/drawing/2014/main" id="{3312B60D-FA2B-4CDE-9518-2470DE499A96}"/>
               </a:ext>
             </a:extLst>
           </p:cNvPr>
@@ -6099,7 +6099,7 @@
           <p:cNvPr id="8" name="">
             <a:extLst xmlns:a="http://schemas.openxmlformats.org/drawingml/2006/main">
               <a:ext uri="{FF2B5EF4-FFF2-40B4-BE49-F238E27FC236}">
-                <a16:creationId xmlns:a16="http://schemas.microsoft.com/office/drawing/2014/main" id="{8006AFF1-3255-44B0-AF2D-1F198A7B96E4}"/>
+                <a16:creationId xmlns:a16="http://schemas.microsoft.com/office/drawing/2014/main" id="{C54A4D16-F916-41D0-9788-0417ABF20C08}"/>
               </a:ext>
             </a:extLst>
           </p:cNvPr>
@@ -6149,7 +6149,7 @@
           <p:cNvPr id="9" name="">
             <a:extLst xmlns:a="http://schemas.openxmlformats.org/drawingml/2006/main">
               <a:ext uri="{FF2B5EF4-FFF2-40B4-BE49-F238E27FC236}">
-                <a16:creationId xmlns:a16="http://schemas.microsoft.com/office/drawing/2014/main" id="{E0999EA9-8583-4984-9A8C-9329FBC01882}"/>
+                <a16:creationId xmlns:a16="http://schemas.microsoft.com/office/drawing/2014/main" id="{225E8FE6-86BE-4E00-816D-4D715D167C08}"/>
               </a:ext>
             </a:extLst>
           </p:cNvPr>
@@ -6180,7 +6180,7 @@
           <p:cNvPr id="10" name="">
             <a:extLst xmlns:a="http://schemas.openxmlformats.org/drawingml/2006/main">
               <a:ext uri="{FF2B5EF4-FFF2-40B4-BE49-F238E27FC236}">
-                <a16:creationId xmlns:a16="http://schemas.microsoft.com/office/drawing/2014/main" id="{9C46A87A-3D47-40C0-8B7A-4012C3EA036C}"/>
+                <a16:creationId xmlns:a16="http://schemas.microsoft.com/office/drawing/2014/main" id="{6009FDC2-79B9-4AD6-8596-941C482AE5EF}"/>
               </a:ext>
             </a:extLst>
           </p:cNvPr>
@@ -6230,7 +6230,7 @@
           <p:cNvPr id="11" name="">
             <a:extLst xmlns:a="http://schemas.openxmlformats.org/drawingml/2006/main">
               <a:ext uri="{FF2B5EF4-FFF2-40B4-BE49-F238E27FC236}">
-                <a16:creationId xmlns:a16="http://schemas.microsoft.com/office/drawing/2014/main" id="{974920D7-59C9-46EC-A1F5-6F3C3CC6152F}"/>
+                <a16:creationId xmlns:a16="http://schemas.microsoft.com/office/drawing/2014/main" id="{C584CB43-BE6A-4FD0-A939-4EA5A6F5D61A}"/>
               </a:ext>
             </a:extLst>
           </p:cNvPr>
@@ -6261,7 +6261,7 @@
           <p:cNvPr id="12" name="">
             <a:extLst xmlns:a="http://schemas.openxmlformats.org/drawingml/2006/main">
               <a:ext uri="{FF2B5EF4-FFF2-40B4-BE49-F238E27FC236}">
-                <a16:creationId xmlns:a16="http://schemas.microsoft.com/office/drawing/2014/main" id="{19A45A10-98C2-4462-9A01-F3C943FBAAEF}"/>
+                <a16:creationId xmlns:a16="http://schemas.microsoft.com/office/drawing/2014/main" id="{2E5AB0FB-3E02-4A3D-A574-4FE66120DF82}"/>
               </a:ext>
             </a:extLst>
           </p:cNvPr>
@@ -6311,7 +6311,7 @@
           <p:cNvPr id="13" name="">
             <a:extLst xmlns:a="http://schemas.openxmlformats.org/drawingml/2006/main">
               <a:ext uri="{FF2B5EF4-FFF2-40B4-BE49-F238E27FC236}">
-                <a16:creationId xmlns:a16="http://schemas.microsoft.com/office/drawing/2014/main" id="{BB230F5A-B866-4967-947D-4DD20062D9DF}"/>
+                <a16:creationId xmlns:a16="http://schemas.microsoft.com/office/drawing/2014/main" id="{F664B784-1F47-4824-90E6-E51F23E31748}"/>
               </a:ext>
             </a:extLst>
           </p:cNvPr>
@@ -6342,7 +6342,7 @@
           <p:cNvPr id="14" name="">
             <a:extLst xmlns:a="http://schemas.openxmlformats.org/drawingml/2006/main">
               <a:ext uri="{FF2B5EF4-FFF2-40B4-BE49-F238E27FC236}">
-                <a16:creationId xmlns:a16="http://schemas.microsoft.com/office/drawing/2014/main" id="{6B377639-8684-4E5A-A2D6-BF904EC89609}"/>
+                <a16:creationId xmlns:a16="http://schemas.microsoft.com/office/drawing/2014/main" id="{528952F6-230F-4E17-9549-F0DF628968EC}"/>
               </a:ext>
             </a:extLst>
           </p:cNvPr>
@@ -6392,7 +6392,7 @@
           <p:cNvPr id="15" name="">
             <a:extLst xmlns:a="http://schemas.openxmlformats.org/drawingml/2006/main">
               <a:ext uri="{FF2B5EF4-FFF2-40B4-BE49-F238E27FC236}">
-                <a16:creationId xmlns:a16="http://schemas.microsoft.com/office/drawing/2014/main" id="{20ECA754-AAA0-4ED3-ADA4-33D145B4DCEE}"/>
+                <a16:creationId xmlns:a16="http://schemas.microsoft.com/office/drawing/2014/main" id="{602DC819-36B6-4197-BE1A-0E49984BC456}"/>
               </a:ext>
             </a:extLst>
           </p:cNvPr>
@@ -6427,7 +6427,7 @@
           <p:nvPr/>
         </p:nvPicPr>
         <p:blipFill>
-          <a:blip xmlns:r="http://schemas.openxmlformats.org/officeDocument/2006/relationships" xmlns:a="http://schemas.openxmlformats.org/drawingml/2006/main" r:embed="Reaf5b17595704321"/>
+          <a:blip xmlns:r="http://schemas.openxmlformats.org/officeDocument/2006/relationships" xmlns:a="http://schemas.openxmlformats.org/drawingml/2006/main" r:embed="R1bd8d240328a44f7"/>
           <a:stretch xmlns:a="http://schemas.openxmlformats.org/drawingml/2006/main"/>
         </p:blipFill>
         <p:spPr>
@@ -6445,7 +6445,7 @@
           <p:cNvPr id="17" name="">
             <a:extLst xmlns:a="http://schemas.openxmlformats.org/drawingml/2006/main">
               <a:ext uri="{FF2B5EF4-FFF2-40B4-BE49-F238E27FC236}">
-                <a16:creationId xmlns:a16="http://schemas.microsoft.com/office/drawing/2014/main" id="{EA5D7230-16CE-4113-9353-6122E01EF001}"/>
+                <a16:creationId xmlns:a16="http://schemas.microsoft.com/office/drawing/2014/main" id="{F2DBEDB9-FB44-44FA-A3F1-A69C54E97A67}"/>
               </a:ext>
             </a:extLst>
           </p:cNvPr>
@@ -6495,7 +6495,7 @@
           <p:cNvPr id="18" name="">
             <a:extLst xmlns:a="http://schemas.openxmlformats.org/drawingml/2006/main">
               <a:ext uri="{FF2B5EF4-FFF2-40B4-BE49-F238E27FC236}">
-                <a16:creationId xmlns:a16="http://schemas.microsoft.com/office/drawing/2014/main" id="{84352F50-9A0D-4863-A337-F0CDEA775785}"/>
+                <a16:creationId xmlns:a16="http://schemas.microsoft.com/office/drawing/2014/main" id="{42AD814E-9457-44A1-BFC2-189C5FBEA8F0}"/>
               </a:ext>
             </a:extLst>
           </p:cNvPr>
@@ -6543,7 +6543,7 @@
     </p:spTree>
     <p:extLst>
       <p:ext uri="{BB962C8B-B14F-4D97-AF65-F5344CB8AC3E}">
-        <p14:creationId xmlns:p14="http://schemas.microsoft.com/office/powerpoint/2010/main" val="1639497942"/>
+        <p14:creationId xmlns:p14="http://schemas.microsoft.com/office/powerpoint/2010/main" val="857715747"/>
       </p:ext>
     </p:extLst>
   </p:cSld>
@@ -6574,7 +6574,7 @@
           <p:cNvPr id="1" name="">
             <a:extLst xmlns:a="http://schemas.openxmlformats.org/drawingml/2006/main">
               <a:ext uri="{FF2B5EF4-FFF2-40B4-BE49-F238E27FC236}">
-                <a16:creationId xmlns:a16="http://schemas.microsoft.com/office/drawing/2014/main" id="{3C35B750-99EC-4037-A488-C895BC11B232}"/>
+                <a16:creationId xmlns:a16="http://schemas.microsoft.com/office/drawing/2014/main" id="{C5E30093-118D-4A0B-92A6-834F85A94BC6}"/>
               </a:ext>
             </a:extLst>
           </p:cNvPr>
@@ -6605,7 +6605,7 @@
           <p:cNvPr id="2" name="">
             <a:extLst xmlns:a="http://schemas.openxmlformats.org/drawingml/2006/main">
               <a:ext uri="{FF2B5EF4-FFF2-40B4-BE49-F238E27FC236}">
-                <a16:creationId xmlns:a16="http://schemas.microsoft.com/office/drawing/2014/main" id="{4B8AE966-AB8F-4371-B924-20C31CAA02AB}"/>
+                <a16:creationId xmlns:a16="http://schemas.microsoft.com/office/drawing/2014/main" id="{69EF3796-9683-4F92-AC3C-3F6AF88F3D35}"/>
               </a:ext>
             </a:extLst>
           </p:cNvPr>
@@ -6655,7 +6655,7 @@
           <p:cNvPr id="3" name="">
             <a:extLst xmlns:a="http://schemas.openxmlformats.org/drawingml/2006/main">
               <a:ext uri="{FF2B5EF4-FFF2-40B4-BE49-F238E27FC236}">
-                <a16:creationId xmlns:a16="http://schemas.microsoft.com/office/drawing/2014/main" id="{EE9E967B-2899-4063-BC1D-2664F087DBE2}"/>
+                <a16:creationId xmlns:a16="http://schemas.microsoft.com/office/drawing/2014/main" id="{F32317B7-0AFF-4DD3-BBE6-AD686FA5DE3A}"/>
               </a:ext>
             </a:extLst>
           </p:cNvPr>
@@ -6705,7 +6705,7 @@
           <p:cNvPr id="4" name="">
             <a:extLst xmlns:a="http://schemas.openxmlformats.org/drawingml/2006/main">
               <a:ext uri="{FF2B5EF4-FFF2-40B4-BE49-F238E27FC236}">
-                <a16:creationId xmlns:a16="http://schemas.microsoft.com/office/drawing/2014/main" id="{94399E46-2841-41C1-BF8A-4A30933E11BF}"/>
+                <a16:creationId xmlns:a16="http://schemas.microsoft.com/office/drawing/2014/main" id="{240B121D-EF5F-46A2-981D-B34F6E9D9E49}"/>
               </a:ext>
             </a:extLst>
           </p:cNvPr>
@@ -6755,7 +6755,7 @@
           <p:cNvPr id="5" name="">
             <a:extLst xmlns:a="http://schemas.openxmlformats.org/drawingml/2006/main">
               <a:ext uri="{FF2B5EF4-FFF2-40B4-BE49-F238E27FC236}">
-                <a16:creationId xmlns:a16="http://schemas.microsoft.com/office/drawing/2014/main" id="{4E4B8A2E-A01D-444D-964B-E2AD0E54B69C}"/>
+                <a16:creationId xmlns:a16="http://schemas.microsoft.com/office/drawing/2014/main" id="{1EDA9EF3-6381-409D-BCD5-13DC6F95D447}"/>
               </a:ext>
             </a:extLst>
           </p:cNvPr>
@@ -6805,7 +6805,7 @@
           <p:cNvPr id="6" name="">
             <a:extLst xmlns:a="http://schemas.openxmlformats.org/drawingml/2006/main">
               <a:ext uri="{FF2B5EF4-FFF2-40B4-BE49-F238E27FC236}">
-                <a16:creationId xmlns:a16="http://schemas.microsoft.com/office/drawing/2014/main" id="{7195471F-FA6C-4F1B-A874-8E3B8285D3CB}"/>
+                <a16:creationId xmlns:a16="http://schemas.microsoft.com/office/drawing/2014/main" id="{7383CE82-13EB-4B6D-A87B-45ECEF0A7BB2}"/>
               </a:ext>
             </a:extLst>
           </p:cNvPr>
@@ -6855,7 +6855,7 @@
           <p:cNvPr id="7" name="">
             <a:extLst xmlns:a="http://schemas.openxmlformats.org/drawingml/2006/main">
               <a:ext uri="{FF2B5EF4-FFF2-40B4-BE49-F238E27FC236}">
-                <a16:creationId xmlns:a16="http://schemas.microsoft.com/office/drawing/2014/main" id="{02D6CDCD-E7A2-42AD-93FE-DFCE9DE13184}"/>
+                <a16:creationId xmlns:a16="http://schemas.microsoft.com/office/drawing/2014/main" id="{61A9443B-A436-4717-944F-539F76AB0D12}"/>
               </a:ext>
             </a:extLst>
           </p:cNvPr>
@@ -6905,7 +6905,7 @@
           <p:cNvPr id="8" name="">
             <a:extLst xmlns:a="http://schemas.openxmlformats.org/drawingml/2006/main">
               <a:ext uri="{FF2B5EF4-FFF2-40B4-BE49-F238E27FC236}">
-                <a16:creationId xmlns:a16="http://schemas.microsoft.com/office/drawing/2014/main" id="{F23887E1-21FD-40AE-A607-E6ADD37A393E}"/>
+                <a16:creationId xmlns:a16="http://schemas.microsoft.com/office/drawing/2014/main" id="{30DB336F-C758-4904-B325-6300759B3347}"/>
               </a:ext>
             </a:extLst>
           </p:cNvPr>
@@ -6936,7 +6936,7 @@
           <p:cNvPr id="9" name="">
             <a:extLst xmlns:a="http://schemas.openxmlformats.org/drawingml/2006/main">
               <a:ext uri="{FF2B5EF4-FFF2-40B4-BE49-F238E27FC236}">
-                <a16:creationId xmlns:a16="http://schemas.microsoft.com/office/drawing/2014/main" id="{D7302C3A-7A1F-4033-A03F-2156849AA51F}"/>
+                <a16:creationId xmlns:a16="http://schemas.microsoft.com/office/drawing/2014/main" id="{5E9CCDED-E54D-458C-98EA-4242BF703E16}"/>
               </a:ext>
             </a:extLst>
           </p:cNvPr>
@@ -6986,7 +6986,7 @@
           <p:cNvPr id="10" name="">
             <a:extLst xmlns:a="http://schemas.openxmlformats.org/drawingml/2006/main">
               <a:ext uri="{FF2B5EF4-FFF2-40B4-BE49-F238E27FC236}">
-                <a16:creationId xmlns:a16="http://schemas.microsoft.com/office/drawing/2014/main" id="{EB3E072F-0919-4A1C-B258-9B70906F0918}"/>
+                <a16:creationId xmlns:a16="http://schemas.microsoft.com/office/drawing/2014/main" id="{FB487B2E-7676-4904-9866-076EAD80046E}"/>
               </a:ext>
             </a:extLst>
           </p:cNvPr>
@@ -7036,7 +7036,7 @@
           <p:cNvPr id="11" name="">
             <a:extLst xmlns:a="http://schemas.openxmlformats.org/drawingml/2006/main">
               <a:ext uri="{FF2B5EF4-FFF2-40B4-BE49-F238E27FC236}">
-                <a16:creationId xmlns:a16="http://schemas.microsoft.com/office/drawing/2014/main" id="{6B5DB668-78EA-41C2-B9A9-6F2DC5C9BF90}"/>
+                <a16:creationId xmlns:a16="http://schemas.microsoft.com/office/drawing/2014/main" id="{76DB084A-D64C-47FA-9F00-F9846C296872}"/>
               </a:ext>
             </a:extLst>
           </p:cNvPr>
@@ -7086,7 +7086,7 @@
           <p:cNvPr id="12" name="">
             <a:extLst xmlns:a="http://schemas.openxmlformats.org/drawingml/2006/main">
               <a:ext uri="{FF2B5EF4-FFF2-40B4-BE49-F238E27FC236}">
-                <a16:creationId xmlns:a16="http://schemas.microsoft.com/office/drawing/2014/main" id="{BD0C9BAE-3010-439F-B843-7F041E8F93BB}"/>
+                <a16:creationId xmlns:a16="http://schemas.microsoft.com/office/drawing/2014/main" id="{E2A18BAD-667B-4693-AA67-C270B862D971}"/>
               </a:ext>
             </a:extLst>
           </p:cNvPr>
@@ -7136,7 +7136,7 @@
           <p:cNvPr id="13" name="">
             <a:extLst xmlns:a="http://schemas.openxmlformats.org/drawingml/2006/main">
               <a:ext uri="{FF2B5EF4-FFF2-40B4-BE49-F238E27FC236}">
-                <a16:creationId xmlns:a16="http://schemas.microsoft.com/office/drawing/2014/main" id="{1E8BBDAC-229F-4715-8E1B-C9DBA30805C7}"/>
+                <a16:creationId xmlns:a16="http://schemas.microsoft.com/office/drawing/2014/main" id="{85DD37D7-7C05-4229-B4B1-FE6657322A49}"/>
               </a:ext>
             </a:extLst>
           </p:cNvPr>
@@ -7167,7 +7167,7 @@
           <p:cNvPr id="14" name="">
             <a:extLst xmlns:a="http://schemas.openxmlformats.org/drawingml/2006/main">
               <a:ext uri="{FF2B5EF4-FFF2-40B4-BE49-F238E27FC236}">
-                <a16:creationId xmlns:a16="http://schemas.microsoft.com/office/drawing/2014/main" id="{5E62F5AB-8674-45A0-B66F-722B1118D94F}"/>
+                <a16:creationId xmlns:a16="http://schemas.microsoft.com/office/drawing/2014/main" id="{16C4E0D1-3785-4511-89CA-AAA89EAF12C9}"/>
               </a:ext>
             </a:extLst>
           </p:cNvPr>
@@ -7217,7 +7217,7 @@
           <p:cNvPr id="15" name="">
             <a:extLst xmlns:a="http://schemas.openxmlformats.org/drawingml/2006/main">
               <a:ext uri="{FF2B5EF4-FFF2-40B4-BE49-F238E27FC236}">
-                <a16:creationId xmlns:a16="http://schemas.microsoft.com/office/drawing/2014/main" id="{486551FA-A005-4DC2-A0F1-25D8D7B5C5D0}"/>
+                <a16:creationId xmlns:a16="http://schemas.microsoft.com/office/drawing/2014/main" id="{FD937B7A-ED21-4E9E-A803-7182A70CB0A3}"/>
               </a:ext>
             </a:extLst>
           </p:cNvPr>
@@ -7267,7 +7267,7 @@
           <p:cNvPr id="16" name="">
             <a:extLst xmlns:a="http://schemas.openxmlformats.org/drawingml/2006/main">
               <a:ext uri="{FF2B5EF4-FFF2-40B4-BE49-F238E27FC236}">
-                <a16:creationId xmlns:a16="http://schemas.microsoft.com/office/drawing/2014/main" id="{2FAE0A6D-C99F-484F-B37E-D579EBD1D68D}"/>
+                <a16:creationId xmlns:a16="http://schemas.microsoft.com/office/drawing/2014/main" id="{2097F291-C1D5-4310-99BA-3C56CC560282}"/>
               </a:ext>
             </a:extLst>
           </p:cNvPr>
@@ -7317,7 +7317,7 @@
           <p:cNvPr id="17" name="">
             <a:extLst xmlns:a="http://schemas.openxmlformats.org/drawingml/2006/main">
               <a:ext uri="{FF2B5EF4-FFF2-40B4-BE49-F238E27FC236}">
-                <a16:creationId xmlns:a16="http://schemas.microsoft.com/office/drawing/2014/main" id="{03F6786A-3445-4DED-8836-94F508C88BC8}"/>
+                <a16:creationId xmlns:a16="http://schemas.microsoft.com/office/drawing/2014/main" id="{4833897E-359F-4980-BCAB-D69ACBC39C8E}"/>
               </a:ext>
             </a:extLst>
           </p:cNvPr>
@@ -7367,7 +7367,7 @@
           <p:cNvPr id="18" name="">
             <a:extLst xmlns:a="http://schemas.openxmlformats.org/drawingml/2006/main">
               <a:ext uri="{FF2B5EF4-FFF2-40B4-BE49-F238E27FC236}">
-                <a16:creationId xmlns:a16="http://schemas.microsoft.com/office/drawing/2014/main" id="{71DF2433-724E-4BC8-9B67-CFB13E95ABF9}"/>
+                <a16:creationId xmlns:a16="http://schemas.microsoft.com/office/drawing/2014/main" id="{1460C546-38A7-406E-BEA3-B4E3B9ABE4FE}"/>
               </a:ext>
             </a:extLst>
           </p:cNvPr>
@@ -7398,7 +7398,7 @@
           <p:cNvPr id="19" name="">
             <a:extLst xmlns:a="http://schemas.openxmlformats.org/drawingml/2006/main">
               <a:ext uri="{FF2B5EF4-FFF2-40B4-BE49-F238E27FC236}">
-                <a16:creationId xmlns:a16="http://schemas.microsoft.com/office/drawing/2014/main" id="{DAE1FB50-10E7-46A5-94B4-96DA23796FAE}"/>
+                <a16:creationId xmlns:a16="http://schemas.microsoft.com/office/drawing/2014/main" id="{54C41168-D2EB-4E7C-836C-8976EA87D47A}"/>
               </a:ext>
             </a:extLst>
           </p:cNvPr>
@@ -7448,7 +7448,7 @@
           <p:cNvPr id="20" name="">
             <a:extLst xmlns:a="http://schemas.openxmlformats.org/drawingml/2006/main">
               <a:ext uri="{FF2B5EF4-FFF2-40B4-BE49-F238E27FC236}">
-                <a16:creationId xmlns:a16="http://schemas.microsoft.com/office/drawing/2014/main" id="{B73020BE-A3A7-46A6-966D-71B63D7A8313}"/>
+                <a16:creationId xmlns:a16="http://schemas.microsoft.com/office/drawing/2014/main" id="{48E287A9-F878-4255-B2F4-37ED7C4F41D3}"/>
               </a:ext>
             </a:extLst>
           </p:cNvPr>
@@ -7498,7 +7498,7 @@
           <p:cNvPr id="21" name="">
             <a:extLst xmlns:a="http://schemas.openxmlformats.org/drawingml/2006/main">
               <a:ext uri="{FF2B5EF4-FFF2-40B4-BE49-F238E27FC236}">
-                <a16:creationId xmlns:a16="http://schemas.microsoft.com/office/drawing/2014/main" id="{7A4522FC-EA77-42A6-B9C9-0888F577EA1B}"/>
+                <a16:creationId xmlns:a16="http://schemas.microsoft.com/office/drawing/2014/main" id="{FB1A2EB6-9A9A-42CA-96DD-6B2FF6D6A90A}"/>
               </a:ext>
             </a:extLst>
           </p:cNvPr>
@@ -7548,7 +7548,7 @@
           <p:cNvPr id="22" name="">
             <a:extLst xmlns:a="http://schemas.openxmlformats.org/drawingml/2006/main">
               <a:ext uri="{FF2B5EF4-FFF2-40B4-BE49-F238E27FC236}">
-                <a16:creationId xmlns:a16="http://schemas.microsoft.com/office/drawing/2014/main" id="{9DD37E9E-2BB8-474E-A258-57936EDDE8E3}"/>
+                <a16:creationId xmlns:a16="http://schemas.microsoft.com/office/drawing/2014/main" id="{8F9C941E-2958-4573-903F-4D4F865FA5C6}"/>
               </a:ext>
             </a:extLst>
           </p:cNvPr>
@@ -7598,7 +7598,7 @@
           <p:cNvPr id="23" name="">
             <a:extLst xmlns:a="http://schemas.openxmlformats.org/drawingml/2006/main">
               <a:ext uri="{FF2B5EF4-FFF2-40B4-BE49-F238E27FC236}">
-                <a16:creationId xmlns:a16="http://schemas.microsoft.com/office/drawing/2014/main" id="{313D8788-3D64-493A-BA4B-C76AB8610FBC}"/>
+                <a16:creationId xmlns:a16="http://schemas.microsoft.com/office/drawing/2014/main" id="{46776066-D629-4B8F-BC89-001CBEA555FA}"/>
               </a:ext>
             </a:extLst>
           </p:cNvPr>
@@ -7629,7 +7629,7 @@
           <p:cNvPr id="24" name="">
             <a:extLst xmlns:a="http://schemas.openxmlformats.org/drawingml/2006/main">
               <a:ext uri="{FF2B5EF4-FFF2-40B4-BE49-F238E27FC236}">
-                <a16:creationId xmlns:a16="http://schemas.microsoft.com/office/drawing/2014/main" id="{FA5F3A24-581D-4D29-AE10-37771E30A0DB}"/>
+                <a16:creationId xmlns:a16="http://schemas.microsoft.com/office/drawing/2014/main" id="{F982C150-D288-453E-A653-FAD201A68F08}"/>
               </a:ext>
             </a:extLst>
           </p:cNvPr>
@@ -7664,7 +7664,7 @@
           <p:nvPr/>
         </p:nvPicPr>
         <p:blipFill>
-          <a:blip xmlns:r="http://schemas.openxmlformats.org/officeDocument/2006/relationships" xmlns:a="http://schemas.openxmlformats.org/drawingml/2006/main" r:embed="R1fe23bb13c5a4be0"/>
+          <a:blip xmlns:r="http://schemas.openxmlformats.org/officeDocument/2006/relationships" xmlns:a="http://schemas.openxmlformats.org/drawingml/2006/main" r:embed="R29ee9b776d444b47"/>
           <a:stretch xmlns:a="http://schemas.openxmlformats.org/drawingml/2006/main"/>
         </p:blipFill>
         <p:spPr>
@@ -7682,7 +7682,7 @@
           <p:cNvPr id="26" name="">
             <a:extLst xmlns:a="http://schemas.openxmlformats.org/drawingml/2006/main">
               <a:ext uri="{FF2B5EF4-FFF2-40B4-BE49-F238E27FC236}">
-                <a16:creationId xmlns:a16="http://schemas.microsoft.com/office/drawing/2014/main" id="{77A4A5D4-68B9-4675-A9AA-A747669FAAFD}"/>
+                <a16:creationId xmlns:a16="http://schemas.microsoft.com/office/drawing/2014/main" id="{6D75F60A-7EE6-4D35-BF0F-E4C4555C6E0B}"/>
               </a:ext>
             </a:extLst>
           </p:cNvPr>
@@ -7732,7 +7732,7 @@
           <p:cNvPr id="27" name="">
             <a:extLst xmlns:a="http://schemas.openxmlformats.org/drawingml/2006/main">
               <a:ext uri="{FF2B5EF4-FFF2-40B4-BE49-F238E27FC236}">
-                <a16:creationId xmlns:a16="http://schemas.microsoft.com/office/drawing/2014/main" id="{21B6C53B-2AA2-41AB-B037-7B0F9F2E0180}"/>
+                <a16:creationId xmlns:a16="http://schemas.microsoft.com/office/drawing/2014/main" id="{528A0F57-E670-4ACC-8A1A-88035DEBE66C}"/>
               </a:ext>
             </a:extLst>
           </p:cNvPr>
@@ -7780,7 +7780,7 @@
     </p:spTree>
     <p:extLst>
       <p:ext uri="{BB962C8B-B14F-4D97-AF65-F5344CB8AC3E}">
-        <p14:creationId xmlns:p14="http://schemas.microsoft.com/office/powerpoint/2010/main" val="1941389232"/>
+        <p14:creationId xmlns:p14="http://schemas.microsoft.com/office/powerpoint/2010/main" val="897401202"/>
       </p:ext>
     </p:extLst>
   </p:cSld>
@@ -7811,7 +7811,7 @@
           <p:cNvPr id="1" name="">
             <a:extLst xmlns:a="http://schemas.openxmlformats.org/drawingml/2006/main">
               <a:ext uri="{FF2B5EF4-FFF2-40B4-BE49-F238E27FC236}">
-                <a16:creationId xmlns:a16="http://schemas.microsoft.com/office/drawing/2014/main" id="{A4D8B5A4-9799-4A4D-9254-A5F854139CB5}"/>
+                <a16:creationId xmlns:a16="http://schemas.microsoft.com/office/drawing/2014/main" id="{F82D7959-3A38-441C-A789-05BACD5A0112}"/>
               </a:ext>
             </a:extLst>
           </p:cNvPr>
@@ -7842,7 +7842,7 @@
           <p:cNvPr id="2" name="">
             <a:extLst xmlns:a="http://schemas.openxmlformats.org/drawingml/2006/main">
               <a:ext uri="{FF2B5EF4-FFF2-40B4-BE49-F238E27FC236}">
-                <a16:creationId xmlns:a16="http://schemas.microsoft.com/office/drawing/2014/main" id="{F69F77DE-4868-4389-B832-5D194BAEE69C}"/>
+                <a16:creationId xmlns:a16="http://schemas.microsoft.com/office/drawing/2014/main" id="{833B0A2F-AECD-48E8-BBB6-DF4D463999F1}"/>
               </a:ext>
             </a:extLst>
           </p:cNvPr>
@@ -7892,7 +7892,7 @@
           <p:cNvPr id="3" name="">
             <a:extLst xmlns:a="http://schemas.openxmlformats.org/drawingml/2006/main">
               <a:ext uri="{FF2B5EF4-FFF2-40B4-BE49-F238E27FC236}">
-                <a16:creationId xmlns:a16="http://schemas.microsoft.com/office/drawing/2014/main" id="{DADFEF49-ADCB-4DCF-8A7A-05F60D3EC746}"/>
+                <a16:creationId xmlns:a16="http://schemas.microsoft.com/office/drawing/2014/main" id="{73C2D56E-8C8F-4CF4-930E-79A7B7B3E4EC}"/>
               </a:ext>
             </a:extLst>
           </p:cNvPr>
@@ -7942,7 +7942,7 @@
           <p:cNvPr id="4" name="">
             <a:extLst xmlns:a="http://schemas.openxmlformats.org/drawingml/2006/main">
               <a:ext uri="{FF2B5EF4-FFF2-40B4-BE49-F238E27FC236}">
-                <a16:creationId xmlns:a16="http://schemas.microsoft.com/office/drawing/2014/main" id="{70AE0A19-060A-4EE7-9198-929437A5099D}"/>
+                <a16:creationId xmlns:a16="http://schemas.microsoft.com/office/drawing/2014/main" id="{800378DC-375B-4192-B720-4761DFF26DF9}"/>
               </a:ext>
             </a:extLst>
           </p:cNvPr>
@@ -7977,7 +7977,7 @@
           <p:cNvPr id="5" name="">
             <a:extLst xmlns:a="http://schemas.openxmlformats.org/drawingml/2006/main">
               <a:ext uri="{FF2B5EF4-FFF2-40B4-BE49-F238E27FC236}">
-                <a16:creationId xmlns:a16="http://schemas.microsoft.com/office/drawing/2014/main" id="{18D3EDB7-C48F-4260-BF66-4597B1F25129}"/>
+                <a16:creationId xmlns:a16="http://schemas.microsoft.com/office/drawing/2014/main" id="{DA8C7FA3-7776-47B8-A152-2BACB770D8F9}"/>
               </a:ext>
             </a:extLst>
           </p:cNvPr>
@@ -8027,7 +8027,7 @@
           <p:cNvPr id="6" name="">
             <a:extLst xmlns:a="http://schemas.openxmlformats.org/drawingml/2006/main">
               <a:ext uri="{FF2B5EF4-FFF2-40B4-BE49-F238E27FC236}">
-                <a16:creationId xmlns:a16="http://schemas.microsoft.com/office/drawing/2014/main" id="{E97AB7EA-D0B1-4F45-8A5A-A9D259E42B98}"/>
+                <a16:creationId xmlns:a16="http://schemas.microsoft.com/office/drawing/2014/main" id="{0D0B09E2-4B80-40A4-914B-C390F21D7B88}"/>
               </a:ext>
             </a:extLst>
           </p:cNvPr>
@@ -8077,7 +8077,7 @@
           <p:cNvPr id="7" name="">
             <a:extLst xmlns:a="http://schemas.openxmlformats.org/drawingml/2006/main">
               <a:ext uri="{FF2B5EF4-FFF2-40B4-BE49-F238E27FC236}">
-                <a16:creationId xmlns:a16="http://schemas.microsoft.com/office/drawing/2014/main" id="{0F2C9F4F-7D92-40A6-9952-64CF5FCC2416}"/>
+                <a16:creationId xmlns:a16="http://schemas.microsoft.com/office/drawing/2014/main" id="{CBF90134-CB55-4742-8592-A99CC1DD4EE8}"/>
               </a:ext>
             </a:extLst>
           </p:cNvPr>
@@ -8112,7 +8112,7 @@
           <p:cNvPr id="8" name="">
             <a:extLst xmlns:a="http://schemas.openxmlformats.org/drawingml/2006/main">
               <a:ext uri="{FF2B5EF4-FFF2-40B4-BE49-F238E27FC236}">
-                <a16:creationId xmlns:a16="http://schemas.microsoft.com/office/drawing/2014/main" id="{940FE4DD-3486-442F-AC3B-AAD3041E81E2}"/>
+                <a16:creationId xmlns:a16="http://schemas.microsoft.com/office/drawing/2014/main" id="{034A0A97-D23A-478D-9CE4-5AF43C37363F}"/>
               </a:ext>
             </a:extLst>
           </p:cNvPr>
@@ -8162,7 +8162,7 @@
           <p:cNvPr id="9" name="">
             <a:extLst xmlns:a="http://schemas.openxmlformats.org/drawingml/2006/main">
               <a:ext uri="{FF2B5EF4-FFF2-40B4-BE49-F238E27FC236}">
-                <a16:creationId xmlns:a16="http://schemas.microsoft.com/office/drawing/2014/main" id="{65DD3472-E43D-4862-A276-83C97CB28B26}"/>
+                <a16:creationId xmlns:a16="http://schemas.microsoft.com/office/drawing/2014/main" id="{DF3B03DE-FC40-4617-B2BD-806A3DB79540}"/>
               </a:ext>
             </a:extLst>
           </p:cNvPr>
@@ -8212,7 +8212,7 @@
           <p:cNvPr id="10" name="">
             <a:extLst xmlns:a="http://schemas.openxmlformats.org/drawingml/2006/main">
               <a:ext uri="{FF2B5EF4-FFF2-40B4-BE49-F238E27FC236}">
-                <a16:creationId xmlns:a16="http://schemas.microsoft.com/office/drawing/2014/main" id="{73EF8C40-6469-4F75-A610-E37DA086E65D}"/>
+                <a16:creationId xmlns:a16="http://schemas.microsoft.com/office/drawing/2014/main" id="{DB98F843-F0F7-44F1-B123-B07FD0732B92}"/>
               </a:ext>
             </a:extLst>
           </p:cNvPr>
@@ -8247,7 +8247,7 @@
           <p:cNvPr id="11" name="">
             <a:extLst xmlns:a="http://schemas.openxmlformats.org/drawingml/2006/main">
               <a:ext uri="{FF2B5EF4-FFF2-40B4-BE49-F238E27FC236}">
-                <a16:creationId xmlns:a16="http://schemas.microsoft.com/office/drawing/2014/main" id="{FDEF69E5-8E8A-4CD7-9312-F8D6E1786638}"/>
+                <a16:creationId xmlns:a16="http://schemas.microsoft.com/office/drawing/2014/main" id="{28D060D2-5A6E-4BB4-969A-FEA769EBEE84}"/>
               </a:ext>
             </a:extLst>
           </p:cNvPr>
@@ -8297,7 +8297,7 @@
           <p:cNvPr id="12" name="">
             <a:extLst xmlns:a="http://schemas.openxmlformats.org/drawingml/2006/main">
               <a:ext uri="{FF2B5EF4-FFF2-40B4-BE49-F238E27FC236}">
-                <a16:creationId xmlns:a16="http://schemas.microsoft.com/office/drawing/2014/main" id="{953CDAD8-7921-46F9-99C1-12DA794FBE1C}"/>
+                <a16:creationId xmlns:a16="http://schemas.microsoft.com/office/drawing/2014/main" id="{0FAAE4CB-C715-4A97-97E6-2580D2EB58D0}"/>
               </a:ext>
             </a:extLst>
           </p:cNvPr>
@@ -8347,7 +8347,7 @@
           <p:cNvPr id="13" name="">
             <a:extLst xmlns:a="http://schemas.openxmlformats.org/drawingml/2006/main">
               <a:ext uri="{FF2B5EF4-FFF2-40B4-BE49-F238E27FC236}">
-                <a16:creationId xmlns:a16="http://schemas.microsoft.com/office/drawing/2014/main" id="{FFA92B63-9B42-482C-9222-67F644E39FED}"/>
+                <a16:creationId xmlns:a16="http://schemas.microsoft.com/office/drawing/2014/main" id="{954FF51E-BCC5-4272-AE7F-13FC0F10C8FB}"/>
               </a:ext>
             </a:extLst>
           </p:cNvPr>
@@ -8382,7 +8382,7 @@
           <p:cNvPr id="14" name="">
             <a:extLst xmlns:a="http://schemas.openxmlformats.org/drawingml/2006/main">
               <a:ext uri="{FF2B5EF4-FFF2-40B4-BE49-F238E27FC236}">
-                <a16:creationId xmlns:a16="http://schemas.microsoft.com/office/drawing/2014/main" id="{7CAA2978-C0E4-4B69-A76C-54669C2A0889}"/>
+                <a16:creationId xmlns:a16="http://schemas.microsoft.com/office/drawing/2014/main" id="{8529DD95-887A-4B68-8652-EC2E558FE6D0}"/>
               </a:ext>
             </a:extLst>
           </p:cNvPr>
@@ -8432,7 +8432,7 @@
           <p:cNvPr id="15" name="">
             <a:extLst xmlns:a="http://schemas.openxmlformats.org/drawingml/2006/main">
               <a:ext uri="{FF2B5EF4-FFF2-40B4-BE49-F238E27FC236}">
-                <a16:creationId xmlns:a16="http://schemas.microsoft.com/office/drawing/2014/main" id="{F340AF19-E016-48EE-A58C-89ACD9B366BE}"/>
+                <a16:creationId xmlns:a16="http://schemas.microsoft.com/office/drawing/2014/main" id="{BF83DF53-1C5C-49F7-8D62-2796A23D1DAE}"/>
               </a:ext>
             </a:extLst>
           </p:cNvPr>
@@ -8482,7 +8482,7 @@
           <p:cNvPr id="16" name="">
             <a:extLst xmlns:a="http://schemas.openxmlformats.org/drawingml/2006/main">
               <a:ext uri="{FF2B5EF4-FFF2-40B4-BE49-F238E27FC236}">
-                <a16:creationId xmlns:a16="http://schemas.microsoft.com/office/drawing/2014/main" id="{26A1C897-4696-4531-ADB0-06CBE671D00C}"/>
+                <a16:creationId xmlns:a16="http://schemas.microsoft.com/office/drawing/2014/main" id="{BF861A74-9C04-46C2-8F3A-ED4250206C2A}"/>
               </a:ext>
             </a:extLst>
           </p:cNvPr>
@@ -8517,7 +8517,7 @@
           <p:cNvPr id="17" name="">
             <a:extLst xmlns:a="http://schemas.openxmlformats.org/drawingml/2006/main">
               <a:ext uri="{FF2B5EF4-FFF2-40B4-BE49-F238E27FC236}">
-                <a16:creationId xmlns:a16="http://schemas.microsoft.com/office/drawing/2014/main" id="{35EBEF04-7019-4670-A705-75C9BA21B478}"/>
+                <a16:creationId xmlns:a16="http://schemas.microsoft.com/office/drawing/2014/main" id="{02FF4E89-1FF4-4331-9209-E8D27BA2A1A0}"/>
               </a:ext>
             </a:extLst>
           </p:cNvPr>
@@ -8567,7 +8567,7 @@
           <p:cNvPr id="18" name="">
             <a:extLst xmlns:a="http://schemas.openxmlformats.org/drawingml/2006/main">
               <a:ext uri="{FF2B5EF4-FFF2-40B4-BE49-F238E27FC236}">
-                <a16:creationId xmlns:a16="http://schemas.microsoft.com/office/drawing/2014/main" id="{BDC4E8B4-EDCF-4044-A4C7-8F0557C975A5}"/>
+                <a16:creationId xmlns:a16="http://schemas.microsoft.com/office/drawing/2014/main" id="{E9700CAE-4F5D-4DE4-86CF-22B8CCF6D88D}"/>
               </a:ext>
             </a:extLst>
           </p:cNvPr>
@@ -8617,7 +8617,7 @@
           <p:cNvPr id="19" name="">
             <a:extLst xmlns:a="http://schemas.openxmlformats.org/drawingml/2006/main">
               <a:ext uri="{FF2B5EF4-FFF2-40B4-BE49-F238E27FC236}">
-                <a16:creationId xmlns:a16="http://schemas.microsoft.com/office/drawing/2014/main" id="{7CA56C8E-24A3-4387-8422-BB6E5C59E8CE}"/>
+                <a16:creationId xmlns:a16="http://schemas.microsoft.com/office/drawing/2014/main" id="{8DE651ED-375D-4211-8645-C1072C53F216}"/>
               </a:ext>
             </a:extLst>
           </p:cNvPr>
@@ -8652,7 +8652,7 @@
           <p:nvPr/>
         </p:nvPicPr>
         <p:blipFill>
-          <a:blip xmlns:r="http://schemas.openxmlformats.org/officeDocument/2006/relationships" xmlns:a="http://schemas.openxmlformats.org/drawingml/2006/main" r:embed="R20f55d58092c4c37"/>
+          <a:blip xmlns:r="http://schemas.openxmlformats.org/officeDocument/2006/relationships" xmlns:a="http://schemas.openxmlformats.org/drawingml/2006/main" r:embed="Rcfdb13b35e324cb3"/>
           <a:stretch xmlns:a="http://schemas.openxmlformats.org/drawingml/2006/main"/>
         </p:blipFill>
         <p:spPr>
@@ -8670,7 +8670,7 @@
           <p:cNvPr id="21" name="">
             <a:extLst xmlns:a="http://schemas.openxmlformats.org/drawingml/2006/main">
               <a:ext uri="{FF2B5EF4-FFF2-40B4-BE49-F238E27FC236}">
-                <a16:creationId xmlns:a16="http://schemas.microsoft.com/office/drawing/2014/main" id="{E479E2B3-38D9-4081-87E8-E6F37F3DF6F3}"/>
+                <a16:creationId xmlns:a16="http://schemas.microsoft.com/office/drawing/2014/main" id="{ED6DF571-08BB-4C44-BF17-7E5231733122}"/>
               </a:ext>
             </a:extLst>
           </p:cNvPr>
@@ -8720,7 +8720,7 @@
           <p:cNvPr id="22" name="">
             <a:extLst xmlns:a="http://schemas.openxmlformats.org/drawingml/2006/main">
               <a:ext uri="{FF2B5EF4-FFF2-40B4-BE49-F238E27FC236}">
-                <a16:creationId xmlns:a16="http://schemas.microsoft.com/office/drawing/2014/main" id="{33A3A089-5354-48CC-8228-00D470B75701}"/>
+                <a16:creationId xmlns:a16="http://schemas.microsoft.com/office/drawing/2014/main" id="{623C2CD3-430D-4402-AE83-EF2C8F17A6BA}"/>
               </a:ext>
             </a:extLst>
           </p:cNvPr>
@@ -8768,7 +8768,7 @@
     </p:spTree>
     <p:extLst>
       <p:ext uri="{BB962C8B-B14F-4D97-AF65-F5344CB8AC3E}">
-        <p14:creationId xmlns:p14="http://schemas.microsoft.com/office/powerpoint/2010/main" val="756097917"/>
+        <p14:creationId xmlns:p14="http://schemas.microsoft.com/office/powerpoint/2010/main" val="1030408821"/>
       </p:ext>
     </p:extLst>
   </p:cSld>
@@ -8799,7 +8799,7 @@
           <p:cNvPr id="1" name="">
             <a:extLst xmlns:a="http://schemas.openxmlformats.org/drawingml/2006/main">
               <a:ext uri="{FF2B5EF4-FFF2-40B4-BE49-F238E27FC236}">
-                <a16:creationId xmlns:a16="http://schemas.microsoft.com/office/drawing/2014/main" id="{058075F2-E6A4-4C08-89E3-69C2F8F12BF6}"/>
+                <a16:creationId xmlns:a16="http://schemas.microsoft.com/office/drawing/2014/main" id="{956420FC-28B3-42A9-A4E3-BBCE374DBCE1}"/>
               </a:ext>
             </a:extLst>
           </p:cNvPr>
@@ -8830,7 +8830,7 @@
           <p:cNvPr id="2" name="">
             <a:extLst xmlns:a="http://schemas.openxmlformats.org/drawingml/2006/main">
               <a:ext uri="{FF2B5EF4-FFF2-40B4-BE49-F238E27FC236}">
-                <a16:creationId xmlns:a16="http://schemas.microsoft.com/office/drawing/2014/main" id="{531F5A8C-B9B7-48BB-AA91-107205723F37}"/>
+                <a16:creationId xmlns:a16="http://schemas.microsoft.com/office/drawing/2014/main" id="{FC7ACDFB-8888-4231-A49E-58BE39C2C336}"/>
               </a:ext>
             </a:extLst>
           </p:cNvPr>
@@ -8880,7 +8880,7 @@
           <p:cNvPr id="3" name="">
             <a:extLst xmlns:a="http://schemas.openxmlformats.org/drawingml/2006/main">
               <a:ext uri="{FF2B5EF4-FFF2-40B4-BE49-F238E27FC236}">
-                <a16:creationId xmlns:a16="http://schemas.microsoft.com/office/drawing/2014/main" id="{690215B5-2519-4199-8669-80E31089C125}"/>
+                <a16:creationId xmlns:a16="http://schemas.microsoft.com/office/drawing/2014/main" id="{A1112ADE-95A9-4CFC-A573-8707E7B36D4B}"/>
               </a:ext>
             </a:extLst>
           </p:cNvPr>
@@ -8920,7 +8920,7 @@
                   <a:srgbClr val="0D1117"/>
                 </a:solidFill>
               </a:rPr>
-              <a:t>0.1.0 已完成三个桌面平台的原生构建与启动验证</a:t>
+              <a:t>0.1.1 已完成三个桌面平台的同源构建与启动验证</a:t>
             </a:r>
           </a:p>
         </p:txBody>
@@ -8930,7 +8930,7 @@
           <p:cNvPr id="4" name="">
             <a:extLst xmlns:a="http://schemas.openxmlformats.org/drawingml/2006/main">
               <a:ext uri="{FF2B5EF4-FFF2-40B4-BE49-F238E27FC236}">
-                <a16:creationId xmlns:a16="http://schemas.microsoft.com/office/drawing/2014/main" id="{D1E7ED6B-43F6-49AD-BB27-73FB748C72DE}"/>
+                <a16:creationId xmlns:a16="http://schemas.microsoft.com/office/drawing/2014/main" id="{31E99643-E5B6-4D20-A55D-79C336E285FA}"/>
               </a:ext>
             </a:extLst>
           </p:cNvPr>
@@ -8965,7 +8965,7 @@
           <p:cNvPr id="5" name="">
             <a:extLst xmlns:a="http://schemas.openxmlformats.org/drawingml/2006/main">
               <a:ext uri="{FF2B5EF4-FFF2-40B4-BE49-F238E27FC236}">
-                <a16:creationId xmlns:a16="http://schemas.microsoft.com/office/drawing/2014/main" id="{62F52EEA-23FC-454F-A7ED-0862F70B6AAA}"/>
+                <a16:creationId xmlns:a16="http://schemas.microsoft.com/office/drawing/2014/main" id="{95611716-56DA-449C-9FE7-6CCCD24E44EE}"/>
               </a:ext>
             </a:extLst>
           </p:cNvPr>
@@ -9015,7 +9015,7 @@
           <p:cNvPr id="6" name="">
             <a:extLst xmlns:a="http://schemas.openxmlformats.org/drawingml/2006/main">
               <a:ext uri="{FF2B5EF4-FFF2-40B4-BE49-F238E27FC236}">
-                <a16:creationId xmlns:a16="http://schemas.microsoft.com/office/drawing/2014/main" id="{15BAA25F-2566-4590-9CD4-034869A6DBF5}"/>
+                <a16:creationId xmlns:a16="http://schemas.microsoft.com/office/drawing/2014/main" id="{3F87D78B-FF5D-4783-8D71-6EF1AC2C1F7B}"/>
               </a:ext>
             </a:extLst>
           </p:cNvPr>
@@ -9055,7 +9055,7 @@
                   <a:srgbClr val="0D1117"/>
                 </a:solidFill>
               </a:rPr>
-              <a:t>BAI-Work-0.1.0-mac-x64.dmg</a:t>
+              <a:t>BAI-Work-0.1.1-mac-x64.dmg</a:t>
             </a:r>
           </a:p>
           <a:p xmlns:a="http://schemas.openxmlformats.org/drawingml/2006/main">
@@ -9072,7 +9072,7 @@
                   <a:srgbClr val="0D1117"/>
                 </a:solidFill>
               </a:rPr>
-              <a:t>BAI-Work-0.1.0-mac-x64.zip</a:t>
+              <a:t>BAI-Work-0.1.1-mac-x64.zip</a:t>
             </a:r>
           </a:p>
         </p:txBody>
@@ -9082,7 +9082,7 @@
           <p:cNvPr id="7" name="">
             <a:extLst xmlns:a="http://schemas.openxmlformats.org/drawingml/2006/main">
               <a:ext uri="{FF2B5EF4-FFF2-40B4-BE49-F238E27FC236}">
-                <a16:creationId xmlns:a16="http://schemas.microsoft.com/office/drawing/2014/main" id="{9D535468-F93A-4B47-A825-536FEC6030AB}"/>
+                <a16:creationId xmlns:a16="http://schemas.microsoft.com/office/drawing/2014/main" id="{2663AE27-84A8-44D7-B1A8-727D4AF21E69}"/>
               </a:ext>
             </a:extLst>
           </p:cNvPr>
@@ -9132,7 +9132,7 @@
           <p:cNvPr id="8" name="">
             <a:extLst xmlns:a="http://schemas.openxmlformats.org/drawingml/2006/main">
               <a:ext uri="{FF2B5EF4-FFF2-40B4-BE49-F238E27FC236}">
-                <a16:creationId xmlns:a16="http://schemas.microsoft.com/office/drawing/2014/main" id="{D47F4FA2-C112-4BD6-8D2E-4DDF882052CD}"/>
+                <a16:creationId xmlns:a16="http://schemas.microsoft.com/office/drawing/2014/main" id="{B7EBA3F5-B3E3-4205-9D07-232F7E1235D9}"/>
               </a:ext>
             </a:extLst>
           </p:cNvPr>
@@ -9163,7 +9163,7 @@
           <p:cNvPr id="9" name="">
             <a:extLst xmlns:a="http://schemas.openxmlformats.org/drawingml/2006/main">
               <a:ext uri="{FF2B5EF4-FFF2-40B4-BE49-F238E27FC236}">
-                <a16:creationId xmlns:a16="http://schemas.microsoft.com/office/drawing/2014/main" id="{63C97E8C-EDD9-49BE-A60C-CCD9D9A21808}"/>
+                <a16:creationId xmlns:a16="http://schemas.microsoft.com/office/drawing/2014/main" id="{B6F670A7-38DD-4837-9FE0-7566E5C792AE}"/>
               </a:ext>
             </a:extLst>
           </p:cNvPr>
@@ -9198,7 +9198,7 @@
           <p:cNvPr id="10" name="">
             <a:extLst xmlns:a="http://schemas.openxmlformats.org/drawingml/2006/main">
               <a:ext uri="{FF2B5EF4-FFF2-40B4-BE49-F238E27FC236}">
-                <a16:creationId xmlns:a16="http://schemas.microsoft.com/office/drawing/2014/main" id="{767D5A05-2338-4230-979F-8ACB93832BCD}"/>
+                <a16:creationId xmlns:a16="http://schemas.microsoft.com/office/drawing/2014/main" id="{40DD7043-4B6B-4884-BE22-883B02B17C58}"/>
               </a:ext>
             </a:extLst>
           </p:cNvPr>
@@ -9248,7 +9248,7 @@
           <p:cNvPr id="11" name="">
             <a:extLst xmlns:a="http://schemas.openxmlformats.org/drawingml/2006/main">
               <a:ext uri="{FF2B5EF4-FFF2-40B4-BE49-F238E27FC236}">
-                <a16:creationId xmlns:a16="http://schemas.microsoft.com/office/drawing/2014/main" id="{1D296BFB-43C3-42F7-AE59-FAE2FD52B817}"/>
+                <a16:creationId xmlns:a16="http://schemas.microsoft.com/office/drawing/2014/main" id="{4C399B7D-E129-444A-AA63-60DC22495E55}"/>
               </a:ext>
             </a:extLst>
           </p:cNvPr>
@@ -9288,7 +9288,7 @@
                   <a:srgbClr val="0D1117"/>
                 </a:solidFill>
               </a:rPr>
-              <a:t>BAI-Work-0.1.0-mac-arm64.dmg</a:t>
+              <a:t>BAI-Work-0.1.1-mac-arm64.dmg</a:t>
             </a:r>
           </a:p>
           <a:p xmlns:a="http://schemas.openxmlformats.org/drawingml/2006/main">
@@ -9305,7 +9305,7 @@
                   <a:srgbClr val="0D1117"/>
                 </a:solidFill>
               </a:rPr>
-              <a:t>BAI-Work-0.1.0-mac-arm64.zip</a:t>
+              <a:t>BAI-Work-0.1.1-mac-arm64.zip</a:t>
             </a:r>
           </a:p>
         </p:txBody>
@@ -9315,7 +9315,7 @@
           <p:cNvPr id="12" name="">
             <a:extLst xmlns:a="http://schemas.openxmlformats.org/drawingml/2006/main">
               <a:ext uri="{FF2B5EF4-FFF2-40B4-BE49-F238E27FC236}">
-                <a16:creationId xmlns:a16="http://schemas.microsoft.com/office/drawing/2014/main" id="{B5E46097-1D48-43CD-B906-C595E6474260}"/>
+                <a16:creationId xmlns:a16="http://schemas.microsoft.com/office/drawing/2014/main" id="{8E96082F-F8F3-496F-ABB9-6CD070E454A7}"/>
               </a:ext>
             </a:extLst>
           </p:cNvPr>
@@ -9365,7 +9365,7 @@
           <p:cNvPr id="13" name="">
             <a:extLst xmlns:a="http://schemas.openxmlformats.org/drawingml/2006/main">
               <a:ext uri="{FF2B5EF4-FFF2-40B4-BE49-F238E27FC236}">
-                <a16:creationId xmlns:a16="http://schemas.microsoft.com/office/drawing/2014/main" id="{77018A15-73B6-417F-8FFE-344BB1E9C322}"/>
+                <a16:creationId xmlns:a16="http://schemas.microsoft.com/office/drawing/2014/main" id="{419AC8CB-5F25-46B1-8980-9CE6E1FE3064}"/>
               </a:ext>
             </a:extLst>
           </p:cNvPr>
@@ -9396,7 +9396,7 @@
           <p:cNvPr id="14" name="">
             <a:extLst xmlns:a="http://schemas.openxmlformats.org/drawingml/2006/main">
               <a:ext uri="{FF2B5EF4-FFF2-40B4-BE49-F238E27FC236}">
-                <a16:creationId xmlns:a16="http://schemas.microsoft.com/office/drawing/2014/main" id="{4E5363C7-404C-4609-9F3E-55329D5A2EEC}"/>
+                <a16:creationId xmlns:a16="http://schemas.microsoft.com/office/drawing/2014/main" id="{991BB55C-558B-4A15-A2B1-DCC9C23ABC1A}"/>
               </a:ext>
             </a:extLst>
           </p:cNvPr>
@@ -9431,7 +9431,7 @@
           <p:cNvPr id="15" name="">
             <a:extLst xmlns:a="http://schemas.openxmlformats.org/drawingml/2006/main">
               <a:ext uri="{FF2B5EF4-FFF2-40B4-BE49-F238E27FC236}">
-                <a16:creationId xmlns:a16="http://schemas.microsoft.com/office/drawing/2014/main" id="{B1D9D15D-CF3A-4335-BB6A-36D4DF29BDA6}"/>
+                <a16:creationId xmlns:a16="http://schemas.microsoft.com/office/drawing/2014/main" id="{D4DC84E6-34F9-4923-A640-61D69BBDEA54}"/>
               </a:ext>
             </a:extLst>
           </p:cNvPr>
@@ -9481,7 +9481,7 @@
           <p:cNvPr id="16" name="">
             <a:extLst xmlns:a="http://schemas.openxmlformats.org/drawingml/2006/main">
               <a:ext uri="{FF2B5EF4-FFF2-40B4-BE49-F238E27FC236}">
-                <a16:creationId xmlns:a16="http://schemas.microsoft.com/office/drawing/2014/main" id="{F2523D40-A1C5-4B12-B7DF-1EF5FEAB1BAA}"/>
+                <a16:creationId xmlns:a16="http://schemas.microsoft.com/office/drawing/2014/main" id="{EE1CE435-B9D4-4D38-8167-90775DE0266C}"/>
               </a:ext>
             </a:extLst>
           </p:cNvPr>
@@ -9521,7 +9521,7 @@
                   <a:srgbClr val="0D1117"/>
                 </a:solidFill>
               </a:rPr>
-              <a:t>BAI-Work-0.1.0-win-x64.exe</a:t>
+              <a:t>BAI-Work-0.1.1-win-x64.exe</a:t>
             </a:r>
           </a:p>
         </p:txBody>
@@ -9531,7 +9531,7 @@
           <p:cNvPr id="17" name="">
             <a:extLst xmlns:a="http://schemas.openxmlformats.org/drawingml/2006/main">
               <a:ext uri="{FF2B5EF4-FFF2-40B4-BE49-F238E27FC236}">
-                <a16:creationId xmlns:a16="http://schemas.microsoft.com/office/drawing/2014/main" id="{CB88522C-06B4-4505-920B-D8E306890E74}"/>
+                <a16:creationId xmlns:a16="http://schemas.microsoft.com/office/drawing/2014/main" id="{63B5A7B4-2898-46B6-8167-91101A683CFB}"/>
               </a:ext>
             </a:extLst>
           </p:cNvPr>
@@ -9581,7 +9581,7 @@
           <p:cNvPr id="18" name="">
             <a:extLst xmlns:a="http://schemas.openxmlformats.org/drawingml/2006/main">
               <a:ext uri="{FF2B5EF4-FFF2-40B4-BE49-F238E27FC236}">
-                <a16:creationId xmlns:a16="http://schemas.microsoft.com/office/drawing/2014/main" id="{F17D54E5-4C61-4CB9-9982-08AA6B1A0072}"/>
+                <a16:creationId xmlns:a16="http://schemas.microsoft.com/office/drawing/2014/main" id="{7965FD92-D01A-48B7-B474-4E762AFB263F}"/>
               </a:ext>
             </a:extLst>
           </p:cNvPr>
@@ -9612,7 +9612,7 @@
           <p:cNvPr id="19" name="">
             <a:extLst xmlns:a="http://schemas.openxmlformats.org/drawingml/2006/main">
               <a:ext uri="{FF2B5EF4-FFF2-40B4-BE49-F238E27FC236}">
-                <a16:creationId xmlns:a16="http://schemas.microsoft.com/office/drawing/2014/main" id="{7FE16557-8299-4F08-BFC0-94E551A5D782}"/>
+                <a16:creationId xmlns:a16="http://schemas.microsoft.com/office/drawing/2014/main" id="{E47DF22D-4B63-47E9-8FF0-9C46194B7027}"/>
               </a:ext>
             </a:extLst>
           </p:cNvPr>
@@ -9647,7 +9647,7 @@
           <p:nvPr/>
         </p:nvPicPr>
         <p:blipFill>
-          <a:blip xmlns:r="http://schemas.openxmlformats.org/officeDocument/2006/relationships" xmlns:a="http://schemas.openxmlformats.org/drawingml/2006/main" r:embed="R2d387e67187f4365"/>
+          <a:blip xmlns:r="http://schemas.openxmlformats.org/officeDocument/2006/relationships" xmlns:a="http://schemas.openxmlformats.org/drawingml/2006/main" r:embed="R43ceeaee849c4a47"/>
           <a:stretch xmlns:a="http://schemas.openxmlformats.org/drawingml/2006/main"/>
         </p:blipFill>
         <p:spPr>
@@ -9665,7 +9665,7 @@
           <p:cNvPr id="21" name="">
             <a:extLst xmlns:a="http://schemas.openxmlformats.org/drawingml/2006/main">
               <a:ext uri="{FF2B5EF4-FFF2-40B4-BE49-F238E27FC236}">
-                <a16:creationId xmlns:a16="http://schemas.microsoft.com/office/drawing/2014/main" id="{7BFAB74F-7D39-4C40-A7AF-3B51AF36E399}"/>
+                <a16:creationId xmlns:a16="http://schemas.microsoft.com/office/drawing/2014/main" id="{0FA98968-BF96-4809-985C-0965D921D690}"/>
               </a:ext>
             </a:extLst>
           </p:cNvPr>
@@ -9715,7 +9715,7 @@
           <p:cNvPr id="22" name="">
             <a:extLst xmlns:a="http://schemas.openxmlformats.org/drawingml/2006/main">
               <a:ext uri="{FF2B5EF4-FFF2-40B4-BE49-F238E27FC236}">
-                <a16:creationId xmlns:a16="http://schemas.microsoft.com/office/drawing/2014/main" id="{B3183199-DD09-4AAC-A9B2-B21958D65270}"/>
+                <a16:creationId xmlns:a16="http://schemas.microsoft.com/office/drawing/2014/main" id="{D36CA892-C301-4400-9A71-15C20EB8E9EB}"/>
               </a:ext>
             </a:extLst>
           </p:cNvPr>
@@ -9763,7 +9763,7 @@
     </p:spTree>
     <p:extLst>
       <p:ext uri="{BB962C8B-B14F-4D97-AF65-F5344CB8AC3E}">
-        <p14:creationId xmlns:p14="http://schemas.microsoft.com/office/powerpoint/2010/main" val="635460999"/>
+        <p14:creationId xmlns:p14="http://schemas.microsoft.com/office/powerpoint/2010/main" val="653128938"/>
       </p:ext>
     </p:extLst>
   </p:cSld>
@@ -9794,7 +9794,7 @@
           <p:cNvPr id="1" name="">
             <a:extLst xmlns:a="http://schemas.openxmlformats.org/drawingml/2006/main">
               <a:ext uri="{FF2B5EF4-FFF2-40B4-BE49-F238E27FC236}">
-                <a16:creationId xmlns:a16="http://schemas.microsoft.com/office/drawing/2014/main" id="{7A62A6D2-8A66-426C-96FC-1E2D689A7F36}"/>
+                <a16:creationId xmlns:a16="http://schemas.microsoft.com/office/drawing/2014/main" id="{4F673B26-F0C3-45B6-83F1-D67DA8D42836}"/>
               </a:ext>
             </a:extLst>
           </p:cNvPr>
@@ -9825,7 +9825,7 @@
           <p:cNvPr id="2" name="">
             <a:extLst xmlns:a="http://schemas.openxmlformats.org/drawingml/2006/main">
               <a:ext uri="{FF2B5EF4-FFF2-40B4-BE49-F238E27FC236}">
-                <a16:creationId xmlns:a16="http://schemas.microsoft.com/office/drawing/2014/main" id="{B3B17746-94DC-40CA-A67C-9DC8A237A560}"/>
+                <a16:creationId xmlns:a16="http://schemas.microsoft.com/office/drawing/2014/main" id="{9F328E71-41C4-42B0-936B-04AE959344B2}"/>
               </a:ext>
             </a:extLst>
           </p:cNvPr>
@@ -9875,7 +9875,7 @@
           <p:cNvPr id="3" name="">
             <a:extLst xmlns:a="http://schemas.openxmlformats.org/drawingml/2006/main">
               <a:ext uri="{FF2B5EF4-FFF2-40B4-BE49-F238E27FC236}">
-                <a16:creationId xmlns:a16="http://schemas.microsoft.com/office/drawing/2014/main" id="{FC94DF9D-2F55-41A8-B527-CE8BFA3FE7D3}"/>
+                <a16:creationId xmlns:a16="http://schemas.microsoft.com/office/drawing/2014/main" id="{B84DFFED-3244-4232-857D-0DC2713DAC5B}"/>
               </a:ext>
             </a:extLst>
           </p:cNvPr>
@@ -9925,7 +9925,7 @@
           <p:cNvPr id="4" name="">
             <a:extLst xmlns:a="http://schemas.openxmlformats.org/drawingml/2006/main">
               <a:ext uri="{FF2B5EF4-FFF2-40B4-BE49-F238E27FC236}">
-                <a16:creationId xmlns:a16="http://schemas.microsoft.com/office/drawing/2014/main" id="{6E64A927-8CBD-45E0-9825-AA9B1B2173B0}"/>
+                <a16:creationId xmlns:a16="http://schemas.microsoft.com/office/drawing/2014/main" id="{11250B1F-DF17-4233-BDBC-F8E6C25F10EB}"/>
               </a:ext>
             </a:extLst>
           </p:cNvPr>
@@ -9956,7 +9956,7 @@
           <p:cNvPr id="5" name="">
             <a:extLst xmlns:a="http://schemas.openxmlformats.org/drawingml/2006/main">
               <a:ext uri="{FF2B5EF4-FFF2-40B4-BE49-F238E27FC236}">
-                <a16:creationId xmlns:a16="http://schemas.microsoft.com/office/drawing/2014/main" id="{DDB9014D-BF39-48AC-B642-13B892F93E29}"/>
+                <a16:creationId xmlns:a16="http://schemas.microsoft.com/office/drawing/2014/main" id="{0686E6FB-EE8B-4013-8F9D-083392D70788}"/>
               </a:ext>
             </a:extLst>
           </p:cNvPr>
@@ -10006,7 +10006,7 @@
           <p:cNvPr id="6" name="">
             <a:extLst xmlns:a="http://schemas.openxmlformats.org/drawingml/2006/main">
               <a:ext uri="{FF2B5EF4-FFF2-40B4-BE49-F238E27FC236}">
-                <a16:creationId xmlns:a16="http://schemas.microsoft.com/office/drawing/2014/main" id="{B486A72B-84A0-4D6D-A4A6-E5DD19A5767C}"/>
+                <a16:creationId xmlns:a16="http://schemas.microsoft.com/office/drawing/2014/main" id="{25B3E47F-EBDB-4167-A090-8B62818482F4}"/>
               </a:ext>
             </a:extLst>
           </p:cNvPr>
@@ -10056,7 +10056,7 @@
           <p:cNvPr id="7" name="">
             <a:extLst xmlns:a="http://schemas.openxmlformats.org/drawingml/2006/main">
               <a:ext uri="{FF2B5EF4-FFF2-40B4-BE49-F238E27FC236}">
-                <a16:creationId xmlns:a16="http://schemas.microsoft.com/office/drawing/2014/main" id="{BCEF7844-D144-4A49-BD84-23C87108D823}"/>
+                <a16:creationId xmlns:a16="http://schemas.microsoft.com/office/drawing/2014/main" id="{1B699EA0-B99D-46BF-A81D-5356F6F3AE86}"/>
               </a:ext>
             </a:extLst>
           </p:cNvPr>
@@ -10087,7 +10087,7 @@
           <p:cNvPr id="8" name="">
             <a:extLst xmlns:a="http://schemas.openxmlformats.org/drawingml/2006/main">
               <a:ext uri="{FF2B5EF4-FFF2-40B4-BE49-F238E27FC236}">
-                <a16:creationId xmlns:a16="http://schemas.microsoft.com/office/drawing/2014/main" id="{BC02696C-DEED-4340-9E0D-F8C5C1CB9302}"/>
+                <a16:creationId xmlns:a16="http://schemas.microsoft.com/office/drawing/2014/main" id="{A02ED9BC-4994-4638-BB8F-0B43D8D941C4}"/>
               </a:ext>
             </a:extLst>
           </p:cNvPr>
@@ -10137,7 +10137,7 @@
           <p:cNvPr id="9" name="">
             <a:extLst xmlns:a="http://schemas.openxmlformats.org/drawingml/2006/main">
               <a:ext uri="{FF2B5EF4-FFF2-40B4-BE49-F238E27FC236}">
-                <a16:creationId xmlns:a16="http://schemas.microsoft.com/office/drawing/2014/main" id="{9141E3F9-D7D3-4DC7-A82C-DC08375CE764}"/>
+                <a16:creationId xmlns:a16="http://schemas.microsoft.com/office/drawing/2014/main" id="{66C82258-5752-485E-AA23-D5F78A3D6601}"/>
               </a:ext>
             </a:extLst>
           </p:cNvPr>
@@ -10187,7 +10187,7 @@
           <p:cNvPr id="10" name="">
             <a:extLst xmlns:a="http://schemas.openxmlformats.org/drawingml/2006/main">
               <a:ext uri="{FF2B5EF4-FFF2-40B4-BE49-F238E27FC236}">
-                <a16:creationId xmlns:a16="http://schemas.microsoft.com/office/drawing/2014/main" id="{0E950A5F-7DCC-40F1-B40B-1CBFF58690CD}"/>
+                <a16:creationId xmlns:a16="http://schemas.microsoft.com/office/drawing/2014/main" id="{5AA148CF-20AF-48E1-8374-67DBEC393865}"/>
               </a:ext>
             </a:extLst>
           </p:cNvPr>
@@ -10218,7 +10218,7 @@
           <p:cNvPr id="11" name="">
             <a:extLst xmlns:a="http://schemas.openxmlformats.org/drawingml/2006/main">
               <a:ext uri="{FF2B5EF4-FFF2-40B4-BE49-F238E27FC236}">
-                <a16:creationId xmlns:a16="http://schemas.microsoft.com/office/drawing/2014/main" id="{CC79426D-BFA8-419C-9EB5-BC3502135F41}"/>
+                <a16:creationId xmlns:a16="http://schemas.microsoft.com/office/drawing/2014/main" id="{5533646E-A7A0-4365-AEAA-390683432BA0}"/>
               </a:ext>
             </a:extLst>
           </p:cNvPr>
@@ -10268,7 +10268,7 @@
           <p:cNvPr id="12" name="">
             <a:extLst xmlns:a="http://schemas.openxmlformats.org/drawingml/2006/main">
               <a:ext uri="{FF2B5EF4-FFF2-40B4-BE49-F238E27FC236}">
-                <a16:creationId xmlns:a16="http://schemas.microsoft.com/office/drawing/2014/main" id="{6EBF0CC9-A027-4C3D-B796-8B1914D72966}"/>
+                <a16:creationId xmlns:a16="http://schemas.microsoft.com/office/drawing/2014/main" id="{38856EDC-037A-4C64-84AA-B74CE175849A}"/>
               </a:ext>
             </a:extLst>
           </p:cNvPr>
@@ -10318,7 +10318,7 @@
           <p:cNvPr id="13" name="">
             <a:extLst xmlns:a="http://schemas.openxmlformats.org/drawingml/2006/main">
               <a:ext uri="{FF2B5EF4-FFF2-40B4-BE49-F238E27FC236}">
-                <a16:creationId xmlns:a16="http://schemas.microsoft.com/office/drawing/2014/main" id="{3FB5377C-3F89-4AA9-A29C-EC25527B76E6}"/>
+                <a16:creationId xmlns:a16="http://schemas.microsoft.com/office/drawing/2014/main" id="{E585A8DB-DCB2-4539-98D4-F01DD6D5A1C7}"/>
               </a:ext>
             </a:extLst>
           </p:cNvPr>
@@ -10349,7 +10349,7 @@
           <p:cNvPr id="14" name="">
             <a:extLst xmlns:a="http://schemas.openxmlformats.org/drawingml/2006/main">
               <a:ext uri="{FF2B5EF4-FFF2-40B4-BE49-F238E27FC236}">
-                <a16:creationId xmlns:a16="http://schemas.microsoft.com/office/drawing/2014/main" id="{92772297-5E29-40DE-9F0C-C8FF41469E6B}"/>
+                <a16:creationId xmlns:a16="http://schemas.microsoft.com/office/drawing/2014/main" id="{062DF025-2DAF-4B2E-965D-B568E83401E2}"/>
               </a:ext>
             </a:extLst>
           </p:cNvPr>
@@ -10399,7 +10399,7 @@
           <p:cNvPr id="15" name="">
             <a:extLst xmlns:a="http://schemas.openxmlformats.org/drawingml/2006/main">
               <a:ext uri="{FF2B5EF4-FFF2-40B4-BE49-F238E27FC236}">
-                <a16:creationId xmlns:a16="http://schemas.microsoft.com/office/drawing/2014/main" id="{AEE2BBC8-2531-4D5B-B81F-10C3AA9278C2}"/>
+                <a16:creationId xmlns:a16="http://schemas.microsoft.com/office/drawing/2014/main" id="{62FF88D6-5C8E-4655-BBB4-F7F08BFF687F}"/>
               </a:ext>
             </a:extLst>
           </p:cNvPr>
@@ -10449,7 +10449,7 @@
           <p:cNvPr id="16" name="">
             <a:extLst xmlns:a="http://schemas.openxmlformats.org/drawingml/2006/main">
               <a:ext uri="{FF2B5EF4-FFF2-40B4-BE49-F238E27FC236}">
-                <a16:creationId xmlns:a16="http://schemas.microsoft.com/office/drawing/2014/main" id="{DD3A15B7-6C05-47CA-8D26-F97A110B2F4B}"/>
+                <a16:creationId xmlns:a16="http://schemas.microsoft.com/office/drawing/2014/main" id="{0A37F0FF-546E-4E7D-8463-E0189041A428}"/>
               </a:ext>
             </a:extLst>
           </p:cNvPr>
@@ -10480,7 +10480,7 @@
           <p:cNvPr id="17" name="">
             <a:extLst xmlns:a="http://schemas.openxmlformats.org/drawingml/2006/main">
               <a:ext uri="{FF2B5EF4-FFF2-40B4-BE49-F238E27FC236}">
-                <a16:creationId xmlns:a16="http://schemas.microsoft.com/office/drawing/2014/main" id="{D7A49BD0-0364-4E6B-B7AF-543553924DDB}"/>
+                <a16:creationId xmlns:a16="http://schemas.microsoft.com/office/drawing/2014/main" id="{A5E11246-2242-47CC-A728-EDF031C24BD4}"/>
               </a:ext>
             </a:extLst>
           </p:cNvPr>
@@ -10530,7 +10530,7 @@
           <p:cNvPr id="18" name="">
             <a:extLst xmlns:a="http://schemas.openxmlformats.org/drawingml/2006/main">
               <a:ext uri="{FF2B5EF4-FFF2-40B4-BE49-F238E27FC236}">
-                <a16:creationId xmlns:a16="http://schemas.microsoft.com/office/drawing/2014/main" id="{1F702AAC-54CF-426F-B4E4-BD17B3B4FFFE}"/>
+                <a16:creationId xmlns:a16="http://schemas.microsoft.com/office/drawing/2014/main" id="{3FED02BD-81AF-48D6-B694-C68C4268A1EC}"/>
               </a:ext>
             </a:extLst>
           </p:cNvPr>
@@ -10580,7 +10580,7 @@
           <p:cNvPr id="19" name="">
             <a:extLst xmlns:a="http://schemas.openxmlformats.org/drawingml/2006/main">
               <a:ext uri="{FF2B5EF4-FFF2-40B4-BE49-F238E27FC236}">
-                <a16:creationId xmlns:a16="http://schemas.microsoft.com/office/drawing/2014/main" id="{F6B79155-520E-460C-B4C4-7D14838EFF1F}"/>
+                <a16:creationId xmlns:a16="http://schemas.microsoft.com/office/drawing/2014/main" id="{DBCF6587-A3DE-4F33-85A9-CB41F37905FF}"/>
               </a:ext>
             </a:extLst>
           </p:cNvPr>
@@ -10615,7 +10615,7 @@
           <p:nvPr/>
         </p:nvPicPr>
         <p:blipFill>
-          <a:blip xmlns:r="http://schemas.openxmlformats.org/officeDocument/2006/relationships" xmlns:a="http://schemas.openxmlformats.org/drawingml/2006/main" r:embed="R29ac850648a948b1"/>
+          <a:blip xmlns:r="http://schemas.openxmlformats.org/officeDocument/2006/relationships" xmlns:a="http://schemas.openxmlformats.org/drawingml/2006/main" r:embed="R7f32fa7b2432424b"/>
           <a:stretch xmlns:a="http://schemas.openxmlformats.org/drawingml/2006/main"/>
         </p:blipFill>
         <p:spPr>
@@ -10633,7 +10633,7 @@
           <p:cNvPr id="21" name="">
             <a:extLst xmlns:a="http://schemas.openxmlformats.org/drawingml/2006/main">
               <a:ext uri="{FF2B5EF4-FFF2-40B4-BE49-F238E27FC236}">
-                <a16:creationId xmlns:a16="http://schemas.microsoft.com/office/drawing/2014/main" id="{360ED614-FD16-4191-B6CD-A2A497B51A29}"/>
+                <a16:creationId xmlns:a16="http://schemas.microsoft.com/office/drawing/2014/main" id="{BD1D9327-CB9A-43FA-9EF9-5008A1051528}"/>
               </a:ext>
             </a:extLst>
           </p:cNvPr>
@@ -10683,7 +10683,7 @@
           <p:cNvPr id="22" name="">
             <a:extLst xmlns:a="http://schemas.openxmlformats.org/drawingml/2006/main">
               <a:ext uri="{FF2B5EF4-FFF2-40B4-BE49-F238E27FC236}">
-                <a16:creationId xmlns:a16="http://schemas.microsoft.com/office/drawing/2014/main" id="{538E92EB-665D-4C8B-8F34-B98E60807352}"/>
+                <a16:creationId xmlns:a16="http://schemas.microsoft.com/office/drawing/2014/main" id="{FAF3FFC4-4860-48F1-A517-D3676FC0A764}"/>
               </a:ext>
             </a:extLst>
           </p:cNvPr>
@@ -10731,7 +10731,7 @@
     </p:spTree>
     <p:extLst>
       <p:ext uri="{BB962C8B-B14F-4D97-AF65-F5344CB8AC3E}">
-        <p14:creationId xmlns:p14="http://schemas.microsoft.com/office/powerpoint/2010/main" val="1823719505"/>
+        <p14:creationId xmlns:p14="http://schemas.microsoft.com/office/powerpoint/2010/main" val="1438754869"/>
       </p:ext>
     </p:extLst>
   </p:cSld>
@@ -10762,7 +10762,7 @@
           <p:cNvPr id="1" name="">
             <a:extLst xmlns:a="http://schemas.openxmlformats.org/drawingml/2006/main">
               <a:ext uri="{FF2B5EF4-FFF2-40B4-BE49-F238E27FC236}">
-                <a16:creationId xmlns:a16="http://schemas.microsoft.com/office/drawing/2014/main" id="{400A2C84-A01F-4812-8C5B-C29A362AB4FB}"/>
+                <a16:creationId xmlns:a16="http://schemas.microsoft.com/office/drawing/2014/main" id="{B9E93D3C-7EA3-4D18-A8FB-615B50A1779B}"/>
               </a:ext>
             </a:extLst>
           </p:cNvPr>
@@ -10793,7 +10793,7 @@
           <p:cNvPr id="2" name="">
             <a:extLst xmlns:a="http://schemas.openxmlformats.org/drawingml/2006/main">
               <a:ext uri="{FF2B5EF4-FFF2-40B4-BE49-F238E27FC236}">
-                <a16:creationId xmlns:a16="http://schemas.microsoft.com/office/drawing/2014/main" id="{DB20F5AA-44BB-450F-9DD6-DD16EE6E7FE8}"/>
+                <a16:creationId xmlns:a16="http://schemas.microsoft.com/office/drawing/2014/main" id="{F29263B6-D5D3-40A5-B3A6-4375B44306FC}"/>
               </a:ext>
             </a:extLst>
           </p:cNvPr>
@@ -10843,7 +10843,7 @@
           <p:cNvPr id="3" name="">
             <a:extLst xmlns:a="http://schemas.openxmlformats.org/drawingml/2006/main">
               <a:ext uri="{FF2B5EF4-FFF2-40B4-BE49-F238E27FC236}">
-                <a16:creationId xmlns:a16="http://schemas.microsoft.com/office/drawing/2014/main" id="{4DD214A4-280C-4ECB-B9BE-ABADF0B3C4E0}"/>
+                <a16:creationId xmlns:a16="http://schemas.microsoft.com/office/drawing/2014/main" id="{19037541-0395-43F8-8D86-FDFB8C6160B6}"/>
               </a:ext>
             </a:extLst>
           </p:cNvPr>
@@ -10893,7 +10893,7 @@
           <p:cNvPr id="4" name="">
             <a:extLst xmlns:a="http://schemas.openxmlformats.org/drawingml/2006/main">
               <a:ext uri="{FF2B5EF4-FFF2-40B4-BE49-F238E27FC236}">
-                <a16:creationId xmlns:a16="http://schemas.microsoft.com/office/drawing/2014/main" id="{C3B1EE4A-A78E-4142-BB40-C9F065C48B69}"/>
+                <a16:creationId xmlns:a16="http://schemas.microsoft.com/office/drawing/2014/main" id="{E4E9E186-C8D8-441A-9486-1917D3277F04}"/>
               </a:ext>
             </a:extLst>
           </p:cNvPr>
@@ -10943,7 +10943,7 @@
           <p:cNvPr id="5" name="">
             <a:extLst xmlns:a="http://schemas.openxmlformats.org/drawingml/2006/main">
               <a:ext uri="{FF2B5EF4-FFF2-40B4-BE49-F238E27FC236}">
-                <a16:creationId xmlns:a16="http://schemas.microsoft.com/office/drawing/2014/main" id="{A1159AF4-74B4-4B4F-8B54-7B943ECACA78}"/>
+                <a16:creationId xmlns:a16="http://schemas.microsoft.com/office/drawing/2014/main" id="{4C47A908-AFB2-4C6D-8BD9-68D21914C265}"/>
               </a:ext>
             </a:extLst>
           </p:cNvPr>
@@ -10974,7 +10974,7 @@
           <p:cNvPr id="6" name="">
             <a:extLst xmlns:a="http://schemas.openxmlformats.org/drawingml/2006/main">
               <a:ext uri="{FF2B5EF4-FFF2-40B4-BE49-F238E27FC236}">
-                <a16:creationId xmlns:a16="http://schemas.microsoft.com/office/drawing/2014/main" id="{E42DA8E1-71BB-43EE-9224-B207240D8BBF}"/>
+                <a16:creationId xmlns:a16="http://schemas.microsoft.com/office/drawing/2014/main" id="{B1630786-4DCE-4035-9C6D-3C21FAF89584}"/>
               </a:ext>
             </a:extLst>
           </p:cNvPr>
@@ -11024,7 +11024,7 @@
           <p:cNvPr id="7" name="">
             <a:extLst xmlns:a="http://schemas.openxmlformats.org/drawingml/2006/main">
               <a:ext uri="{FF2B5EF4-FFF2-40B4-BE49-F238E27FC236}">
-                <a16:creationId xmlns:a16="http://schemas.microsoft.com/office/drawing/2014/main" id="{3F954D7D-4CAF-4E5C-AD89-1D471F36E83D}"/>
+                <a16:creationId xmlns:a16="http://schemas.microsoft.com/office/drawing/2014/main" id="{AD253993-C44C-4CC3-A44E-585A096D8E51}"/>
               </a:ext>
             </a:extLst>
           </p:cNvPr>
@@ -11074,7 +11074,7 @@
           <p:cNvPr id="8" name="">
             <a:extLst xmlns:a="http://schemas.openxmlformats.org/drawingml/2006/main">
               <a:ext uri="{FF2B5EF4-FFF2-40B4-BE49-F238E27FC236}">
-                <a16:creationId xmlns:a16="http://schemas.microsoft.com/office/drawing/2014/main" id="{D9451D0B-7F84-4EF2-8EE1-5ED101D22A07}"/>
+                <a16:creationId xmlns:a16="http://schemas.microsoft.com/office/drawing/2014/main" id="{C9E747E8-EB4A-4406-8D3D-2BFBAF788D44}"/>
               </a:ext>
             </a:extLst>
           </p:cNvPr>
@@ -11105,7 +11105,7 @@
           <p:cNvPr id="9" name="">
             <a:extLst xmlns:a="http://schemas.openxmlformats.org/drawingml/2006/main">
               <a:ext uri="{FF2B5EF4-FFF2-40B4-BE49-F238E27FC236}">
-                <a16:creationId xmlns:a16="http://schemas.microsoft.com/office/drawing/2014/main" id="{C26F9A81-17B3-4B36-AD84-7757686AAE44}"/>
+                <a16:creationId xmlns:a16="http://schemas.microsoft.com/office/drawing/2014/main" id="{70B18F7D-0C9D-4159-951B-3227CEEA29A2}"/>
               </a:ext>
             </a:extLst>
           </p:cNvPr>
@@ -11155,7 +11155,7 @@
           <p:cNvPr id="10" name="">
             <a:extLst xmlns:a="http://schemas.openxmlformats.org/drawingml/2006/main">
               <a:ext uri="{FF2B5EF4-FFF2-40B4-BE49-F238E27FC236}">
-                <a16:creationId xmlns:a16="http://schemas.microsoft.com/office/drawing/2014/main" id="{E094EDDF-AD1C-45EB-BB0A-3A8059B8B5C0}"/>
+                <a16:creationId xmlns:a16="http://schemas.microsoft.com/office/drawing/2014/main" id="{2E714D9B-DFE3-499C-9858-2F58EB78FBDB}"/>
               </a:ext>
             </a:extLst>
           </p:cNvPr>
@@ -11205,7 +11205,7 @@
           <p:cNvPr id="11" name="">
             <a:extLst xmlns:a="http://schemas.openxmlformats.org/drawingml/2006/main">
               <a:ext uri="{FF2B5EF4-FFF2-40B4-BE49-F238E27FC236}">
-                <a16:creationId xmlns:a16="http://schemas.microsoft.com/office/drawing/2014/main" id="{65E77E6C-655B-49C8-AC3E-EDDD2C13CFFB}"/>
+                <a16:creationId xmlns:a16="http://schemas.microsoft.com/office/drawing/2014/main" id="{D307B812-0EC2-4EE0-B8CF-9CB6DD3E54C1}"/>
               </a:ext>
             </a:extLst>
           </p:cNvPr>
@@ -11236,7 +11236,7 @@
           <p:cNvPr id="12" name="">
             <a:extLst xmlns:a="http://schemas.openxmlformats.org/drawingml/2006/main">
               <a:ext uri="{FF2B5EF4-FFF2-40B4-BE49-F238E27FC236}">
-                <a16:creationId xmlns:a16="http://schemas.microsoft.com/office/drawing/2014/main" id="{8DD54F70-07F6-476A-95A7-B2E89A3D8003}"/>
+                <a16:creationId xmlns:a16="http://schemas.microsoft.com/office/drawing/2014/main" id="{F879061F-EF6D-473F-99AE-D4BA095B91ED}"/>
               </a:ext>
             </a:extLst>
           </p:cNvPr>
@@ -11286,7 +11286,7 @@
           <p:cNvPr id="13" name="">
             <a:extLst xmlns:a="http://schemas.openxmlformats.org/drawingml/2006/main">
               <a:ext uri="{FF2B5EF4-FFF2-40B4-BE49-F238E27FC236}">
-                <a16:creationId xmlns:a16="http://schemas.microsoft.com/office/drawing/2014/main" id="{0DCA98D6-AE8A-407F-A076-D5B64239878F}"/>
+                <a16:creationId xmlns:a16="http://schemas.microsoft.com/office/drawing/2014/main" id="{EA0A95A7-5AF6-4D89-ABD1-49199107507F}"/>
               </a:ext>
             </a:extLst>
           </p:cNvPr>
@@ -11336,7 +11336,7 @@
           <p:cNvPr id="14" name="">
             <a:extLst xmlns:a="http://schemas.openxmlformats.org/drawingml/2006/main">
               <a:ext uri="{FF2B5EF4-FFF2-40B4-BE49-F238E27FC236}">
-                <a16:creationId xmlns:a16="http://schemas.microsoft.com/office/drawing/2014/main" id="{467257FD-8684-482F-858B-26EB0BDFEF49}"/>
+                <a16:creationId xmlns:a16="http://schemas.microsoft.com/office/drawing/2014/main" id="{9AD8D046-C0DC-4A3F-8AA1-43368EA5179D}"/>
               </a:ext>
             </a:extLst>
           </p:cNvPr>
@@ -11367,7 +11367,7 @@
           <p:cNvPr id="15" name="">
             <a:extLst xmlns:a="http://schemas.openxmlformats.org/drawingml/2006/main">
               <a:ext uri="{FF2B5EF4-FFF2-40B4-BE49-F238E27FC236}">
-                <a16:creationId xmlns:a16="http://schemas.microsoft.com/office/drawing/2014/main" id="{C31C3627-E2E0-4AB3-8425-E33A2256C2CF}"/>
+                <a16:creationId xmlns:a16="http://schemas.microsoft.com/office/drawing/2014/main" id="{CB222411-9E2A-4045-B6B4-09E37F5FDD99}"/>
               </a:ext>
             </a:extLst>
           </p:cNvPr>
@@ -11417,7 +11417,7 @@
           <p:cNvPr id="16" name="">
             <a:extLst xmlns:a="http://schemas.openxmlformats.org/drawingml/2006/main">
               <a:ext uri="{FF2B5EF4-FFF2-40B4-BE49-F238E27FC236}">
-                <a16:creationId xmlns:a16="http://schemas.microsoft.com/office/drawing/2014/main" id="{28E6F040-BF78-474D-A6CE-70CB5C79D723}"/>
+                <a16:creationId xmlns:a16="http://schemas.microsoft.com/office/drawing/2014/main" id="{B975D8F4-A374-4AA3-95CF-686F61D8D0EB}"/>
               </a:ext>
             </a:extLst>
           </p:cNvPr>
@@ -11467,7 +11467,7 @@
           <p:cNvPr id="17" name="">
             <a:extLst xmlns:a="http://schemas.openxmlformats.org/drawingml/2006/main">
               <a:ext uri="{FF2B5EF4-FFF2-40B4-BE49-F238E27FC236}">
-                <a16:creationId xmlns:a16="http://schemas.microsoft.com/office/drawing/2014/main" id="{AE0ACE27-847A-44F1-80B5-1BF8F268E968}"/>
+                <a16:creationId xmlns:a16="http://schemas.microsoft.com/office/drawing/2014/main" id="{B4661CAC-495C-481E-86D1-C4C28A885D7E}"/>
               </a:ext>
             </a:extLst>
           </p:cNvPr>
@@ -11498,7 +11498,7 @@
           <p:cNvPr id="18" name="">
             <a:extLst xmlns:a="http://schemas.openxmlformats.org/drawingml/2006/main">
               <a:ext uri="{FF2B5EF4-FFF2-40B4-BE49-F238E27FC236}">
-                <a16:creationId xmlns:a16="http://schemas.microsoft.com/office/drawing/2014/main" id="{0D6EE375-39E8-4D0E-9CAF-E6AA396B2238}"/>
+                <a16:creationId xmlns:a16="http://schemas.microsoft.com/office/drawing/2014/main" id="{69B310BE-774D-43DD-8B1B-C3196B0A0EE5}"/>
               </a:ext>
             </a:extLst>
           </p:cNvPr>
@@ -11548,7 +11548,7 @@
           <p:cNvPr id="19" name="">
             <a:extLst xmlns:a="http://schemas.openxmlformats.org/drawingml/2006/main">
               <a:ext uri="{FF2B5EF4-FFF2-40B4-BE49-F238E27FC236}">
-                <a16:creationId xmlns:a16="http://schemas.microsoft.com/office/drawing/2014/main" id="{04F48020-B5D4-4E55-A214-DD64520E8660}"/>
+                <a16:creationId xmlns:a16="http://schemas.microsoft.com/office/drawing/2014/main" id="{BDAB7351-7271-47DA-B0A8-1E5CB6264FF8}"/>
               </a:ext>
             </a:extLst>
           </p:cNvPr>
@@ -11583,7 +11583,7 @@
           <p:nvPr/>
         </p:nvPicPr>
         <p:blipFill>
-          <a:blip xmlns:r="http://schemas.openxmlformats.org/officeDocument/2006/relationships" xmlns:a="http://schemas.openxmlformats.org/drawingml/2006/main" r:embed="R6759dacc0d1c4734"/>
+          <a:blip xmlns:r="http://schemas.openxmlformats.org/officeDocument/2006/relationships" xmlns:a="http://schemas.openxmlformats.org/drawingml/2006/main" r:embed="R36cbd5802fd64502"/>
           <a:stretch xmlns:a="http://schemas.openxmlformats.org/drawingml/2006/main"/>
         </p:blipFill>
         <p:spPr>
@@ -11601,7 +11601,7 @@
           <p:cNvPr id="21" name="">
             <a:extLst xmlns:a="http://schemas.openxmlformats.org/drawingml/2006/main">
               <a:ext uri="{FF2B5EF4-FFF2-40B4-BE49-F238E27FC236}">
-                <a16:creationId xmlns:a16="http://schemas.microsoft.com/office/drawing/2014/main" id="{2364EF8B-4060-4F43-BE49-958D16E6C413}"/>
+                <a16:creationId xmlns:a16="http://schemas.microsoft.com/office/drawing/2014/main" id="{96C556E0-A991-4652-B986-99BE295485E3}"/>
               </a:ext>
             </a:extLst>
           </p:cNvPr>
@@ -11651,7 +11651,7 @@
           <p:cNvPr id="22" name="">
             <a:extLst xmlns:a="http://schemas.openxmlformats.org/drawingml/2006/main">
               <a:ext uri="{FF2B5EF4-FFF2-40B4-BE49-F238E27FC236}">
-                <a16:creationId xmlns:a16="http://schemas.microsoft.com/office/drawing/2014/main" id="{0815BD8D-9C75-41D2-AC3B-B521ECA36ECD}"/>
+                <a16:creationId xmlns:a16="http://schemas.microsoft.com/office/drawing/2014/main" id="{E3D08B0A-797C-4061-B0CF-D1521CF2E4F2}"/>
               </a:ext>
             </a:extLst>
           </p:cNvPr>
@@ -11699,7 +11699,7 @@
     </p:spTree>
     <p:extLst>
       <p:ext uri="{BB962C8B-B14F-4D97-AF65-F5344CB8AC3E}">
-        <p14:creationId xmlns:p14="http://schemas.microsoft.com/office/powerpoint/2010/main" val="1613608530"/>
+        <p14:creationId xmlns:p14="http://schemas.microsoft.com/office/powerpoint/2010/main" val="581742498"/>
       </p:ext>
     </p:extLst>
   </p:cSld>
@@ -11730,7 +11730,7 @@
           <p:cNvPr id="1" name="">
             <a:extLst xmlns:a="http://schemas.openxmlformats.org/drawingml/2006/main">
               <a:ext uri="{FF2B5EF4-FFF2-40B4-BE49-F238E27FC236}">
-                <a16:creationId xmlns:a16="http://schemas.microsoft.com/office/drawing/2014/main" id="{231E0CC9-36F2-4E5C-B56D-20277B62CE67}"/>
+                <a16:creationId xmlns:a16="http://schemas.microsoft.com/office/drawing/2014/main" id="{190F085A-3DE2-440D-AF43-1D3A6CA1BFB5}"/>
               </a:ext>
             </a:extLst>
           </p:cNvPr>
@@ -11761,7 +11761,7 @@
           <p:cNvPr id="2" name="">
             <a:extLst xmlns:a="http://schemas.openxmlformats.org/drawingml/2006/main">
               <a:ext uri="{FF2B5EF4-FFF2-40B4-BE49-F238E27FC236}">
-                <a16:creationId xmlns:a16="http://schemas.microsoft.com/office/drawing/2014/main" id="{875108DF-FD8C-4145-ADEC-9CB07A196A79}"/>
+                <a16:creationId xmlns:a16="http://schemas.microsoft.com/office/drawing/2014/main" id="{D5001C77-A9D2-49AE-9784-9CA8BFCCE5C4}"/>
               </a:ext>
             </a:extLst>
           </p:cNvPr>
@@ -11811,7 +11811,7 @@
           <p:cNvPr id="3" name="">
             <a:extLst xmlns:a="http://schemas.openxmlformats.org/drawingml/2006/main">
               <a:ext uri="{FF2B5EF4-FFF2-40B4-BE49-F238E27FC236}">
-                <a16:creationId xmlns:a16="http://schemas.microsoft.com/office/drawing/2014/main" id="{B0FB2A34-6DAF-4896-AD25-AD111D1ACF77}"/>
+                <a16:creationId xmlns:a16="http://schemas.microsoft.com/office/drawing/2014/main" id="{1A2FC8EC-BEB9-4524-AAB1-7F899CB135CE}"/>
               </a:ext>
             </a:extLst>
           </p:cNvPr>
@@ -11861,7 +11861,7 @@
           <p:cNvPr id="4" name="">
             <a:extLst xmlns:a="http://schemas.openxmlformats.org/drawingml/2006/main">
               <a:ext uri="{FF2B5EF4-FFF2-40B4-BE49-F238E27FC236}">
-                <a16:creationId xmlns:a16="http://schemas.microsoft.com/office/drawing/2014/main" id="{899AFE4E-86E1-4EC1-A44C-788DA2424DBC}"/>
+                <a16:creationId xmlns:a16="http://schemas.microsoft.com/office/drawing/2014/main" id="{A3C6C743-35C5-4DCE-B806-8F569281643B}"/>
               </a:ext>
             </a:extLst>
           </p:cNvPr>
@@ -11896,7 +11896,7 @@
           <p:cNvPr id="5" name="">
             <a:extLst xmlns:a="http://schemas.openxmlformats.org/drawingml/2006/main">
               <a:ext uri="{FF2B5EF4-FFF2-40B4-BE49-F238E27FC236}">
-                <a16:creationId xmlns:a16="http://schemas.microsoft.com/office/drawing/2014/main" id="{311F0607-22BF-449E-BFD1-59E564229B17}"/>
+                <a16:creationId xmlns:a16="http://schemas.microsoft.com/office/drawing/2014/main" id="{0F344989-4D9C-4A2E-9804-4EEE824F3873}"/>
               </a:ext>
             </a:extLst>
           </p:cNvPr>
@@ -11946,7 +11946,7 @@
           <p:cNvPr id="6" name="">
             <a:extLst xmlns:a="http://schemas.openxmlformats.org/drawingml/2006/main">
               <a:ext uri="{FF2B5EF4-FFF2-40B4-BE49-F238E27FC236}">
-                <a16:creationId xmlns:a16="http://schemas.microsoft.com/office/drawing/2014/main" id="{DBDAC530-0773-46DF-8F0C-0C2A00E19E4B}"/>
+                <a16:creationId xmlns:a16="http://schemas.microsoft.com/office/drawing/2014/main" id="{AC65E1D0-CD33-4EB2-9FBD-F52EA46C5612}"/>
               </a:ext>
             </a:extLst>
           </p:cNvPr>
@@ -11977,7 +11977,7 @@
           <p:cNvPr id="7" name="">
             <a:extLst xmlns:a="http://schemas.openxmlformats.org/drawingml/2006/main">
               <a:ext uri="{FF2B5EF4-FFF2-40B4-BE49-F238E27FC236}">
-                <a16:creationId xmlns:a16="http://schemas.microsoft.com/office/drawing/2014/main" id="{2D5F76EB-AF05-4196-843B-251085E57483}"/>
+                <a16:creationId xmlns:a16="http://schemas.microsoft.com/office/drawing/2014/main" id="{C7CD1FB4-78B0-4A1B-9384-46AB8B4A4EE7}"/>
               </a:ext>
             </a:extLst>
           </p:cNvPr>
@@ -12027,7 +12027,7 @@
           <p:cNvPr id="8" name="">
             <a:extLst xmlns:a="http://schemas.openxmlformats.org/drawingml/2006/main">
               <a:ext uri="{FF2B5EF4-FFF2-40B4-BE49-F238E27FC236}">
-                <a16:creationId xmlns:a16="http://schemas.microsoft.com/office/drawing/2014/main" id="{4E3D12A7-25EA-4281-9645-3F42CAFFD0B6}"/>
+                <a16:creationId xmlns:a16="http://schemas.microsoft.com/office/drawing/2014/main" id="{4611E088-7FD5-4506-A093-443C872519A2}"/>
               </a:ext>
             </a:extLst>
           </p:cNvPr>
@@ -12058,7 +12058,7 @@
           <p:cNvPr id="9" name="">
             <a:extLst xmlns:a="http://schemas.openxmlformats.org/drawingml/2006/main">
               <a:ext uri="{FF2B5EF4-FFF2-40B4-BE49-F238E27FC236}">
-                <a16:creationId xmlns:a16="http://schemas.microsoft.com/office/drawing/2014/main" id="{173FFFF1-45CA-48AF-8111-5430D7F1AE78}"/>
+                <a16:creationId xmlns:a16="http://schemas.microsoft.com/office/drawing/2014/main" id="{F3FD0E49-53DE-4E50-9D05-66EB395C889A}"/>
               </a:ext>
             </a:extLst>
           </p:cNvPr>
@@ -12108,7 +12108,7 @@
           <p:cNvPr id="10" name="">
             <a:extLst xmlns:a="http://schemas.openxmlformats.org/drawingml/2006/main">
               <a:ext uri="{FF2B5EF4-FFF2-40B4-BE49-F238E27FC236}">
-                <a16:creationId xmlns:a16="http://schemas.microsoft.com/office/drawing/2014/main" id="{8B317475-ABAC-48BB-8131-79E3EE3F58E4}"/>
+                <a16:creationId xmlns:a16="http://schemas.microsoft.com/office/drawing/2014/main" id="{7A0DA452-A73D-49B1-B406-853A042DC130}"/>
               </a:ext>
             </a:extLst>
           </p:cNvPr>
@@ -12139,7 +12139,7 @@
           <p:cNvPr id="11" name="">
             <a:extLst xmlns:a="http://schemas.openxmlformats.org/drawingml/2006/main">
               <a:ext uri="{FF2B5EF4-FFF2-40B4-BE49-F238E27FC236}">
-                <a16:creationId xmlns:a16="http://schemas.microsoft.com/office/drawing/2014/main" id="{FE628BE9-4BE4-4AD6-88D3-C6EFD72E3AD3}"/>
+                <a16:creationId xmlns:a16="http://schemas.microsoft.com/office/drawing/2014/main" id="{0EE10C3E-E58D-499F-A214-B0208EECC4AD}"/>
               </a:ext>
             </a:extLst>
           </p:cNvPr>
@@ -12189,7 +12189,7 @@
           <p:cNvPr id="12" name="">
             <a:extLst xmlns:a="http://schemas.openxmlformats.org/drawingml/2006/main">
               <a:ext uri="{FF2B5EF4-FFF2-40B4-BE49-F238E27FC236}">
-                <a16:creationId xmlns:a16="http://schemas.microsoft.com/office/drawing/2014/main" id="{2109A5AD-38A8-4378-BBFE-3B0146CF4269}"/>
+                <a16:creationId xmlns:a16="http://schemas.microsoft.com/office/drawing/2014/main" id="{5775C72B-0DF3-49CF-8B96-A80F5B372934}"/>
               </a:ext>
             </a:extLst>
           </p:cNvPr>
@@ -12224,7 +12224,7 @@
           <p:cNvPr id="13" name="">
             <a:extLst xmlns:a="http://schemas.openxmlformats.org/drawingml/2006/main">
               <a:ext uri="{FF2B5EF4-FFF2-40B4-BE49-F238E27FC236}">
-                <a16:creationId xmlns:a16="http://schemas.microsoft.com/office/drawing/2014/main" id="{E120A711-F04C-4568-97E7-D6DAEB5C0BCF}"/>
+                <a16:creationId xmlns:a16="http://schemas.microsoft.com/office/drawing/2014/main" id="{AFB756EB-7829-4E0B-A82F-C8D25429CEE6}"/>
               </a:ext>
             </a:extLst>
           </p:cNvPr>
@@ -12274,7 +12274,7 @@
           <p:cNvPr id="14" name="">
             <a:extLst xmlns:a="http://schemas.openxmlformats.org/drawingml/2006/main">
               <a:ext uri="{FF2B5EF4-FFF2-40B4-BE49-F238E27FC236}">
-                <a16:creationId xmlns:a16="http://schemas.microsoft.com/office/drawing/2014/main" id="{C312A1CF-7C8B-4ABE-BC6D-ED06FD0684C3}"/>
+                <a16:creationId xmlns:a16="http://schemas.microsoft.com/office/drawing/2014/main" id="{BB9DE928-D925-4D71-9ADC-9E6F7F46EDB6}"/>
               </a:ext>
             </a:extLst>
           </p:cNvPr>
@@ -12305,7 +12305,7 @@
           <p:cNvPr id="15" name="">
             <a:extLst xmlns:a="http://schemas.openxmlformats.org/drawingml/2006/main">
               <a:ext uri="{FF2B5EF4-FFF2-40B4-BE49-F238E27FC236}">
-                <a16:creationId xmlns:a16="http://schemas.microsoft.com/office/drawing/2014/main" id="{9981FF3C-83CB-44F5-9CC6-241FF363845F}"/>
+                <a16:creationId xmlns:a16="http://schemas.microsoft.com/office/drawing/2014/main" id="{95587C15-2482-4829-BC19-69436B98D8D4}"/>
               </a:ext>
             </a:extLst>
           </p:cNvPr>
@@ -12355,7 +12355,7 @@
           <p:cNvPr id="16" name="">
             <a:extLst xmlns:a="http://schemas.openxmlformats.org/drawingml/2006/main">
               <a:ext uri="{FF2B5EF4-FFF2-40B4-BE49-F238E27FC236}">
-                <a16:creationId xmlns:a16="http://schemas.microsoft.com/office/drawing/2014/main" id="{EE751B24-F603-42D3-A074-40FC48280F6E}"/>
+                <a16:creationId xmlns:a16="http://schemas.microsoft.com/office/drawing/2014/main" id="{003CB83C-7C78-4B1D-8FD2-50CB40E301A6}"/>
               </a:ext>
             </a:extLst>
           </p:cNvPr>
@@ -12386,7 +12386,7 @@
           <p:cNvPr id="17" name="">
             <a:extLst xmlns:a="http://schemas.openxmlformats.org/drawingml/2006/main">
               <a:ext uri="{FF2B5EF4-FFF2-40B4-BE49-F238E27FC236}">
-                <a16:creationId xmlns:a16="http://schemas.microsoft.com/office/drawing/2014/main" id="{FB6CC5CE-A52E-4158-9882-C022284103FF}"/>
+                <a16:creationId xmlns:a16="http://schemas.microsoft.com/office/drawing/2014/main" id="{D4B3DB5D-0D1A-42EA-BAE4-A5AACB8DFDC8}"/>
               </a:ext>
             </a:extLst>
           </p:cNvPr>
@@ -12436,7 +12436,7 @@
           <p:cNvPr id="18" name="">
             <a:extLst xmlns:a="http://schemas.openxmlformats.org/drawingml/2006/main">
               <a:ext uri="{FF2B5EF4-FFF2-40B4-BE49-F238E27FC236}">
-                <a16:creationId xmlns:a16="http://schemas.microsoft.com/office/drawing/2014/main" id="{7383116D-AC50-4678-99EE-B7DA6DF62140}"/>
+                <a16:creationId xmlns:a16="http://schemas.microsoft.com/office/drawing/2014/main" id="{64C7A414-B5A0-4A87-A9B8-11CE6CCC07F9}"/>
               </a:ext>
             </a:extLst>
           </p:cNvPr>
@@ -12467,7 +12467,7 @@
           <p:cNvPr id="19" name="">
             <a:extLst xmlns:a="http://schemas.openxmlformats.org/drawingml/2006/main">
               <a:ext uri="{FF2B5EF4-FFF2-40B4-BE49-F238E27FC236}">
-                <a16:creationId xmlns:a16="http://schemas.microsoft.com/office/drawing/2014/main" id="{8E307CDA-0C01-4507-BFF5-3A3A01E684A7}"/>
+                <a16:creationId xmlns:a16="http://schemas.microsoft.com/office/drawing/2014/main" id="{E9F168FB-D555-41AC-9461-220773EF047B}"/>
               </a:ext>
             </a:extLst>
           </p:cNvPr>
@@ -12517,7 +12517,7 @@
           <p:cNvPr id="20" name="">
             <a:extLst xmlns:a="http://schemas.openxmlformats.org/drawingml/2006/main">
               <a:ext uri="{FF2B5EF4-FFF2-40B4-BE49-F238E27FC236}">
-                <a16:creationId xmlns:a16="http://schemas.microsoft.com/office/drawing/2014/main" id="{3D9F3BAA-8220-447F-BD7B-1CA04F08E85D}"/>
+                <a16:creationId xmlns:a16="http://schemas.microsoft.com/office/drawing/2014/main" id="{50810325-E21B-4E1E-986C-E8BE4AEBAC4E}"/>
               </a:ext>
             </a:extLst>
           </p:cNvPr>
@@ -12552,7 +12552,7 @@
           <p:cNvPr id="21" name="">
             <a:extLst xmlns:a="http://schemas.openxmlformats.org/drawingml/2006/main">
               <a:ext uri="{FF2B5EF4-FFF2-40B4-BE49-F238E27FC236}">
-                <a16:creationId xmlns:a16="http://schemas.microsoft.com/office/drawing/2014/main" id="{275029A4-FA4D-49B9-83AF-29C72D99FA74}"/>
+                <a16:creationId xmlns:a16="http://schemas.microsoft.com/office/drawing/2014/main" id="{271BFE94-4BBB-4B6D-8865-23F0A069974E}"/>
               </a:ext>
             </a:extLst>
           </p:cNvPr>
@@ -12602,7 +12602,7 @@
           <p:cNvPr id="22" name="">
             <a:extLst xmlns:a="http://schemas.openxmlformats.org/drawingml/2006/main">
               <a:ext uri="{FF2B5EF4-FFF2-40B4-BE49-F238E27FC236}">
-                <a16:creationId xmlns:a16="http://schemas.microsoft.com/office/drawing/2014/main" id="{C33161BD-09D9-4FC2-A6AB-D335C168C56A}"/>
+                <a16:creationId xmlns:a16="http://schemas.microsoft.com/office/drawing/2014/main" id="{426AC53B-977B-453C-B974-ACCC6FA78DCA}"/>
               </a:ext>
             </a:extLst>
           </p:cNvPr>
@@ -12633,7 +12633,7 @@
           <p:cNvPr id="23" name="">
             <a:extLst xmlns:a="http://schemas.openxmlformats.org/drawingml/2006/main">
               <a:ext uri="{FF2B5EF4-FFF2-40B4-BE49-F238E27FC236}">
-                <a16:creationId xmlns:a16="http://schemas.microsoft.com/office/drawing/2014/main" id="{61FD76D0-0686-493E-AB9C-FD4604C06233}"/>
+                <a16:creationId xmlns:a16="http://schemas.microsoft.com/office/drawing/2014/main" id="{F8F3AAFF-6B63-47C8-804B-A27EF4FFE752}"/>
               </a:ext>
             </a:extLst>
           </p:cNvPr>
@@ -12683,7 +12683,7 @@
           <p:cNvPr id="24" name="">
             <a:extLst xmlns:a="http://schemas.openxmlformats.org/drawingml/2006/main">
               <a:ext uri="{FF2B5EF4-FFF2-40B4-BE49-F238E27FC236}">
-                <a16:creationId xmlns:a16="http://schemas.microsoft.com/office/drawing/2014/main" id="{623F5334-6109-4E62-8E06-349CCAF9AA79}"/>
+                <a16:creationId xmlns:a16="http://schemas.microsoft.com/office/drawing/2014/main" id="{F73AFC44-8DBB-4C1E-B469-A0419411FA1B}"/>
               </a:ext>
             </a:extLst>
           </p:cNvPr>
@@ -12714,7 +12714,7 @@
           <p:cNvPr id="25" name="">
             <a:extLst xmlns:a="http://schemas.openxmlformats.org/drawingml/2006/main">
               <a:ext uri="{FF2B5EF4-FFF2-40B4-BE49-F238E27FC236}">
-                <a16:creationId xmlns:a16="http://schemas.microsoft.com/office/drawing/2014/main" id="{FF7F2362-BECD-49E7-8678-14C0038FFE59}"/>
+                <a16:creationId xmlns:a16="http://schemas.microsoft.com/office/drawing/2014/main" id="{22A5A021-F6BE-41C9-9767-7AF35AD5DA6D}"/>
               </a:ext>
             </a:extLst>
           </p:cNvPr>
@@ -12764,7 +12764,7 @@
           <p:cNvPr id="26" name="">
             <a:extLst xmlns:a="http://schemas.openxmlformats.org/drawingml/2006/main">
               <a:ext uri="{FF2B5EF4-FFF2-40B4-BE49-F238E27FC236}">
-                <a16:creationId xmlns:a16="http://schemas.microsoft.com/office/drawing/2014/main" id="{0A5C4307-14E0-46F2-88FE-2C93D2B53578}"/>
+                <a16:creationId xmlns:a16="http://schemas.microsoft.com/office/drawing/2014/main" id="{EDB203DB-5081-4E18-BB0C-86510FFCEEA0}"/>
               </a:ext>
             </a:extLst>
           </p:cNvPr>
@@ -12795,7 +12795,7 @@
           <p:cNvPr id="27" name="">
             <a:extLst xmlns:a="http://schemas.openxmlformats.org/drawingml/2006/main">
               <a:ext uri="{FF2B5EF4-FFF2-40B4-BE49-F238E27FC236}">
-                <a16:creationId xmlns:a16="http://schemas.microsoft.com/office/drawing/2014/main" id="{3F4C450A-936E-43BF-AA11-F57F6F66E9D0}"/>
+                <a16:creationId xmlns:a16="http://schemas.microsoft.com/office/drawing/2014/main" id="{2E51D271-80E8-4EE9-83BC-A521B58FF934}"/>
               </a:ext>
             </a:extLst>
           </p:cNvPr>
@@ -12845,7 +12845,7 @@
           <p:cNvPr id="28" name="">
             <a:extLst xmlns:a="http://schemas.openxmlformats.org/drawingml/2006/main">
               <a:ext uri="{FF2B5EF4-FFF2-40B4-BE49-F238E27FC236}">
-                <a16:creationId xmlns:a16="http://schemas.microsoft.com/office/drawing/2014/main" id="{160FC0C7-2F8F-4001-B626-24DD40341A57}"/>
+                <a16:creationId xmlns:a16="http://schemas.microsoft.com/office/drawing/2014/main" id="{446057EF-C807-4103-B4D9-0F68DC815CF5}"/>
               </a:ext>
             </a:extLst>
           </p:cNvPr>
@@ -12880,7 +12880,7 @@
           <p:cNvPr id="29" name="">
             <a:extLst xmlns:a="http://schemas.openxmlformats.org/drawingml/2006/main">
               <a:ext uri="{FF2B5EF4-FFF2-40B4-BE49-F238E27FC236}">
-                <a16:creationId xmlns:a16="http://schemas.microsoft.com/office/drawing/2014/main" id="{C628AFE7-2375-4CB7-9468-BC7C131F4A82}"/>
+                <a16:creationId xmlns:a16="http://schemas.microsoft.com/office/drawing/2014/main" id="{EC7824AC-75CD-4FE5-8DF1-5013F0622101}"/>
               </a:ext>
             </a:extLst>
           </p:cNvPr>
@@ -12930,7 +12930,7 @@
           <p:cNvPr id="30" name="">
             <a:extLst xmlns:a="http://schemas.openxmlformats.org/drawingml/2006/main">
               <a:ext uri="{FF2B5EF4-FFF2-40B4-BE49-F238E27FC236}">
-                <a16:creationId xmlns:a16="http://schemas.microsoft.com/office/drawing/2014/main" id="{04BDC41F-0FDE-46F3-8BDB-9DF99CDE37B3}"/>
+                <a16:creationId xmlns:a16="http://schemas.microsoft.com/office/drawing/2014/main" id="{1A3BDA2C-282B-4321-A8C9-9C110362C3A2}"/>
               </a:ext>
             </a:extLst>
           </p:cNvPr>
@@ -12961,7 +12961,7 @@
           <p:cNvPr id="31" name="">
             <a:extLst xmlns:a="http://schemas.openxmlformats.org/drawingml/2006/main">
               <a:ext uri="{FF2B5EF4-FFF2-40B4-BE49-F238E27FC236}">
-                <a16:creationId xmlns:a16="http://schemas.microsoft.com/office/drawing/2014/main" id="{6BECC75A-66BD-45AD-853D-445B07FCE4E0}"/>
+                <a16:creationId xmlns:a16="http://schemas.microsoft.com/office/drawing/2014/main" id="{CA36C47C-BB36-49A0-A920-52F242678CA6}"/>
               </a:ext>
             </a:extLst>
           </p:cNvPr>
@@ -13011,7 +13011,7 @@
           <p:cNvPr id="32" name="">
             <a:extLst xmlns:a="http://schemas.openxmlformats.org/drawingml/2006/main">
               <a:ext uri="{FF2B5EF4-FFF2-40B4-BE49-F238E27FC236}">
-                <a16:creationId xmlns:a16="http://schemas.microsoft.com/office/drawing/2014/main" id="{B15B9AF1-22F5-4037-B048-A132530EFF5C}"/>
+                <a16:creationId xmlns:a16="http://schemas.microsoft.com/office/drawing/2014/main" id="{16429F2E-C57E-4D6B-A65B-ADFB675FC279}"/>
               </a:ext>
             </a:extLst>
           </p:cNvPr>
@@ -13042,7 +13042,7 @@
           <p:cNvPr id="33" name="">
             <a:extLst xmlns:a="http://schemas.openxmlformats.org/drawingml/2006/main">
               <a:ext uri="{FF2B5EF4-FFF2-40B4-BE49-F238E27FC236}">
-                <a16:creationId xmlns:a16="http://schemas.microsoft.com/office/drawing/2014/main" id="{35BC5EA1-3DB9-4680-9397-2B000562B51E}"/>
+                <a16:creationId xmlns:a16="http://schemas.microsoft.com/office/drawing/2014/main" id="{511B82FE-9A1B-431E-8041-C652558D4E59}"/>
               </a:ext>
             </a:extLst>
           </p:cNvPr>
@@ -13092,7 +13092,7 @@
           <p:cNvPr id="34" name="">
             <a:extLst xmlns:a="http://schemas.openxmlformats.org/drawingml/2006/main">
               <a:ext uri="{FF2B5EF4-FFF2-40B4-BE49-F238E27FC236}">
-                <a16:creationId xmlns:a16="http://schemas.microsoft.com/office/drawing/2014/main" id="{15259D86-F94D-4D22-A1B1-50203AD2D766}"/>
+                <a16:creationId xmlns:a16="http://schemas.microsoft.com/office/drawing/2014/main" id="{9898B525-4418-492A-9EB8-7F9E66BD2292}"/>
               </a:ext>
             </a:extLst>
           </p:cNvPr>
@@ -13123,7 +13123,7 @@
           <p:cNvPr id="35" name="">
             <a:extLst xmlns:a="http://schemas.openxmlformats.org/drawingml/2006/main">
               <a:ext uri="{FF2B5EF4-FFF2-40B4-BE49-F238E27FC236}">
-                <a16:creationId xmlns:a16="http://schemas.microsoft.com/office/drawing/2014/main" id="{B9ACCD11-C189-4BB4-AA4D-25AECE5B6806}"/>
+                <a16:creationId xmlns:a16="http://schemas.microsoft.com/office/drawing/2014/main" id="{9EBAC24B-229D-41E9-A369-257058376FD0}"/>
               </a:ext>
             </a:extLst>
           </p:cNvPr>
@@ -13173,7 +13173,7 @@
           <p:cNvPr id="36" name="">
             <a:extLst xmlns:a="http://schemas.openxmlformats.org/drawingml/2006/main">
               <a:ext uri="{FF2B5EF4-FFF2-40B4-BE49-F238E27FC236}">
-                <a16:creationId xmlns:a16="http://schemas.microsoft.com/office/drawing/2014/main" id="{A556DCBF-4DAA-4CE1-83AB-C4216B9BAF82}"/>
+                <a16:creationId xmlns:a16="http://schemas.microsoft.com/office/drawing/2014/main" id="{4F8A330A-637A-4677-9A29-5ABD6DC47567}"/>
               </a:ext>
             </a:extLst>
           </p:cNvPr>
@@ -13208,7 +13208,7 @@
           <p:nvPr/>
         </p:nvPicPr>
         <p:blipFill>
-          <a:blip xmlns:r="http://schemas.openxmlformats.org/officeDocument/2006/relationships" xmlns:a="http://schemas.openxmlformats.org/drawingml/2006/main" r:embed="R49e0895385b342b8"/>
+          <a:blip xmlns:r="http://schemas.openxmlformats.org/officeDocument/2006/relationships" xmlns:a="http://schemas.openxmlformats.org/drawingml/2006/main" r:embed="Rc3f5b3035c944328"/>
           <a:stretch xmlns:a="http://schemas.openxmlformats.org/drawingml/2006/main"/>
         </p:blipFill>
         <p:spPr>
@@ -13226,7 +13226,7 @@
           <p:cNvPr id="38" name="">
             <a:extLst xmlns:a="http://schemas.openxmlformats.org/drawingml/2006/main">
               <a:ext uri="{FF2B5EF4-FFF2-40B4-BE49-F238E27FC236}">
-                <a16:creationId xmlns:a16="http://schemas.microsoft.com/office/drawing/2014/main" id="{9F210B6B-853B-4805-A9BF-A78D2800D89F}"/>
+                <a16:creationId xmlns:a16="http://schemas.microsoft.com/office/drawing/2014/main" id="{EF5F997F-FB4E-45C6-84DA-D7300D79E18D}"/>
               </a:ext>
             </a:extLst>
           </p:cNvPr>
@@ -13276,7 +13276,7 @@
           <p:cNvPr id="39" name="">
             <a:extLst xmlns:a="http://schemas.openxmlformats.org/drawingml/2006/main">
               <a:ext uri="{FF2B5EF4-FFF2-40B4-BE49-F238E27FC236}">
-                <a16:creationId xmlns:a16="http://schemas.microsoft.com/office/drawing/2014/main" id="{8C69E982-9733-4D04-B8BC-EB965CB14FF9}"/>
+                <a16:creationId xmlns:a16="http://schemas.microsoft.com/office/drawing/2014/main" id="{EDA9A3BA-96AE-42D6-885B-29D8DD3ACAB1}"/>
               </a:ext>
             </a:extLst>
           </p:cNvPr>
@@ -13324,7 +13324,7 @@
     </p:spTree>
     <p:extLst>
       <p:ext uri="{BB962C8B-B14F-4D97-AF65-F5344CB8AC3E}">
-        <p14:creationId xmlns:p14="http://schemas.microsoft.com/office/powerpoint/2010/main" val="422993195"/>
+        <p14:creationId xmlns:p14="http://schemas.microsoft.com/office/powerpoint/2010/main" val="920469634"/>
       </p:ext>
     </p:extLst>
   </p:cSld>
@@ -13355,7 +13355,7 @@
           <p:cNvPr id="1" name="">
             <a:extLst xmlns:a="http://schemas.openxmlformats.org/drawingml/2006/main">
               <a:ext uri="{FF2B5EF4-FFF2-40B4-BE49-F238E27FC236}">
-                <a16:creationId xmlns:a16="http://schemas.microsoft.com/office/drawing/2014/main" id="{EAD827A8-AB68-4A39-B1FB-3637954090D8}"/>
+                <a16:creationId xmlns:a16="http://schemas.microsoft.com/office/drawing/2014/main" id="{C66EF3EB-F867-4A6F-810C-E0AFEB8E7201}"/>
               </a:ext>
             </a:extLst>
           </p:cNvPr>
@@ -13386,7 +13386,7 @@
           <p:cNvPr id="2" name="">
             <a:extLst xmlns:a="http://schemas.openxmlformats.org/drawingml/2006/main">
               <a:ext uri="{FF2B5EF4-FFF2-40B4-BE49-F238E27FC236}">
-                <a16:creationId xmlns:a16="http://schemas.microsoft.com/office/drawing/2014/main" id="{92B864C3-C486-4411-883B-A325D262DFBA}"/>
+                <a16:creationId xmlns:a16="http://schemas.microsoft.com/office/drawing/2014/main" id="{AFAE1EE1-5E0B-44A2-81A6-DBB548225863}"/>
               </a:ext>
             </a:extLst>
           </p:cNvPr>
@@ -13436,7 +13436,7 @@
           <p:cNvPr id="3" name="">
             <a:extLst xmlns:a="http://schemas.openxmlformats.org/drawingml/2006/main">
               <a:ext uri="{FF2B5EF4-FFF2-40B4-BE49-F238E27FC236}">
-                <a16:creationId xmlns:a16="http://schemas.microsoft.com/office/drawing/2014/main" id="{06C629B2-7E55-4BDF-9F79-8D536448D8E0}"/>
+                <a16:creationId xmlns:a16="http://schemas.microsoft.com/office/drawing/2014/main" id="{6A614D2C-AF75-462E-833A-F768F1D2A0D7}"/>
               </a:ext>
             </a:extLst>
           </p:cNvPr>
@@ -13486,7 +13486,7 @@
           <p:cNvPr id="4" name="">
             <a:extLst xmlns:a="http://schemas.openxmlformats.org/drawingml/2006/main">
               <a:ext uri="{FF2B5EF4-FFF2-40B4-BE49-F238E27FC236}">
-                <a16:creationId xmlns:a16="http://schemas.microsoft.com/office/drawing/2014/main" id="{995DDBAB-1595-4F4E-B02C-7AA736619C98}"/>
+                <a16:creationId xmlns:a16="http://schemas.microsoft.com/office/drawing/2014/main" id="{56FFF396-259D-421A-A411-E564F7197E1B}"/>
               </a:ext>
             </a:extLst>
           </p:cNvPr>
@@ -13521,7 +13521,7 @@
           <p:cNvPr id="5" name="">
             <a:extLst xmlns:a="http://schemas.openxmlformats.org/drawingml/2006/main">
               <a:ext uri="{FF2B5EF4-FFF2-40B4-BE49-F238E27FC236}">
-                <a16:creationId xmlns:a16="http://schemas.microsoft.com/office/drawing/2014/main" id="{C154A1F5-EAF9-403F-A711-DDDF7E67181A}"/>
+                <a16:creationId xmlns:a16="http://schemas.microsoft.com/office/drawing/2014/main" id="{7B6543FB-3728-4526-8A75-5F6DA9F234A6}"/>
               </a:ext>
             </a:extLst>
           </p:cNvPr>
@@ -13571,7 +13571,7 @@
           <p:cNvPr id="6" name="">
             <a:extLst xmlns:a="http://schemas.openxmlformats.org/drawingml/2006/main">
               <a:ext uri="{FF2B5EF4-FFF2-40B4-BE49-F238E27FC236}">
-                <a16:creationId xmlns:a16="http://schemas.microsoft.com/office/drawing/2014/main" id="{FE3795C4-2B5F-46E4-A788-847B4AD04456}"/>
+                <a16:creationId xmlns:a16="http://schemas.microsoft.com/office/drawing/2014/main" id="{A83AC7B1-5BB8-4F6C-B3D8-A0515E93FEE7}"/>
               </a:ext>
             </a:extLst>
           </p:cNvPr>
@@ -13621,7 +13621,7 @@
           <p:cNvPr id="7" name="">
             <a:extLst xmlns:a="http://schemas.openxmlformats.org/drawingml/2006/main">
               <a:ext uri="{FF2B5EF4-FFF2-40B4-BE49-F238E27FC236}">
-                <a16:creationId xmlns:a16="http://schemas.microsoft.com/office/drawing/2014/main" id="{C9E94826-B0E0-44DE-B91D-873386C06A63}"/>
+                <a16:creationId xmlns:a16="http://schemas.microsoft.com/office/drawing/2014/main" id="{621CFDEE-27CF-43A5-BFE3-B23E27F8DF8E}"/>
               </a:ext>
             </a:extLst>
           </p:cNvPr>
@@ -13656,7 +13656,7 @@
           <p:cNvPr id="8" name="">
             <a:extLst xmlns:a="http://schemas.openxmlformats.org/drawingml/2006/main">
               <a:ext uri="{FF2B5EF4-FFF2-40B4-BE49-F238E27FC236}">
-                <a16:creationId xmlns:a16="http://schemas.microsoft.com/office/drawing/2014/main" id="{260B57BF-4078-4FB3-9ACC-153500A01162}"/>
+                <a16:creationId xmlns:a16="http://schemas.microsoft.com/office/drawing/2014/main" id="{19BEF3F5-754E-41E1-8747-BE05F165BD82}"/>
               </a:ext>
             </a:extLst>
           </p:cNvPr>
@@ -13706,7 +13706,7 @@
           <p:cNvPr id="9" name="">
             <a:extLst xmlns:a="http://schemas.openxmlformats.org/drawingml/2006/main">
               <a:ext uri="{FF2B5EF4-FFF2-40B4-BE49-F238E27FC236}">
-                <a16:creationId xmlns:a16="http://schemas.microsoft.com/office/drawing/2014/main" id="{8B8D91D6-427A-4742-A6D4-EC921A192272}"/>
+                <a16:creationId xmlns:a16="http://schemas.microsoft.com/office/drawing/2014/main" id="{02A0AC4D-4F61-412D-A9E1-51302E1E4572}"/>
               </a:ext>
             </a:extLst>
           </p:cNvPr>
@@ -13746,7 +13746,7 @@
                   <a:srgbClr val="1F2933"/>
                 </a:solidFill>
               </a:rPr>
-              <a:t>Mac Intel x64、Mac Apple Silicon arm64、Windows x64 均已有 0.1.0 构建产物。</a:t>
+              <a:t>Mac Intel x64、Mac Apple Silicon arm64、Windows x64 均已有 0.1.1 同源构建产物。</a:t>
             </a:r>
           </a:p>
         </p:txBody>
@@ -13756,7 +13756,7 @@
           <p:cNvPr id="10" name="">
             <a:extLst xmlns:a="http://schemas.openxmlformats.org/drawingml/2006/main">
               <a:ext uri="{FF2B5EF4-FFF2-40B4-BE49-F238E27FC236}">
-                <a16:creationId xmlns:a16="http://schemas.microsoft.com/office/drawing/2014/main" id="{BAD968EB-2845-4F51-8817-E2DCFB3F8B54}"/>
+                <a16:creationId xmlns:a16="http://schemas.microsoft.com/office/drawing/2014/main" id="{2C2B88CB-91E7-4AEC-A441-C64106D1D8F0}"/>
               </a:ext>
             </a:extLst>
           </p:cNvPr>
@@ -13791,7 +13791,7 @@
           <p:cNvPr id="11" name="">
             <a:extLst xmlns:a="http://schemas.openxmlformats.org/drawingml/2006/main">
               <a:ext uri="{FF2B5EF4-FFF2-40B4-BE49-F238E27FC236}">
-                <a16:creationId xmlns:a16="http://schemas.microsoft.com/office/drawing/2014/main" id="{7711D42E-467E-49EE-ADB7-EE0617079C0B}"/>
+                <a16:creationId xmlns:a16="http://schemas.microsoft.com/office/drawing/2014/main" id="{8C5A2E5C-2C95-4193-8EBD-8DC4A67DF920}"/>
               </a:ext>
             </a:extLst>
           </p:cNvPr>
@@ -13841,7 +13841,7 @@
           <p:cNvPr id="12" name="">
             <a:extLst xmlns:a="http://schemas.openxmlformats.org/drawingml/2006/main">
               <a:ext uri="{FF2B5EF4-FFF2-40B4-BE49-F238E27FC236}">
-                <a16:creationId xmlns:a16="http://schemas.microsoft.com/office/drawing/2014/main" id="{19905B85-971B-4785-98E1-3CCA2AC06A37}"/>
+                <a16:creationId xmlns:a16="http://schemas.microsoft.com/office/drawing/2014/main" id="{5FFFA941-23D6-4D82-B4B3-4BDF46B98091}"/>
               </a:ext>
             </a:extLst>
           </p:cNvPr>
@@ -13891,7 +13891,7 @@
           <p:cNvPr id="13" name="">
             <a:extLst xmlns:a="http://schemas.openxmlformats.org/drawingml/2006/main">
               <a:ext uri="{FF2B5EF4-FFF2-40B4-BE49-F238E27FC236}">
-                <a16:creationId xmlns:a16="http://schemas.microsoft.com/office/drawing/2014/main" id="{0B2C6511-1C16-4A81-B8B0-BE39EC4BC569}"/>
+                <a16:creationId xmlns:a16="http://schemas.microsoft.com/office/drawing/2014/main" id="{F0F1B6E0-8DC0-446B-9DF1-1D4DFA7A0BA9}"/>
               </a:ext>
             </a:extLst>
           </p:cNvPr>
@@ -13926,7 +13926,7 @@
           <p:cNvPr id="14" name="">
             <a:extLst xmlns:a="http://schemas.openxmlformats.org/drawingml/2006/main">
               <a:ext uri="{FF2B5EF4-FFF2-40B4-BE49-F238E27FC236}">
-                <a16:creationId xmlns:a16="http://schemas.microsoft.com/office/drawing/2014/main" id="{1B45A1DA-2AFE-4DA4-85EA-DBEA83646393}"/>
+                <a16:creationId xmlns:a16="http://schemas.microsoft.com/office/drawing/2014/main" id="{BCBFF5E6-1097-4E5D-BFFF-B7A0FC7A7363}"/>
               </a:ext>
             </a:extLst>
           </p:cNvPr>
@@ -13976,7 +13976,7 @@
           <p:cNvPr id="15" name="">
             <a:extLst xmlns:a="http://schemas.openxmlformats.org/drawingml/2006/main">
               <a:ext uri="{FF2B5EF4-FFF2-40B4-BE49-F238E27FC236}">
-                <a16:creationId xmlns:a16="http://schemas.microsoft.com/office/drawing/2014/main" id="{C472A4B5-8297-44C7-AF69-9F8EFF61C793}"/>
+                <a16:creationId xmlns:a16="http://schemas.microsoft.com/office/drawing/2014/main" id="{6C272533-4743-4673-BF1B-E28A7DE6BAA3}"/>
               </a:ext>
             </a:extLst>
           </p:cNvPr>
@@ -14026,7 +14026,7 @@
           <p:cNvPr id="16" name="">
             <a:extLst xmlns:a="http://schemas.openxmlformats.org/drawingml/2006/main">
               <a:ext uri="{FF2B5EF4-FFF2-40B4-BE49-F238E27FC236}">
-                <a16:creationId xmlns:a16="http://schemas.microsoft.com/office/drawing/2014/main" id="{ABF2A7C8-AFF3-4E67-8FDB-5E738E1DB3EA}"/>
+                <a16:creationId xmlns:a16="http://schemas.microsoft.com/office/drawing/2014/main" id="{7891ABC6-3DB7-45AE-93BA-68AB91777011}"/>
               </a:ext>
             </a:extLst>
           </p:cNvPr>
@@ -14061,7 +14061,7 @@
           <p:nvPr/>
         </p:nvPicPr>
         <p:blipFill>
-          <a:blip xmlns:r="http://schemas.openxmlformats.org/officeDocument/2006/relationships" xmlns:a="http://schemas.openxmlformats.org/drawingml/2006/main" r:embed="R5dace8200dfc4253"/>
+          <a:blip xmlns:r="http://schemas.openxmlformats.org/officeDocument/2006/relationships" xmlns:a="http://schemas.openxmlformats.org/drawingml/2006/main" r:embed="R9f1483f368e7469b"/>
           <a:stretch xmlns:a="http://schemas.openxmlformats.org/drawingml/2006/main"/>
         </p:blipFill>
         <p:spPr>
@@ -14079,7 +14079,7 @@
           <p:cNvPr id="18" name="">
             <a:extLst xmlns:a="http://schemas.openxmlformats.org/drawingml/2006/main">
               <a:ext uri="{FF2B5EF4-FFF2-40B4-BE49-F238E27FC236}">
-                <a16:creationId xmlns:a16="http://schemas.microsoft.com/office/drawing/2014/main" id="{3B2AB0E7-F9C1-46FE-A73C-DA117C25764C}"/>
+                <a16:creationId xmlns:a16="http://schemas.microsoft.com/office/drawing/2014/main" id="{25E9F723-8AC2-4226-9A30-4D4B65964902}"/>
               </a:ext>
             </a:extLst>
           </p:cNvPr>
@@ -14129,7 +14129,7 @@
           <p:cNvPr id="19" name="">
             <a:extLst xmlns:a="http://schemas.openxmlformats.org/drawingml/2006/main">
               <a:ext uri="{FF2B5EF4-FFF2-40B4-BE49-F238E27FC236}">
-                <a16:creationId xmlns:a16="http://schemas.microsoft.com/office/drawing/2014/main" id="{668D082E-A359-420E-8969-C8EAA17E856A}"/>
+                <a16:creationId xmlns:a16="http://schemas.microsoft.com/office/drawing/2014/main" id="{41660F4E-F728-44EF-98D1-542108EB4C51}"/>
               </a:ext>
             </a:extLst>
           </p:cNvPr>
@@ -14177,7 +14177,7 @@
     </p:spTree>
     <p:extLst>
       <p:ext uri="{BB962C8B-B14F-4D97-AF65-F5344CB8AC3E}">
-        <p14:creationId xmlns:p14="http://schemas.microsoft.com/office/powerpoint/2010/main" val="1269623103"/>
+        <p14:creationId xmlns:p14="http://schemas.microsoft.com/office/powerpoint/2010/main" val="799342423"/>
       </p:ext>
     </p:extLst>
   </p:cSld>
@@ -14208,7 +14208,7 @@
           <p:cNvPr id="1" name="">
             <a:extLst xmlns:a="http://schemas.openxmlformats.org/drawingml/2006/main">
               <a:ext uri="{FF2B5EF4-FFF2-40B4-BE49-F238E27FC236}">
-                <a16:creationId xmlns:a16="http://schemas.microsoft.com/office/drawing/2014/main" id="{05CC909B-9966-4A0E-9650-4810951CEC5C}"/>
+                <a16:creationId xmlns:a16="http://schemas.microsoft.com/office/drawing/2014/main" id="{17DC7363-F3EB-46C2-B67D-56B2DC70D2B1}"/>
               </a:ext>
             </a:extLst>
           </p:cNvPr>
@@ -14239,7 +14239,7 @@
           <p:cNvPr id="2" name="">
             <a:extLst xmlns:a="http://schemas.openxmlformats.org/drawingml/2006/main">
               <a:ext uri="{FF2B5EF4-FFF2-40B4-BE49-F238E27FC236}">
-                <a16:creationId xmlns:a16="http://schemas.microsoft.com/office/drawing/2014/main" id="{B92D37C9-CA6D-4AA1-AE18-715775009D7D}"/>
+                <a16:creationId xmlns:a16="http://schemas.microsoft.com/office/drawing/2014/main" id="{88D81DF7-CDA3-49EE-A7D9-9A3475333A43}"/>
               </a:ext>
             </a:extLst>
           </p:cNvPr>
@@ -14289,7 +14289,7 @@
           <p:cNvPr id="3" name="">
             <a:extLst xmlns:a="http://schemas.openxmlformats.org/drawingml/2006/main">
               <a:ext uri="{FF2B5EF4-FFF2-40B4-BE49-F238E27FC236}">
-                <a16:creationId xmlns:a16="http://schemas.microsoft.com/office/drawing/2014/main" id="{203A1D8C-1EE4-4D49-86FB-C960170E8F8C}"/>
+                <a16:creationId xmlns:a16="http://schemas.microsoft.com/office/drawing/2014/main" id="{E91CB9BA-30D4-401B-8C0F-89EB7BF114D1}"/>
               </a:ext>
             </a:extLst>
           </p:cNvPr>
@@ -14339,7 +14339,7 @@
           <p:cNvPr id="4" name="">
             <a:extLst xmlns:a="http://schemas.openxmlformats.org/drawingml/2006/main">
               <a:ext uri="{FF2B5EF4-FFF2-40B4-BE49-F238E27FC236}">
-                <a16:creationId xmlns:a16="http://schemas.microsoft.com/office/drawing/2014/main" id="{2A9C8AAC-A1DD-49D8-8819-1922802BBD48}"/>
+                <a16:creationId xmlns:a16="http://schemas.microsoft.com/office/drawing/2014/main" id="{831B50E2-761B-4916-9BFA-B47B13B87F3B}"/>
               </a:ext>
             </a:extLst>
           </p:cNvPr>
@@ -14389,7 +14389,7 @@
           <p:cNvPr id="5" name="">
             <a:extLst xmlns:a="http://schemas.openxmlformats.org/drawingml/2006/main">
               <a:ext uri="{FF2B5EF4-FFF2-40B4-BE49-F238E27FC236}">
-                <a16:creationId xmlns:a16="http://schemas.microsoft.com/office/drawing/2014/main" id="{C536E91F-7343-441C-AB2A-0A3CF81CD2D3}"/>
+                <a16:creationId xmlns:a16="http://schemas.microsoft.com/office/drawing/2014/main" id="{D1EBFA21-8851-4D71-853F-B830D36B5786}"/>
               </a:ext>
             </a:extLst>
           </p:cNvPr>
@@ -14439,7 +14439,7 @@
           <p:cNvPr id="6" name="">
             <a:extLst xmlns:a="http://schemas.openxmlformats.org/drawingml/2006/main">
               <a:ext uri="{FF2B5EF4-FFF2-40B4-BE49-F238E27FC236}">
-                <a16:creationId xmlns:a16="http://schemas.microsoft.com/office/drawing/2014/main" id="{D49A98CC-9FA4-4418-B6BA-67473F8C3F98}"/>
+                <a16:creationId xmlns:a16="http://schemas.microsoft.com/office/drawing/2014/main" id="{E74B6B55-8572-4778-9D30-B99FE520D66B}"/>
               </a:ext>
             </a:extLst>
           </p:cNvPr>
@@ -14470,7 +14470,7 @@
           <p:cNvPr id="7" name="">
             <a:extLst xmlns:a="http://schemas.openxmlformats.org/drawingml/2006/main">
               <a:ext uri="{FF2B5EF4-FFF2-40B4-BE49-F238E27FC236}">
-                <a16:creationId xmlns:a16="http://schemas.microsoft.com/office/drawing/2014/main" id="{C159217F-90DB-4031-8159-E5EB503E226B}"/>
+                <a16:creationId xmlns:a16="http://schemas.microsoft.com/office/drawing/2014/main" id="{0F0A930F-AF59-421A-8335-6B16829086B6}"/>
               </a:ext>
             </a:extLst>
           </p:cNvPr>
@@ -14520,7 +14520,7 @@
           <p:cNvPr id="8" name="">
             <a:extLst xmlns:a="http://schemas.openxmlformats.org/drawingml/2006/main">
               <a:ext uri="{FF2B5EF4-FFF2-40B4-BE49-F238E27FC236}">
-                <a16:creationId xmlns:a16="http://schemas.microsoft.com/office/drawing/2014/main" id="{2B411E2D-0C93-4588-AE11-9C01639B7CC2}"/>
+                <a16:creationId xmlns:a16="http://schemas.microsoft.com/office/drawing/2014/main" id="{94FF1182-7C14-4F3B-A3BF-99D0C75E04CC}"/>
               </a:ext>
             </a:extLst>
           </p:cNvPr>
@@ -14551,7 +14551,7 @@
           <p:cNvPr id="9" name="">
             <a:extLst xmlns:a="http://schemas.openxmlformats.org/drawingml/2006/main">
               <a:ext uri="{FF2B5EF4-FFF2-40B4-BE49-F238E27FC236}">
-                <a16:creationId xmlns:a16="http://schemas.microsoft.com/office/drawing/2014/main" id="{C566F65B-D654-46AB-B00C-699CAECDA301}"/>
+                <a16:creationId xmlns:a16="http://schemas.microsoft.com/office/drawing/2014/main" id="{3850AEAA-50A4-4B56-8D3F-77571A1766D8}"/>
               </a:ext>
             </a:extLst>
           </p:cNvPr>
@@ -14601,7 +14601,7 @@
           <p:cNvPr id="10" name="">
             <a:extLst xmlns:a="http://schemas.openxmlformats.org/drawingml/2006/main">
               <a:ext uri="{FF2B5EF4-FFF2-40B4-BE49-F238E27FC236}">
-                <a16:creationId xmlns:a16="http://schemas.microsoft.com/office/drawing/2014/main" id="{EDFF46A8-8F65-474B-9452-FDD138B45AFD}"/>
+                <a16:creationId xmlns:a16="http://schemas.microsoft.com/office/drawing/2014/main" id="{9841513B-1BF8-4744-A16B-2C0D6AE96AB4}"/>
               </a:ext>
             </a:extLst>
           </p:cNvPr>
@@ -14632,7 +14632,7 @@
           <p:cNvPr id="11" name="">
             <a:extLst xmlns:a="http://schemas.openxmlformats.org/drawingml/2006/main">
               <a:ext uri="{FF2B5EF4-FFF2-40B4-BE49-F238E27FC236}">
-                <a16:creationId xmlns:a16="http://schemas.microsoft.com/office/drawing/2014/main" id="{86116473-C232-432A-88CE-C9270403DA1E}"/>
+                <a16:creationId xmlns:a16="http://schemas.microsoft.com/office/drawing/2014/main" id="{8440E16D-759A-4276-BAEF-540398315756}"/>
               </a:ext>
             </a:extLst>
           </p:cNvPr>
@@ -14682,7 +14682,7 @@
           <p:cNvPr id="12" name="">
             <a:extLst xmlns:a="http://schemas.openxmlformats.org/drawingml/2006/main">
               <a:ext uri="{FF2B5EF4-FFF2-40B4-BE49-F238E27FC236}">
-                <a16:creationId xmlns:a16="http://schemas.microsoft.com/office/drawing/2014/main" id="{2EA84E4E-A12B-4547-B6C9-EB5E69D87BBC}"/>
+                <a16:creationId xmlns:a16="http://schemas.microsoft.com/office/drawing/2014/main" id="{BD999A68-729A-47BC-BFCB-FB7DD252FE76}"/>
               </a:ext>
             </a:extLst>
           </p:cNvPr>
@@ -14713,7 +14713,7 @@
           <p:cNvPr id="13" name="">
             <a:extLst xmlns:a="http://schemas.openxmlformats.org/drawingml/2006/main">
               <a:ext uri="{FF2B5EF4-FFF2-40B4-BE49-F238E27FC236}">
-                <a16:creationId xmlns:a16="http://schemas.microsoft.com/office/drawing/2014/main" id="{86355C89-854B-47D7-B265-0183F61671D1}"/>
+                <a16:creationId xmlns:a16="http://schemas.microsoft.com/office/drawing/2014/main" id="{2438C50B-998E-47AE-BEC7-BB3CB4F9840D}"/>
               </a:ext>
             </a:extLst>
           </p:cNvPr>
@@ -14763,7 +14763,7 @@
           <p:cNvPr id="14" name="">
             <a:extLst xmlns:a="http://schemas.openxmlformats.org/drawingml/2006/main">
               <a:ext uri="{FF2B5EF4-FFF2-40B4-BE49-F238E27FC236}">
-                <a16:creationId xmlns:a16="http://schemas.microsoft.com/office/drawing/2014/main" id="{8222B921-92B6-4DC8-B985-4FA8C591FC3C}"/>
+                <a16:creationId xmlns:a16="http://schemas.microsoft.com/office/drawing/2014/main" id="{FEA57085-D204-46F6-A059-6BC8D72E1983}"/>
               </a:ext>
             </a:extLst>
           </p:cNvPr>
@@ -14794,7 +14794,7 @@
           <p:cNvPr id="15" name="">
             <a:extLst xmlns:a="http://schemas.openxmlformats.org/drawingml/2006/main">
               <a:ext uri="{FF2B5EF4-FFF2-40B4-BE49-F238E27FC236}">
-                <a16:creationId xmlns:a16="http://schemas.microsoft.com/office/drawing/2014/main" id="{A79411C1-A5C2-47CD-9794-FF7261E54C68}"/>
+                <a16:creationId xmlns:a16="http://schemas.microsoft.com/office/drawing/2014/main" id="{F9457889-1704-46E3-9F15-A07DF61C10EE}"/>
               </a:ext>
             </a:extLst>
           </p:cNvPr>
@@ -14844,7 +14844,7 @@
           <p:cNvPr id="16" name="">
             <a:extLst xmlns:a="http://schemas.openxmlformats.org/drawingml/2006/main">
               <a:ext uri="{FF2B5EF4-FFF2-40B4-BE49-F238E27FC236}">
-                <a16:creationId xmlns:a16="http://schemas.microsoft.com/office/drawing/2014/main" id="{83CB4D03-CBA7-40DF-A53C-7496E4876464}"/>
+                <a16:creationId xmlns:a16="http://schemas.microsoft.com/office/drawing/2014/main" id="{E91A6017-C889-4D00-80ED-88DABC4D88FE}"/>
               </a:ext>
             </a:extLst>
           </p:cNvPr>
@@ -14875,7 +14875,7 @@
           <p:cNvPr id="17" name="">
             <a:extLst xmlns:a="http://schemas.openxmlformats.org/drawingml/2006/main">
               <a:ext uri="{FF2B5EF4-FFF2-40B4-BE49-F238E27FC236}">
-                <a16:creationId xmlns:a16="http://schemas.microsoft.com/office/drawing/2014/main" id="{A5E46105-AF8F-4392-AB6A-EEB5A63D66F7}"/>
+                <a16:creationId xmlns:a16="http://schemas.microsoft.com/office/drawing/2014/main" id="{3D32B38D-A963-41A7-BFDC-C40AFE0431C4}"/>
               </a:ext>
             </a:extLst>
           </p:cNvPr>
@@ -14925,7 +14925,7 @@
           <p:cNvPr id="18" name="">
             <a:extLst xmlns:a="http://schemas.openxmlformats.org/drawingml/2006/main">
               <a:ext uri="{FF2B5EF4-FFF2-40B4-BE49-F238E27FC236}">
-                <a16:creationId xmlns:a16="http://schemas.microsoft.com/office/drawing/2014/main" id="{31B35728-48E9-4832-A3DB-956ED013DD1D}"/>
+                <a16:creationId xmlns:a16="http://schemas.microsoft.com/office/drawing/2014/main" id="{46405144-0946-4177-A3B5-41C60ADEC3AA}"/>
               </a:ext>
             </a:extLst>
           </p:cNvPr>
@@ -14956,7 +14956,7 @@
           <p:cNvPr id="19" name="">
             <a:extLst xmlns:a="http://schemas.openxmlformats.org/drawingml/2006/main">
               <a:ext uri="{FF2B5EF4-FFF2-40B4-BE49-F238E27FC236}">
-                <a16:creationId xmlns:a16="http://schemas.microsoft.com/office/drawing/2014/main" id="{CAC8A403-E1AE-455E-B1C4-53AF96941A5F}"/>
+                <a16:creationId xmlns:a16="http://schemas.microsoft.com/office/drawing/2014/main" id="{2574598A-E254-4F35-8B19-71769DFBD12F}"/>
               </a:ext>
             </a:extLst>
           </p:cNvPr>
@@ -15006,7 +15006,7 @@
           <p:cNvPr id="20" name="">
             <a:extLst xmlns:a="http://schemas.openxmlformats.org/drawingml/2006/main">
               <a:ext uri="{FF2B5EF4-FFF2-40B4-BE49-F238E27FC236}">
-                <a16:creationId xmlns:a16="http://schemas.microsoft.com/office/drawing/2014/main" id="{32E4C68E-62C6-49A0-977F-8D4898C54DD2}"/>
+                <a16:creationId xmlns:a16="http://schemas.microsoft.com/office/drawing/2014/main" id="{5AB523C8-01FF-44C2-8136-900B4AF60484}"/>
               </a:ext>
             </a:extLst>
           </p:cNvPr>
@@ -15037,7 +15037,7 @@
           <p:cNvPr id="21" name="">
             <a:extLst xmlns:a="http://schemas.openxmlformats.org/drawingml/2006/main">
               <a:ext uri="{FF2B5EF4-FFF2-40B4-BE49-F238E27FC236}">
-                <a16:creationId xmlns:a16="http://schemas.microsoft.com/office/drawing/2014/main" id="{43F9CCB3-4AD8-4309-95BD-6BA6114DEF6F}"/>
+                <a16:creationId xmlns:a16="http://schemas.microsoft.com/office/drawing/2014/main" id="{E5B9286A-4980-4F3D-A9C4-E39D15925824}"/>
               </a:ext>
             </a:extLst>
           </p:cNvPr>
@@ -15087,7 +15087,7 @@
           <p:cNvPr id="22" name="">
             <a:extLst xmlns:a="http://schemas.openxmlformats.org/drawingml/2006/main">
               <a:ext uri="{FF2B5EF4-FFF2-40B4-BE49-F238E27FC236}">
-                <a16:creationId xmlns:a16="http://schemas.microsoft.com/office/drawing/2014/main" id="{509D6120-8B50-4641-9498-E517118D28BF}"/>
+                <a16:creationId xmlns:a16="http://schemas.microsoft.com/office/drawing/2014/main" id="{1A4882D6-1198-47E8-90F9-018995A846CA}"/>
               </a:ext>
             </a:extLst>
           </p:cNvPr>
@@ -15118,7 +15118,7 @@
           <p:cNvPr id="23" name="">
             <a:extLst xmlns:a="http://schemas.openxmlformats.org/drawingml/2006/main">
               <a:ext uri="{FF2B5EF4-FFF2-40B4-BE49-F238E27FC236}">
-                <a16:creationId xmlns:a16="http://schemas.microsoft.com/office/drawing/2014/main" id="{8768B07B-7A88-49F8-B98C-EED6D0D4CF52}"/>
+                <a16:creationId xmlns:a16="http://schemas.microsoft.com/office/drawing/2014/main" id="{7DBD2DBC-2EBD-4030-9712-32764DE4EFCD}"/>
               </a:ext>
             </a:extLst>
           </p:cNvPr>
@@ -15153,7 +15153,7 @@
           <p:nvPr/>
         </p:nvPicPr>
         <p:blipFill>
-          <a:blip xmlns:r="http://schemas.openxmlformats.org/officeDocument/2006/relationships" xmlns:a="http://schemas.openxmlformats.org/drawingml/2006/main" r:embed="R9aca5759bde84fff"/>
+          <a:blip xmlns:r="http://schemas.openxmlformats.org/officeDocument/2006/relationships" xmlns:a="http://schemas.openxmlformats.org/drawingml/2006/main" r:embed="R3c635b24477b4915"/>
           <a:stretch xmlns:a="http://schemas.openxmlformats.org/drawingml/2006/main"/>
         </p:blipFill>
         <p:spPr>
@@ -15171,7 +15171,7 @@
           <p:cNvPr id="25" name="">
             <a:extLst xmlns:a="http://schemas.openxmlformats.org/drawingml/2006/main">
               <a:ext uri="{FF2B5EF4-FFF2-40B4-BE49-F238E27FC236}">
-                <a16:creationId xmlns:a16="http://schemas.microsoft.com/office/drawing/2014/main" id="{E7B39962-6C7A-46CD-BF25-BD5BD03449D7}"/>
+                <a16:creationId xmlns:a16="http://schemas.microsoft.com/office/drawing/2014/main" id="{CE17F147-5608-4EE8-A7A3-5C9E52F14298}"/>
               </a:ext>
             </a:extLst>
           </p:cNvPr>
@@ -15221,7 +15221,7 @@
           <p:cNvPr id="26" name="">
             <a:extLst xmlns:a="http://schemas.openxmlformats.org/drawingml/2006/main">
               <a:ext uri="{FF2B5EF4-FFF2-40B4-BE49-F238E27FC236}">
-                <a16:creationId xmlns:a16="http://schemas.microsoft.com/office/drawing/2014/main" id="{7192E5D4-6FB7-4F6E-8FC3-C985D1BF70F8}"/>
+                <a16:creationId xmlns:a16="http://schemas.microsoft.com/office/drawing/2014/main" id="{E3FA298C-62AB-45BA-A15C-B17360011F76}"/>
               </a:ext>
             </a:extLst>
           </p:cNvPr>
@@ -15269,7 +15269,7 @@
     </p:spTree>
     <p:extLst>
       <p:ext uri="{BB962C8B-B14F-4D97-AF65-F5344CB8AC3E}">
-        <p14:creationId xmlns:p14="http://schemas.microsoft.com/office/powerpoint/2010/main" val="930693788"/>
+        <p14:creationId xmlns:p14="http://schemas.microsoft.com/office/powerpoint/2010/main" val="416087577"/>
       </p:ext>
     </p:extLst>
   </p:cSld>
@@ -15300,7 +15300,7 @@
           <p:cNvPr id="1" name="">
             <a:extLst xmlns:a="http://schemas.openxmlformats.org/drawingml/2006/main">
               <a:ext uri="{FF2B5EF4-FFF2-40B4-BE49-F238E27FC236}">
-                <a16:creationId xmlns:a16="http://schemas.microsoft.com/office/drawing/2014/main" id="{AE08BB95-09DE-4850-907B-04598C88230D}"/>
+                <a16:creationId xmlns:a16="http://schemas.microsoft.com/office/drawing/2014/main" id="{E5DFA749-0AC1-4CB2-8600-F35721A9B412}"/>
               </a:ext>
             </a:extLst>
           </p:cNvPr>
@@ -15331,7 +15331,7 @@
           <p:cNvPr id="2" name="">
             <a:extLst xmlns:a="http://schemas.openxmlformats.org/drawingml/2006/main">
               <a:ext uri="{FF2B5EF4-FFF2-40B4-BE49-F238E27FC236}">
-                <a16:creationId xmlns:a16="http://schemas.microsoft.com/office/drawing/2014/main" id="{DDF768E9-7855-4468-BEA6-D2A8E7D789A2}"/>
+                <a16:creationId xmlns:a16="http://schemas.microsoft.com/office/drawing/2014/main" id="{0F6EB687-82FC-45CD-8612-B36C63E330D3}"/>
               </a:ext>
             </a:extLst>
           </p:cNvPr>
@@ -15381,7 +15381,7 @@
           <p:cNvPr id="3" name="">
             <a:extLst xmlns:a="http://schemas.openxmlformats.org/drawingml/2006/main">
               <a:ext uri="{FF2B5EF4-FFF2-40B4-BE49-F238E27FC236}">
-                <a16:creationId xmlns:a16="http://schemas.microsoft.com/office/drawing/2014/main" id="{324C8E93-4EA4-43F7-B37F-0971D6D670CC}"/>
+                <a16:creationId xmlns:a16="http://schemas.microsoft.com/office/drawing/2014/main" id="{23C243F3-FEC4-4F89-936F-2B69BBFCDD0E}"/>
               </a:ext>
             </a:extLst>
           </p:cNvPr>
@@ -15431,7 +15431,7 @@
           <p:cNvPr id="4" name="">
             <a:extLst xmlns:a="http://schemas.openxmlformats.org/drawingml/2006/main">
               <a:ext uri="{FF2B5EF4-FFF2-40B4-BE49-F238E27FC236}">
-                <a16:creationId xmlns:a16="http://schemas.microsoft.com/office/drawing/2014/main" id="{1072D900-D4DE-4B01-A4B5-4D7FD0DF3743}"/>
+                <a16:creationId xmlns:a16="http://schemas.microsoft.com/office/drawing/2014/main" id="{469DC89D-9F79-47BB-884A-5C86234B0A5D}"/>
               </a:ext>
             </a:extLst>
           </p:cNvPr>
@@ -15464,7 +15464,7 @@
           <p:cNvPr id="5" name="">
             <a:extLst xmlns:a="http://schemas.openxmlformats.org/drawingml/2006/main">
               <a:ext uri="{FF2B5EF4-FFF2-40B4-BE49-F238E27FC236}">
-                <a16:creationId xmlns:a16="http://schemas.microsoft.com/office/drawing/2014/main" id="{DC02C9BD-7302-433A-AB20-C9FF09823BE2}"/>
+                <a16:creationId xmlns:a16="http://schemas.microsoft.com/office/drawing/2014/main" id="{105BC3B8-13CD-4A5F-86AB-1D60E97543C1}"/>
               </a:ext>
             </a:extLst>
           </p:cNvPr>
@@ -15514,7 +15514,7 @@
           <p:cNvPr id="6" name="">
             <a:extLst xmlns:a="http://schemas.openxmlformats.org/drawingml/2006/main">
               <a:ext uri="{FF2B5EF4-FFF2-40B4-BE49-F238E27FC236}">
-                <a16:creationId xmlns:a16="http://schemas.microsoft.com/office/drawing/2014/main" id="{0F4CEBFD-54BF-4DAA-8DAC-FCA88ACDEB92}"/>
+                <a16:creationId xmlns:a16="http://schemas.microsoft.com/office/drawing/2014/main" id="{35DD7155-E414-45A2-98A8-28E406E333BF}"/>
               </a:ext>
             </a:extLst>
           </p:cNvPr>
@@ -15564,7 +15564,7 @@
           <p:cNvPr id="7" name="">
             <a:extLst xmlns:a="http://schemas.openxmlformats.org/drawingml/2006/main">
               <a:ext uri="{FF2B5EF4-FFF2-40B4-BE49-F238E27FC236}">
-                <a16:creationId xmlns:a16="http://schemas.microsoft.com/office/drawing/2014/main" id="{B77BA9F6-F47B-42B1-99CE-D482EE00F825}"/>
+                <a16:creationId xmlns:a16="http://schemas.microsoft.com/office/drawing/2014/main" id="{92DEE97F-6780-406F-BD6B-2D7C9593191E}"/>
               </a:ext>
             </a:extLst>
           </p:cNvPr>
@@ -15614,7 +15614,7 @@
           <p:cNvPr id="8" name="">
             <a:extLst xmlns:a="http://schemas.openxmlformats.org/drawingml/2006/main">
               <a:ext uri="{FF2B5EF4-FFF2-40B4-BE49-F238E27FC236}">
-                <a16:creationId xmlns:a16="http://schemas.microsoft.com/office/drawing/2014/main" id="{27ACFA33-B66D-4F85-BD85-B17D86CC6C5A}"/>
+                <a16:creationId xmlns:a16="http://schemas.microsoft.com/office/drawing/2014/main" id="{301031CB-696E-4FA9-BF7B-ECC0DADE3399}"/>
               </a:ext>
             </a:extLst>
           </p:cNvPr>
@@ -15647,7 +15647,7 @@
           <p:cNvPr id="9" name="">
             <a:extLst xmlns:a="http://schemas.openxmlformats.org/drawingml/2006/main">
               <a:ext uri="{FF2B5EF4-FFF2-40B4-BE49-F238E27FC236}">
-                <a16:creationId xmlns:a16="http://schemas.microsoft.com/office/drawing/2014/main" id="{1E925B15-3A87-40D6-9546-0BB74B693DFE}"/>
+                <a16:creationId xmlns:a16="http://schemas.microsoft.com/office/drawing/2014/main" id="{D6D2F563-74EB-42E6-A527-C2A123C9EB20}"/>
               </a:ext>
             </a:extLst>
           </p:cNvPr>
@@ -15697,7 +15697,7 @@
           <p:cNvPr id="10" name="">
             <a:extLst xmlns:a="http://schemas.openxmlformats.org/drawingml/2006/main">
               <a:ext uri="{FF2B5EF4-FFF2-40B4-BE49-F238E27FC236}">
-                <a16:creationId xmlns:a16="http://schemas.microsoft.com/office/drawing/2014/main" id="{A8F78543-7718-4B5C-B815-C97CC0B1AF4C}"/>
+                <a16:creationId xmlns:a16="http://schemas.microsoft.com/office/drawing/2014/main" id="{67F40167-7BD2-4907-8F5D-22689B9B2617}"/>
               </a:ext>
             </a:extLst>
           </p:cNvPr>
@@ -15747,7 +15747,7 @@
           <p:cNvPr id="11" name="">
             <a:extLst xmlns:a="http://schemas.openxmlformats.org/drawingml/2006/main">
               <a:ext uri="{FF2B5EF4-FFF2-40B4-BE49-F238E27FC236}">
-                <a16:creationId xmlns:a16="http://schemas.microsoft.com/office/drawing/2014/main" id="{A6782F65-7EBA-46E0-B331-0ED0B3F463FB}"/>
+                <a16:creationId xmlns:a16="http://schemas.microsoft.com/office/drawing/2014/main" id="{BCF16F5C-1BCC-4DFE-A837-5AF3A0930F3F}"/>
               </a:ext>
             </a:extLst>
           </p:cNvPr>
@@ -15797,7 +15797,7 @@
           <p:cNvPr id="12" name="">
             <a:extLst xmlns:a="http://schemas.openxmlformats.org/drawingml/2006/main">
               <a:ext uri="{FF2B5EF4-FFF2-40B4-BE49-F238E27FC236}">
-                <a16:creationId xmlns:a16="http://schemas.microsoft.com/office/drawing/2014/main" id="{39DC123D-162D-42B0-B446-29F9531561E1}"/>
+                <a16:creationId xmlns:a16="http://schemas.microsoft.com/office/drawing/2014/main" id="{B3E355F2-C4A9-4428-83A4-CE590191608A}"/>
               </a:ext>
             </a:extLst>
           </p:cNvPr>
@@ -15830,7 +15830,7 @@
           <p:cNvPr id="13" name="">
             <a:extLst xmlns:a="http://schemas.openxmlformats.org/drawingml/2006/main">
               <a:ext uri="{FF2B5EF4-FFF2-40B4-BE49-F238E27FC236}">
-                <a16:creationId xmlns:a16="http://schemas.microsoft.com/office/drawing/2014/main" id="{8FC034FA-0B7A-41DD-9E0E-8421E6B30739}"/>
+                <a16:creationId xmlns:a16="http://schemas.microsoft.com/office/drawing/2014/main" id="{7FA5667E-3E52-4BDF-A936-0A5070E713B5}"/>
               </a:ext>
             </a:extLst>
           </p:cNvPr>
@@ -15880,7 +15880,7 @@
           <p:cNvPr id="14" name="">
             <a:extLst xmlns:a="http://schemas.openxmlformats.org/drawingml/2006/main">
               <a:ext uri="{FF2B5EF4-FFF2-40B4-BE49-F238E27FC236}">
-                <a16:creationId xmlns:a16="http://schemas.microsoft.com/office/drawing/2014/main" id="{C3521241-333C-4E14-B45C-57CCA16B50D8}"/>
+                <a16:creationId xmlns:a16="http://schemas.microsoft.com/office/drawing/2014/main" id="{AD0082BC-964B-4F65-98A9-BF6A616A9DCA}"/>
               </a:ext>
             </a:extLst>
           </p:cNvPr>
@@ -15930,7 +15930,7 @@
           <p:cNvPr id="15" name="">
             <a:extLst xmlns:a="http://schemas.openxmlformats.org/drawingml/2006/main">
               <a:ext uri="{FF2B5EF4-FFF2-40B4-BE49-F238E27FC236}">
-                <a16:creationId xmlns:a16="http://schemas.microsoft.com/office/drawing/2014/main" id="{026F3041-517B-49F4-A105-3669CB57559A}"/>
+                <a16:creationId xmlns:a16="http://schemas.microsoft.com/office/drawing/2014/main" id="{73CB1D24-953B-4249-A7D4-F038B8FF1D28}"/>
               </a:ext>
             </a:extLst>
           </p:cNvPr>
@@ -15980,7 +15980,7 @@
           <p:cNvPr id="16" name="">
             <a:extLst xmlns:a="http://schemas.openxmlformats.org/drawingml/2006/main">
               <a:ext uri="{FF2B5EF4-FFF2-40B4-BE49-F238E27FC236}">
-                <a16:creationId xmlns:a16="http://schemas.microsoft.com/office/drawing/2014/main" id="{5DB2489F-5182-48B9-B4BE-864A217DAE4A}"/>
+                <a16:creationId xmlns:a16="http://schemas.microsoft.com/office/drawing/2014/main" id="{2231A880-A1CD-4329-A5DA-C0226E05FC17}"/>
               </a:ext>
             </a:extLst>
           </p:cNvPr>
@@ -16013,7 +16013,7 @@
           <p:cNvPr id="17" name="">
             <a:extLst xmlns:a="http://schemas.openxmlformats.org/drawingml/2006/main">
               <a:ext uri="{FF2B5EF4-FFF2-40B4-BE49-F238E27FC236}">
-                <a16:creationId xmlns:a16="http://schemas.microsoft.com/office/drawing/2014/main" id="{8ADFE2A8-7183-4657-814B-6143B691210E}"/>
+                <a16:creationId xmlns:a16="http://schemas.microsoft.com/office/drawing/2014/main" id="{158FF374-16E4-4D47-BABF-C0B1B55B5E0C}"/>
               </a:ext>
             </a:extLst>
           </p:cNvPr>
@@ -16063,7 +16063,7 @@
           <p:cNvPr id="18" name="">
             <a:extLst xmlns:a="http://schemas.openxmlformats.org/drawingml/2006/main">
               <a:ext uri="{FF2B5EF4-FFF2-40B4-BE49-F238E27FC236}">
-                <a16:creationId xmlns:a16="http://schemas.microsoft.com/office/drawing/2014/main" id="{9CFD7BC0-48DD-4133-B33F-8DF30D8F22B6}"/>
+                <a16:creationId xmlns:a16="http://schemas.microsoft.com/office/drawing/2014/main" id="{C0EE6CF5-0DE4-4095-9FE2-3C1299D0F8B9}"/>
               </a:ext>
             </a:extLst>
           </p:cNvPr>
@@ -16113,7 +16113,7 @@
           <p:cNvPr id="19" name="">
             <a:extLst xmlns:a="http://schemas.openxmlformats.org/drawingml/2006/main">
               <a:ext uri="{FF2B5EF4-FFF2-40B4-BE49-F238E27FC236}">
-                <a16:creationId xmlns:a16="http://schemas.microsoft.com/office/drawing/2014/main" id="{7D9C114C-EB5D-4E05-A391-0798C32C8675}"/>
+                <a16:creationId xmlns:a16="http://schemas.microsoft.com/office/drawing/2014/main" id="{B6D2B7C1-9041-47D4-9F98-C5DFB720FFD1}"/>
               </a:ext>
             </a:extLst>
           </p:cNvPr>
@@ -16163,7 +16163,7 @@
           <p:cNvPr id="20" name="">
             <a:extLst xmlns:a="http://schemas.openxmlformats.org/drawingml/2006/main">
               <a:ext uri="{FF2B5EF4-FFF2-40B4-BE49-F238E27FC236}">
-                <a16:creationId xmlns:a16="http://schemas.microsoft.com/office/drawing/2014/main" id="{AF66ACEB-204D-4E9C-9FA8-B2D2410F2371}"/>
+                <a16:creationId xmlns:a16="http://schemas.microsoft.com/office/drawing/2014/main" id="{63CED8D2-5360-4270-BFD5-C473FB341185}"/>
               </a:ext>
             </a:extLst>
           </p:cNvPr>
@@ -16196,7 +16196,7 @@
           <p:cNvPr id="21" name="">
             <a:extLst xmlns:a="http://schemas.openxmlformats.org/drawingml/2006/main">
               <a:ext uri="{FF2B5EF4-FFF2-40B4-BE49-F238E27FC236}">
-                <a16:creationId xmlns:a16="http://schemas.microsoft.com/office/drawing/2014/main" id="{24FA7AFC-BC0C-4A3D-94D2-2BEDE7B28B2D}"/>
+                <a16:creationId xmlns:a16="http://schemas.microsoft.com/office/drawing/2014/main" id="{6DB14535-1588-4BEE-84A3-BDAAEAE297E6}"/>
               </a:ext>
             </a:extLst>
           </p:cNvPr>
@@ -16246,7 +16246,7 @@
           <p:cNvPr id="22" name="">
             <a:extLst xmlns:a="http://schemas.openxmlformats.org/drawingml/2006/main">
               <a:ext uri="{FF2B5EF4-FFF2-40B4-BE49-F238E27FC236}">
-                <a16:creationId xmlns:a16="http://schemas.microsoft.com/office/drawing/2014/main" id="{94559871-8290-412E-BEE9-36FA1EDABC9B}"/>
+                <a16:creationId xmlns:a16="http://schemas.microsoft.com/office/drawing/2014/main" id="{AB8AD20F-950C-449A-A963-CCA538F8AA6D}"/>
               </a:ext>
             </a:extLst>
           </p:cNvPr>
@@ -16296,7 +16296,7 @@
           <p:cNvPr id="23" name="">
             <a:extLst xmlns:a="http://schemas.openxmlformats.org/drawingml/2006/main">
               <a:ext uri="{FF2B5EF4-FFF2-40B4-BE49-F238E27FC236}">
-                <a16:creationId xmlns:a16="http://schemas.microsoft.com/office/drawing/2014/main" id="{A9FCABD2-C333-4639-B659-269E6E3F0050}"/>
+                <a16:creationId xmlns:a16="http://schemas.microsoft.com/office/drawing/2014/main" id="{A4307D95-6E09-4E6B-A5E9-36735E8537DF}"/>
               </a:ext>
             </a:extLst>
           </p:cNvPr>
@@ -16346,7 +16346,7 @@
           <p:cNvPr id="24" name="">
             <a:extLst xmlns:a="http://schemas.openxmlformats.org/drawingml/2006/main">
               <a:ext uri="{FF2B5EF4-FFF2-40B4-BE49-F238E27FC236}">
-                <a16:creationId xmlns:a16="http://schemas.microsoft.com/office/drawing/2014/main" id="{9FF067E3-6CC7-493F-99E8-CB2D52D0BB2D}"/>
+                <a16:creationId xmlns:a16="http://schemas.microsoft.com/office/drawing/2014/main" id="{D4D6AF90-7041-4146-ABEE-16CC12844414}"/>
               </a:ext>
             </a:extLst>
           </p:cNvPr>
@@ -16381,7 +16381,7 @@
           <p:nvPr/>
         </p:nvPicPr>
         <p:blipFill>
-          <a:blip xmlns:r="http://schemas.openxmlformats.org/officeDocument/2006/relationships" xmlns:a="http://schemas.openxmlformats.org/drawingml/2006/main" r:embed="Re2209435afc74c46"/>
+          <a:blip xmlns:r="http://schemas.openxmlformats.org/officeDocument/2006/relationships" xmlns:a="http://schemas.openxmlformats.org/drawingml/2006/main" r:embed="R47d68bcc1ecc4820"/>
           <a:stretch xmlns:a="http://schemas.openxmlformats.org/drawingml/2006/main"/>
         </p:blipFill>
         <p:spPr>
@@ -16399,7 +16399,7 @@
           <p:cNvPr id="26" name="">
             <a:extLst xmlns:a="http://schemas.openxmlformats.org/drawingml/2006/main">
               <a:ext uri="{FF2B5EF4-FFF2-40B4-BE49-F238E27FC236}">
-                <a16:creationId xmlns:a16="http://schemas.microsoft.com/office/drawing/2014/main" id="{08E8DDA0-B0E0-48C5-A6DC-0A457E1CFA6C}"/>
+                <a16:creationId xmlns:a16="http://schemas.microsoft.com/office/drawing/2014/main" id="{DF83077A-C1E2-41B3-B29A-BA2C7E38C31A}"/>
               </a:ext>
             </a:extLst>
           </p:cNvPr>
@@ -16449,7 +16449,7 @@
           <p:cNvPr id="27" name="">
             <a:extLst xmlns:a="http://schemas.openxmlformats.org/drawingml/2006/main">
               <a:ext uri="{FF2B5EF4-FFF2-40B4-BE49-F238E27FC236}">
-                <a16:creationId xmlns:a16="http://schemas.microsoft.com/office/drawing/2014/main" id="{13B5FC75-85B8-4285-8EC1-4F08ECE8A08F}"/>
+                <a16:creationId xmlns:a16="http://schemas.microsoft.com/office/drawing/2014/main" id="{A9AC5547-B7C8-402A-A787-8E3984AF9B9D}"/>
               </a:ext>
             </a:extLst>
           </p:cNvPr>
@@ -16497,7 +16497,7 @@
     </p:spTree>
     <p:extLst>
       <p:ext uri="{BB962C8B-B14F-4D97-AF65-F5344CB8AC3E}">
-        <p14:creationId xmlns:p14="http://schemas.microsoft.com/office/powerpoint/2010/main" val="2044895150"/>
+        <p14:creationId xmlns:p14="http://schemas.microsoft.com/office/powerpoint/2010/main" val="1235375310"/>
       </p:ext>
     </p:extLst>
   </p:cSld>
@@ -16532,7 +16532,7 @@
           <p:nvPr/>
         </p:nvPicPr>
         <p:blipFill>
-          <a:blip xmlns:r="http://schemas.openxmlformats.org/officeDocument/2006/relationships" xmlns:a="http://schemas.openxmlformats.org/drawingml/2006/main" r:embed="R178c84f177884773"/>
+          <a:blip xmlns:r="http://schemas.openxmlformats.org/officeDocument/2006/relationships" xmlns:a="http://schemas.openxmlformats.org/drawingml/2006/main" r:embed="Rc96cf8e3a4ba484f"/>
           <a:stretch xmlns:a="http://schemas.openxmlformats.org/drawingml/2006/main"/>
         </p:blipFill>
         <p:spPr>
@@ -16550,7 +16550,7 @@
           <p:cNvPr id="2" name="">
             <a:extLst xmlns:a="http://schemas.openxmlformats.org/drawingml/2006/main">
               <a:ext uri="{FF2B5EF4-FFF2-40B4-BE49-F238E27FC236}">
-                <a16:creationId xmlns:a16="http://schemas.microsoft.com/office/drawing/2014/main" id="{90F0422F-A254-4031-BF64-A4EB5A2F3662}"/>
+                <a16:creationId xmlns:a16="http://schemas.microsoft.com/office/drawing/2014/main" id="{50BA6172-2C43-4C5B-A6B5-AA54E652FCEA}"/>
               </a:ext>
             </a:extLst>
           </p:cNvPr>
@@ -16600,7 +16600,7 @@
           <p:cNvPr id="3" name="">
             <a:extLst xmlns:a="http://schemas.openxmlformats.org/drawingml/2006/main">
               <a:ext uri="{FF2B5EF4-FFF2-40B4-BE49-F238E27FC236}">
-                <a16:creationId xmlns:a16="http://schemas.microsoft.com/office/drawing/2014/main" id="{B1A158E8-E61D-4AB9-AD53-57E883BFF480}"/>
+                <a16:creationId xmlns:a16="http://schemas.microsoft.com/office/drawing/2014/main" id="{5CD2EBAC-EB2A-40CB-AF41-4C8F2E82863D}"/>
               </a:ext>
             </a:extLst>
           </p:cNvPr>
@@ -16650,7 +16650,7 @@
           <p:cNvPr id="4" name="">
             <a:extLst xmlns:a="http://schemas.openxmlformats.org/drawingml/2006/main">
               <a:ext uri="{FF2B5EF4-FFF2-40B4-BE49-F238E27FC236}">
-                <a16:creationId xmlns:a16="http://schemas.microsoft.com/office/drawing/2014/main" id="{1F33A56B-C887-425F-AD23-C2F49A1023EB}"/>
+                <a16:creationId xmlns:a16="http://schemas.microsoft.com/office/drawing/2014/main" id="{2B3F2BB8-FAB9-4CDF-840E-2EA9E83E3013}"/>
               </a:ext>
             </a:extLst>
           </p:cNvPr>
@@ -16685,7 +16685,7 @@
           <p:cNvPr id="5" name="">
             <a:extLst xmlns:a="http://schemas.openxmlformats.org/drawingml/2006/main">
               <a:ext uri="{FF2B5EF4-FFF2-40B4-BE49-F238E27FC236}">
-                <a16:creationId xmlns:a16="http://schemas.microsoft.com/office/drawing/2014/main" id="{D07A5DF0-56CF-4869-A460-7892B82E94BE}"/>
+                <a16:creationId xmlns:a16="http://schemas.microsoft.com/office/drawing/2014/main" id="{734E50A0-1005-4619-9D99-F314D352DD55}"/>
               </a:ext>
             </a:extLst>
           </p:cNvPr>
@@ -16733,7 +16733,7 @@
     </p:spTree>
     <p:extLst>
       <p:ext uri="{BB962C8B-B14F-4D97-AF65-F5344CB8AC3E}">
-        <p14:creationId xmlns:p14="http://schemas.microsoft.com/office/powerpoint/2010/main" val="691819470"/>
+        <p14:creationId xmlns:p14="http://schemas.microsoft.com/office/powerpoint/2010/main" val="1768747631"/>
       </p:ext>
     </p:extLst>
   </p:cSld>
@@ -16764,7 +16764,7 @@
           <p:cNvPr id="1" name="">
             <a:extLst xmlns:a="http://schemas.openxmlformats.org/drawingml/2006/main">
               <a:ext uri="{FF2B5EF4-FFF2-40B4-BE49-F238E27FC236}">
-                <a16:creationId xmlns:a16="http://schemas.microsoft.com/office/drawing/2014/main" id="{66094B2B-A2D3-4161-B582-C4F110C7A14F}"/>
+                <a16:creationId xmlns:a16="http://schemas.microsoft.com/office/drawing/2014/main" id="{4180C6C6-542B-439E-BACC-8548ABFB3B15}"/>
               </a:ext>
             </a:extLst>
           </p:cNvPr>
@@ -16795,7 +16795,7 @@
           <p:cNvPr id="2" name="">
             <a:extLst xmlns:a="http://schemas.openxmlformats.org/drawingml/2006/main">
               <a:ext uri="{FF2B5EF4-FFF2-40B4-BE49-F238E27FC236}">
-                <a16:creationId xmlns:a16="http://schemas.microsoft.com/office/drawing/2014/main" id="{CC2684E8-B571-478A-AEE5-90E64784CCD5}"/>
+                <a16:creationId xmlns:a16="http://schemas.microsoft.com/office/drawing/2014/main" id="{52471FE3-6EB5-48C8-8B24-BCAA7443F6CA}"/>
               </a:ext>
             </a:extLst>
           </p:cNvPr>
@@ -16845,7 +16845,7 @@
           <p:cNvPr id="3" name="">
             <a:extLst xmlns:a="http://schemas.openxmlformats.org/drawingml/2006/main">
               <a:ext uri="{FF2B5EF4-FFF2-40B4-BE49-F238E27FC236}">
-                <a16:creationId xmlns:a16="http://schemas.microsoft.com/office/drawing/2014/main" id="{C40CD30D-8A25-46AF-958A-2E3DA31A95C5}"/>
+                <a16:creationId xmlns:a16="http://schemas.microsoft.com/office/drawing/2014/main" id="{1A171E36-B76D-4EA2-B924-22C77E215F2D}"/>
               </a:ext>
             </a:extLst>
           </p:cNvPr>
@@ -16895,7 +16895,7 @@
           <p:cNvPr id="4" name="">
             <a:extLst xmlns:a="http://schemas.openxmlformats.org/drawingml/2006/main">
               <a:ext uri="{FF2B5EF4-FFF2-40B4-BE49-F238E27FC236}">
-                <a16:creationId xmlns:a16="http://schemas.microsoft.com/office/drawing/2014/main" id="{138DBF00-BECE-4F3A-A854-A4EC8656E941}"/>
+                <a16:creationId xmlns:a16="http://schemas.microsoft.com/office/drawing/2014/main" id="{AAE507AC-14D7-45AB-AE44-F80B9AB75A2B}"/>
               </a:ext>
             </a:extLst>
           </p:cNvPr>
@@ -16945,7 +16945,7 @@
           <p:cNvPr id="5" name="">
             <a:extLst xmlns:a="http://schemas.openxmlformats.org/drawingml/2006/main">
               <a:ext uri="{FF2B5EF4-FFF2-40B4-BE49-F238E27FC236}">
-                <a16:creationId xmlns:a16="http://schemas.microsoft.com/office/drawing/2014/main" id="{887B898F-2C41-478D-80E9-55BDAF62269A}"/>
+                <a16:creationId xmlns:a16="http://schemas.microsoft.com/office/drawing/2014/main" id="{84D237D5-8417-498F-A641-FBC018F8FD26}"/>
               </a:ext>
             </a:extLst>
           </p:cNvPr>
@@ -16976,7 +16976,7 @@
           <p:cNvPr id="6" name="">
             <a:extLst xmlns:a="http://schemas.openxmlformats.org/drawingml/2006/main">
               <a:ext uri="{FF2B5EF4-FFF2-40B4-BE49-F238E27FC236}">
-                <a16:creationId xmlns:a16="http://schemas.microsoft.com/office/drawing/2014/main" id="{D773DF0C-46BB-4467-B383-15735038604F}"/>
+                <a16:creationId xmlns:a16="http://schemas.microsoft.com/office/drawing/2014/main" id="{D4793D2D-BBF4-48DC-8809-B4FC7225A52C}"/>
               </a:ext>
             </a:extLst>
           </p:cNvPr>
@@ -17026,7 +17026,7 @@
           <p:cNvPr id="7" name="">
             <a:extLst xmlns:a="http://schemas.openxmlformats.org/drawingml/2006/main">
               <a:ext uri="{FF2B5EF4-FFF2-40B4-BE49-F238E27FC236}">
-                <a16:creationId xmlns:a16="http://schemas.microsoft.com/office/drawing/2014/main" id="{8CDB0E06-8B2D-459E-8EC6-10F3B3D5C365}"/>
+                <a16:creationId xmlns:a16="http://schemas.microsoft.com/office/drawing/2014/main" id="{2D00B09C-F705-4129-8798-F67ABB21416A}"/>
               </a:ext>
             </a:extLst>
           </p:cNvPr>
@@ -17057,7 +17057,7 @@
           <p:cNvPr id="8" name="">
             <a:extLst xmlns:a="http://schemas.openxmlformats.org/drawingml/2006/main">
               <a:ext uri="{FF2B5EF4-FFF2-40B4-BE49-F238E27FC236}">
-                <a16:creationId xmlns:a16="http://schemas.microsoft.com/office/drawing/2014/main" id="{C0874A17-7C82-4C6D-8CCA-1990FFF8AA64}"/>
+                <a16:creationId xmlns:a16="http://schemas.microsoft.com/office/drawing/2014/main" id="{15871F01-78F6-44AE-9CE7-90D936E19670}"/>
               </a:ext>
             </a:extLst>
           </p:cNvPr>
@@ -17107,7 +17107,7 @@
           <p:cNvPr id="9" name="">
             <a:extLst xmlns:a="http://schemas.openxmlformats.org/drawingml/2006/main">
               <a:ext uri="{FF2B5EF4-FFF2-40B4-BE49-F238E27FC236}">
-                <a16:creationId xmlns:a16="http://schemas.microsoft.com/office/drawing/2014/main" id="{2F3F1C7E-A4BB-4393-8B5F-291827FE377A}"/>
+                <a16:creationId xmlns:a16="http://schemas.microsoft.com/office/drawing/2014/main" id="{DF5B0CF4-EC95-407D-83A5-B09A0F6B47CE}"/>
               </a:ext>
             </a:extLst>
           </p:cNvPr>
@@ -17138,7 +17138,7 @@
           <p:cNvPr id="10" name="">
             <a:extLst xmlns:a="http://schemas.openxmlformats.org/drawingml/2006/main">
               <a:ext uri="{FF2B5EF4-FFF2-40B4-BE49-F238E27FC236}">
-                <a16:creationId xmlns:a16="http://schemas.microsoft.com/office/drawing/2014/main" id="{A270728E-F04F-4209-91D8-71E300DD45F5}"/>
+                <a16:creationId xmlns:a16="http://schemas.microsoft.com/office/drawing/2014/main" id="{39E19FCA-B4A4-4CEE-BC44-94732667E29E}"/>
               </a:ext>
             </a:extLst>
           </p:cNvPr>
@@ -17188,7 +17188,7 @@
           <p:cNvPr id="11" name="">
             <a:extLst xmlns:a="http://schemas.openxmlformats.org/drawingml/2006/main">
               <a:ext uri="{FF2B5EF4-FFF2-40B4-BE49-F238E27FC236}">
-                <a16:creationId xmlns:a16="http://schemas.microsoft.com/office/drawing/2014/main" id="{EE5A5D4D-A12D-4A48-B002-0E23903D4AD5}"/>
+                <a16:creationId xmlns:a16="http://schemas.microsoft.com/office/drawing/2014/main" id="{F06C59B2-59EF-4DC8-8A20-C7796CDA5CEF}"/>
               </a:ext>
             </a:extLst>
           </p:cNvPr>
@@ -17219,7 +17219,7 @@
           <p:cNvPr id="12" name="">
             <a:extLst xmlns:a="http://schemas.openxmlformats.org/drawingml/2006/main">
               <a:ext uri="{FF2B5EF4-FFF2-40B4-BE49-F238E27FC236}">
-                <a16:creationId xmlns:a16="http://schemas.microsoft.com/office/drawing/2014/main" id="{E8E75770-44D8-4706-9CEC-7E34564BAC99}"/>
+                <a16:creationId xmlns:a16="http://schemas.microsoft.com/office/drawing/2014/main" id="{1F5A04D9-FE51-48F0-9043-38B684505EE2}"/>
               </a:ext>
             </a:extLst>
           </p:cNvPr>
@@ -17269,7 +17269,7 @@
           <p:cNvPr id="13" name="">
             <a:extLst xmlns:a="http://schemas.openxmlformats.org/drawingml/2006/main">
               <a:ext uri="{FF2B5EF4-FFF2-40B4-BE49-F238E27FC236}">
-                <a16:creationId xmlns:a16="http://schemas.microsoft.com/office/drawing/2014/main" id="{9F431790-41AE-4F2B-890B-D68B1614B616}"/>
+                <a16:creationId xmlns:a16="http://schemas.microsoft.com/office/drawing/2014/main" id="{D56D1A91-93F4-4947-8BFB-7CB7A1502630}"/>
               </a:ext>
             </a:extLst>
           </p:cNvPr>
@@ -17300,7 +17300,7 @@
           <p:cNvPr id="14" name="">
             <a:extLst xmlns:a="http://schemas.openxmlformats.org/drawingml/2006/main">
               <a:ext uri="{FF2B5EF4-FFF2-40B4-BE49-F238E27FC236}">
-                <a16:creationId xmlns:a16="http://schemas.microsoft.com/office/drawing/2014/main" id="{EB939360-9CA3-443D-B16C-5CB466E17EA3}"/>
+                <a16:creationId xmlns:a16="http://schemas.microsoft.com/office/drawing/2014/main" id="{CFC76D08-6639-4A03-B402-D3196498387E}"/>
               </a:ext>
             </a:extLst>
           </p:cNvPr>
@@ -17350,7 +17350,7 @@
           <p:cNvPr id="15" name="">
             <a:extLst xmlns:a="http://schemas.openxmlformats.org/drawingml/2006/main">
               <a:ext uri="{FF2B5EF4-FFF2-40B4-BE49-F238E27FC236}">
-                <a16:creationId xmlns:a16="http://schemas.microsoft.com/office/drawing/2014/main" id="{E400C5F7-FC29-4EDE-891A-4863DE15D6E8}"/>
+                <a16:creationId xmlns:a16="http://schemas.microsoft.com/office/drawing/2014/main" id="{AC788166-69D8-4DAD-9263-8BAE3F77E6F2}"/>
               </a:ext>
             </a:extLst>
           </p:cNvPr>
@@ -17385,7 +17385,7 @@
           <p:nvPr/>
         </p:nvPicPr>
         <p:blipFill>
-          <a:blip xmlns:r="http://schemas.openxmlformats.org/officeDocument/2006/relationships" xmlns:a="http://schemas.openxmlformats.org/drawingml/2006/main" r:embed="R6f34c0dfe75d40a6"/>
+          <a:blip xmlns:r="http://schemas.openxmlformats.org/officeDocument/2006/relationships" xmlns:a="http://schemas.openxmlformats.org/drawingml/2006/main" r:embed="R13a47fae8f8f456d"/>
           <a:stretch xmlns:a="http://schemas.openxmlformats.org/drawingml/2006/main"/>
         </p:blipFill>
         <p:spPr>
@@ -17403,7 +17403,7 @@
           <p:cNvPr id="17" name="">
             <a:extLst xmlns:a="http://schemas.openxmlformats.org/drawingml/2006/main">
               <a:ext uri="{FF2B5EF4-FFF2-40B4-BE49-F238E27FC236}">
-                <a16:creationId xmlns:a16="http://schemas.microsoft.com/office/drawing/2014/main" id="{35D75AB5-7B13-486E-8288-C1C65A4F4860}"/>
+                <a16:creationId xmlns:a16="http://schemas.microsoft.com/office/drawing/2014/main" id="{C917C2AA-6A61-4DE7-9041-22680BF3679C}"/>
               </a:ext>
             </a:extLst>
           </p:cNvPr>
@@ -17453,7 +17453,7 @@
           <p:cNvPr id="18" name="">
             <a:extLst xmlns:a="http://schemas.openxmlformats.org/drawingml/2006/main">
               <a:ext uri="{FF2B5EF4-FFF2-40B4-BE49-F238E27FC236}">
-                <a16:creationId xmlns:a16="http://schemas.microsoft.com/office/drawing/2014/main" id="{16D317D3-6A54-421B-B6EE-4374A0A7D9FF}"/>
+                <a16:creationId xmlns:a16="http://schemas.microsoft.com/office/drawing/2014/main" id="{3E3461F8-5186-4066-A81B-EAF5B8DD479E}"/>
               </a:ext>
             </a:extLst>
           </p:cNvPr>
@@ -17501,7 +17501,7 @@
     </p:spTree>
     <p:extLst>
       <p:ext uri="{BB962C8B-B14F-4D97-AF65-F5344CB8AC3E}">
-        <p14:creationId xmlns:p14="http://schemas.microsoft.com/office/powerpoint/2010/main" val="1909768989"/>
+        <p14:creationId xmlns:p14="http://schemas.microsoft.com/office/powerpoint/2010/main" val="350551006"/>
       </p:ext>
     </p:extLst>
   </p:cSld>
@@ -17532,7 +17532,7 @@
           <p:cNvPr id="1" name="">
             <a:extLst xmlns:a="http://schemas.openxmlformats.org/drawingml/2006/main">
               <a:ext uri="{FF2B5EF4-FFF2-40B4-BE49-F238E27FC236}">
-                <a16:creationId xmlns:a16="http://schemas.microsoft.com/office/drawing/2014/main" id="{D1E47C29-9F40-4900-9204-25631A5CCA0F}"/>
+                <a16:creationId xmlns:a16="http://schemas.microsoft.com/office/drawing/2014/main" id="{5D0E95CD-7A98-4145-BD6E-6AF0B3E868EB}"/>
               </a:ext>
             </a:extLst>
           </p:cNvPr>
@@ -17563,7 +17563,7 @@
           <p:cNvPr id="2" name="">
             <a:extLst xmlns:a="http://schemas.openxmlformats.org/drawingml/2006/main">
               <a:ext uri="{FF2B5EF4-FFF2-40B4-BE49-F238E27FC236}">
-                <a16:creationId xmlns:a16="http://schemas.microsoft.com/office/drawing/2014/main" id="{254412EE-B6C7-4BB0-8149-D826CCF6AF6C}"/>
+                <a16:creationId xmlns:a16="http://schemas.microsoft.com/office/drawing/2014/main" id="{B08C5794-51FC-4263-9ECF-22BF6F187231}"/>
               </a:ext>
             </a:extLst>
           </p:cNvPr>
@@ -17613,7 +17613,7 @@
           <p:cNvPr id="3" name="">
             <a:extLst xmlns:a="http://schemas.openxmlformats.org/drawingml/2006/main">
               <a:ext uri="{FF2B5EF4-FFF2-40B4-BE49-F238E27FC236}">
-                <a16:creationId xmlns:a16="http://schemas.microsoft.com/office/drawing/2014/main" id="{9E70EDF3-9278-48AA-9756-32794A8BD16D}"/>
+                <a16:creationId xmlns:a16="http://schemas.microsoft.com/office/drawing/2014/main" id="{893F5DBD-3727-401D-9A10-4B00FF2C22CE}"/>
               </a:ext>
             </a:extLst>
           </p:cNvPr>
@@ -17663,7 +17663,7 @@
           <p:cNvPr id="4" name="">
             <a:extLst xmlns:a="http://schemas.openxmlformats.org/drawingml/2006/main">
               <a:ext uri="{FF2B5EF4-FFF2-40B4-BE49-F238E27FC236}">
-                <a16:creationId xmlns:a16="http://schemas.microsoft.com/office/drawing/2014/main" id="{D165104D-4359-4383-8832-044E4116F873}"/>
+                <a16:creationId xmlns:a16="http://schemas.microsoft.com/office/drawing/2014/main" id="{7904FB10-EC9B-45BE-A8BC-93D757205FB3}"/>
               </a:ext>
             </a:extLst>
           </p:cNvPr>
@@ -17713,7 +17713,7 @@
           <p:cNvPr id="5" name="">
             <a:extLst xmlns:a="http://schemas.openxmlformats.org/drawingml/2006/main">
               <a:ext uri="{FF2B5EF4-FFF2-40B4-BE49-F238E27FC236}">
-                <a16:creationId xmlns:a16="http://schemas.microsoft.com/office/drawing/2014/main" id="{98C6A9E4-9B43-427F-B8F7-0F55A7F3407C}"/>
+                <a16:creationId xmlns:a16="http://schemas.microsoft.com/office/drawing/2014/main" id="{39820CBC-43CB-42B0-80EE-B9C7ED34BC42}"/>
               </a:ext>
             </a:extLst>
           </p:cNvPr>
@@ -17744,7 +17744,7 @@
           <p:cNvPr id="6" name="">
             <a:extLst xmlns:a="http://schemas.openxmlformats.org/drawingml/2006/main">
               <a:ext uri="{FF2B5EF4-FFF2-40B4-BE49-F238E27FC236}">
-                <a16:creationId xmlns:a16="http://schemas.microsoft.com/office/drawing/2014/main" id="{88587BE8-69B2-44E3-BA73-F1B665CDF2C1}"/>
+                <a16:creationId xmlns:a16="http://schemas.microsoft.com/office/drawing/2014/main" id="{D7D91852-51DE-4A6A-8CC1-841162239FF1}"/>
               </a:ext>
             </a:extLst>
           </p:cNvPr>
@@ -17794,7 +17794,7 @@
           <p:cNvPr id="7" name="">
             <a:extLst xmlns:a="http://schemas.openxmlformats.org/drawingml/2006/main">
               <a:ext uri="{FF2B5EF4-FFF2-40B4-BE49-F238E27FC236}">
-                <a16:creationId xmlns:a16="http://schemas.microsoft.com/office/drawing/2014/main" id="{9F0F1868-0453-449B-BB37-93BBDB596DCF}"/>
+                <a16:creationId xmlns:a16="http://schemas.microsoft.com/office/drawing/2014/main" id="{9201E24D-004D-456F-9D08-B22F4F08C13E}"/>
               </a:ext>
             </a:extLst>
           </p:cNvPr>
@@ -17844,7 +17844,7 @@
           <p:cNvPr id="8" name="">
             <a:extLst xmlns:a="http://schemas.openxmlformats.org/drawingml/2006/main">
               <a:ext uri="{FF2B5EF4-FFF2-40B4-BE49-F238E27FC236}">
-                <a16:creationId xmlns:a16="http://schemas.microsoft.com/office/drawing/2014/main" id="{0AE0BC2A-816D-4970-8118-180841E40471}"/>
+                <a16:creationId xmlns:a16="http://schemas.microsoft.com/office/drawing/2014/main" id="{9CAC5CD8-B58D-49BD-A3A5-265B526144A5}"/>
               </a:ext>
             </a:extLst>
           </p:cNvPr>
@@ -17875,7 +17875,7 @@
           <p:cNvPr id="9" name="">
             <a:extLst xmlns:a="http://schemas.openxmlformats.org/drawingml/2006/main">
               <a:ext uri="{FF2B5EF4-FFF2-40B4-BE49-F238E27FC236}">
-                <a16:creationId xmlns:a16="http://schemas.microsoft.com/office/drawing/2014/main" id="{8142B0F3-AB50-4FED-9E22-9C5B9DC60186}"/>
+                <a16:creationId xmlns:a16="http://schemas.microsoft.com/office/drawing/2014/main" id="{292FBFA2-65D4-473A-800A-FCAC267DDEC4}"/>
               </a:ext>
             </a:extLst>
           </p:cNvPr>
@@ -17925,7 +17925,7 @@
           <p:cNvPr id="10" name="">
             <a:extLst xmlns:a="http://schemas.openxmlformats.org/drawingml/2006/main">
               <a:ext uri="{FF2B5EF4-FFF2-40B4-BE49-F238E27FC236}">
-                <a16:creationId xmlns:a16="http://schemas.microsoft.com/office/drawing/2014/main" id="{89A35DDC-EC30-447E-9935-D05B4E65DE0D}"/>
+                <a16:creationId xmlns:a16="http://schemas.microsoft.com/office/drawing/2014/main" id="{5FC293A9-054E-4710-9637-5084EEF8443B}"/>
               </a:ext>
             </a:extLst>
           </p:cNvPr>
@@ -17975,7 +17975,7 @@
           <p:cNvPr id="11" name="">
             <a:extLst xmlns:a="http://schemas.openxmlformats.org/drawingml/2006/main">
               <a:ext uri="{FF2B5EF4-FFF2-40B4-BE49-F238E27FC236}">
-                <a16:creationId xmlns:a16="http://schemas.microsoft.com/office/drawing/2014/main" id="{878AAB86-795B-4E56-9809-C397D5449530}"/>
+                <a16:creationId xmlns:a16="http://schemas.microsoft.com/office/drawing/2014/main" id="{88F5DE2C-8AAC-4DF1-9931-F0215BAFEB37}"/>
               </a:ext>
             </a:extLst>
           </p:cNvPr>
@@ -18006,7 +18006,7 @@
           <p:cNvPr id="12" name="">
             <a:extLst xmlns:a="http://schemas.openxmlformats.org/drawingml/2006/main">
               <a:ext uri="{FF2B5EF4-FFF2-40B4-BE49-F238E27FC236}">
-                <a16:creationId xmlns:a16="http://schemas.microsoft.com/office/drawing/2014/main" id="{EB992E89-A628-433A-8143-5574843C6C22}"/>
+                <a16:creationId xmlns:a16="http://schemas.microsoft.com/office/drawing/2014/main" id="{E6BD6C37-480C-42C8-AD98-97584603ECBB}"/>
               </a:ext>
             </a:extLst>
           </p:cNvPr>
@@ -18056,7 +18056,7 @@
           <p:cNvPr id="13" name="">
             <a:extLst xmlns:a="http://schemas.openxmlformats.org/drawingml/2006/main">
               <a:ext uri="{FF2B5EF4-FFF2-40B4-BE49-F238E27FC236}">
-                <a16:creationId xmlns:a16="http://schemas.microsoft.com/office/drawing/2014/main" id="{DCB1509A-B39C-481A-8C1F-FF17EBC424D7}"/>
+                <a16:creationId xmlns:a16="http://schemas.microsoft.com/office/drawing/2014/main" id="{2AFBEE34-4B4B-4AC4-89CE-962642D72663}"/>
               </a:ext>
             </a:extLst>
           </p:cNvPr>
@@ -18106,7 +18106,7 @@
           <p:cNvPr id="14" name="">
             <a:extLst xmlns:a="http://schemas.openxmlformats.org/drawingml/2006/main">
               <a:ext uri="{FF2B5EF4-FFF2-40B4-BE49-F238E27FC236}">
-                <a16:creationId xmlns:a16="http://schemas.microsoft.com/office/drawing/2014/main" id="{895FBD66-AA5F-4D97-B36A-AE1A60856DAE}"/>
+                <a16:creationId xmlns:a16="http://schemas.microsoft.com/office/drawing/2014/main" id="{23BE86AE-A562-4DAF-9B08-1FF32E42E018}"/>
               </a:ext>
             </a:extLst>
           </p:cNvPr>
@@ -18141,7 +18141,7 @@
           <p:nvPr/>
         </p:nvPicPr>
         <p:blipFill>
-          <a:blip xmlns:r="http://schemas.openxmlformats.org/officeDocument/2006/relationships" xmlns:a="http://schemas.openxmlformats.org/drawingml/2006/main" r:embed="R77bfcb40c6364fd8"/>
+          <a:blip xmlns:r="http://schemas.openxmlformats.org/officeDocument/2006/relationships" xmlns:a="http://schemas.openxmlformats.org/drawingml/2006/main" r:embed="Rbc70faaf9b5046c3"/>
           <a:stretch xmlns:a="http://schemas.openxmlformats.org/drawingml/2006/main"/>
         </p:blipFill>
         <p:spPr>
@@ -18159,7 +18159,7 @@
           <p:cNvPr id="16" name="">
             <a:extLst xmlns:a="http://schemas.openxmlformats.org/drawingml/2006/main">
               <a:ext uri="{FF2B5EF4-FFF2-40B4-BE49-F238E27FC236}">
-                <a16:creationId xmlns:a16="http://schemas.microsoft.com/office/drawing/2014/main" id="{12050D88-1278-4A88-ABDB-997DC14A09A8}"/>
+                <a16:creationId xmlns:a16="http://schemas.microsoft.com/office/drawing/2014/main" id="{954B5A73-9075-4FC3-8638-BF949087D39F}"/>
               </a:ext>
             </a:extLst>
           </p:cNvPr>
@@ -18209,7 +18209,7 @@
           <p:cNvPr id="17" name="">
             <a:extLst xmlns:a="http://schemas.openxmlformats.org/drawingml/2006/main">
               <a:ext uri="{FF2B5EF4-FFF2-40B4-BE49-F238E27FC236}">
-                <a16:creationId xmlns:a16="http://schemas.microsoft.com/office/drawing/2014/main" id="{7CD56507-34C5-4D2A-BA3C-8FB9DAFBC6BB}"/>
+                <a16:creationId xmlns:a16="http://schemas.microsoft.com/office/drawing/2014/main" id="{C5020893-B3BE-4757-B67A-6CD74CF572C7}"/>
               </a:ext>
             </a:extLst>
           </p:cNvPr>
@@ -18257,7 +18257,7 @@
     </p:spTree>
     <p:extLst>
       <p:ext uri="{BB962C8B-B14F-4D97-AF65-F5344CB8AC3E}">
-        <p14:creationId xmlns:p14="http://schemas.microsoft.com/office/powerpoint/2010/main" val="165023335"/>
+        <p14:creationId xmlns:p14="http://schemas.microsoft.com/office/powerpoint/2010/main" val="510999114"/>
       </p:ext>
     </p:extLst>
   </p:cSld>
@@ -18288,7 +18288,7 @@
           <p:cNvPr id="1" name="">
             <a:extLst xmlns:a="http://schemas.openxmlformats.org/drawingml/2006/main">
               <a:ext uri="{FF2B5EF4-FFF2-40B4-BE49-F238E27FC236}">
-                <a16:creationId xmlns:a16="http://schemas.microsoft.com/office/drawing/2014/main" id="{B3DBBDCD-70B3-46D6-B2AD-F3653ACFA86E}"/>
+                <a16:creationId xmlns:a16="http://schemas.microsoft.com/office/drawing/2014/main" id="{BAD18E52-3071-4300-870D-A6516ADD3B84}"/>
               </a:ext>
             </a:extLst>
           </p:cNvPr>
@@ -18319,7 +18319,7 @@
           <p:cNvPr id="2" name="">
             <a:extLst xmlns:a="http://schemas.openxmlformats.org/drawingml/2006/main">
               <a:ext uri="{FF2B5EF4-FFF2-40B4-BE49-F238E27FC236}">
-                <a16:creationId xmlns:a16="http://schemas.microsoft.com/office/drawing/2014/main" id="{1478FC75-3116-4FAF-83A8-0B72C3313155}"/>
+                <a16:creationId xmlns:a16="http://schemas.microsoft.com/office/drawing/2014/main" id="{B3656EA1-6859-4E8E-A94D-541F29F3C1ED}"/>
               </a:ext>
             </a:extLst>
           </p:cNvPr>
@@ -18369,7 +18369,7 @@
           <p:cNvPr id="3" name="">
             <a:extLst xmlns:a="http://schemas.openxmlformats.org/drawingml/2006/main">
               <a:ext uri="{FF2B5EF4-FFF2-40B4-BE49-F238E27FC236}">
-                <a16:creationId xmlns:a16="http://schemas.microsoft.com/office/drawing/2014/main" id="{02A2BCD7-82C2-4BE5-AC9F-1DB5DAE486FC}"/>
+                <a16:creationId xmlns:a16="http://schemas.microsoft.com/office/drawing/2014/main" id="{46CB8449-09E3-4ED0-9605-A30741941C9E}"/>
               </a:ext>
             </a:extLst>
           </p:cNvPr>
@@ -18419,7 +18419,7 @@
           <p:cNvPr id="4" name="">
             <a:extLst xmlns:a="http://schemas.openxmlformats.org/drawingml/2006/main">
               <a:ext uri="{FF2B5EF4-FFF2-40B4-BE49-F238E27FC236}">
-                <a16:creationId xmlns:a16="http://schemas.microsoft.com/office/drawing/2014/main" id="{BC39F205-3892-450E-9932-EF4FEC4EA062}"/>
+                <a16:creationId xmlns:a16="http://schemas.microsoft.com/office/drawing/2014/main" id="{36EE5B76-DF5C-4DC3-9FFD-820F830C7EE6}"/>
               </a:ext>
             </a:extLst>
           </p:cNvPr>
@@ -18452,7 +18452,7 @@
           <p:cNvPr id="5" name="">
             <a:extLst xmlns:a="http://schemas.openxmlformats.org/drawingml/2006/main">
               <a:ext uri="{FF2B5EF4-FFF2-40B4-BE49-F238E27FC236}">
-                <a16:creationId xmlns:a16="http://schemas.microsoft.com/office/drawing/2014/main" id="{F5E6B111-6DD3-48F9-95DB-472FB3A7070B}"/>
+                <a16:creationId xmlns:a16="http://schemas.microsoft.com/office/drawing/2014/main" id="{8C2BE2EA-75A6-48C5-A05C-0CE51F879032}"/>
               </a:ext>
             </a:extLst>
           </p:cNvPr>
@@ -18502,7 +18502,7 @@
           <p:cNvPr id="6" name="">
             <a:extLst xmlns:a="http://schemas.openxmlformats.org/drawingml/2006/main">
               <a:ext uri="{FF2B5EF4-FFF2-40B4-BE49-F238E27FC236}">
-                <a16:creationId xmlns:a16="http://schemas.microsoft.com/office/drawing/2014/main" id="{60A3DDE6-CD69-43D3-9991-094E668F4982}"/>
+                <a16:creationId xmlns:a16="http://schemas.microsoft.com/office/drawing/2014/main" id="{FA2299A0-5C83-44F7-986B-BE2EA3C6AE3A}"/>
               </a:ext>
             </a:extLst>
           </p:cNvPr>
@@ -18552,7 +18552,7 @@
           <p:cNvPr id="7" name="">
             <a:extLst xmlns:a="http://schemas.openxmlformats.org/drawingml/2006/main">
               <a:ext uri="{FF2B5EF4-FFF2-40B4-BE49-F238E27FC236}">
-                <a16:creationId xmlns:a16="http://schemas.microsoft.com/office/drawing/2014/main" id="{ACD92F6F-CEBD-4C36-9280-5D36AEFE239A}"/>
+                <a16:creationId xmlns:a16="http://schemas.microsoft.com/office/drawing/2014/main" id="{1A20A9B3-F456-4DA8-B935-8CC18DD43F3A}"/>
               </a:ext>
             </a:extLst>
           </p:cNvPr>
@@ -18602,7 +18602,7 @@
           <p:cNvPr id="8" name="">
             <a:extLst xmlns:a="http://schemas.openxmlformats.org/drawingml/2006/main">
               <a:ext uri="{FF2B5EF4-FFF2-40B4-BE49-F238E27FC236}">
-                <a16:creationId xmlns:a16="http://schemas.microsoft.com/office/drawing/2014/main" id="{E0260963-A6F8-40DB-9FE3-D3F873B7038E}"/>
+                <a16:creationId xmlns:a16="http://schemas.microsoft.com/office/drawing/2014/main" id="{10439291-A609-410D-96DD-2BFF4F70DC09}"/>
               </a:ext>
             </a:extLst>
           </p:cNvPr>
@@ -18652,7 +18652,7 @@
           <p:cNvPr id="9" name="">
             <a:extLst xmlns:a="http://schemas.openxmlformats.org/drawingml/2006/main">
               <a:ext uri="{FF2B5EF4-FFF2-40B4-BE49-F238E27FC236}">
-                <a16:creationId xmlns:a16="http://schemas.microsoft.com/office/drawing/2014/main" id="{F3379C0D-764F-4AF3-BEA3-812DF1525BCF}"/>
+                <a16:creationId xmlns:a16="http://schemas.microsoft.com/office/drawing/2014/main" id="{8B3237FB-ABCC-4E17-8880-DBAB4BF70EDF}"/>
               </a:ext>
             </a:extLst>
           </p:cNvPr>
@@ -18685,7 +18685,7 @@
           <p:cNvPr id="10" name="">
             <a:extLst xmlns:a="http://schemas.openxmlformats.org/drawingml/2006/main">
               <a:ext uri="{FF2B5EF4-FFF2-40B4-BE49-F238E27FC236}">
-                <a16:creationId xmlns:a16="http://schemas.microsoft.com/office/drawing/2014/main" id="{ECC5BD32-174E-4CC1-A5F4-8902F10CDF4B}"/>
+                <a16:creationId xmlns:a16="http://schemas.microsoft.com/office/drawing/2014/main" id="{54B9FE27-2BDD-40F9-A67F-08FF578210A6}"/>
               </a:ext>
             </a:extLst>
           </p:cNvPr>
@@ -18735,7 +18735,7 @@
           <p:cNvPr id="11" name="">
             <a:extLst xmlns:a="http://schemas.openxmlformats.org/drawingml/2006/main">
               <a:ext uri="{FF2B5EF4-FFF2-40B4-BE49-F238E27FC236}">
-                <a16:creationId xmlns:a16="http://schemas.microsoft.com/office/drawing/2014/main" id="{C053EE2C-60DC-40D3-BC18-621416C086ED}"/>
+                <a16:creationId xmlns:a16="http://schemas.microsoft.com/office/drawing/2014/main" id="{9F7622DF-FE32-4835-A667-A89B439B6F0F}"/>
               </a:ext>
             </a:extLst>
           </p:cNvPr>
@@ -18785,7 +18785,7 @@
           <p:cNvPr id="12" name="">
             <a:extLst xmlns:a="http://schemas.openxmlformats.org/drawingml/2006/main">
               <a:ext uri="{FF2B5EF4-FFF2-40B4-BE49-F238E27FC236}">
-                <a16:creationId xmlns:a16="http://schemas.microsoft.com/office/drawing/2014/main" id="{C1DED71E-5083-4A08-9B2E-072EFFC5D4C3}"/>
+                <a16:creationId xmlns:a16="http://schemas.microsoft.com/office/drawing/2014/main" id="{10F611AB-8E41-47F5-B79A-C04E9CAEFF09}"/>
               </a:ext>
             </a:extLst>
           </p:cNvPr>
@@ -18835,7 +18835,7 @@
           <p:cNvPr id="13" name="">
             <a:extLst xmlns:a="http://schemas.openxmlformats.org/drawingml/2006/main">
               <a:ext uri="{FF2B5EF4-FFF2-40B4-BE49-F238E27FC236}">
-                <a16:creationId xmlns:a16="http://schemas.microsoft.com/office/drawing/2014/main" id="{C39F648C-F7BC-47B6-A3A1-383BE1276099}"/>
+                <a16:creationId xmlns:a16="http://schemas.microsoft.com/office/drawing/2014/main" id="{7D718034-520D-4664-88ED-C0F33B0EFA0E}"/>
               </a:ext>
             </a:extLst>
           </p:cNvPr>
@@ -18885,7 +18885,7 @@
           <p:cNvPr id="14" name="">
             <a:extLst xmlns:a="http://schemas.openxmlformats.org/drawingml/2006/main">
               <a:ext uri="{FF2B5EF4-FFF2-40B4-BE49-F238E27FC236}">
-                <a16:creationId xmlns:a16="http://schemas.microsoft.com/office/drawing/2014/main" id="{3F95A170-FFC1-417E-9588-FE9D4214812F}"/>
+                <a16:creationId xmlns:a16="http://schemas.microsoft.com/office/drawing/2014/main" id="{0D2E9A5F-EE8C-4A15-A1B1-1BD9E9E2153D}"/>
               </a:ext>
             </a:extLst>
           </p:cNvPr>
@@ -18918,7 +18918,7 @@
           <p:cNvPr id="15" name="">
             <a:extLst xmlns:a="http://schemas.openxmlformats.org/drawingml/2006/main">
               <a:ext uri="{FF2B5EF4-FFF2-40B4-BE49-F238E27FC236}">
-                <a16:creationId xmlns:a16="http://schemas.microsoft.com/office/drawing/2014/main" id="{C83815D0-9864-40A1-953C-77C6D62FE728}"/>
+                <a16:creationId xmlns:a16="http://schemas.microsoft.com/office/drawing/2014/main" id="{5C861111-79EC-4631-BEB0-7DB6573F1F8E}"/>
               </a:ext>
             </a:extLst>
           </p:cNvPr>
@@ -18968,7 +18968,7 @@
           <p:cNvPr id="16" name="">
             <a:extLst xmlns:a="http://schemas.openxmlformats.org/drawingml/2006/main">
               <a:ext uri="{FF2B5EF4-FFF2-40B4-BE49-F238E27FC236}">
-                <a16:creationId xmlns:a16="http://schemas.microsoft.com/office/drawing/2014/main" id="{4AA03FBE-356D-474B-8784-DD0C5B848695}"/>
+                <a16:creationId xmlns:a16="http://schemas.microsoft.com/office/drawing/2014/main" id="{E96AB821-2C7F-4C99-AE0C-2DBEA908E07C}"/>
               </a:ext>
             </a:extLst>
           </p:cNvPr>
@@ -19018,7 +19018,7 @@
           <p:cNvPr id="17" name="">
             <a:extLst xmlns:a="http://schemas.openxmlformats.org/drawingml/2006/main">
               <a:ext uri="{FF2B5EF4-FFF2-40B4-BE49-F238E27FC236}">
-                <a16:creationId xmlns:a16="http://schemas.microsoft.com/office/drawing/2014/main" id="{84517271-AF70-45AD-A014-25BABA86FC3F}"/>
+                <a16:creationId xmlns:a16="http://schemas.microsoft.com/office/drawing/2014/main" id="{569ECB9E-289C-4DC2-A028-FAFDDBFC17BD}"/>
               </a:ext>
             </a:extLst>
           </p:cNvPr>
@@ -19068,7 +19068,7 @@
           <p:cNvPr id="18" name="">
             <a:extLst xmlns:a="http://schemas.openxmlformats.org/drawingml/2006/main">
               <a:ext uri="{FF2B5EF4-FFF2-40B4-BE49-F238E27FC236}">
-                <a16:creationId xmlns:a16="http://schemas.microsoft.com/office/drawing/2014/main" id="{33D225F3-E30D-4010-A899-E081EC5A68D3}"/>
+                <a16:creationId xmlns:a16="http://schemas.microsoft.com/office/drawing/2014/main" id="{5116B743-EFDE-4CBD-B541-4D13A6AD1E75}"/>
               </a:ext>
             </a:extLst>
           </p:cNvPr>
@@ -19118,7 +19118,7 @@
           <p:cNvPr id="19" name="">
             <a:extLst xmlns:a="http://schemas.openxmlformats.org/drawingml/2006/main">
               <a:ext uri="{FF2B5EF4-FFF2-40B4-BE49-F238E27FC236}">
-                <a16:creationId xmlns:a16="http://schemas.microsoft.com/office/drawing/2014/main" id="{CCA30AEA-1C40-49FF-9D97-B72BCCC6B1E4}"/>
+                <a16:creationId xmlns:a16="http://schemas.microsoft.com/office/drawing/2014/main" id="{28859B12-332D-4107-9596-1FBBE2A79BA0}"/>
               </a:ext>
             </a:extLst>
           </p:cNvPr>
@@ -19151,7 +19151,7 @@
           <p:cNvPr id="20" name="">
             <a:extLst xmlns:a="http://schemas.openxmlformats.org/drawingml/2006/main">
               <a:ext uri="{FF2B5EF4-FFF2-40B4-BE49-F238E27FC236}">
-                <a16:creationId xmlns:a16="http://schemas.microsoft.com/office/drawing/2014/main" id="{BCBFC9D1-0C93-46E4-B9BC-52F73EC7DBFD}"/>
+                <a16:creationId xmlns:a16="http://schemas.microsoft.com/office/drawing/2014/main" id="{6100C1E5-2B73-4911-B293-F6C5D2F2CA53}"/>
               </a:ext>
             </a:extLst>
           </p:cNvPr>
@@ -19201,7 +19201,7 @@
           <p:cNvPr id="21" name="">
             <a:extLst xmlns:a="http://schemas.openxmlformats.org/drawingml/2006/main">
               <a:ext uri="{FF2B5EF4-FFF2-40B4-BE49-F238E27FC236}">
-                <a16:creationId xmlns:a16="http://schemas.microsoft.com/office/drawing/2014/main" id="{B5D1ED85-34A0-457F-AEC0-40B931BCD0D2}"/>
+                <a16:creationId xmlns:a16="http://schemas.microsoft.com/office/drawing/2014/main" id="{D304EBC7-7F7C-43DF-9FCC-A573660CE72B}"/>
               </a:ext>
             </a:extLst>
           </p:cNvPr>
@@ -19251,7 +19251,7 @@
           <p:cNvPr id="22" name="">
             <a:extLst xmlns:a="http://schemas.openxmlformats.org/drawingml/2006/main">
               <a:ext uri="{FF2B5EF4-FFF2-40B4-BE49-F238E27FC236}">
-                <a16:creationId xmlns:a16="http://schemas.microsoft.com/office/drawing/2014/main" id="{853B59A7-6B4C-46CB-96A7-1B5B7E40A6E7}"/>
+                <a16:creationId xmlns:a16="http://schemas.microsoft.com/office/drawing/2014/main" id="{47C882EA-8066-463C-B04B-3522DF7C4A27}"/>
               </a:ext>
             </a:extLst>
           </p:cNvPr>
@@ -19301,7 +19301,7 @@
           <p:cNvPr id="23" name="">
             <a:extLst xmlns:a="http://schemas.openxmlformats.org/drawingml/2006/main">
               <a:ext uri="{FF2B5EF4-FFF2-40B4-BE49-F238E27FC236}">
-                <a16:creationId xmlns:a16="http://schemas.microsoft.com/office/drawing/2014/main" id="{F6A2FBAF-9B52-43A2-AB60-5FF56EAD3D8D}"/>
+                <a16:creationId xmlns:a16="http://schemas.microsoft.com/office/drawing/2014/main" id="{B6F7FD85-7E4A-421B-9E6F-D871A3CE68FD}"/>
               </a:ext>
             </a:extLst>
           </p:cNvPr>
@@ -19351,7 +19351,7 @@
           <p:cNvPr id="24" name="">
             <a:extLst xmlns:a="http://schemas.openxmlformats.org/drawingml/2006/main">
               <a:ext uri="{FF2B5EF4-FFF2-40B4-BE49-F238E27FC236}">
-                <a16:creationId xmlns:a16="http://schemas.microsoft.com/office/drawing/2014/main" id="{AEC8C279-25B1-4B08-8110-EB374A2F3BED}"/>
+                <a16:creationId xmlns:a16="http://schemas.microsoft.com/office/drawing/2014/main" id="{3D8184BB-B629-4891-A2A8-709A43143693}"/>
               </a:ext>
             </a:extLst>
           </p:cNvPr>
@@ -19384,7 +19384,7 @@
           <p:cNvPr id="25" name="">
             <a:extLst xmlns:a="http://schemas.openxmlformats.org/drawingml/2006/main">
               <a:ext uri="{FF2B5EF4-FFF2-40B4-BE49-F238E27FC236}">
-                <a16:creationId xmlns:a16="http://schemas.microsoft.com/office/drawing/2014/main" id="{0279A071-4AF4-47D3-A221-07F24437D23E}"/>
+                <a16:creationId xmlns:a16="http://schemas.microsoft.com/office/drawing/2014/main" id="{CDB407F3-C0C0-46C0-BFA5-7C9DD02560AB}"/>
               </a:ext>
             </a:extLst>
           </p:cNvPr>
@@ -19434,7 +19434,7 @@
           <p:cNvPr id="26" name="">
             <a:extLst xmlns:a="http://schemas.openxmlformats.org/drawingml/2006/main">
               <a:ext uri="{FF2B5EF4-FFF2-40B4-BE49-F238E27FC236}">
-                <a16:creationId xmlns:a16="http://schemas.microsoft.com/office/drawing/2014/main" id="{F510C94A-3661-446E-A401-B30B8B74B910}"/>
+                <a16:creationId xmlns:a16="http://schemas.microsoft.com/office/drawing/2014/main" id="{0B9CBB3E-25C9-46E0-A03C-C5369615C812}"/>
               </a:ext>
             </a:extLst>
           </p:cNvPr>
@@ -19484,7 +19484,7 @@
           <p:cNvPr id="27" name="">
             <a:extLst xmlns:a="http://schemas.openxmlformats.org/drawingml/2006/main">
               <a:ext uri="{FF2B5EF4-FFF2-40B4-BE49-F238E27FC236}">
-                <a16:creationId xmlns:a16="http://schemas.microsoft.com/office/drawing/2014/main" id="{F47E1C7E-7ED7-45CA-AC57-749ABF84131B}"/>
+                <a16:creationId xmlns:a16="http://schemas.microsoft.com/office/drawing/2014/main" id="{4FE2E58F-368D-417B-A30E-FB13CCBC0844}"/>
               </a:ext>
             </a:extLst>
           </p:cNvPr>
@@ -19534,7 +19534,7 @@
           <p:cNvPr id="28" name="">
             <a:extLst xmlns:a="http://schemas.openxmlformats.org/drawingml/2006/main">
               <a:ext uri="{FF2B5EF4-FFF2-40B4-BE49-F238E27FC236}">
-                <a16:creationId xmlns:a16="http://schemas.microsoft.com/office/drawing/2014/main" id="{88D44710-782C-4BAD-A06F-693EA7869D04}"/>
+                <a16:creationId xmlns:a16="http://schemas.microsoft.com/office/drawing/2014/main" id="{32930EE5-9600-4408-90E8-FFFB6E256354}"/>
               </a:ext>
             </a:extLst>
           </p:cNvPr>
@@ -19569,7 +19569,7 @@
           <p:nvPr/>
         </p:nvPicPr>
         <p:blipFill>
-          <a:blip xmlns:r="http://schemas.openxmlformats.org/officeDocument/2006/relationships" xmlns:a="http://schemas.openxmlformats.org/drawingml/2006/main" r:embed="R4b6d5b95e8ea41d3"/>
+          <a:blip xmlns:r="http://schemas.openxmlformats.org/officeDocument/2006/relationships" xmlns:a="http://schemas.openxmlformats.org/drawingml/2006/main" r:embed="R0d2cfe70b0b84dba"/>
           <a:stretch xmlns:a="http://schemas.openxmlformats.org/drawingml/2006/main"/>
         </p:blipFill>
         <p:spPr>
@@ -19587,7 +19587,7 @@
           <p:cNvPr id="30" name="">
             <a:extLst xmlns:a="http://schemas.openxmlformats.org/drawingml/2006/main">
               <a:ext uri="{FF2B5EF4-FFF2-40B4-BE49-F238E27FC236}">
-                <a16:creationId xmlns:a16="http://schemas.microsoft.com/office/drawing/2014/main" id="{7CA83613-2AA3-482A-AA2C-6A6FC1E650B3}"/>
+                <a16:creationId xmlns:a16="http://schemas.microsoft.com/office/drawing/2014/main" id="{309D6A5D-732C-4B4D-99C8-AA2BC7E2D221}"/>
               </a:ext>
             </a:extLst>
           </p:cNvPr>
@@ -19637,7 +19637,7 @@
           <p:cNvPr id="31" name="">
             <a:extLst xmlns:a="http://schemas.openxmlformats.org/drawingml/2006/main">
               <a:ext uri="{FF2B5EF4-FFF2-40B4-BE49-F238E27FC236}">
-                <a16:creationId xmlns:a16="http://schemas.microsoft.com/office/drawing/2014/main" id="{6AAC0A7A-97D6-4652-9A11-891AD89D75D7}"/>
+                <a16:creationId xmlns:a16="http://schemas.microsoft.com/office/drawing/2014/main" id="{551AC58D-59EA-4D4A-B56B-51B8B55882F6}"/>
               </a:ext>
             </a:extLst>
           </p:cNvPr>
@@ -19685,7 +19685,7 @@
     </p:spTree>
     <p:extLst>
       <p:ext uri="{BB962C8B-B14F-4D97-AF65-F5344CB8AC3E}">
-        <p14:creationId xmlns:p14="http://schemas.microsoft.com/office/powerpoint/2010/main" val="672774303"/>
+        <p14:creationId xmlns:p14="http://schemas.microsoft.com/office/powerpoint/2010/main" val="333055538"/>
       </p:ext>
     </p:extLst>
   </p:cSld>
@@ -19716,7 +19716,7 @@
           <p:cNvPr id="1" name="">
             <a:extLst xmlns:a="http://schemas.openxmlformats.org/drawingml/2006/main">
               <a:ext uri="{FF2B5EF4-FFF2-40B4-BE49-F238E27FC236}">
-                <a16:creationId xmlns:a16="http://schemas.microsoft.com/office/drawing/2014/main" id="{8AD371E9-91E0-4B31-AAD8-EFB784BC0609}"/>
+                <a16:creationId xmlns:a16="http://schemas.microsoft.com/office/drawing/2014/main" id="{DB8A7F5D-22B8-49C4-A8E1-E0F54FEF6781}"/>
               </a:ext>
             </a:extLst>
           </p:cNvPr>
@@ -19747,7 +19747,7 @@
           <p:cNvPr id="2" name="">
             <a:extLst xmlns:a="http://schemas.openxmlformats.org/drawingml/2006/main">
               <a:ext uri="{FF2B5EF4-FFF2-40B4-BE49-F238E27FC236}">
-                <a16:creationId xmlns:a16="http://schemas.microsoft.com/office/drawing/2014/main" id="{94DAECF3-7697-4BBF-B0A4-0BD96E061470}"/>
+                <a16:creationId xmlns:a16="http://schemas.microsoft.com/office/drawing/2014/main" id="{1CB98C6D-9E00-4EB3-8F3E-68BE88AC08D1}"/>
               </a:ext>
             </a:extLst>
           </p:cNvPr>
@@ -19797,7 +19797,7 @@
           <p:cNvPr id="3" name="">
             <a:extLst xmlns:a="http://schemas.openxmlformats.org/drawingml/2006/main">
               <a:ext uri="{FF2B5EF4-FFF2-40B4-BE49-F238E27FC236}">
-                <a16:creationId xmlns:a16="http://schemas.microsoft.com/office/drawing/2014/main" id="{C24B3019-3C66-4147-B515-B2B06CE8729D}"/>
+                <a16:creationId xmlns:a16="http://schemas.microsoft.com/office/drawing/2014/main" id="{8F6F47A0-716B-48AF-86B4-A7424C1348C1}"/>
               </a:ext>
             </a:extLst>
           </p:cNvPr>
@@ -19847,7 +19847,7 @@
           <p:cNvPr id="4" name="">
             <a:extLst xmlns:a="http://schemas.openxmlformats.org/drawingml/2006/main">
               <a:ext uri="{FF2B5EF4-FFF2-40B4-BE49-F238E27FC236}">
-                <a16:creationId xmlns:a16="http://schemas.microsoft.com/office/drawing/2014/main" id="{943B4043-73E5-4BD7-8132-CDD2BA83364B}"/>
+                <a16:creationId xmlns:a16="http://schemas.microsoft.com/office/drawing/2014/main" id="{001E5399-6E91-4426-8102-679D8A05CB07}"/>
               </a:ext>
             </a:extLst>
           </p:cNvPr>
@@ -19882,7 +19882,7 @@
           <p:cNvPr id="5" name="">
             <a:extLst xmlns:a="http://schemas.openxmlformats.org/drawingml/2006/main">
               <a:ext uri="{FF2B5EF4-FFF2-40B4-BE49-F238E27FC236}">
-                <a16:creationId xmlns:a16="http://schemas.microsoft.com/office/drawing/2014/main" id="{359E83D6-6C5C-4A29-A3C7-64042138DDBF}"/>
+                <a16:creationId xmlns:a16="http://schemas.microsoft.com/office/drawing/2014/main" id="{B54508B2-E90E-487A-8F0A-BEEE0354AE1F}"/>
               </a:ext>
             </a:extLst>
           </p:cNvPr>
@@ -19913,7 +19913,7 @@
           <p:cNvPr id="6" name="">
             <a:extLst xmlns:a="http://schemas.openxmlformats.org/drawingml/2006/main">
               <a:ext uri="{FF2B5EF4-FFF2-40B4-BE49-F238E27FC236}">
-                <a16:creationId xmlns:a16="http://schemas.microsoft.com/office/drawing/2014/main" id="{1DCFEC18-75FF-46B0-BE1D-2D7B540C3D3A}"/>
+                <a16:creationId xmlns:a16="http://schemas.microsoft.com/office/drawing/2014/main" id="{1245EDA5-205B-48DE-8695-773508C0F963}"/>
               </a:ext>
             </a:extLst>
           </p:cNvPr>
@@ -19963,7 +19963,7 @@
           <p:cNvPr id="7" name="">
             <a:extLst xmlns:a="http://schemas.openxmlformats.org/drawingml/2006/main">
               <a:ext uri="{FF2B5EF4-FFF2-40B4-BE49-F238E27FC236}">
-                <a16:creationId xmlns:a16="http://schemas.microsoft.com/office/drawing/2014/main" id="{DB78139F-564E-45DB-A26D-E20558C36627}"/>
+                <a16:creationId xmlns:a16="http://schemas.microsoft.com/office/drawing/2014/main" id="{AE09A35D-3735-4257-9551-679D4C229F50}"/>
               </a:ext>
             </a:extLst>
           </p:cNvPr>
@@ -19994,7 +19994,7 @@
           <p:cNvPr id="8" name="">
             <a:extLst xmlns:a="http://schemas.openxmlformats.org/drawingml/2006/main">
               <a:ext uri="{FF2B5EF4-FFF2-40B4-BE49-F238E27FC236}">
-                <a16:creationId xmlns:a16="http://schemas.microsoft.com/office/drawing/2014/main" id="{2DBAF56B-9B9E-4865-B81D-5D527ADF2F66}"/>
+                <a16:creationId xmlns:a16="http://schemas.microsoft.com/office/drawing/2014/main" id="{B7E8A0DA-FD0F-41D7-87C0-5745A638C694}"/>
               </a:ext>
             </a:extLst>
           </p:cNvPr>
@@ -20025,7 +20025,7 @@
           <p:cNvPr id="9" name="">
             <a:extLst xmlns:a="http://schemas.openxmlformats.org/drawingml/2006/main">
               <a:ext uri="{FF2B5EF4-FFF2-40B4-BE49-F238E27FC236}">
-                <a16:creationId xmlns:a16="http://schemas.microsoft.com/office/drawing/2014/main" id="{B62AAF29-68EF-4ABD-A292-A9D1BA172E56}"/>
+                <a16:creationId xmlns:a16="http://schemas.microsoft.com/office/drawing/2014/main" id="{EA8DE296-0E93-407B-808A-E95DDB88181A}"/>
               </a:ext>
             </a:extLst>
           </p:cNvPr>
@@ -20056,7 +20056,7 @@
           <p:cNvPr id="10" name="">
             <a:extLst xmlns:a="http://schemas.openxmlformats.org/drawingml/2006/main">
               <a:ext uri="{FF2B5EF4-FFF2-40B4-BE49-F238E27FC236}">
-                <a16:creationId xmlns:a16="http://schemas.microsoft.com/office/drawing/2014/main" id="{47033173-589F-4AFB-B7A9-C1713A457A70}"/>
+                <a16:creationId xmlns:a16="http://schemas.microsoft.com/office/drawing/2014/main" id="{A902F403-BA51-4078-8E3D-23731DD96E74}"/>
               </a:ext>
             </a:extLst>
           </p:cNvPr>
@@ -20140,7 +20140,7 @@
           <p:cNvPr id="11" name="">
             <a:extLst xmlns:a="http://schemas.openxmlformats.org/drawingml/2006/main">
               <a:ext uri="{FF2B5EF4-FFF2-40B4-BE49-F238E27FC236}">
-                <a16:creationId xmlns:a16="http://schemas.microsoft.com/office/drawing/2014/main" id="{60C96CDB-BA66-4561-B653-44BB173C985B}"/>
+                <a16:creationId xmlns:a16="http://schemas.microsoft.com/office/drawing/2014/main" id="{D532B6D0-3392-4243-98BA-3872AD7B83E7}"/>
               </a:ext>
             </a:extLst>
           </p:cNvPr>
@@ -20234,7 +20234,7 @@
           <p:cNvPr id="12" name="">
             <a:extLst xmlns:a="http://schemas.openxmlformats.org/drawingml/2006/main">
               <a:ext uri="{FF2B5EF4-FFF2-40B4-BE49-F238E27FC236}">
-                <a16:creationId xmlns:a16="http://schemas.microsoft.com/office/drawing/2014/main" id="{3290E43F-B0DD-4AC0-980B-DECADC7D3DE0}"/>
+                <a16:creationId xmlns:a16="http://schemas.microsoft.com/office/drawing/2014/main" id="{EA8F3029-6D43-46CD-85BB-2A6AEC4D9A12}"/>
               </a:ext>
             </a:extLst>
           </p:cNvPr>
@@ -20335,7 +20335,7 @@
           <p:cNvPr id="13" name="">
             <a:extLst xmlns:a="http://schemas.openxmlformats.org/drawingml/2006/main">
               <a:ext uri="{FF2B5EF4-FFF2-40B4-BE49-F238E27FC236}">
-                <a16:creationId xmlns:a16="http://schemas.microsoft.com/office/drawing/2014/main" id="{B35D8335-D2B8-4E66-B8B9-AA5DEBEE030F}"/>
+                <a16:creationId xmlns:a16="http://schemas.microsoft.com/office/drawing/2014/main" id="{388C1888-AFC1-43F9-BB75-8618F79EAF15}"/>
               </a:ext>
             </a:extLst>
           </p:cNvPr>
@@ -20366,7 +20366,7 @@
           <p:cNvPr id="14" name="">
             <a:extLst xmlns:a="http://schemas.openxmlformats.org/drawingml/2006/main">
               <a:ext uri="{FF2B5EF4-FFF2-40B4-BE49-F238E27FC236}">
-                <a16:creationId xmlns:a16="http://schemas.microsoft.com/office/drawing/2014/main" id="{75C178D6-3A4E-4DD8-A5A5-73541EBBCD6B}"/>
+                <a16:creationId xmlns:a16="http://schemas.microsoft.com/office/drawing/2014/main" id="{E520E226-9BD0-4F99-BC7E-ECE8549286EF}"/>
               </a:ext>
             </a:extLst>
           </p:cNvPr>
@@ -20416,7 +20416,7 @@
           <p:cNvPr id="15" name="">
             <a:extLst xmlns:a="http://schemas.openxmlformats.org/drawingml/2006/main">
               <a:ext uri="{FF2B5EF4-FFF2-40B4-BE49-F238E27FC236}">
-                <a16:creationId xmlns:a16="http://schemas.microsoft.com/office/drawing/2014/main" id="{CB35069B-C695-4123-A90C-BF89272FE7B6}"/>
+                <a16:creationId xmlns:a16="http://schemas.microsoft.com/office/drawing/2014/main" id="{C0ED40B3-BF7F-483D-9E12-2DDB2276E4E6}"/>
               </a:ext>
             </a:extLst>
           </p:cNvPr>
@@ -20466,7 +20466,7 @@
           <p:cNvPr id="16" name="">
             <a:extLst xmlns:a="http://schemas.openxmlformats.org/drawingml/2006/main">
               <a:ext uri="{FF2B5EF4-FFF2-40B4-BE49-F238E27FC236}">
-                <a16:creationId xmlns:a16="http://schemas.microsoft.com/office/drawing/2014/main" id="{FDDC978D-E310-43BD-8BAF-4D8FA27AFBA3}"/>
+                <a16:creationId xmlns:a16="http://schemas.microsoft.com/office/drawing/2014/main" id="{DBA8ED40-5052-44BB-8972-4AEB1110953E}"/>
               </a:ext>
             </a:extLst>
           </p:cNvPr>
@@ -20497,7 +20497,7 @@
           <p:cNvPr id="17" name="">
             <a:extLst xmlns:a="http://schemas.openxmlformats.org/drawingml/2006/main">
               <a:ext uri="{FF2B5EF4-FFF2-40B4-BE49-F238E27FC236}">
-                <a16:creationId xmlns:a16="http://schemas.microsoft.com/office/drawing/2014/main" id="{F8B3B26F-CAF2-414E-A570-B4CD378B35EA}"/>
+                <a16:creationId xmlns:a16="http://schemas.microsoft.com/office/drawing/2014/main" id="{1A298318-5F94-4EFD-9771-720C5F263715}"/>
               </a:ext>
             </a:extLst>
           </p:cNvPr>
@@ -20547,7 +20547,7 @@
           <p:cNvPr id="18" name="">
             <a:extLst xmlns:a="http://schemas.openxmlformats.org/drawingml/2006/main">
               <a:ext uri="{FF2B5EF4-FFF2-40B4-BE49-F238E27FC236}">
-                <a16:creationId xmlns:a16="http://schemas.microsoft.com/office/drawing/2014/main" id="{10FEA8FD-FD94-405F-B4EC-0E990E540AA8}"/>
+                <a16:creationId xmlns:a16="http://schemas.microsoft.com/office/drawing/2014/main" id="{3FC8AEC4-EADC-4039-BCEC-0001966AC53F}"/>
               </a:ext>
             </a:extLst>
           </p:cNvPr>
@@ -20597,7 +20597,7 @@
           <p:cNvPr id="19" name="">
             <a:extLst xmlns:a="http://schemas.openxmlformats.org/drawingml/2006/main">
               <a:ext uri="{FF2B5EF4-FFF2-40B4-BE49-F238E27FC236}">
-                <a16:creationId xmlns:a16="http://schemas.microsoft.com/office/drawing/2014/main" id="{F8CE098C-ECA4-4E9D-B9F1-A33D1A293210}"/>
+                <a16:creationId xmlns:a16="http://schemas.microsoft.com/office/drawing/2014/main" id="{B9ADC0DF-B747-4B5F-8ADE-53E71FE55F4E}"/>
               </a:ext>
             </a:extLst>
           </p:cNvPr>
@@ -20628,7 +20628,7 @@
           <p:cNvPr id="20" name="">
             <a:extLst xmlns:a="http://schemas.openxmlformats.org/drawingml/2006/main">
               <a:ext uri="{FF2B5EF4-FFF2-40B4-BE49-F238E27FC236}">
-                <a16:creationId xmlns:a16="http://schemas.microsoft.com/office/drawing/2014/main" id="{7780C6B2-4F4E-45B0-8BC4-4FBE008D3697}"/>
+                <a16:creationId xmlns:a16="http://schemas.microsoft.com/office/drawing/2014/main" id="{FB80D237-85EE-4AC3-AB39-0504DA50FD2D}"/>
               </a:ext>
             </a:extLst>
           </p:cNvPr>
@@ -20678,7 +20678,7 @@
           <p:cNvPr id="21" name="">
             <a:extLst xmlns:a="http://schemas.openxmlformats.org/drawingml/2006/main">
               <a:ext uri="{FF2B5EF4-FFF2-40B4-BE49-F238E27FC236}">
-                <a16:creationId xmlns:a16="http://schemas.microsoft.com/office/drawing/2014/main" id="{135FB8A4-92B8-4A1A-9F24-CAB5E12AB306}"/>
+                <a16:creationId xmlns:a16="http://schemas.microsoft.com/office/drawing/2014/main" id="{9CEDA089-0A42-4619-AB4A-562734FA7145}"/>
               </a:ext>
             </a:extLst>
           </p:cNvPr>
@@ -20728,7 +20728,7 @@
           <p:cNvPr id="22" name="">
             <a:extLst xmlns:a="http://schemas.openxmlformats.org/drawingml/2006/main">
               <a:ext uri="{FF2B5EF4-FFF2-40B4-BE49-F238E27FC236}">
-                <a16:creationId xmlns:a16="http://schemas.microsoft.com/office/drawing/2014/main" id="{04F98D94-E599-4DEA-A7C7-49B80D8BDC2D}"/>
+                <a16:creationId xmlns:a16="http://schemas.microsoft.com/office/drawing/2014/main" id="{5A80F372-837D-4494-B545-2B5168A94205}"/>
               </a:ext>
             </a:extLst>
           </p:cNvPr>
@@ -20759,7 +20759,7 @@
           <p:cNvPr id="23" name="">
             <a:extLst xmlns:a="http://schemas.openxmlformats.org/drawingml/2006/main">
               <a:ext uri="{FF2B5EF4-FFF2-40B4-BE49-F238E27FC236}">
-                <a16:creationId xmlns:a16="http://schemas.microsoft.com/office/drawing/2014/main" id="{4DB4192C-95C0-4AED-B214-59A748E17638}"/>
+                <a16:creationId xmlns:a16="http://schemas.microsoft.com/office/drawing/2014/main" id="{16F2E31C-6D4E-4A66-AB46-23CAB42AB64E}"/>
               </a:ext>
             </a:extLst>
           </p:cNvPr>
@@ -20809,7 +20809,7 @@
           <p:cNvPr id="24" name="">
             <a:extLst xmlns:a="http://schemas.openxmlformats.org/drawingml/2006/main">
               <a:ext uri="{FF2B5EF4-FFF2-40B4-BE49-F238E27FC236}">
-                <a16:creationId xmlns:a16="http://schemas.microsoft.com/office/drawing/2014/main" id="{297E0E9B-9C40-4EA4-ACBC-DC31DCBB18CB}"/>
+                <a16:creationId xmlns:a16="http://schemas.microsoft.com/office/drawing/2014/main" id="{A74CF2BD-761D-41A6-B56B-ECE62AE1D53E}"/>
               </a:ext>
             </a:extLst>
           </p:cNvPr>
@@ -20859,7 +20859,7 @@
           <p:cNvPr id="25" name="">
             <a:extLst xmlns:a="http://schemas.openxmlformats.org/drawingml/2006/main">
               <a:ext uri="{FF2B5EF4-FFF2-40B4-BE49-F238E27FC236}">
-                <a16:creationId xmlns:a16="http://schemas.microsoft.com/office/drawing/2014/main" id="{8F9E1346-AED2-4C99-80F7-2E1361D9D05F}"/>
+                <a16:creationId xmlns:a16="http://schemas.microsoft.com/office/drawing/2014/main" id="{A19820A4-11C0-4ED7-A228-F06365675B60}"/>
               </a:ext>
             </a:extLst>
           </p:cNvPr>
@@ -20894,7 +20894,7 @@
           <p:nvPr/>
         </p:nvPicPr>
         <p:blipFill>
-          <a:blip xmlns:r="http://schemas.openxmlformats.org/officeDocument/2006/relationships" xmlns:a="http://schemas.openxmlformats.org/drawingml/2006/main" r:embed="Rd4778fbbc44049d9"/>
+          <a:blip xmlns:r="http://schemas.openxmlformats.org/officeDocument/2006/relationships" xmlns:a="http://schemas.openxmlformats.org/drawingml/2006/main" r:embed="R6fa585fe50bb47b6"/>
           <a:stretch xmlns:a="http://schemas.openxmlformats.org/drawingml/2006/main"/>
         </p:blipFill>
         <p:spPr>
@@ -20912,7 +20912,7 @@
           <p:cNvPr id="27" name="">
             <a:extLst xmlns:a="http://schemas.openxmlformats.org/drawingml/2006/main">
               <a:ext uri="{FF2B5EF4-FFF2-40B4-BE49-F238E27FC236}">
-                <a16:creationId xmlns:a16="http://schemas.microsoft.com/office/drawing/2014/main" id="{1C32D0C5-4D17-4C5A-8CB1-04F4182D056B}"/>
+                <a16:creationId xmlns:a16="http://schemas.microsoft.com/office/drawing/2014/main" id="{B3EBB559-9002-4D82-BF17-8E5E03E39C36}"/>
               </a:ext>
             </a:extLst>
           </p:cNvPr>
@@ -20962,7 +20962,7 @@
           <p:cNvPr id="28" name="">
             <a:extLst xmlns:a="http://schemas.openxmlformats.org/drawingml/2006/main">
               <a:ext uri="{FF2B5EF4-FFF2-40B4-BE49-F238E27FC236}">
-                <a16:creationId xmlns:a16="http://schemas.microsoft.com/office/drawing/2014/main" id="{4E1B1B12-76C8-4C6C-99A7-B75641C2DC17}"/>
+                <a16:creationId xmlns:a16="http://schemas.microsoft.com/office/drawing/2014/main" id="{37812A67-1C63-47D9-996D-461852F60960}"/>
               </a:ext>
             </a:extLst>
           </p:cNvPr>
@@ -21010,7 +21010,7 @@
     </p:spTree>
     <p:extLst>
       <p:ext uri="{BB962C8B-B14F-4D97-AF65-F5344CB8AC3E}">
-        <p14:creationId xmlns:p14="http://schemas.microsoft.com/office/powerpoint/2010/main" val="148458322"/>
+        <p14:creationId xmlns:p14="http://schemas.microsoft.com/office/powerpoint/2010/main" val="240365831"/>
       </p:ext>
     </p:extLst>
   </p:cSld>
@@ -21041,7 +21041,7 @@
           <p:cNvPr id="1" name="">
             <a:extLst xmlns:a="http://schemas.openxmlformats.org/drawingml/2006/main">
               <a:ext uri="{FF2B5EF4-FFF2-40B4-BE49-F238E27FC236}">
-                <a16:creationId xmlns:a16="http://schemas.microsoft.com/office/drawing/2014/main" id="{93404B0D-7F78-4FBC-A559-2C2640A881BE}"/>
+                <a16:creationId xmlns:a16="http://schemas.microsoft.com/office/drawing/2014/main" id="{5C8DAFFB-508C-45DC-AA17-EA85F3FE3EEA}"/>
               </a:ext>
             </a:extLst>
           </p:cNvPr>
@@ -21072,7 +21072,7 @@
           <p:cNvPr id="2" name="">
             <a:extLst xmlns:a="http://schemas.openxmlformats.org/drawingml/2006/main">
               <a:ext uri="{FF2B5EF4-FFF2-40B4-BE49-F238E27FC236}">
-                <a16:creationId xmlns:a16="http://schemas.microsoft.com/office/drawing/2014/main" id="{6D6DCF94-F419-4674-852B-006F0FAA1AE1}"/>
+                <a16:creationId xmlns:a16="http://schemas.microsoft.com/office/drawing/2014/main" id="{44898B31-6335-4892-9E5B-75606DE45E5B}"/>
               </a:ext>
             </a:extLst>
           </p:cNvPr>
@@ -21122,7 +21122,7 @@
           <p:cNvPr id="3" name="">
             <a:extLst xmlns:a="http://schemas.openxmlformats.org/drawingml/2006/main">
               <a:ext uri="{FF2B5EF4-FFF2-40B4-BE49-F238E27FC236}">
-                <a16:creationId xmlns:a16="http://schemas.microsoft.com/office/drawing/2014/main" id="{FF4E22BC-55CA-4C77-ABEF-57A7F0645F2D}"/>
+                <a16:creationId xmlns:a16="http://schemas.microsoft.com/office/drawing/2014/main" id="{688F9133-66A8-45B8-B9C6-DBD87128615E}"/>
               </a:ext>
             </a:extLst>
           </p:cNvPr>
@@ -21172,7 +21172,7 @@
           <p:cNvPr id="4" name="">
             <a:extLst xmlns:a="http://schemas.openxmlformats.org/drawingml/2006/main">
               <a:ext uri="{FF2B5EF4-FFF2-40B4-BE49-F238E27FC236}">
-                <a16:creationId xmlns:a16="http://schemas.microsoft.com/office/drawing/2014/main" id="{F51B8D3C-3E16-4DA2-9602-2C4A8A2FB23F}"/>
+                <a16:creationId xmlns:a16="http://schemas.microsoft.com/office/drawing/2014/main" id="{90F5914E-592E-421D-9FCF-03B5CFFDCB5E}"/>
               </a:ext>
             </a:extLst>
           </p:cNvPr>
@@ -21207,7 +21207,7 @@
           <p:cNvPr id="5" name="">
             <a:extLst xmlns:a="http://schemas.openxmlformats.org/drawingml/2006/main">
               <a:ext uri="{FF2B5EF4-FFF2-40B4-BE49-F238E27FC236}">
-                <a16:creationId xmlns:a16="http://schemas.microsoft.com/office/drawing/2014/main" id="{DB923F82-FD12-41D4-A18E-53435FC5D850}"/>
+                <a16:creationId xmlns:a16="http://schemas.microsoft.com/office/drawing/2014/main" id="{CD412701-E058-4C57-B8D3-B826AD96256E}"/>
               </a:ext>
             </a:extLst>
           </p:cNvPr>
@@ -21257,7 +21257,7 @@
           <p:cNvPr id="6" name="">
             <a:extLst xmlns:a="http://schemas.openxmlformats.org/drawingml/2006/main">
               <a:ext uri="{FF2B5EF4-FFF2-40B4-BE49-F238E27FC236}">
-                <a16:creationId xmlns:a16="http://schemas.microsoft.com/office/drawing/2014/main" id="{9F29D6AD-82B2-46AA-A028-62B5C5752F68}"/>
+                <a16:creationId xmlns:a16="http://schemas.microsoft.com/office/drawing/2014/main" id="{6E3E394A-9DA4-4A50-BF46-E92EE8247702}"/>
               </a:ext>
             </a:extLst>
           </p:cNvPr>
@@ -21358,7 +21358,7 @@
           <p:cNvPr id="7" name="">
             <a:extLst xmlns:a="http://schemas.openxmlformats.org/drawingml/2006/main">
               <a:ext uri="{FF2B5EF4-FFF2-40B4-BE49-F238E27FC236}">
-                <a16:creationId xmlns:a16="http://schemas.microsoft.com/office/drawing/2014/main" id="{488C972A-C1A6-43A7-A11F-8195C28B6820}"/>
+                <a16:creationId xmlns:a16="http://schemas.microsoft.com/office/drawing/2014/main" id="{EA1C6EA7-0C87-48B3-959F-6674C3EA33DD}"/>
               </a:ext>
             </a:extLst>
           </p:cNvPr>
@@ -21393,7 +21393,7 @@
           <p:cNvPr id="8" name="">
             <a:extLst xmlns:a="http://schemas.openxmlformats.org/drawingml/2006/main">
               <a:ext uri="{FF2B5EF4-FFF2-40B4-BE49-F238E27FC236}">
-                <a16:creationId xmlns:a16="http://schemas.microsoft.com/office/drawing/2014/main" id="{0477C3CC-A874-431F-BE4E-611ED5C91E98}"/>
+                <a16:creationId xmlns:a16="http://schemas.microsoft.com/office/drawing/2014/main" id="{747D9660-4209-4795-BB97-7526C31C14AD}"/>
               </a:ext>
             </a:extLst>
           </p:cNvPr>
@@ -21443,7 +21443,7 @@
           <p:cNvPr id="9" name="">
             <a:extLst xmlns:a="http://schemas.openxmlformats.org/drawingml/2006/main">
               <a:ext uri="{FF2B5EF4-FFF2-40B4-BE49-F238E27FC236}">
-                <a16:creationId xmlns:a16="http://schemas.microsoft.com/office/drawing/2014/main" id="{C97AC7FD-D9C3-4CDC-B90C-4B3325839CF6}"/>
+                <a16:creationId xmlns:a16="http://schemas.microsoft.com/office/drawing/2014/main" id="{78E356D4-46ED-413B-A408-B1C0CC94C602}"/>
               </a:ext>
             </a:extLst>
           </p:cNvPr>
@@ -21544,7 +21544,7 @@
           <p:cNvPr id="10" name="">
             <a:extLst xmlns:a="http://schemas.openxmlformats.org/drawingml/2006/main">
               <a:ext uri="{FF2B5EF4-FFF2-40B4-BE49-F238E27FC236}">
-                <a16:creationId xmlns:a16="http://schemas.microsoft.com/office/drawing/2014/main" id="{17C304A9-3705-44F6-9289-B22FDABF310D}"/>
+                <a16:creationId xmlns:a16="http://schemas.microsoft.com/office/drawing/2014/main" id="{86589F05-DDA6-4BCA-90A1-39D375C16B6F}"/>
               </a:ext>
             </a:extLst>
           </p:cNvPr>
@@ -21575,7 +21575,7 @@
           <p:cNvPr id="11" name="">
             <a:extLst xmlns:a="http://schemas.openxmlformats.org/drawingml/2006/main">
               <a:ext uri="{FF2B5EF4-FFF2-40B4-BE49-F238E27FC236}">
-                <a16:creationId xmlns:a16="http://schemas.microsoft.com/office/drawing/2014/main" id="{9DFA7F27-2C0B-44CD-B44E-B3485BFAE9C0}"/>
+                <a16:creationId xmlns:a16="http://schemas.microsoft.com/office/drawing/2014/main" id="{29D77A09-B19F-4C30-9E31-5EFE114B69D0}"/>
               </a:ext>
             </a:extLst>
           </p:cNvPr>
@@ -21606,7 +21606,7 @@
           <p:cNvPr id="12" name="">
             <a:extLst xmlns:a="http://schemas.openxmlformats.org/drawingml/2006/main">
               <a:ext uri="{FF2B5EF4-FFF2-40B4-BE49-F238E27FC236}">
-                <a16:creationId xmlns:a16="http://schemas.microsoft.com/office/drawing/2014/main" id="{7AD3EA7A-4F2D-46F5-AEF7-29824DA4B6B5}"/>
+                <a16:creationId xmlns:a16="http://schemas.microsoft.com/office/drawing/2014/main" id="{F74574BE-8AE1-4E2C-9B19-83F25088CD7B}"/>
               </a:ext>
             </a:extLst>
           </p:cNvPr>
@@ -21641,7 +21641,7 @@
           <p:nvPr/>
         </p:nvPicPr>
         <p:blipFill>
-          <a:blip xmlns:r="http://schemas.openxmlformats.org/officeDocument/2006/relationships" xmlns:a="http://schemas.openxmlformats.org/drawingml/2006/main" r:embed="R7e2b82a43d9d4b4a"/>
+          <a:blip xmlns:r="http://schemas.openxmlformats.org/officeDocument/2006/relationships" xmlns:a="http://schemas.openxmlformats.org/drawingml/2006/main" r:embed="Ree0ffe2c44f54a7c"/>
           <a:stretch xmlns:a="http://schemas.openxmlformats.org/drawingml/2006/main"/>
         </p:blipFill>
         <p:spPr>
@@ -21659,7 +21659,7 @@
           <p:cNvPr id="14" name="">
             <a:extLst xmlns:a="http://schemas.openxmlformats.org/drawingml/2006/main">
               <a:ext uri="{FF2B5EF4-FFF2-40B4-BE49-F238E27FC236}">
-                <a16:creationId xmlns:a16="http://schemas.microsoft.com/office/drawing/2014/main" id="{0DF806FC-80C2-45F3-B810-27D24CF30BB7}"/>
+                <a16:creationId xmlns:a16="http://schemas.microsoft.com/office/drawing/2014/main" id="{CBADBE92-DEA7-4A5A-AAD9-DE71DAD3B2F4}"/>
               </a:ext>
             </a:extLst>
           </p:cNvPr>
@@ -21709,7 +21709,7 @@
           <p:cNvPr id="15" name="">
             <a:extLst xmlns:a="http://schemas.openxmlformats.org/drawingml/2006/main">
               <a:ext uri="{FF2B5EF4-FFF2-40B4-BE49-F238E27FC236}">
-                <a16:creationId xmlns:a16="http://schemas.microsoft.com/office/drawing/2014/main" id="{CBCD2BDB-B001-46AC-9269-393F1B18B27E}"/>
+                <a16:creationId xmlns:a16="http://schemas.microsoft.com/office/drawing/2014/main" id="{785B3A98-7B10-46BF-BF10-E3878949966B}"/>
               </a:ext>
             </a:extLst>
           </p:cNvPr>
@@ -21757,7 +21757,7 @@
     </p:spTree>
     <p:extLst>
       <p:ext uri="{BB962C8B-B14F-4D97-AF65-F5344CB8AC3E}">
-        <p14:creationId xmlns:p14="http://schemas.microsoft.com/office/powerpoint/2010/main" val="120375887"/>
+        <p14:creationId xmlns:p14="http://schemas.microsoft.com/office/powerpoint/2010/main" val="318192158"/>
       </p:ext>
     </p:extLst>
   </p:cSld>
@@ -21788,7 +21788,7 @@
           <p:cNvPr id="1" name="">
             <a:extLst xmlns:a="http://schemas.openxmlformats.org/drawingml/2006/main">
               <a:ext uri="{FF2B5EF4-FFF2-40B4-BE49-F238E27FC236}">
-                <a16:creationId xmlns:a16="http://schemas.microsoft.com/office/drawing/2014/main" id="{3BADE4D2-1014-4DE2-97D8-F0AC4863AB7E}"/>
+                <a16:creationId xmlns:a16="http://schemas.microsoft.com/office/drawing/2014/main" id="{2650B8C9-0D99-4E05-AAF8-CC6455F53382}"/>
               </a:ext>
             </a:extLst>
           </p:cNvPr>
@@ -21819,7 +21819,7 @@
           <p:cNvPr id="2" name="">
             <a:extLst xmlns:a="http://schemas.openxmlformats.org/drawingml/2006/main">
               <a:ext uri="{FF2B5EF4-FFF2-40B4-BE49-F238E27FC236}">
-                <a16:creationId xmlns:a16="http://schemas.microsoft.com/office/drawing/2014/main" id="{C099DD89-6E0B-4D28-9AA0-9EBF83A0F334}"/>
+                <a16:creationId xmlns:a16="http://schemas.microsoft.com/office/drawing/2014/main" id="{A3D0667D-5160-413E-9572-49069FB86AE1}"/>
               </a:ext>
             </a:extLst>
           </p:cNvPr>
@@ -21869,7 +21869,7 @@
           <p:cNvPr id="3" name="">
             <a:extLst xmlns:a="http://schemas.openxmlformats.org/drawingml/2006/main">
               <a:ext uri="{FF2B5EF4-FFF2-40B4-BE49-F238E27FC236}">
-                <a16:creationId xmlns:a16="http://schemas.microsoft.com/office/drawing/2014/main" id="{85B2AFAB-1832-4971-98CE-BBCE4CB78AE5}"/>
+                <a16:creationId xmlns:a16="http://schemas.microsoft.com/office/drawing/2014/main" id="{A6BE8F4A-D910-48C0-AFC3-8535B69104B6}"/>
               </a:ext>
             </a:extLst>
           </p:cNvPr>
@@ -21919,7 +21919,7 @@
           <p:cNvPr id="4" name="">
             <a:extLst xmlns:a="http://schemas.openxmlformats.org/drawingml/2006/main">
               <a:ext uri="{FF2B5EF4-FFF2-40B4-BE49-F238E27FC236}">
-                <a16:creationId xmlns:a16="http://schemas.microsoft.com/office/drawing/2014/main" id="{8240FD01-7322-4520-9C52-1A4D81B7E2DC}"/>
+                <a16:creationId xmlns:a16="http://schemas.microsoft.com/office/drawing/2014/main" id="{9F64205C-3E8C-43EC-97C8-5D12D827B0D5}"/>
               </a:ext>
             </a:extLst>
           </p:cNvPr>
@@ -21954,7 +21954,7 @@
           <p:cNvPr id="5" name="">
             <a:extLst xmlns:a="http://schemas.openxmlformats.org/drawingml/2006/main">
               <a:ext uri="{FF2B5EF4-FFF2-40B4-BE49-F238E27FC236}">
-                <a16:creationId xmlns:a16="http://schemas.microsoft.com/office/drawing/2014/main" id="{05CD9A7E-D98F-4F9D-BB70-CA247B17C01F}"/>
+                <a16:creationId xmlns:a16="http://schemas.microsoft.com/office/drawing/2014/main" id="{F16732D8-E27C-4635-A0B8-ECD2CDF53F9A}"/>
               </a:ext>
             </a:extLst>
           </p:cNvPr>
@@ -22004,7 +22004,7 @@
           <p:cNvPr id="6" name="">
             <a:extLst xmlns:a="http://schemas.openxmlformats.org/drawingml/2006/main">
               <a:ext uri="{FF2B5EF4-FFF2-40B4-BE49-F238E27FC236}">
-                <a16:creationId xmlns:a16="http://schemas.microsoft.com/office/drawing/2014/main" id="{9C62D8A9-D750-4189-BC59-2AA8B29A31C8}"/>
+                <a16:creationId xmlns:a16="http://schemas.microsoft.com/office/drawing/2014/main" id="{B4BA3DD5-5300-4F80-B9DF-A240259FF747}"/>
               </a:ext>
             </a:extLst>
           </p:cNvPr>
@@ -22071,7 +22071,7 @@
           <p:cNvPr id="7" name="">
             <a:extLst xmlns:a="http://schemas.openxmlformats.org/drawingml/2006/main">
               <a:ext uri="{FF2B5EF4-FFF2-40B4-BE49-F238E27FC236}">
-                <a16:creationId xmlns:a16="http://schemas.microsoft.com/office/drawing/2014/main" id="{9CB83B64-10BF-4653-B3A7-7FD0FFA562BA}"/>
+                <a16:creationId xmlns:a16="http://schemas.microsoft.com/office/drawing/2014/main" id="{DEEA1640-DB0C-47E8-AF5B-750668C02B91}"/>
               </a:ext>
             </a:extLst>
           </p:cNvPr>
@@ -22121,7 +22121,7 @@
           <p:cNvPr id="8" name="">
             <a:extLst xmlns:a="http://schemas.openxmlformats.org/drawingml/2006/main">
               <a:ext uri="{FF2B5EF4-FFF2-40B4-BE49-F238E27FC236}">
-                <a16:creationId xmlns:a16="http://schemas.microsoft.com/office/drawing/2014/main" id="{B3885A43-A561-41BE-A853-5D489CCE914A}"/>
+                <a16:creationId xmlns:a16="http://schemas.microsoft.com/office/drawing/2014/main" id="{F6245952-A886-4656-95F3-E17F8D0703A5}"/>
               </a:ext>
             </a:extLst>
           </p:cNvPr>
@@ -22156,7 +22156,7 @@
           <p:cNvPr id="9" name="">
             <a:extLst xmlns:a="http://schemas.openxmlformats.org/drawingml/2006/main">
               <a:ext uri="{FF2B5EF4-FFF2-40B4-BE49-F238E27FC236}">
-                <a16:creationId xmlns:a16="http://schemas.microsoft.com/office/drawing/2014/main" id="{5D6A1916-6561-4DF4-B00D-CB1E428A5DF7}"/>
+                <a16:creationId xmlns:a16="http://schemas.microsoft.com/office/drawing/2014/main" id="{EC5A97EE-1A14-470E-86EB-BCA18CE274F0}"/>
               </a:ext>
             </a:extLst>
           </p:cNvPr>
@@ -22206,7 +22206,7 @@
           <p:cNvPr id="10" name="">
             <a:extLst xmlns:a="http://schemas.openxmlformats.org/drawingml/2006/main">
               <a:ext uri="{FF2B5EF4-FFF2-40B4-BE49-F238E27FC236}">
-                <a16:creationId xmlns:a16="http://schemas.microsoft.com/office/drawing/2014/main" id="{76B945F3-83E4-469C-BCEC-CEB988ECD782}"/>
+                <a16:creationId xmlns:a16="http://schemas.microsoft.com/office/drawing/2014/main" id="{1CDBA19F-7C24-4E37-ABC1-30E1A8E8C9F9}"/>
               </a:ext>
             </a:extLst>
           </p:cNvPr>
@@ -22273,7 +22273,7 @@
           <p:cNvPr id="11" name="">
             <a:extLst xmlns:a="http://schemas.openxmlformats.org/drawingml/2006/main">
               <a:ext uri="{FF2B5EF4-FFF2-40B4-BE49-F238E27FC236}">
-                <a16:creationId xmlns:a16="http://schemas.microsoft.com/office/drawing/2014/main" id="{ACE7AE50-3ABD-4AC9-8B5A-81C7BEA15170}"/>
+                <a16:creationId xmlns:a16="http://schemas.microsoft.com/office/drawing/2014/main" id="{189D9335-F46A-44FD-9859-BF3954C5F2B7}"/>
               </a:ext>
             </a:extLst>
           </p:cNvPr>
@@ -22323,7 +22323,7 @@
           <p:cNvPr id="12" name="">
             <a:extLst xmlns:a="http://schemas.openxmlformats.org/drawingml/2006/main">
               <a:ext uri="{FF2B5EF4-FFF2-40B4-BE49-F238E27FC236}">
-                <a16:creationId xmlns:a16="http://schemas.microsoft.com/office/drawing/2014/main" id="{31E742E6-6E39-4B78-8E87-B78B8904A063}"/>
+                <a16:creationId xmlns:a16="http://schemas.microsoft.com/office/drawing/2014/main" id="{BCC92185-2647-4E56-A35F-03D2FCE2F393}"/>
               </a:ext>
             </a:extLst>
           </p:cNvPr>
@@ -22358,7 +22358,7 @@
           <p:cNvPr id="13" name="">
             <a:extLst xmlns:a="http://schemas.openxmlformats.org/drawingml/2006/main">
               <a:ext uri="{FF2B5EF4-FFF2-40B4-BE49-F238E27FC236}">
-                <a16:creationId xmlns:a16="http://schemas.microsoft.com/office/drawing/2014/main" id="{B22A7BFC-29E0-4823-ABA7-26247CF97949}"/>
+                <a16:creationId xmlns:a16="http://schemas.microsoft.com/office/drawing/2014/main" id="{D90C7BCF-87AA-4347-8D9E-1CF9FED7076A}"/>
               </a:ext>
             </a:extLst>
           </p:cNvPr>
@@ -22408,7 +22408,7 @@
           <p:cNvPr id="14" name="">
             <a:extLst xmlns:a="http://schemas.openxmlformats.org/drawingml/2006/main">
               <a:ext uri="{FF2B5EF4-FFF2-40B4-BE49-F238E27FC236}">
-                <a16:creationId xmlns:a16="http://schemas.microsoft.com/office/drawing/2014/main" id="{E0ECFB7C-01F3-46A7-BF06-895068489A54}"/>
+                <a16:creationId xmlns:a16="http://schemas.microsoft.com/office/drawing/2014/main" id="{32EA2B6C-91D9-48D4-A86F-1BC1E3481DBF}"/>
               </a:ext>
             </a:extLst>
           </p:cNvPr>
@@ -22492,7 +22492,7 @@
           <p:cNvPr id="15" name="">
             <a:extLst xmlns:a="http://schemas.openxmlformats.org/drawingml/2006/main">
               <a:ext uri="{FF2B5EF4-FFF2-40B4-BE49-F238E27FC236}">
-                <a16:creationId xmlns:a16="http://schemas.microsoft.com/office/drawing/2014/main" id="{AF8F896F-C638-4F08-B6F6-7848D0AABAF2}"/>
+                <a16:creationId xmlns:a16="http://schemas.microsoft.com/office/drawing/2014/main" id="{7C12FF98-A8B0-4571-A80D-13A84C198EBA}"/>
               </a:ext>
             </a:extLst>
           </p:cNvPr>
@@ -22542,7 +22542,7 @@
           <p:cNvPr id="16" name="">
             <a:extLst xmlns:a="http://schemas.openxmlformats.org/drawingml/2006/main">
               <a:ext uri="{FF2B5EF4-FFF2-40B4-BE49-F238E27FC236}">
-                <a16:creationId xmlns:a16="http://schemas.microsoft.com/office/drawing/2014/main" id="{E25812F6-A10D-4FD9-BC5F-869622E66F8F}"/>
+                <a16:creationId xmlns:a16="http://schemas.microsoft.com/office/drawing/2014/main" id="{4EC474D9-E09C-4F01-A60B-D76F03E32B2B}"/>
               </a:ext>
             </a:extLst>
           </p:cNvPr>
@@ -22577,7 +22577,7 @@
           <p:cNvPr id="17" name="">
             <a:extLst xmlns:a="http://schemas.openxmlformats.org/drawingml/2006/main">
               <a:ext uri="{FF2B5EF4-FFF2-40B4-BE49-F238E27FC236}">
-                <a16:creationId xmlns:a16="http://schemas.microsoft.com/office/drawing/2014/main" id="{57B48DEE-2A03-4323-A158-088CAA0776B0}"/>
+                <a16:creationId xmlns:a16="http://schemas.microsoft.com/office/drawing/2014/main" id="{F7FC25AB-660D-4ADB-AE97-A5887FC941AC}"/>
               </a:ext>
             </a:extLst>
           </p:cNvPr>
@@ -22627,7 +22627,7 @@
           <p:cNvPr id="18" name="">
             <a:extLst xmlns:a="http://schemas.openxmlformats.org/drawingml/2006/main">
               <a:ext uri="{FF2B5EF4-FFF2-40B4-BE49-F238E27FC236}">
-                <a16:creationId xmlns:a16="http://schemas.microsoft.com/office/drawing/2014/main" id="{A8FB9933-77D6-415C-949B-072DA268C032}"/>
+                <a16:creationId xmlns:a16="http://schemas.microsoft.com/office/drawing/2014/main" id="{66702A76-B415-4206-9530-31A084E2D168}"/>
               </a:ext>
             </a:extLst>
           </p:cNvPr>
@@ -22711,7 +22711,7 @@
           <p:cNvPr id="19" name="">
             <a:extLst xmlns:a="http://schemas.openxmlformats.org/drawingml/2006/main">
               <a:ext uri="{FF2B5EF4-FFF2-40B4-BE49-F238E27FC236}">
-                <a16:creationId xmlns:a16="http://schemas.microsoft.com/office/drawing/2014/main" id="{759EC42E-E1DF-4011-AC05-47AF95B67777}"/>
+                <a16:creationId xmlns:a16="http://schemas.microsoft.com/office/drawing/2014/main" id="{00407634-7919-48FC-8E8A-0D86FC4031B1}"/>
               </a:ext>
             </a:extLst>
           </p:cNvPr>
@@ -22761,7 +22761,7 @@
           <p:cNvPr id="20" name="">
             <a:extLst xmlns:a="http://schemas.openxmlformats.org/drawingml/2006/main">
               <a:ext uri="{FF2B5EF4-FFF2-40B4-BE49-F238E27FC236}">
-                <a16:creationId xmlns:a16="http://schemas.microsoft.com/office/drawing/2014/main" id="{A20DA11E-79A6-4870-83F4-4083005C98D6}"/>
+                <a16:creationId xmlns:a16="http://schemas.microsoft.com/office/drawing/2014/main" id="{238815BA-42D7-4E8B-B6AC-B1F0C839BE78}"/>
               </a:ext>
             </a:extLst>
           </p:cNvPr>
@@ -22796,7 +22796,7 @@
           <p:cNvPr id="21" name="">
             <a:extLst xmlns:a="http://schemas.openxmlformats.org/drawingml/2006/main">
               <a:ext uri="{FF2B5EF4-FFF2-40B4-BE49-F238E27FC236}">
-                <a16:creationId xmlns:a16="http://schemas.microsoft.com/office/drawing/2014/main" id="{80B27474-B6BE-417E-8FA7-CB47BD731E8E}"/>
+                <a16:creationId xmlns:a16="http://schemas.microsoft.com/office/drawing/2014/main" id="{08A4052B-D8C5-4F34-AB52-C7AC5FDADB91}"/>
               </a:ext>
             </a:extLst>
           </p:cNvPr>
@@ -22846,7 +22846,7 @@
           <p:cNvPr id="22" name="">
             <a:extLst xmlns:a="http://schemas.openxmlformats.org/drawingml/2006/main">
               <a:ext uri="{FF2B5EF4-FFF2-40B4-BE49-F238E27FC236}">
-                <a16:creationId xmlns:a16="http://schemas.microsoft.com/office/drawing/2014/main" id="{E936224C-1512-4F1E-934B-54E6AC352787}"/>
+                <a16:creationId xmlns:a16="http://schemas.microsoft.com/office/drawing/2014/main" id="{6744163A-939B-4B07-8AD1-30405AA3FC2E}"/>
               </a:ext>
             </a:extLst>
           </p:cNvPr>
@@ -22913,7 +22913,7 @@
           <p:cNvPr id="23" name="">
             <a:extLst xmlns:a="http://schemas.openxmlformats.org/drawingml/2006/main">
               <a:ext uri="{FF2B5EF4-FFF2-40B4-BE49-F238E27FC236}">
-                <a16:creationId xmlns:a16="http://schemas.microsoft.com/office/drawing/2014/main" id="{E8808DB2-01D2-4B57-9729-5DC4DB0915C4}"/>
+                <a16:creationId xmlns:a16="http://schemas.microsoft.com/office/drawing/2014/main" id="{7FC6B044-F808-48F6-A1CA-AC68F5823D8A}"/>
               </a:ext>
             </a:extLst>
           </p:cNvPr>
@@ -22963,7 +22963,7 @@
           <p:cNvPr id="24" name="">
             <a:extLst xmlns:a="http://schemas.openxmlformats.org/drawingml/2006/main">
               <a:ext uri="{FF2B5EF4-FFF2-40B4-BE49-F238E27FC236}">
-                <a16:creationId xmlns:a16="http://schemas.microsoft.com/office/drawing/2014/main" id="{E4945FC8-85D1-4E40-9449-A4C6C1042A1A}"/>
+                <a16:creationId xmlns:a16="http://schemas.microsoft.com/office/drawing/2014/main" id="{1FC9BD6F-198D-4A1B-91AA-D78B8F0D37E9}"/>
               </a:ext>
             </a:extLst>
           </p:cNvPr>
@@ -22998,7 +22998,7 @@
           <p:nvPr/>
         </p:nvPicPr>
         <p:blipFill>
-          <a:blip xmlns:r="http://schemas.openxmlformats.org/officeDocument/2006/relationships" xmlns:a="http://schemas.openxmlformats.org/drawingml/2006/main" r:embed="R1eba8f7d89d142ca"/>
+          <a:blip xmlns:r="http://schemas.openxmlformats.org/officeDocument/2006/relationships" xmlns:a="http://schemas.openxmlformats.org/drawingml/2006/main" r:embed="Rcdd8628feb6e4f1a"/>
           <a:stretch xmlns:a="http://schemas.openxmlformats.org/drawingml/2006/main"/>
         </p:blipFill>
         <p:spPr>
@@ -23016,7 +23016,7 @@
           <p:cNvPr id="26" name="">
             <a:extLst xmlns:a="http://schemas.openxmlformats.org/drawingml/2006/main">
               <a:ext uri="{FF2B5EF4-FFF2-40B4-BE49-F238E27FC236}">
-                <a16:creationId xmlns:a16="http://schemas.microsoft.com/office/drawing/2014/main" id="{D1C5AAF0-F6F4-4DE6-BFD4-A8D8F8F72A82}"/>
+                <a16:creationId xmlns:a16="http://schemas.microsoft.com/office/drawing/2014/main" id="{A6A86DC0-6ADC-4C37-98AC-E7D6F9137A0D}"/>
               </a:ext>
             </a:extLst>
           </p:cNvPr>
@@ -23066,7 +23066,7 @@
           <p:cNvPr id="27" name="">
             <a:extLst xmlns:a="http://schemas.openxmlformats.org/drawingml/2006/main">
               <a:ext uri="{FF2B5EF4-FFF2-40B4-BE49-F238E27FC236}">
-                <a16:creationId xmlns:a16="http://schemas.microsoft.com/office/drawing/2014/main" id="{48F64EFF-CFB1-48D5-A182-989B963209C1}"/>
+                <a16:creationId xmlns:a16="http://schemas.microsoft.com/office/drawing/2014/main" id="{F0BB4026-CA48-4248-8778-0C94AC538BB4}"/>
               </a:ext>
             </a:extLst>
           </p:cNvPr>
@@ -23114,7 +23114,7 @@
     </p:spTree>
     <p:extLst>
       <p:ext uri="{BB962C8B-B14F-4D97-AF65-F5344CB8AC3E}">
-        <p14:creationId xmlns:p14="http://schemas.microsoft.com/office/powerpoint/2010/main" val="1413776054"/>
+        <p14:creationId xmlns:p14="http://schemas.microsoft.com/office/powerpoint/2010/main" val="1166252465"/>
       </p:ext>
     </p:extLst>
   </p:cSld>
@@ -23145,7 +23145,7 @@
           <p:cNvPr id="1" name="">
             <a:extLst xmlns:a="http://schemas.openxmlformats.org/drawingml/2006/main">
               <a:ext uri="{FF2B5EF4-FFF2-40B4-BE49-F238E27FC236}">
-                <a16:creationId xmlns:a16="http://schemas.microsoft.com/office/drawing/2014/main" id="{AF4EE09C-DC69-4190-B543-B029F119D2DC}"/>
+                <a16:creationId xmlns:a16="http://schemas.microsoft.com/office/drawing/2014/main" id="{1A66812C-4E78-49DA-BA94-7F51AE043215}"/>
               </a:ext>
             </a:extLst>
           </p:cNvPr>
@@ -23176,7 +23176,7 @@
           <p:cNvPr id="2" name="">
             <a:extLst xmlns:a="http://schemas.openxmlformats.org/drawingml/2006/main">
               <a:ext uri="{FF2B5EF4-FFF2-40B4-BE49-F238E27FC236}">
-                <a16:creationId xmlns:a16="http://schemas.microsoft.com/office/drawing/2014/main" id="{E28255C7-0F8B-4CC3-AC35-CEEBA4777ED6}"/>
+                <a16:creationId xmlns:a16="http://schemas.microsoft.com/office/drawing/2014/main" id="{46CC1BA4-CA73-4849-B0AB-60D19AB608D2}"/>
               </a:ext>
             </a:extLst>
           </p:cNvPr>
@@ -23226,7 +23226,7 @@
           <p:cNvPr id="3" name="">
             <a:extLst xmlns:a="http://schemas.openxmlformats.org/drawingml/2006/main">
               <a:ext uri="{FF2B5EF4-FFF2-40B4-BE49-F238E27FC236}">
-                <a16:creationId xmlns:a16="http://schemas.microsoft.com/office/drawing/2014/main" id="{A74C922F-7BF1-41E1-A203-E6C6D11C563F}"/>
+                <a16:creationId xmlns:a16="http://schemas.microsoft.com/office/drawing/2014/main" id="{C123C892-AC80-4EE0-A80C-4DF2BD3D12AF}"/>
               </a:ext>
             </a:extLst>
           </p:cNvPr>
@@ -23276,7 +23276,7 @@
           <p:cNvPr id="4" name="">
             <a:extLst xmlns:a="http://schemas.openxmlformats.org/drawingml/2006/main">
               <a:ext uri="{FF2B5EF4-FFF2-40B4-BE49-F238E27FC236}">
-                <a16:creationId xmlns:a16="http://schemas.microsoft.com/office/drawing/2014/main" id="{6A93E582-46D1-4968-AC04-FAE67968142C}"/>
+                <a16:creationId xmlns:a16="http://schemas.microsoft.com/office/drawing/2014/main" id="{94E9E82B-BA02-466E-BB51-9622B0EC7192}"/>
               </a:ext>
             </a:extLst>
           </p:cNvPr>
@@ -23326,7 +23326,7 @@
           <p:cNvPr id="5" name="">
             <a:extLst xmlns:a="http://schemas.openxmlformats.org/drawingml/2006/main">
               <a:ext uri="{FF2B5EF4-FFF2-40B4-BE49-F238E27FC236}">
-                <a16:creationId xmlns:a16="http://schemas.microsoft.com/office/drawing/2014/main" id="{37CD41AD-85B0-49EB-A522-652AB9F49750}"/>
+                <a16:creationId xmlns:a16="http://schemas.microsoft.com/office/drawing/2014/main" id="{780912FC-32E1-436E-8B28-6C269ED3B845}"/>
               </a:ext>
             </a:extLst>
           </p:cNvPr>
@@ -23357,7 +23357,7 @@
           <p:cNvPr id="6" name="">
             <a:extLst xmlns:a="http://schemas.openxmlformats.org/drawingml/2006/main">
               <a:ext uri="{FF2B5EF4-FFF2-40B4-BE49-F238E27FC236}">
-                <a16:creationId xmlns:a16="http://schemas.microsoft.com/office/drawing/2014/main" id="{8223234F-5640-4D18-938C-DFC7001B5112}"/>
+                <a16:creationId xmlns:a16="http://schemas.microsoft.com/office/drawing/2014/main" id="{F9DA1852-B04E-4160-85C0-3D550F51A662}"/>
               </a:ext>
             </a:extLst>
           </p:cNvPr>
@@ -23388,7 +23388,7 @@
           <p:cNvPr id="7" name="">
             <a:extLst xmlns:a="http://schemas.openxmlformats.org/drawingml/2006/main">
               <a:ext uri="{FF2B5EF4-FFF2-40B4-BE49-F238E27FC236}">
-                <a16:creationId xmlns:a16="http://schemas.microsoft.com/office/drawing/2014/main" id="{503F4A46-C8B4-426F-8DBD-BDAD22EAA38A}"/>
+                <a16:creationId xmlns:a16="http://schemas.microsoft.com/office/drawing/2014/main" id="{AC269D8C-92AC-4D38-9D44-98C6DE333B34}"/>
               </a:ext>
             </a:extLst>
           </p:cNvPr>
@@ -23438,7 +23438,7 @@
           <p:cNvPr id="8" name="">
             <a:extLst xmlns:a="http://schemas.openxmlformats.org/drawingml/2006/main">
               <a:ext uri="{FF2B5EF4-FFF2-40B4-BE49-F238E27FC236}">
-                <a16:creationId xmlns:a16="http://schemas.microsoft.com/office/drawing/2014/main" id="{DB075523-9666-47CE-8BA1-3FAF2CCDB7AC}"/>
+                <a16:creationId xmlns:a16="http://schemas.microsoft.com/office/drawing/2014/main" id="{38DF8D8D-1982-48C7-84A3-957D6D9BA0AB}"/>
               </a:ext>
             </a:extLst>
           </p:cNvPr>
@@ -23469,7 +23469,7 @@
           <p:cNvPr id="9" name="">
             <a:extLst xmlns:a="http://schemas.openxmlformats.org/drawingml/2006/main">
               <a:ext uri="{FF2B5EF4-FFF2-40B4-BE49-F238E27FC236}">
-                <a16:creationId xmlns:a16="http://schemas.microsoft.com/office/drawing/2014/main" id="{E2017AEC-334D-44AA-BC48-A2FB3B9CA647}"/>
+                <a16:creationId xmlns:a16="http://schemas.microsoft.com/office/drawing/2014/main" id="{37B686CF-5FD9-443F-8170-93FCD12458DC}"/>
               </a:ext>
             </a:extLst>
           </p:cNvPr>
@@ -23519,7 +23519,7 @@
           <p:cNvPr id="10" name="">
             <a:extLst xmlns:a="http://schemas.openxmlformats.org/drawingml/2006/main">
               <a:ext uri="{FF2B5EF4-FFF2-40B4-BE49-F238E27FC236}">
-                <a16:creationId xmlns:a16="http://schemas.microsoft.com/office/drawing/2014/main" id="{2B49C4BB-4CD2-454F-98A2-EAF7A20E8318}"/>
+                <a16:creationId xmlns:a16="http://schemas.microsoft.com/office/drawing/2014/main" id="{EAB1FF3C-FCB5-4E62-B63E-D9C68310174B}"/>
               </a:ext>
             </a:extLst>
           </p:cNvPr>
@@ -23550,7 +23550,7 @@
           <p:cNvPr id="11" name="">
             <a:extLst xmlns:a="http://schemas.openxmlformats.org/drawingml/2006/main">
               <a:ext uri="{FF2B5EF4-FFF2-40B4-BE49-F238E27FC236}">
-                <a16:creationId xmlns:a16="http://schemas.microsoft.com/office/drawing/2014/main" id="{660FCBB0-780A-42D9-A333-4BAE5600A76D}"/>
+                <a16:creationId xmlns:a16="http://schemas.microsoft.com/office/drawing/2014/main" id="{A14D0F98-C3DC-475A-BB99-233E6FEDE37C}"/>
               </a:ext>
             </a:extLst>
           </p:cNvPr>
@@ -23600,7 +23600,7 @@
           <p:cNvPr id="12" name="">
             <a:extLst xmlns:a="http://schemas.openxmlformats.org/drawingml/2006/main">
               <a:ext uri="{FF2B5EF4-FFF2-40B4-BE49-F238E27FC236}">
-                <a16:creationId xmlns:a16="http://schemas.microsoft.com/office/drawing/2014/main" id="{942EB28D-CD44-4E62-88C8-AE17C6A5DD67}"/>
+                <a16:creationId xmlns:a16="http://schemas.microsoft.com/office/drawing/2014/main" id="{09BE4728-B858-446D-B682-5E2C07A78C93}"/>
               </a:ext>
             </a:extLst>
           </p:cNvPr>
@@ -23650,7 +23650,7 @@
           <p:cNvPr id="13" name="">
             <a:extLst xmlns:a="http://schemas.openxmlformats.org/drawingml/2006/main">
               <a:ext uri="{FF2B5EF4-FFF2-40B4-BE49-F238E27FC236}">
-                <a16:creationId xmlns:a16="http://schemas.microsoft.com/office/drawing/2014/main" id="{A3A17247-9360-472E-9753-D00449E87F8E}"/>
+                <a16:creationId xmlns:a16="http://schemas.microsoft.com/office/drawing/2014/main" id="{5BB7B264-5253-4FEB-96A9-A04A71ACC992}"/>
               </a:ext>
             </a:extLst>
           </p:cNvPr>
@@ -23681,7 +23681,7 @@
           <p:cNvPr id="14" name="">
             <a:extLst xmlns:a="http://schemas.openxmlformats.org/drawingml/2006/main">
               <a:ext uri="{FF2B5EF4-FFF2-40B4-BE49-F238E27FC236}">
-                <a16:creationId xmlns:a16="http://schemas.microsoft.com/office/drawing/2014/main" id="{F0A1888D-44D3-49C0-829A-2344C569DAA8}"/>
+                <a16:creationId xmlns:a16="http://schemas.microsoft.com/office/drawing/2014/main" id="{D7E29186-9278-417E-ACED-C7EC7E3257B6}"/>
               </a:ext>
             </a:extLst>
           </p:cNvPr>
@@ -23712,7 +23712,7 @@
           <p:cNvPr id="15" name="">
             <a:extLst xmlns:a="http://schemas.openxmlformats.org/drawingml/2006/main">
               <a:ext uri="{FF2B5EF4-FFF2-40B4-BE49-F238E27FC236}">
-                <a16:creationId xmlns:a16="http://schemas.microsoft.com/office/drawing/2014/main" id="{232E1604-1A5C-4E11-B9B3-1FDCFDB0C310}"/>
+                <a16:creationId xmlns:a16="http://schemas.microsoft.com/office/drawing/2014/main" id="{08709728-3FAE-4476-9721-023957E193B6}"/>
               </a:ext>
             </a:extLst>
           </p:cNvPr>
@@ -23762,7 +23762,7 @@
           <p:cNvPr id="16" name="">
             <a:extLst xmlns:a="http://schemas.openxmlformats.org/drawingml/2006/main">
               <a:ext uri="{FF2B5EF4-FFF2-40B4-BE49-F238E27FC236}">
-                <a16:creationId xmlns:a16="http://schemas.microsoft.com/office/drawing/2014/main" id="{A99A9433-1E00-48D5-AB98-8F8B3971B018}"/>
+                <a16:creationId xmlns:a16="http://schemas.microsoft.com/office/drawing/2014/main" id="{07C6753F-31C7-458A-9D18-534542A5F89A}"/>
               </a:ext>
             </a:extLst>
           </p:cNvPr>
@@ -23793,7 +23793,7 @@
           <p:cNvPr id="17" name="">
             <a:extLst xmlns:a="http://schemas.openxmlformats.org/drawingml/2006/main">
               <a:ext uri="{FF2B5EF4-FFF2-40B4-BE49-F238E27FC236}">
-                <a16:creationId xmlns:a16="http://schemas.microsoft.com/office/drawing/2014/main" id="{0EE56683-44DB-468D-B0DE-F18A0DF6E7C5}"/>
+                <a16:creationId xmlns:a16="http://schemas.microsoft.com/office/drawing/2014/main" id="{75B63F5C-440B-4731-9CBA-CED2C8E0F194}"/>
               </a:ext>
             </a:extLst>
           </p:cNvPr>
@@ -23843,7 +23843,7 @@
           <p:cNvPr id="18" name="">
             <a:extLst xmlns:a="http://schemas.openxmlformats.org/drawingml/2006/main">
               <a:ext uri="{FF2B5EF4-FFF2-40B4-BE49-F238E27FC236}">
-                <a16:creationId xmlns:a16="http://schemas.microsoft.com/office/drawing/2014/main" id="{EE396A5A-64C8-4A8F-991B-2564C9F706D0}"/>
+                <a16:creationId xmlns:a16="http://schemas.microsoft.com/office/drawing/2014/main" id="{ED4F7B6A-29AC-49A8-98EE-A97F2B2329BF}"/>
               </a:ext>
             </a:extLst>
           </p:cNvPr>
@@ -23874,7 +23874,7 @@
           <p:cNvPr id="19" name="">
             <a:extLst xmlns:a="http://schemas.openxmlformats.org/drawingml/2006/main">
               <a:ext uri="{FF2B5EF4-FFF2-40B4-BE49-F238E27FC236}">
-                <a16:creationId xmlns:a16="http://schemas.microsoft.com/office/drawing/2014/main" id="{0FA31711-E09D-490C-B56D-4E2D255CE10E}"/>
+                <a16:creationId xmlns:a16="http://schemas.microsoft.com/office/drawing/2014/main" id="{837CBF97-A2B6-4011-A19B-9C366992DED6}"/>
               </a:ext>
             </a:extLst>
           </p:cNvPr>
@@ -23924,7 +23924,7 @@
           <p:cNvPr id="20" name="">
             <a:extLst xmlns:a="http://schemas.openxmlformats.org/drawingml/2006/main">
               <a:ext uri="{FF2B5EF4-FFF2-40B4-BE49-F238E27FC236}">
-                <a16:creationId xmlns:a16="http://schemas.microsoft.com/office/drawing/2014/main" id="{8D815F48-66B7-4992-9FC7-DD8D46F06E41}"/>
+                <a16:creationId xmlns:a16="http://schemas.microsoft.com/office/drawing/2014/main" id="{E6FD838B-3957-4004-BFA2-A56B84D027CD}"/>
               </a:ext>
             </a:extLst>
           </p:cNvPr>
@@ -23974,7 +23974,7 @@
           <p:cNvPr id="21" name="">
             <a:extLst xmlns:a="http://schemas.openxmlformats.org/drawingml/2006/main">
               <a:ext uri="{FF2B5EF4-FFF2-40B4-BE49-F238E27FC236}">
-                <a16:creationId xmlns:a16="http://schemas.microsoft.com/office/drawing/2014/main" id="{9BB6CADE-7AB4-41FB-BB23-22C28560BCCB}"/>
+                <a16:creationId xmlns:a16="http://schemas.microsoft.com/office/drawing/2014/main" id="{0095BFE7-D445-4B1E-979A-BED3FAF9E402}"/>
               </a:ext>
             </a:extLst>
           </p:cNvPr>
@@ -24005,7 +24005,7 @@
           <p:cNvPr id="22" name="">
             <a:extLst xmlns:a="http://schemas.openxmlformats.org/drawingml/2006/main">
               <a:ext uri="{FF2B5EF4-FFF2-40B4-BE49-F238E27FC236}">
-                <a16:creationId xmlns:a16="http://schemas.microsoft.com/office/drawing/2014/main" id="{73EB057C-2247-4338-B5AC-E87B5132A64A}"/>
+                <a16:creationId xmlns:a16="http://schemas.microsoft.com/office/drawing/2014/main" id="{840DE3B2-D352-496E-A6BC-16FBEC3701C8}"/>
               </a:ext>
             </a:extLst>
           </p:cNvPr>
@@ -24036,7 +24036,7 @@
           <p:cNvPr id="23" name="">
             <a:extLst xmlns:a="http://schemas.openxmlformats.org/drawingml/2006/main">
               <a:ext uri="{FF2B5EF4-FFF2-40B4-BE49-F238E27FC236}">
-                <a16:creationId xmlns:a16="http://schemas.microsoft.com/office/drawing/2014/main" id="{0F162104-4F7D-4776-8B86-A9ABF80C876D}"/>
+                <a16:creationId xmlns:a16="http://schemas.microsoft.com/office/drawing/2014/main" id="{F8233F7A-5FAC-4E67-A8C4-F74C3005BFEE}"/>
               </a:ext>
             </a:extLst>
           </p:cNvPr>
@@ -24086,7 +24086,7 @@
           <p:cNvPr id="24" name="">
             <a:extLst xmlns:a="http://schemas.openxmlformats.org/drawingml/2006/main">
               <a:ext uri="{FF2B5EF4-FFF2-40B4-BE49-F238E27FC236}">
-                <a16:creationId xmlns:a16="http://schemas.microsoft.com/office/drawing/2014/main" id="{CC6A4E85-A4B0-4003-9A24-5FE2F6297807}"/>
+                <a16:creationId xmlns:a16="http://schemas.microsoft.com/office/drawing/2014/main" id="{758413E5-1877-497E-ADCE-0BCE7B0E70A6}"/>
               </a:ext>
             </a:extLst>
           </p:cNvPr>
@@ -24117,7 +24117,7 @@
           <p:cNvPr id="25" name="">
             <a:extLst xmlns:a="http://schemas.openxmlformats.org/drawingml/2006/main">
               <a:ext uri="{FF2B5EF4-FFF2-40B4-BE49-F238E27FC236}">
-                <a16:creationId xmlns:a16="http://schemas.microsoft.com/office/drawing/2014/main" id="{ABE79A55-6FAE-4262-9C41-C5ECCBD03192}"/>
+                <a16:creationId xmlns:a16="http://schemas.microsoft.com/office/drawing/2014/main" id="{03716F30-13B4-46BB-B855-1DAA095D5E96}"/>
               </a:ext>
             </a:extLst>
           </p:cNvPr>
@@ -24167,7 +24167,7 @@
           <p:cNvPr id="26" name="">
             <a:extLst xmlns:a="http://schemas.openxmlformats.org/drawingml/2006/main">
               <a:ext uri="{FF2B5EF4-FFF2-40B4-BE49-F238E27FC236}">
-                <a16:creationId xmlns:a16="http://schemas.microsoft.com/office/drawing/2014/main" id="{9ED14469-A40C-42A3-86DC-2961E4AF1036}"/>
+                <a16:creationId xmlns:a16="http://schemas.microsoft.com/office/drawing/2014/main" id="{A9340811-308A-423D-B4F4-6C6CA2A1DCAC}"/>
               </a:ext>
             </a:extLst>
           </p:cNvPr>
@@ -24198,7 +24198,7 @@
           <p:cNvPr id="27" name="">
             <a:extLst xmlns:a="http://schemas.openxmlformats.org/drawingml/2006/main">
               <a:ext uri="{FF2B5EF4-FFF2-40B4-BE49-F238E27FC236}">
-                <a16:creationId xmlns:a16="http://schemas.microsoft.com/office/drawing/2014/main" id="{185197C3-1448-4703-9596-8164A61DC420}"/>
+                <a16:creationId xmlns:a16="http://schemas.microsoft.com/office/drawing/2014/main" id="{A3EB230C-014B-4B7D-8928-D3D2DDEC1CBD}"/>
               </a:ext>
             </a:extLst>
           </p:cNvPr>
@@ -24248,7 +24248,7 @@
           <p:cNvPr id="28" name="">
             <a:extLst xmlns:a="http://schemas.openxmlformats.org/drawingml/2006/main">
               <a:ext uri="{FF2B5EF4-FFF2-40B4-BE49-F238E27FC236}">
-                <a16:creationId xmlns:a16="http://schemas.microsoft.com/office/drawing/2014/main" id="{59FD88E6-C1D6-4B56-9DA7-3F317EF01348}"/>
+                <a16:creationId xmlns:a16="http://schemas.microsoft.com/office/drawing/2014/main" id="{D199E94B-088C-4068-9716-B62DA968E3B6}"/>
               </a:ext>
             </a:extLst>
           </p:cNvPr>
@@ -24283,7 +24283,7 @@
           <p:nvPr/>
         </p:nvPicPr>
         <p:blipFill>
-          <a:blip xmlns:r="http://schemas.openxmlformats.org/officeDocument/2006/relationships" xmlns:a="http://schemas.openxmlformats.org/drawingml/2006/main" r:embed="R8f5c32abad56449b"/>
+          <a:blip xmlns:r="http://schemas.openxmlformats.org/officeDocument/2006/relationships" xmlns:a="http://schemas.openxmlformats.org/drawingml/2006/main" r:embed="R9f5fbe400f3041b1"/>
           <a:stretch xmlns:a="http://schemas.openxmlformats.org/drawingml/2006/main"/>
         </p:blipFill>
         <p:spPr>
@@ -24301,7 +24301,7 @@
           <p:cNvPr id="30" name="">
             <a:extLst xmlns:a="http://schemas.openxmlformats.org/drawingml/2006/main">
               <a:ext uri="{FF2B5EF4-FFF2-40B4-BE49-F238E27FC236}">
-                <a16:creationId xmlns:a16="http://schemas.microsoft.com/office/drawing/2014/main" id="{6A004670-FB73-4F80-888A-50310946C1F3}"/>
+                <a16:creationId xmlns:a16="http://schemas.microsoft.com/office/drawing/2014/main" id="{0E1B2FEC-D1DA-4378-9C4A-043C72AFD1FC}"/>
               </a:ext>
             </a:extLst>
           </p:cNvPr>
@@ -24351,7 +24351,7 @@
           <p:cNvPr id="31" name="">
             <a:extLst xmlns:a="http://schemas.openxmlformats.org/drawingml/2006/main">
               <a:ext uri="{FF2B5EF4-FFF2-40B4-BE49-F238E27FC236}">
-                <a16:creationId xmlns:a16="http://schemas.microsoft.com/office/drawing/2014/main" id="{480F2A73-22B8-4B7C-B630-A61F9C2BD680}"/>
+                <a16:creationId xmlns:a16="http://schemas.microsoft.com/office/drawing/2014/main" id="{0D289602-1E76-46B8-8B3F-B570A5F90194}"/>
               </a:ext>
             </a:extLst>
           </p:cNvPr>
@@ -24399,7 +24399,7 @@
     </p:spTree>
     <p:extLst>
       <p:ext uri="{BB962C8B-B14F-4D97-AF65-F5344CB8AC3E}">
-        <p14:creationId xmlns:p14="http://schemas.microsoft.com/office/powerpoint/2010/main" val="547678951"/>
+        <p14:creationId xmlns:p14="http://schemas.microsoft.com/office/powerpoint/2010/main" val="903316932"/>
       </p:ext>
     </p:extLst>
   </p:cSld>

</xml_diff>